<commit_message>
dockerfile added and ppt restructured
</commit_message>
<xml_diff>
--- a/templates/sample_ppt_template.pptx
+++ b/templates/sample_ppt_template.pptx
@@ -10,9 +10,9 @@
   <p:sldIdLst>
     <p:sldId id="263" r:id="rId2"/>
     <p:sldId id="270" r:id="rId3"/>
-    <p:sldId id="279" r:id="rId4"/>
-    <p:sldId id="280" r:id="rId5"/>
-    <p:sldId id="278" r:id="rId6"/>
+    <p:sldId id="281" r:id="rId4"/>
+    <p:sldId id="282" r:id="rId5"/>
+    <p:sldId id="283" r:id="rId6"/>
   </p:sldIdLst>
   <p:sldSz cx="12192000" cy="6858000"/>
   <p:notesSz cx="6858000" cy="9144000"/>
@@ -122,59 +122,51 @@
 <file path=ppt/changesInfos/changesInfo1.xml><?xml version="1.0" encoding="utf-8"?>
 <pc:chgInfo xmlns:a="http://schemas.openxmlformats.org/drawingml/2006/main" xmlns:r="http://schemas.openxmlformats.org/officeDocument/2006/relationships" xmlns:ac="http://schemas.microsoft.com/office/drawing/2013/main/command" xmlns:pc="http://schemas.microsoft.com/office/powerpoint/2013/main/command">
   <pc:docChgLst>
-    <pc:chgData name="Swetha  Akkala" userId="29270fab-d501-4f7b-a920-3b1278439804" providerId="ADAL" clId="{17097428-0DAC-400A-9866-F07FECCE981B}"/>
-    <pc:docChg chg="undo custSel modSld">
-      <pc:chgData name="Swetha  Akkala" userId="29270fab-d501-4f7b-a920-3b1278439804" providerId="ADAL" clId="{17097428-0DAC-400A-9866-F07FECCE981B}" dt="2026-02-11T15:06:05.758" v="84" actId="208"/>
+    <pc:chgData name="jennis rufina" userId="82f03a850a9f00a2" providerId="LiveId" clId="{FAA1ECB5-B8B8-4660-8381-16C5214360E0}"/>
+    <pc:docChg chg="modSld">
+      <pc:chgData name="jennis rufina" userId="82f03a850a9f00a2" providerId="LiveId" clId="{FAA1ECB5-B8B8-4660-8381-16C5214360E0}" dt="2026-03-10T10:44:36.489" v="284" actId="20577"/>
       <pc:docMkLst>
         <pc:docMk/>
       </pc:docMkLst>
       <pc:sldChg chg="modSp mod">
-        <pc:chgData name="Swetha  Akkala" userId="29270fab-d501-4f7b-a920-3b1278439804" providerId="ADAL" clId="{17097428-0DAC-400A-9866-F07FECCE981B}" dt="2026-02-11T15:06:05.758" v="84" actId="208"/>
+        <pc:chgData name="jennis rufina" userId="82f03a850a9f00a2" providerId="LiveId" clId="{FAA1ECB5-B8B8-4660-8381-16C5214360E0}" dt="2026-03-10T10:43:21.274" v="254" actId="20577"/>
         <pc:sldMkLst>
           <pc:docMk/>
           <pc:sldMk cId="2663611645" sldId="263"/>
         </pc:sldMkLst>
         <pc:spChg chg="mod">
-          <ac:chgData name="Swetha  Akkala" userId="29270fab-d501-4f7b-a920-3b1278439804" providerId="ADAL" clId="{17097428-0DAC-400A-9866-F07FECCE981B}" dt="2026-02-11T15:06:05.758" v="84" actId="208"/>
+          <ac:chgData name="jennis rufina" userId="82f03a850a9f00a2" providerId="LiveId" clId="{FAA1ECB5-B8B8-4660-8381-16C5214360E0}" dt="2026-03-10T10:43:21.274" v="254" actId="20577"/>
           <ac:spMkLst>
             <pc:docMk/>
             <pc:sldMk cId="2663611645" sldId="263"/>
-            <ac:spMk id="5" creationId="{00000000-0000-0000-0000-000000000000}"/>
+            <ac:spMk id="2" creationId="{F4D74AF3-3042-C613-21D4-BDECAE090733}"/>
           </ac:spMkLst>
         </pc:spChg>
         <pc:spChg chg="mod">
-          <ac:chgData name="Swetha  Akkala" userId="29270fab-d501-4f7b-a920-3b1278439804" providerId="ADAL" clId="{17097428-0DAC-400A-9866-F07FECCE981B}" dt="2026-02-11T15:06:05.758" v="84" actId="208"/>
+          <ac:chgData name="jennis rufina" userId="82f03a850a9f00a2" providerId="LiveId" clId="{FAA1ECB5-B8B8-4660-8381-16C5214360E0}" dt="2026-03-10T10:43:15.498" v="247" actId="20577"/>
           <ac:spMkLst>
             <pc:docMk/>
             <pc:sldMk cId="2663611645" sldId="263"/>
             <ac:spMk id="7" creationId="{DFFA6C3A-1489-8B4F-A83F-028609D5F052}"/>
           </ac:spMkLst>
         </pc:spChg>
-        <pc:spChg chg="mod">
-          <ac:chgData name="Swetha  Akkala" userId="29270fab-d501-4f7b-a920-3b1278439804" providerId="ADAL" clId="{17097428-0DAC-400A-9866-F07FECCE981B}" dt="2026-02-11T15:06:05.758" v="84" actId="208"/>
-          <ac:spMkLst>
-            <pc:docMk/>
-            <pc:sldMk cId="2663611645" sldId="263"/>
-            <ac:spMk id="10" creationId="{120A1E06-2121-84D8-8A75-138438476A5A}"/>
-          </ac:spMkLst>
-        </pc:spChg>
-        <pc:spChg chg="mod">
-          <ac:chgData name="Swetha  Akkala" userId="29270fab-d501-4f7b-a920-3b1278439804" providerId="ADAL" clId="{17097428-0DAC-400A-9866-F07FECCE981B}" dt="2026-02-11T15:06:05.758" v="84" actId="208"/>
-          <ac:spMkLst>
-            <pc:docMk/>
-            <pc:sldMk cId="2663611645" sldId="263"/>
-            <ac:spMk id="16" creationId="{F4243315-F4CA-C185-99AF-A0AEEDA89C38}"/>
-          </ac:spMkLst>
-        </pc:spChg>
       </pc:sldChg>
       <pc:sldChg chg="modSp mod">
-        <pc:chgData name="Swetha  Akkala" userId="29270fab-d501-4f7b-a920-3b1278439804" providerId="ADAL" clId="{17097428-0DAC-400A-9866-F07FECCE981B}" dt="2026-02-11T15:00:41.857" v="75" actId="108"/>
+        <pc:chgData name="jennis rufina" userId="82f03a850a9f00a2" providerId="LiveId" clId="{FAA1ECB5-B8B8-4660-8381-16C5214360E0}" dt="2026-02-25T08:07:54.699" v="42" actId="20577"/>
         <pc:sldMkLst>
           <pc:docMk/>
           <pc:sldMk cId="4121649048" sldId="270"/>
         </pc:sldMkLst>
         <pc:spChg chg="mod">
-          <ac:chgData name="Swetha  Akkala" userId="29270fab-d501-4f7b-a920-3b1278439804" providerId="ADAL" clId="{17097428-0DAC-400A-9866-F07FECCE981B}" dt="2026-02-11T15:00:41.857" v="75" actId="108"/>
+          <ac:chgData name="jennis rufina" userId="82f03a850a9f00a2" providerId="LiveId" clId="{FAA1ECB5-B8B8-4660-8381-16C5214360E0}" dt="2026-02-25T08:07:39.331" v="32" actId="20577"/>
+          <ac:spMkLst>
+            <pc:docMk/>
+            <pc:sldMk cId="4121649048" sldId="270"/>
+            <ac:spMk id="7" creationId="{CBC7D05A-9F91-615D-CE48-576F37B0F8CA}"/>
+          </ac:spMkLst>
+        </pc:spChg>
+        <pc:spChg chg="mod">
+          <ac:chgData name="jennis rufina" userId="82f03a850a9f00a2" providerId="LiveId" clId="{FAA1ECB5-B8B8-4660-8381-16C5214360E0}" dt="2026-02-25T08:07:54.699" v="42" actId="20577"/>
           <ac:spMkLst>
             <pc:docMk/>
             <pc:sldMk cId="4121649048" sldId="270"/>
@@ -183,168 +175,71 @@
         </pc:spChg>
       </pc:sldChg>
       <pc:sldChg chg="modSp mod">
-        <pc:chgData name="Swetha  Akkala" userId="29270fab-d501-4f7b-a920-3b1278439804" providerId="ADAL" clId="{17097428-0DAC-400A-9866-F07FECCE981B}" dt="2026-02-11T14:59:39.496" v="66" actId="20577"/>
+        <pc:chgData name="jennis rufina" userId="82f03a850a9f00a2" providerId="LiveId" clId="{FAA1ECB5-B8B8-4660-8381-16C5214360E0}" dt="2026-03-10T10:44:36.489" v="284" actId="20577"/>
         <pc:sldMkLst>
           <pc:docMk/>
-          <pc:sldMk cId="648717608" sldId="271"/>
+          <pc:sldMk cId="2821146086" sldId="281"/>
         </pc:sldMkLst>
         <pc:spChg chg="mod">
-          <ac:chgData name="Swetha  Akkala" userId="29270fab-d501-4f7b-a920-3b1278439804" providerId="ADAL" clId="{17097428-0DAC-400A-9866-F07FECCE981B}" dt="2026-02-11T14:59:39.496" v="66" actId="20577"/>
+          <ac:chgData name="jennis rufina" userId="82f03a850a9f00a2" providerId="LiveId" clId="{FAA1ECB5-B8B8-4660-8381-16C5214360E0}" dt="2026-03-10T10:44:36.489" v="284" actId="20577"/>
           <ac:spMkLst>
             <pc:docMk/>
-            <pc:sldMk cId="648717608" sldId="271"/>
-            <ac:spMk id="11" creationId="{D8323F5C-39A1-9D33-A961-82D37EBD9A6B}"/>
+            <pc:sldMk cId="2821146086" sldId="281"/>
+            <ac:spMk id="7" creationId="{281E5FE1-4888-CBDF-0DD5-A41BA5FEEA8D}"/>
+          </ac:spMkLst>
+        </pc:spChg>
+        <pc:spChg chg="mod">
+          <ac:chgData name="jennis rufina" userId="82f03a850a9f00a2" providerId="LiveId" clId="{FAA1ECB5-B8B8-4660-8381-16C5214360E0}" dt="2026-02-25T08:08:28.423" v="73" actId="20577"/>
+          <ac:spMkLst>
+            <pc:docMk/>
+            <pc:sldMk cId="2821146086" sldId="281"/>
+            <ac:spMk id="11" creationId="{901A2AF5-92CA-8F25-88FA-D406713C067E}"/>
           </ac:spMkLst>
         </pc:spChg>
       </pc:sldChg>
       <pc:sldChg chg="modSp mod">
-        <pc:chgData name="Swetha  Akkala" userId="29270fab-d501-4f7b-a920-3b1278439804" providerId="ADAL" clId="{17097428-0DAC-400A-9866-F07FECCE981B}" dt="2026-02-11T14:59:56.105" v="70" actId="6549"/>
+        <pc:chgData name="jennis rufina" userId="82f03a850a9f00a2" providerId="LiveId" clId="{FAA1ECB5-B8B8-4660-8381-16C5214360E0}" dt="2026-02-25T08:09:04.057" v="104" actId="20577"/>
         <pc:sldMkLst>
           <pc:docMk/>
-          <pc:sldMk cId="805950796" sldId="272"/>
+          <pc:sldMk cId="2262051643" sldId="282"/>
         </pc:sldMkLst>
         <pc:spChg chg="mod">
-          <ac:chgData name="Swetha  Akkala" userId="29270fab-d501-4f7b-a920-3b1278439804" providerId="ADAL" clId="{17097428-0DAC-400A-9866-F07FECCE981B}" dt="2026-02-11T14:59:56.105" v="70" actId="6549"/>
+          <ac:chgData name="jennis rufina" userId="82f03a850a9f00a2" providerId="LiveId" clId="{FAA1ECB5-B8B8-4660-8381-16C5214360E0}" dt="2026-02-25T08:08:51.255" v="94" actId="20577"/>
           <ac:spMkLst>
             <pc:docMk/>
-            <pc:sldMk cId="805950796" sldId="272"/>
-            <ac:spMk id="11" creationId="{C0DBFA1B-D25D-D84D-F693-39645FDCE4DE}"/>
+            <pc:sldMk cId="2262051643" sldId="282"/>
+            <ac:spMk id="7" creationId="{5D00FC8E-1F2A-3890-1644-19DF13D3FFB6}"/>
+          </ac:spMkLst>
+        </pc:spChg>
+        <pc:spChg chg="mod">
+          <ac:chgData name="jennis rufina" userId="82f03a850a9f00a2" providerId="LiveId" clId="{FAA1ECB5-B8B8-4660-8381-16C5214360E0}" dt="2026-02-25T08:09:04.057" v="104" actId="20577"/>
+          <ac:spMkLst>
+            <pc:docMk/>
+            <pc:sldMk cId="2262051643" sldId="282"/>
+            <ac:spMk id="11" creationId="{8C183A66-42F8-F13C-795D-00913B38A72C}"/>
           </ac:spMkLst>
         </pc:spChg>
       </pc:sldChg>
       <pc:sldChg chg="modSp mod">
-        <pc:chgData name="Swetha  Akkala" userId="29270fab-d501-4f7b-a920-3b1278439804" providerId="ADAL" clId="{17097428-0DAC-400A-9866-F07FECCE981B}" dt="2026-02-11T15:00:02.525" v="71" actId="20577"/>
+        <pc:chgData name="jennis rufina" userId="82f03a850a9f00a2" providerId="LiveId" clId="{FAA1ECB5-B8B8-4660-8381-16C5214360E0}" dt="2026-03-03T14:13:17.818" v="203" actId="20577"/>
         <pc:sldMkLst>
           <pc:docMk/>
-          <pc:sldMk cId="1816062349" sldId="273"/>
+          <pc:sldMk cId="119268449" sldId="283"/>
         </pc:sldMkLst>
         <pc:spChg chg="mod">
-          <ac:chgData name="Swetha  Akkala" userId="29270fab-d501-4f7b-a920-3b1278439804" providerId="ADAL" clId="{17097428-0DAC-400A-9866-F07FECCE981B}" dt="2026-02-11T15:00:02.525" v="71" actId="20577"/>
+          <ac:chgData name="jennis rufina" userId="82f03a850a9f00a2" providerId="LiveId" clId="{FAA1ECB5-B8B8-4660-8381-16C5214360E0}" dt="2026-03-03T14:13:17.818" v="203" actId="20577"/>
           <ac:spMkLst>
             <pc:docMk/>
-            <pc:sldMk cId="1816062349" sldId="273"/>
-            <ac:spMk id="11" creationId="{5B6841F3-EE42-62A4-E730-5C5DD6C5042B}"/>
-          </ac:spMkLst>
-        </pc:spChg>
-      </pc:sldChg>
-      <pc:sldChg chg="modSp mod">
-        <pc:chgData name="Swetha  Akkala" userId="29270fab-d501-4f7b-a920-3b1278439804" providerId="ADAL" clId="{17097428-0DAC-400A-9866-F07FECCE981B}" dt="2026-02-11T15:00:08.086" v="72" actId="20577"/>
-        <pc:sldMkLst>
-          <pc:docMk/>
-          <pc:sldMk cId="1407599107" sldId="274"/>
-        </pc:sldMkLst>
-        <pc:spChg chg="mod">
-          <ac:chgData name="Swetha  Akkala" userId="29270fab-d501-4f7b-a920-3b1278439804" providerId="ADAL" clId="{17097428-0DAC-400A-9866-F07FECCE981B}" dt="2026-02-11T15:00:08.086" v="72" actId="20577"/>
-          <ac:spMkLst>
-            <pc:docMk/>
-            <pc:sldMk cId="1407599107" sldId="274"/>
-            <ac:spMk id="11" creationId="{A401934D-905F-324B-9C99-DCEA3E134CC1}"/>
-          </ac:spMkLst>
-        </pc:spChg>
-      </pc:sldChg>
-      <pc:sldChg chg="modSp mod">
-        <pc:chgData name="Swetha  Akkala" userId="29270fab-d501-4f7b-a920-3b1278439804" providerId="ADAL" clId="{17097428-0DAC-400A-9866-F07FECCE981B}" dt="2026-02-11T14:56:53.277" v="27" actId="20577"/>
-        <pc:sldMkLst>
-          <pc:docMk/>
-          <pc:sldMk cId="926711311" sldId="275"/>
-        </pc:sldMkLst>
-        <pc:spChg chg="mod">
-          <ac:chgData name="Swetha  Akkala" userId="29270fab-d501-4f7b-a920-3b1278439804" providerId="ADAL" clId="{17097428-0DAC-400A-9866-F07FECCE981B}" dt="2026-02-11T14:56:53.277" v="27" actId="20577"/>
-          <ac:spMkLst>
-            <pc:docMk/>
-            <pc:sldMk cId="926711311" sldId="275"/>
-            <ac:spMk id="11" creationId="{EFF2B2A6-C3FC-1FFA-F104-2AB7E11CB6F4}"/>
-          </ac:spMkLst>
-        </pc:spChg>
-      </pc:sldChg>
-      <pc:sldChg chg="modSp mod">
-        <pc:chgData name="Swetha  Akkala" userId="29270fab-d501-4f7b-a920-3b1278439804" providerId="ADAL" clId="{17097428-0DAC-400A-9866-F07FECCE981B}" dt="2026-02-11T14:56:40.726" v="25" actId="20577"/>
-        <pc:sldMkLst>
-          <pc:docMk/>
-          <pc:sldMk cId="3146498507" sldId="276"/>
-        </pc:sldMkLst>
-        <pc:spChg chg="mod">
-          <ac:chgData name="Swetha  Akkala" userId="29270fab-d501-4f7b-a920-3b1278439804" providerId="ADAL" clId="{17097428-0DAC-400A-9866-F07FECCE981B}" dt="2026-02-11T14:56:40.726" v="25" actId="20577"/>
-          <ac:spMkLst>
-            <pc:docMk/>
-            <pc:sldMk cId="3146498507" sldId="276"/>
-            <ac:spMk id="11" creationId="{CEC959A5-A1C1-02A7-3318-467F21764977}"/>
-          </ac:spMkLst>
-        </pc:spChg>
-      </pc:sldChg>
-      <pc:sldChg chg="modSp mod">
-        <pc:chgData name="Swetha  Akkala" userId="29270fab-d501-4f7b-a920-3b1278439804" providerId="ADAL" clId="{17097428-0DAC-400A-9866-F07FECCE981B}" dt="2026-02-11T14:58:14.414" v="59" actId="255"/>
-        <pc:sldMkLst>
-          <pc:docMk/>
-          <pc:sldMk cId="2977330921" sldId="277"/>
-        </pc:sldMkLst>
-        <pc:spChg chg="mod">
-          <ac:chgData name="Swetha  Akkala" userId="29270fab-d501-4f7b-a920-3b1278439804" providerId="ADAL" clId="{17097428-0DAC-400A-9866-F07FECCE981B}" dt="2026-02-11T14:58:14.414" v="59" actId="255"/>
-          <ac:spMkLst>
-            <pc:docMk/>
-            <pc:sldMk cId="2977330921" sldId="277"/>
-            <ac:spMk id="11" creationId="{5C1D1234-F87E-33E0-0BD2-0D1863584470}"/>
-          </ac:spMkLst>
-        </pc:spChg>
-      </pc:sldChg>
-      <pc:sldChg chg="modSp mod">
-        <pc:chgData name="Swetha  Akkala" userId="29270fab-d501-4f7b-a920-3b1278439804" providerId="ADAL" clId="{17097428-0DAC-400A-9866-F07FECCE981B}" dt="2026-02-11T14:56:25.326" v="21" actId="123"/>
-        <pc:sldMkLst>
-          <pc:docMk/>
-          <pc:sldMk cId="88817511" sldId="278"/>
-        </pc:sldMkLst>
-        <pc:spChg chg="mod">
-          <ac:chgData name="Swetha  Akkala" userId="29270fab-d501-4f7b-a920-3b1278439804" providerId="ADAL" clId="{17097428-0DAC-400A-9866-F07FECCE981B}" dt="2026-02-11T14:56:25.326" v="21" actId="123"/>
-          <ac:spMkLst>
-            <pc:docMk/>
-            <pc:sldMk cId="88817511" sldId="278"/>
-            <ac:spMk id="11" creationId="{B7FE0190-4CB5-2F4F-C984-D5C304ED4B0A}"/>
-          </ac:spMkLst>
-        </pc:spChg>
-      </pc:sldChg>
-      <pc:sldChg chg="modSp mod">
-        <pc:chgData name="Swetha  Akkala" userId="29270fab-d501-4f7b-a920-3b1278439804" providerId="ADAL" clId="{17097428-0DAC-400A-9866-F07FECCE981B}" dt="2026-02-11T15:02:34.323" v="83" actId="255"/>
-        <pc:sldMkLst>
-          <pc:docMk/>
-          <pc:sldMk cId="859413911" sldId="279"/>
-        </pc:sldMkLst>
-        <pc:spChg chg="mod">
-          <ac:chgData name="Swetha  Akkala" userId="29270fab-d501-4f7b-a920-3b1278439804" providerId="ADAL" clId="{17097428-0DAC-400A-9866-F07FECCE981B}" dt="2026-02-11T15:02:02.166" v="81" actId="20577"/>
-          <ac:spMkLst>
-            <pc:docMk/>
-            <pc:sldMk cId="859413911" sldId="279"/>
-            <ac:spMk id="7" creationId="{6BAA8868-FDEB-212D-0E84-B1B339220F85}"/>
+            <pc:sldMk cId="119268449" sldId="283"/>
+            <ac:spMk id="7" creationId="{B9B22AF1-3840-9008-3CA4-0A6A790F3B2B}"/>
           </ac:spMkLst>
         </pc:spChg>
         <pc:spChg chg="mod">
-          <ac:chgData name="Swetha  Akkala" userId="29270fab-d501-4f7b-a920-3b1278439804" providerId="ADAL" clId="{17097428-0DAC-400A-9866-F07FECCE981B}" dt="2026-02-11T15:00:24.435" v="74" actId="20577"/>
+          <ac:chgData name="jennis rufina" userId="82f03a850a9f00a2" providerId="LiveId" clId="{FAA1ECB5-B8B8-4660-8381-16C5214360E0}" dt="2026-02-25T08:09:51.622" v="137" actId="20577"/>
           <ac:spMkLst>
             <pc:docMk/>
-            <pc:sldMk cId="859413911" sldId="279"/>
-            <ac:spMk id="11" creationId="{3F56B683-987F-2AB2-3C43-65E5943B627C}"/>
-          </ac:spMkLst>
-        </pc:spChg>
-        <pc:spChg chg="mod">
-          <ac:chgData name="Swetha  Akkala" userId="29270fab-d501-4f7b-a920-3b1278439804" providerId="ADAL" clId="{17097428-0DAC-400A-9866-F07FECCE981B}" dt="2026-02-11T15:02:34.323" v="83" actId="255"/>
-          <ac:spMkLst>
-            <pc:docMk/>
-            <pc:sldMk cId="859413911" sldId="279"/>
-            <ac:spMk id="12" creationId="{FF5044C3-FB81-37EB-A51F-BF41E9D309C6}"/>
-          </ac:spMkLst>
-        </pc:spChg>
-      </pc:sldChg>
-      <pc:sldChg chg="modSp mod">
-        <pc:chgData name="Swetha  Akkala" userId="29270fab-d501-4f7b-a920-3b1278439804" providerId="ADAL" clId="{17097428-0DAC-400A-9866-F07FECCE981B}" dt="2026-02-11T14:56:20.029" v="20" actId="123"/>
-        <pc:sldMkLst>
-          <pc:docMk/>
-          <pc:sldMk cId="2512149221" sldId="280"/>
-        </pc:sldMkLst>
-        <pc:spChg chg="mod">
-          <ac:chgData name="Swetha  Akkala" userId="29270fab-d501-4f7b-a920-3b1278439804" providerId="ADAL" clId="{17097428-0DAC-400A-9866-F07FECCE981B}" dt="2026-02-11T14:56:20.029" v="20" actId="123"/>
-          <ac:spMkLst>
-            <pc:docMk/>
-            <pc:sldMk cId="2512149221" sldId="280"/>
-            <ac:spMk id="11" creationId="{5195D475-D617-D7E2-0AAE-F20B3E7BBCAA}"/>
+            <pc:sldMk cId="119268449" sldId="283"/>
+            <ac:spMk id="11" creationId="{E710390A-553C-B68D-9AAF-E63341E911D8}"/>
           </ac:spMkLst>
         </pc:spChg>
       </pc:sldChg>
@@ -435,7 +330,7 @@
           <a:p>
             <a:fld id="{E40DDB01-B6F6-4D19-B7EB-82B79169DABA}" type="datetimeFigureOut">
               <a:rPr lang="en-IN" smtClean="0"/>
-              <a:t>16-02-2026</a:t>
+              <a:t>10-03-2026</a:t>
             </a:fld>
             <a:endParaRPr lang="en-IN"/>
           </a:p>
@@ -703,90 +598,6 @@
 </p:notesMaster>
 </file>
 
-<file path=ppt/notesSlides/notesSlide1.xml><?xml version="1.0" encoding="utf-8"?>
-<p:notes xmlns:a="http://schemas.openxmlformats.org/drawingml/2006/main" xmlns:r="http://schemas.openxmlformats.org/officeDocument/2006/relationships" xmlns:p="http://schemas.openxmlformats.org/presentationml/2006/main">
-  <p:cSld>
-    <p:spTree>
-      <p:nvGrpSpPr>
-        <p:cNvPr id="1" name=""/>
-        <p:cNvGrpSpPr/>
-        <p:nvPr/>
-      </p:nvGrpSpPr>
-      <p:grpSpPr>
-        <a:xfrm>
-          <a:off x="0" y="0"/>
-          <a:ext cx="0" cy="0"/>
-          <a:chOff x="0" y="0"/>
-          <a:chExt cx="0" cy="0"/>
-        </a:xfrm>
-      </p:grpSpPr>
-      <p:sp>
-        <p:nvSpPr>
-          <p:cNvPr id="2" name="Slide Image Placeholder 1"/>
-          <p:cNvSpPr>
-            <a:spLocks noGrp="1" noRot="1" noChangeAspect="1"/>
-          </p:cNvSpPr>
-          <p:nvPr>
-            <p:ph type="sldImg"/>
-          </p:nvPr>
-        </p:nvSpPr>
-        <p:spPr/>
-      </p:sp>
-      <p:sp>
-        <p:nvSpPr>
-          <p:cNvPr id="3" name="Notes Placeholder 2"/>
-          <p:cNvSpPr>
-            <a:spLocks noGrp="1"/>
-          </p:cNvSpPr>
-          <p:nvPr>
-            <p:ph type="body" idx="1"/>
-          </p:nvPr>
-        </p:nvSpPr>
-        <p:spPr/>
-        <p:txBody>
-          <a:bodyPr/>
-          <a:lstStyle/>
-          <a:p>
-            <a:endParaRPr lang="en-IN" dirty="0"/>
-          </a:p>
-        </p:txBody>
-      </p:sp>
-      <p:sp>
-        <p:nvSpPr>
-          <p:cNvPr id="4" name="Slide Number Placeholder 3"/>
-          <p:cNvSpPr>
-            <a:spLocks noGrp="1"/>
-          </p:cNvSpPr>
-          <p:nvPr>
-            <p:ph type="sldNum" sz="quarter" idx="5"/>
-          </p:nvPr>
-        </p:nvSpPr>
-        <p:spPr/>
-        <p:txBody>
-          <a:bodyPr/>
-          <a:lstStyle/>
-          <a:p>
-            <a:fld id="{E681C110-5E53-4DE7-B91B-A84D7659A2DC}" type="slidenum">
-              <a:rPr lang="en-IN" smtClean="0"/>
-              <a:t>4</a:t>
-            </a:fld>
-            <a:endParaRPr lang="en-IN"/>
-          </a:p>
-        </p:txBody>
-      </p:sp>
-    </p:spTree>
-    <p:extLst>
-      <p:ext uri="{BB962C8B-B14F-4D97-AF65-F5344CB8AC3E}">
-        <p14:creationId xmlns:p14="http://schemas.microsoft.com/office/powerpoint/2010/main" val="985720059"/>
-      </p:ext>
-    </p:extLst>
-  </p:cSld>
-  <p:clrMapOvr>
-    <a:masterClrMapping/>
-  </p:clrMapOvr>
-</p:notes>
-</file>
-
 <file path=ppt/slideLayouts/slideLayout1.xml><?xml version="1.0" encoding="utf-8"?>
 <p:sldLayout xmlns:a="http://schemas.openxmlformats.org/drawingml/2006/main" xmlns:r="http://schemas.openxmlformats.org/officeDocument/2006/relationships" xmlns:p="http://schemas.openxmlformats.org/presentationml/2006/main" type="title" preserve="1">
   <p:cSld name="Title Slide">
@@ -936,7 +747,7 @@
           <a:p>
             <a:fld id="{C456AD15-A154-4F8D-9983-D4D8643F4F81}" type="datetimeFigureOut">
               <a:rPr lang="en-IN" smtClean="0"/>
-              <a:t>16-02-2026</a:t>
+              <a:t>10-03-2026</a:t>
             </a:fld>
             <a:endParaRPr lang="en-IN"/>
           </a:p>
@@ -1136,7 +947,7 @@
           <a:p>
             <a:fld id="{C456AD15-A154-4F8D-9983-D4D8643F4F81}" type="datetimeFigureOut">
               <a:rPr lang="en-IN" smtClean="0"/>
-              <a:t>16-02-2026</a:t>
+              <a:t>10-03-2026</a:t>
             </a:fld>
             <a:endParaRPr lang="en-IN"/>
           </a:p>
@@ -1346,7 +1157,7 @@
           <a:p>
             <a:fld id="{C456AD15-A154-4F8D-9983-D4D8643F4F81}" type="datetimeFigureOut">
               <a:rPr lang="en-IN" smtClean="0"/>
-              <a:t>16-02-2026</a:t>
+              <a:t>10-03-2026</a:t>
             </a:fld>
             <a:endParaRPr lang="en-IN"/>
           </a:p>
@@ -1546,7 +1357,7 @@
           <a:p>
             <a:fld id="{C456AD15-A154-4F8D-9983-D4D8643F4F81}" type="datetimeFigureOut">
               <a:rPr lang="en-IN" smtClean="0"/>
-              <a:t>16-02-2026</a:t>
+              <a:t>10-03-2026</a:t>
             </a:fld>
             <a:endParaRPr lang="en-IN"/>
           </a:p>
@@ -1822,7 +1633,7 @@
           <a:p>
             <a:fld id="{C456AD15-A154-4F8D-9983-D4D8643F4F81}" type="datetimeFigureOut">
               <a:rPr lang="en-IN" smtClean="0"/>
-              <a:t>16-02-2026</a:t>
+              <a:t>10-03-2026</a:t>
             </a:fld>
             <a:endParaRPr lang="en-IN"/>
           </a:p>
@@ -2090,7 +1901,7 @@
           <a:p>
             <a:fld id="{C456AD15-A154-4F8D-9983-D4D8643F4F81}" type="datetimeFigureOut">
               <a:rPr lang="en-IN" smtClean="0"/>
-              <a:t>16-02-2026</a:t>
+              <a:t>10-03-2026</a:t>
             </a:fld>
             <a:endParaRPr lang="en-IN"/>
           </a:p>
@@ -2505,7 +2316,7 @@
           <a:p>
             <a:fld id="{C456AD15-A154-4F8D-9983-D4D8643F4F81}" type="datetimeFigureOut">
               <a:rPr lang="en-IN" smtClean="0"/>
-              <a:t>16-02-2026</a:t>
+              <a:t>10-03-2026</a:t>
             </a:fld>
             <a:endParaRPr lang="en-IN"/>
           </a:p>
@@ -2647,7 +2458,7 @@
           <a:p>
             <a:fld id="{C456AD15-A154-4F8D-9983-D4D8643F4F81}" type="datetimeFigureOut">
               <a:rPr lang="en-IN" smtClean="0"/>
-              <a:t>16-02-2026</a:t>
+              <a:t>10-03-2026</a:t>
             </a:fld>
             <a:endParaRPr lang="en-IN"/>
           </a:p>
@@ -2760,7 +2571,7 @@
           <a:p>
             <a:fld id="{C456AD15-A154-4F8D-9983-D4D8643F4F81}" type="datetimeFigureOut">
               <a:rPr lang="en-IN" smtClean="0"/>
-              <a:t>16-02-2026</a:t>
+              <a:t>10-03-2026</a:t>
             </a:fld>
             <a:endParaRPr lang="en-IN"/>
           </a:p>
@@ -3073,7 +2884,7 @@
           <a:p>
             <a:fld id="{C456AD15-A154-4F8D-9983-D4D8643F4F81}" type="datetimeFigureOut">
               <a:rPr lang="en-IN" smtClean="0"/>
-              <a:t>16-02-2026</a:t>
+              <a:t>10-03-2026</a:t>
             </a:fld>
             <a:endParaRPr lang="en-IN"/>
           </a:p>
@@ -3362,7 +3173,7 @@
           <a:p>
             <a:fld id="{C456AD15-A154-4F8D-9983-D4D8643F4F81}" type="datetimeFigureOut">
               <a:rPr lang="en-IN" smtClean="0"/>
-              <a:t>16-02-2026</a:t>
+              <a:t>10-03-2026</a:t>
             </a:fld>
             <a:endParaRPr lang="en-IN"/>
           </a:p>
@@ -3605,7 +3416,7 @@
           <a:p>
             <a:fld id="{C456AD15-A154-4F8D-9983-D4D8643F4F81}" type="datetimeFigureOut">
               <a:rPr lang="en-IN" smtClean="0"/>
-              <a:t>16-02-2026</a:t>
+              <a:t>10-03-2026</a:t>
             </a:fld>
             <a:endParaRPr lang="en-IN"/>
           </a:p>
@@ -4125,7 +3936,7 @@
                 <a:ea typeface="Calibri" panose="020F0502020204030204" pitchFamily="34" charset="0"/>
                 <a:cs typeface="Calibri" panose="020F0502020204030204" pitchFamily="34" charset="0"/>
               </a:rPr>
-              <a:t>Automation Test Engineer with 6+ years of experience in Software Quality Assurance, encompassing both Manual and Automation Testing for web applications. </a:t>
+              <a:t>{PROFESSIONAL_SUMMARY} :</a:t>
             </a:r>
           </a:p>
           <a:p>
@@ -4139,39 +3950,14 @@
               <a:buSzPts val="1150"/>
               <a:buNone/>
             </a:pPr>
-            <a:r>
-              <a:rPr lang="en-US" sz="1500" dirty="0">
-                <a:solidFill>
-                  <a:schemeClr val="tx1"/>
-                </a:solidFill>
-                <a:latin typeface="Calibri" panose="020F0502020204030204" pitchFamily="34" charset="0"/>
-                <a:ea typeface="Calibri" panose="020F0502020204030204" pitchFamily="34" charset="0"/>
-                <a:cs typeface="Calibri" panose="020F0502020204030204" pitchFamily="34" charset="0"/>
-              </a:rPr>
-              <a:t>Strong expertise in Selenium with Python and Playwright with Python, with hands-on experience in designing, developing, and maintaining scalable automation frameworks using </a:t>
-            </a:r>
-            <a:r>
-              <a:rPr lang="en-US" sz="1500" dirty="0" err="1">
-                <a:solidFill>
-                  <a:schemeClr val="tx1"/>
-                </a:solidFill>
-                <a:latin typeface="Calibri" panose="020F0502020204030204" pitchFamily="34" charset="0"/>
-                <a:ea typeface="Calibri" panose="020F0502020204030204" pitchFamily="34" charset="0"/>
-                <a:cs typeface="Calibri" panose="020F0502020204030204" pitchFamily="34" charset="0"/>
-              </a:rPr>
-              <a:t>PyTest</a:t>
-            </a:r>
-            <a:r>
-              <a:rPr lang="en-US" sz="1500" dirty="0">
-                <a:solidFill>
-                  <a:schemeClr val="tx1"/>
-                </a:solidFill>
-                <a:latin typeface="Calibri" panose="020F0502020204030204" pitchFamily="34" charset="0"/>
-                <a:ea typeface="Calibri" panose="020F0502020204030204" pitchFamily="34" charset="0"/>
-                <a:cs typeface="Calibri" panose="020F0502020204030204" pitchFamily="34" charset="0"/>
-              </a:rPr>
-              <a:t>, Robot Framework, and Page Object Model (POM). </a:t>
-            </a:r>
+            <a:endParaRPr lang="en-US" sz="1500" dirty="0">
+              <a:solidFill>
+                <a:schemeClr val="tx1"/>
+              </a:solidFill>
+              <a:latin typeface="Calibri" panose="020F0502020204030204" pitchFamily="34" charset="0"/>
+              <a:ea typeface="Calibri" panose="020F0502020204030204" pitchFamily="34" charset="0"/>
+              <a:cs typeface="Calibri" panose="020F0502020204030204" pitchFamily="34" charset="0"/>
+            </a:endParaRPr>
           </a:p>
           <a:p>
             <a:pPr marL="88900" marR="0" indent="0">
@@ -4184,17 +3970,14 @@
               <a:buSzPts val="1150"/>
               <a:buNone/>
             </a:pPr>
-            <a:r>
-              <a:rPr lang="en-US" sz="1500" dirty="0">
-                <a:solidFill>
-                  <a:schemeClr val="tx1"/>
-                </a:solidFill>
-                <a:latin typeface="Calibri" panose="020F0502020204030204" pitchFamily="34" charset="0"/>
-                <a:ea typeface="Calibri" panose="020F0502020204030204" pitchFamily="34" charset="0"/>
-                <a:cs typeface="Calibri" panose="020F0502020204030204" pitchFamily="34" charset="0"/>
-              </a:rPr>
-              <a:t>Proficient in API testing using Postman and Python Requests, with exposure to CI/CD integration using Jenkins for continuous test execution. Possess solid programming skills in Python, including Object-Oriented Programming concepts, along with strong experience in writing XPath and CSS selectors for dynamic web elements. </a:t>
-            </a:r>
+            <a:endParaRPr lang="en-US" sz="1500" dirty="0">
+              <a:solidFill>
+                <a:schemeClr val="tx1"/>
+              </a:solidFill>
+              <a:latin typeface="Calibri" panose="020F0502020204030204" pitchFamily="34" charset="0"/>
+              <a:ea typeface="Calibri" panose="020F0502020204030204" pitchFamily="34" charset="0"/>
+              <a:cs typeface="Calibri" panose="020F0502020204030204" pitchFamily="34" charset="0"/>
+            </a:endParaRPr>
           </a:p>
           <a:p>
             <a:pPr marL="88900" marR="0" indent="0">
@@ -4207,17 +3990,114 @@
               <a:buSzPts val="1150"/>
               <a:buNone/>
             </a:pPr>
-            <a:r>
-              <a:rPr lang="en-US" sz="1500" dirty="0">
-                <a:solidFill>
-                  <a:schemeClr val="tx1"/>
-                </a:solidFill>
-                <a:latin typeface="Calibri" panose="020F0502020204030204" pitchFamily="34" charset="0"/>
-                <a:ea typeface="Calibri" panose="020F0502020204030204" pitchFamily="34" charset="0"/>
-                <a:cs typeface="Calibri" panose="020F0502020204030204" pitchFamily="34" charset="0"/>
-              </a:rPr>
-              <a:t>Well-versed in SDLC, STLC, Defect Life Cycle, Agile methodologies, and defect management using JIRA, with additional knowledge of SQL, version control tools (Git, GitHub, GitLab, Bitbucket), and modern testing practices.  </a:t>
-            </a:r>
+            <a:endParaRPr lang="en-US" sz="1500" dirty="0">
+              <a:solidFill>
+                <a:schemeClr val="tx1"/>
+              </a:solidFill>
+              <a:latin typeface="Calibri" panose="020F0502020204030204" pitchFamily="34" charset="0"/>
+              <a:ea typeface="Calibri" panose="020F0502020204030204" pitchFamily="34" charset="0"/>
+              <a:cs typeface="Calibri" panose="020F0502020204030204" pitchFamily="34" charset="0"/>
+            </a:endParaRPr>
+          </a:p>
+          <a:p>
+            <a:pPr marL="88900" marR="0" indent="0">
+              <a:spcBef>
+                <a:spcPct val="0"/>
+              </a:spcBef>
+              <a:spcAft>
+                <a:spcPct val="0"/>
+              </a:spcAft>
+              <a:buSzPts val="1150"/>
+              <a:buNone/>
+            </a:pPr>
+            <a:endParaRPr lang="en-US" sz="1500" dirty="0">
+              <a:solidFill>
+                <a:schemeClr val="tx1"/>
+              </a:solidFill>
+              <a:latin typeface="Calibri" panose="020F0502020204030204" pitchFamily="34" charset="0"/>
+              <a:ea typeface="Calibri" panose="020F0502020204030204" pitchFamily="34" charset="0"/>
+              <a:cs typeface="Calibri" panose="020F0502020204030204" pitchFamily="34" charset="0"/>
+            </a:endParaRPr>
+          </a:p>
+          <a:p>
+            <a:pPr marL="88900" marR="0" indent="0">
+              <a:spcBef>
+                <a:spcPct val="0"/>
+              </a:spcBef>
+              <a:spcAft>
+                <a:spcPct val="0"/>
+              </a:spcAft>
+              <a:buSzPts val="1150"/>
+              <a:buNone/>
+            </a:pPr>
+            <a:endParaRPr lang="en-US" sz="1500" dirty="0">
+              <a:solidFill>
+                <a:schemeClr val="tx1"/>
+              </a:solidFill>
+              <a:latin typeface="Calibri" panose="020F0502020204030204" pitchFamily="34" charset="0"/>
+              <a:ea typeface="Calibri" panose="020F0502020204030204" pitchFamily="34" charset="0"/>
+              <a:cs typeface="Calibri" panose="020F0502020204030204" pitchFamily="34" charset="0"/>
+            </a:endParaRPr>
+          </a:p>
+          <a:p>
+            <a:pPr marL="88900" marR="0" indent="0">
+              <a:spcBef>
+                <a:spcPct val="0"/>
+              </a:spcBef>
+              <a:spcAft>
+                <a:spcPct val="0"/>
+              </a:spcAft>
+              <a:buSzPts val="1150"/>
+              <a:buNone/>
+            </a:pPr>
+            <a:endParaRPr lang="en-US" sz="1500" dirty="0">
+              <a:solidFill>
+                <a:schemeClr val="tx1"/>
+              </a:solidFill>
+              <a:latin typeface="Calibri" panose="020F0502020204030204" pitchFamily="34" charset="0"/>
+              <a:ea typeface="Calibri" panose="020F0502020204030204" pitchFamily="34" charset="0"/>
+              <a:cs typeface="Calibri" panose="020F0502020204030204" pitchFamily="34" charset="0"/>
+            </a:endParaRPr>
+          </a:p>
+          <a:p>
+            <a:pPr marL="88900" marR="0" indent="0">
+              <a:spcBef>
+                <a:spcPct val="0"/>
+              </a:spcBef>
+              <a:spcAft>
+                <a:spcPct val="0"/>
+              </a:spcAft>
+              <a:buSzPts val="1150"/>
+              <a:buNone/>
+            </a:pPr>
+            <a:endParaRPr lang="en-US" sz="1500" dirty="0">
+              <a:solidFill>
+                <a:schemeClr val="tx1"/>
+              </a:solidFill>
+              <a:latin typeface="Calibri" panose="020F0502020204030204" pitchFamily="34" charset="0"/>
+              <a:ea typeface="Calibri" panose="020F0502020204030204" pitchFamily="34" charset="0"/>
+              <a:cs typeface="Calibri" panose="020F0502020204030204" pitchFamily="34" charset="0"/>
+            </a:endParaRPr>
+          </a:p>
+          <a:p>
+            <a:pPr marL="88900" marR="0" indent="0">
+              <a:spcBef>
+                <a:spcPct val="0"/>
+              </a:spcBef>
+              <a:spcAft>
+                <a:spcPct val="0"/>
+              </a:spcAft>
+              <a:buSzPts val="1150"/>
+              <a:buNone/>
+            </a:pPr>
+            <a:endParaRPr lang="en-US" sz="1500" dirty="0">
+              <a:solidFill>
+                <a:schemeClr val="tx1"/>
+              </a:solidFill>
+              <a:latin typeface="Calibri" panose="020F0502020204030204" pitchFamily="34" charset="0"/>
+              <a:ea typeface="Calibri" panose="020F0502020204030204" pitchFamily="34" charset="0"/>
+              <a:cs typeface="Calibri" panose="020F0502020204030204" pitchFamily="34" charset="0"/>
+            </a:endParaRPr>
           </a:p>
         </p:txBody>
       </p:sp>
@@ -4236,7 +4116,7 @@
         <p:spPr>
           <a:xfrm>
             <a:off x="7620000" y="2935271"/>
-            <a:ext cx="4288748" cy="244298"/>
+            <a:ext cx="4288748" cy="1613903"/>
           </a:xfrm>
           <a:prstGeom prst="rect">
             <a:avLst/>
@@ -4281,7 +4161,7 @@
               <a:buNone/>
             </a:pPr>
             <a:r>
-              <a:rPr lang="en-IN" sz="1400" dirty="0">
+              <a:rPr lang="en-US" sz="1400" dirty="0">
                 <a:solidFill>
                   <a:schemeClr val="tx1"/>
                 </a:solidFill>
@@ -4290,8 +4170,119 @@
                 <a:cs typeface="Calibri" panose="020F0502020204030204" pitchFamily="34" charset="0"/>
                 <a:sym typeface="Calibri"/>
               </a:rPr>
-              <a:t>B.E – SSN Engineering College (2019) </a:t>
-            </a:r>
+              <a:t>{EDUCATION_DETAILS}</a:t>
+            </a:r>
+            <a:endParaRPr lang="en-IN" sz="1400" dirty="0">
+              <a:solidFill>
+                <a:schemeClr val="tx1"/>
+              </a:solidFill>
+              <a:latin typeface="Calibri" panose="020F0502020204030204" pitchFamily="34" charset="0"/>
+              <a:ea typeface="Calibri" panose="020F0502020204030204" pitchFamily="34" charset="0"/>
+              <a:cs typeface="Calibri" panose="020F0502020204030204" pitchFamily="34" charset="0"/>
+              <a:sym typeface="Calibri"/>
+            </a:endParaRPr>
+          </a:p>
+          <a:p>
+            <a:pPr marL="72390" indent="0">
+              <a:spcBef>
+                <a:spcPts val="133"/>
+              </a:spcBef>
+              <a:buNone/>
+            </a:pPr>
+            <a:endParaRPr lang="en-IN" sz="1400" dirty="0">
+              <a:solidFill>
+                <a:schemeClr val="tx1"/>
+              </a:solidFill>
+              <a:latin typeface="Calibri" panose="020F0502020204030204" pitchFamily="34" charset="0"/>
+              <a:ea typeface="Calibri" panose="020F0502020204030204" pitchFamily="34" charset="0"/>
+              <a:cs typeface="Calibri" panose="020F0502020204030204" pitchFamily="34" charset="0"/>
+              <a:sym typeface="Calibri"/>
+            </a:endParaRPr>
+          </a:p>
+          <a:p>
+            <a:pPr marL="72390" indent="0">
+              <a:spcBef>
+                <a:spcPts val="133"/>
+              </a:spcBef>
+              <a:buNone/>
+            </a:pPr>
+            <a:endParaRPr lang="en-IN" sz="1400" dirty="0">
+              <a:solidFill>
+                <a:schemeClr val="tx1"/>
+              </a:solidFill>
+              <a:latin typeface="Calibri" panose="020F0502020204030204" pitchFamily="34" charset="0"/>
+              <a:ea typeface="Calibri" panose="020F0502020204030204" pitchFamily="34" charset="0"/>
+              <a:cs typeface="Calibri" panose="020F0502020204030204" pitchFamily="34" charset="0"/>
+              <a:sym typeface="Calibri"/>
+            </a:endParaRPr>
+          </a:p>
+          <a:p>
+            <a:pPr marL="72390" indent="0">
+              <a:spcBef>
+                <a:spcPts val="133"/>
+              </a:spcBef>
+              <a:buNone/>
+            </a:pPr>
+            <a:endParaRPr lang="en-IN" sz="1400" dirty="0">
+              <a:solidFill>
+                <a:schemeClr val="tx1"/>
+              </a:solidFill>
+              <a:latin typeface="Calibri" panose="020F0502020204030204" pitchFamily="34" charset="0"/>
+              <a:ea typeface="Calibri" panose="020F0502020204030204" pitchFamily="34" charset="0"/>
+              <a:cs typeface="Calibri" panose="020F0502020204030204" pitchFamily="34" charset="0"/>
+              <a:sym typeface="Calibri"/>
+            </a:endParaRPr>
+          </a:p>
+          <a:p>
+            <a:pPr marL="72390" indent="0">
+              <a:spcBef>
+                <a:spcPts val="133"/>
+              </a:spcBef>
+              <a:buNone/>
+            </a:pPr>
+            <a:endParaRPr lang="en-IN" sz="1400" dirty="0">
+              <a:solidFill>
+                <a:schemeClr val="tx1"/>
+              </a:solidFill>
+              <a:latin typeface="Calibri" panose="020F0502020204030204" pitchFamily="34" charset="0"/>
+              <a:ea typeface="Calibri" panose="020F0502020204030204" pitchFamily="34" charset="0"/>
+              <a:cs typeface="Calibri" panose="020F0502020204030204" pitchFamily="34" charset="0"/>
+              <a:sym typeface="Calibri"/>
+            </a:endParaRPr>
+          </a:p>
+          <a:p>
+            <a:pPr marL="72390" indent="0">
+              <a:spcBef>
+                <a:spcPts val="133"/>
+              </a:spcBef>
+              <a:buNone/>
+            </a:pPr>
+            <a:endParaRPr lang="en-IN" sz="1400" dirty="0">
+              <a:solidFill>
+                <a:schemeClr val="tx1"/>
+              </a:solidFill>
+              <a:latin typeface="Calibri" panose="020F0502020204030204" pitchFamily="34" charset="0"/>
+              <a:ea typeface="Calibri" panose="020F0502020204030204" pitchFamily="34" charset="0"/>
+              <a:cs typeface="Calibri" panose="020F0502020204030204" pitchFamily="34" charset="0"/>
+              <a:sym typeface="Calibri"/>
+            </a:endParaRPr>
+          </a:p>
+          <a:p>
+            <a:pPr marL="72390" indent="0">
+              <a:spcBef>
+                <a:spcPts val="133"/>
+              </a:spcBef>
+              <a:buNone/>
+            </a:pPr>
+            <a:endParaRPr lang="en-IN" sz="1400" dirty="0">
+              <a:solidFill>
+                <a:schemeClr val="tx1"/>
+              </a:solidFill>
+              <a:latin typeface="Calibri" panose="020F0502020204030204" pitchFamily="34" charset="0"/>
+              <a:ea typeface="Calibri" panose="020F0502020204030204" pitchFamily="34" charset="0"/>
+              <a:cs typeface="Calibri" panose="020F0502020204030204" pitchFamily="34" charset="0"/>
+              <a:sym typeface="Calibri"/>
+            </a:endParaRPr>
           </a:p>
         </p:txBody>
       </p:sp>
@@ -4381,7 +4372,7 @@
           <p:spPr>
             <a:xfrm>
               <a:off x="1044680" y="1990412"/>
-              <a:ext cx="1677725" cy="388068"/>
+              <a:ext cx="1677725" cy="388067"/>
             </a:xfrm>
             <a:prstGeom prst="rect">
               <a:avLst/>
@@ -4424,7 +4415,7 @@
         <p:spPr>
           <a:xfrm>
             <a:off x="250371" y="2943376"/>
-            <a:ext cx="7242137" cy="3835024"/>
+            <a:ext cx="7242137" cy="2655214"/>
           </a:xfrm>
           <a:prstGeom prst="rect">
             <a:avLst/>
@@ -4466,196 +4457,29 @@
               <a:buNone/>
             </a:pPr>
             <a:r>
-              <a:rPr lang="en-US" sz="1400" b="1" dirty="0">
-                <a:solidFill>
-                  <a:schemeClr val="tx1"/>
-                </a:solidFill>
-              </a:rPr>
-              <a:t>Testing Skills</a:t>
-            </a:r>
-            <a:endParaRPr lang="en-IN" sz="1400" b="1" dirty="0">
-              <a:solidFill>
-                <a:schemeClr val="tx1"/>
-              </a:solidFill>
-            </a:endParaRPr>
-          </a:p>
-          <a:p>
-            <a:pPr marL="374650" marR="83820" lvl="1" indent="-285750">
-              <a:spcBef>
-                <a:spcPts val="225"/>
-              </a:spcBef>
-              <a:buFont typeface="Arial" panose="020B0604020202020204" pitchFamily="34" charset="0"/>
-              <a:buChar char="•"/>
-            </a:pPr>
-            <a:r>
-              <a:rPr lang="en-US" sz="1400" spc="-5" dirty="0"/>
-              <a:t>Manual Testing: Functional, Regression, Smoke, Sanity, System, Integration, UAT</a:t>
-            </a:r>
-            <a:endParaRPr lang="en-IN" sz="1400" spc="-5" dirty="0"/>
-          </a:p>
-          <a:p>
-            <a:pPr marL="374650" marR="83820" lvl="1" indent="-285750">
-              <a:spcBef>
-                <a:spcPts val="225"/>
-              </a:spcBef>
-              <a:buFont typeface="Arial" panose="020B0604020202020204" pitchFamily="34" charset="0"/>
-              <a:buChar char="•"/>
-            </a:pPr>
-            <a:r>
-              <a:rPr lang="en-US" sz="1400" spc="-5" dirty="0"/>
-              <a:t>Automation Testing: Selenium WebDriver with Python Test Case Design using BVA &amp; Equivalence Partitioning</a:t>
-            </a:r>
-            <a:endParaRPr lang="en-IN" sz="1400" spc="-5" dirty="0"/>
-          </a:p>
-          <a:p>
-            <a:pPr marL="374650" marR="83820" lvl="1" indent="-285750">
-              <a:spcBef>
-                <a:spcPts val="225"/>
-              </a:spcBef>
-              <a:buFont typeface="Arial" panose="020B0604020202020204" pitchFamily="34" charset="0"/>
-              <a:buChar char="•"/>
-            </a:pPr>
-            <a:r>
-              <a:rPr lang="en-US" sz="1400" spc="-5" dirty="0"/>
-              <a:t>Defect Tracking &amp; Management (Defect Life Cycle)</a:t>
-            </a:r>
-            <a:endParaRPr lang="en-IN" sz="1400" spc="-5" dirty="0"/>
-          </a:p>
-          <a:p>
-            <a:pPr marL="88900" indent="0">
-              <a:buNone/>
-            </a:pPr>
-            <a:r>
-              <a:rPr lang="en-US" sz="1400" b="1" dirty="0">
-                <a:solidFill>
-                  <a:schemeClr val="tx1"/>
-                </a:solidFill>
-              </a:rPr>
-              <a:t>Automation Frameworks &amp; Tools</a:t>
-            </a:r>
-          </a:p>
-          <a:p>
-            <a:r>
-              <a:rPr lang="en-US" sz="1400" dirty="0">
-                <a:solidFill>
-                  <a:schemeClr val="tx1"/>
-                </a:solidFill>
-                <a:latin typeface="+mn-lt"/>
-                <a:cs typeface="+mn-cs"/>
-              </a:rPr>
-              <a:t>Selenium WebDriver, </a:t>
-            </a:r>
-            <a:r>
-              <a:rPr lang="en-US" sz="1400" dirty="0" err="1">
-                <a:solidFill>
-                  <a:schemeClr val="tx1"/>
-                </a:solidFill>
-                <a:latin typeface="+mn-lt"/>
-                <a:cs typeface="+mn-cs"/>
-              </a:rPr>
-              <a:t>PyTest</a:t>
-            </a:r>
-            <a:r>
-              <a:rPr lang="en-US" sz="1400" dirty="0">
-                <a:solidFill>
-                  <a:schemeClr val="tx1"/>
-                </a:solidFill>
-                <a:latin typeface="+mn-lt"/>
-                <a:cs typeface="+mn-cs"/>
-              </a:rPr>
-              <a:t>, Page Object Model (POM)</a:t>
-            </a:r>
-            <a:endParaRPr lang="en-IN" sz="1400" dirty="0">
-              <a:solidFill>
-                <a:schemeClr val="tx1"/>
-              </a:solidFill>
-              <a:latin typeface="+mn-lt"/>
-              <a:cs typeface="+mn-cs"/>
-            </a:endParaRPr>
-          </a:p>
-          <a:p>
-            <a:r>
-              <a:rPr lang="en-US" sz="1400" dirty="0">
-                <a:solidFill>
-                  <a:schemeClr val="tx1"/>
-                </a:solidFill>
-                <a:latin typeface="+mn-lt"/>
-                <a:cs typeface="+mn-cs"/>
-              </a:rPr>
-              <a:t>Data-driven &amp; Keyword-driven testing (basic)</a:t>
-            </a:r>
-            <a:endParaRPr lang="en-IN" sz="1400" dirty="0">
-              <a:solidFill>
-                <a:schemeClr val="tx1"/>
-              </a:solidFill>
-              <a:latin typeface="+mn-lt"/>
-              <a:cs typeface="+mn-cs"/>
-            </a:endParaRPr>
-          </a:p>
-          <a:p>
-            <a:r>
-              <a:rPr lang="en-US" sz="1400" dirty="0">
-                <a:solidFill>
-                  <a:schemeClr val="tx1"/>
-                </a:solidFill>
-                <a:latin typeface="+mn-lt"/>
-                <a:cs typeface="+mn-cs"/>
-              </a:rPr>
-              <a:t>Git (Version Control) &amp; Jenkins (CI/CD pipeline integration for automation test execution)</a:t>
-            </a:r>
-            <a:endParaRPr lang="en-IN" sz="1400" dirty="0">
-              <a:solidFill>
-                <a:schemeClr val="tx1"/>
-              </a:solidFill>
-              <a:latin typeface="+mn-lt"/>
-              <a:cs typeface="+mn-cs"/>
-            </a:endParaRPr>
-          </a:p>
-          <a:p>
-            <a:pPr marL="88900" indent="0">
-              <a:buNone/>
-            </a:pPr>
-            <a:r>
-              <a:rPr lang="en-US" sz="1400" b="1" dirty="0">
-                <a:solidFill>
-                  <a:schemeClr val="tx1"/>
-                </a:solidFill>
-              </a:rPr>
-              <a:t>Programming &amp; Scripting</a:t>
-            </a:r>
-            <a:endParaRPr lang="en-IN" sz="1400" b="1" dirty="0">
-              <a:solidFill>
-                <a:schemeClr val="tx1"/>
-              </a:solidFill>
-            </a:endParaRPr>
-          </a:p>
-          <a:p>
-            <a:pPr lvl="0"/>
-            <a:r>
               <a:rPr lang="en-US" sz="1400" dirty="0">
                 <a:solidFill>
                   <a:schemeClr val="tx1"/>
                 </a:solidFill>
               </a:rPr>
-              <a:t>Core Python (OOPs, Functions, Exception Handling), Python requests library for API testing</a:t>
-            </a:r>
-            <a:endParaRPr lang="en-IN" sz="1400" dirty="0">
+              <a:t>{TECHNICAL_SKILLS}</a:t>
+            </a:r>
+          </a:p>
+          <a:p>
+            <a:pPr marL="88900" indent="0">
+              <a:buNone/>
+            </a:pPr>
+            <a:endParaRPr lang="en-US" sz="1400" dirty="0">
               <a:solidFill>
                 <a:schemeClr val="tx1"/>
               </a:solidFill>
             </a:endParaRPr>
           </a:p>
           <a:p>
-            <a:pPr lvl="0"/>
-            <a:r>
-              <a:rPr lang="en-US" sz="1400" dirty="0">
-                <a:solidFill>
-                  <a:schemeClr val="tx1"/>
-                </a:solidFill>
-              </a:rPr>
-              <a:t>SQL &amp; Snowflake SQL</a:t>
-            </a:r>
-            <a:endParaRPr lang="en-IN" sz="1400" dirty="0">
+            <a:pPr marL="88900" indent="0">
+              <a:buNone/>
+            </a:pPr>
+            <a:endParaRPr lang="en-US" sz="1400" dirty="0">
               <a:solidFill>
                 <a:schemeClr val="tx1"/>
               </a:solidFill>
@@ -4665,31 +4489,17 @@
             <a:pPr marL="88900" indent="0">
               <a:buNone/>
             </a:pPr>
-            <a:r>
-              <a:rPr lang="en-US" sz="1400" b="1" dirty="0">
-                <a:solidFill>
-                  <a:schemeClr val="tx1"/>
-                </a:solidFill>
-              </a:rPr>
-              <a:t>Web Technologies</a:t>
-            </a:r>
-            <a:endParaRPr lang="en-IN" sz="1400" b="1" dirty="0">
+            <a:endParaRPr lang="en-US" sz="1400" dirty="0">
               <a:solidFill>
                 <a:schemeClr val="tx1"/>
               </a:solidFill>
             </a:endParaRPr>
           </a:p>
           <a:p>
-            <a:pPr lvl="0"/>
-            <a:r>
-              <a:rPr lang="en-US" sz="1400" dirty="0">
-                <a:solidFill>
-                  <a:schemeClr val="tx1"/>
-                </a:solidFill>
-              </a:rPr>
-              <a:t>HTML, CSS, DOM,  XPath (Absolute, Relative, Dynamic XPath)</a:t>
-            </a:r>
-            <a:endParaRPr lang="en-IN" sz="1400" dirty="0">
+            <a:pPr marL="88900" indent="0">
+              <a:buNone/>
+            </a:pPr>
+            <a:endParaRPr lang="en-US" sz="1400" dirty="0">
               <a:solidFill>
                 <a:schemeClr val="tx1"/>
               </a:solidFill>
@@ -4699,30 +4509,56 @@
             <a:pPr marL="88900" indent="0">
               <a:buNone/>
             </a:pPr>
-            <a:r>
-              <a:rPr lang="en-US" sz="1400" b="1" dirty="0">
-                <a:solidFill>
-                  <a:schemeClr val="tx1"/>
-                </a:solidFill>
-              </a:rPr>
-              <a:t>Test &amp; Project Management Tools</a:t>
-            </a:r>
-            <a:endParaRPr lang="en-IN" sz="1400" b="1" dirty="0">
+            <a:endParaRPr lang="en-US" sz="1400" dirty="0">
               <a:solidFill>
                 <a:schemeClr val="tx1"/>
               </a:solidFill>
             </a:endParaRPr>
           </a:p>
           <a:p>
-            <a:pPr lvl="0"/>
-            <a:r>
-              <a:rPr lang="en-US" sz="1400" dirty="0">
-                <a:solidFill>
-                  <a:schemeClr val="tx1"/>
-                </a:solidFill>
-              </a:rPr>
-              <a:t>JIRA (Defect &amp; Story Tracking),  Postman (API Testing)</a:t>
-            </a:r>
+            <a:pPr marL="88900" indent="0">
+              <a:buNone/>
+            </a:pPr>
+            <a:endParaRPr lang="en-US" sz="1400" dirty="0">
+              <a:solidFill>
+                <a:schemeClr val="tx1"/>
+              </a:solidFill>
+            </a:endParaRPr>
+          </a:p>
+          <a:p>
+            <a:pPr marL="88900" indent="0">
+              <a:buNone/>
+            </a:pPr>
+            <a:endParaRPr lang="en-US" sz="1400" dirty="0">
+              <a:solidFill>
+                <a:schemeClr val="tx1"/>
+              </a:solidFill>
+            </a:endParaRPr>
+          </a:p>
+          <a:p>
+            <a:pPr marL="88900" indent="0">
+              <a:buNone/>
+            </a:pPr>
+            <a:endParaRPr lang="en-US" sz="1400" dirty="0">
+              <a:solidFill>
+                <a:schemeClr val="tx1"/>
+              </a:solidFill>
+            </a:endParaRPr>
+          </a:p>
+          <a:p>
+            <a:pPr marL="88900" indent="0">
+              <a:buNone/>
+            </a:pPr>
+            <a:endParaRPr lang="en-US" sz="1400" dirty="0">
+              <a:solidFill>
+                <a:schemeClr val="tx1"/>
+              </a:solidFill>
+            </a:endParaRPr>
+          </a:p>
+          <a:p>
+            <a:pPr marL="88900" indent="0">
+              <a:buNone/>
+            </a:pPr>
             <a:endParaRPr lang="en-IN" sz="1400" dirty="0">
               <a:solidFill>
                 <a:schemeClr val="tx1"/>
@@ -4850,23 +4686,7 @@
                 <a:ea typeface="Calibri" panose="020F0502020204030204" pitchFamily="34" charset="0"/>
                 <a:cs typeface="Calibri" panose="020F0502020204030204" pitchFamily="34" charset="0"/>
               </a:rPr>
-              <a:t>Prasad </a:t>
-            </a:r>
-            <a:r>
-              <a:rPr lang="en-US" sz="2400" b="1" dirty="0" err="1">
-                <a:latin typeface="Calibri" panose="020F0502020204030204" pitchFamily="34" charset="0"/>
-                <a:ea typeface="Calibri" panose="020F0502020204030204" pitchFamily="34" charset="0"/>
-                <a:cs typeface="Calibri" panose="020F0502020204030204" pitchFamily="34" charset="0"/>
-              </a:rPr>
-              <a:t>Chittiboina</a:t>
-            </a:r>
-            <a:r>
-              <a:rPr lang="en-US" sz="2400" b="1" dirty="0">
-                <a:latin typeface="Calibri" panose="020F0502020204030204" pitchFamily="34" charset="0"/>
-                <a:ea typeface="Calibri" panose="020F0502020204030204" pitchFamily="34" charset="0"/>
-                <a:cs typeface="Calibri" panose="020F0502020204030204" pitchFamily="34" charset="0"/>
-              </a:rPr>
-              <a:t>– Senior Automation Test Engineer </a:t>
+              <a:t>{FULL_NAME}– {CURRENT_ROLE} </a:t>
             </a:r>
           </a:p>
         </p:txBody>
@@ -5089,7 +4909,7 @@
                 <a:ea typeface="Calibri"/>
                 <a:cs typeface="Calibri"/>
               </a:rPr>
-              <a:t>Project:</a:t>
+              <a:t>Project: {PROJECT1_NAME}</a:t>
             </a:r>
             <a:r>
               <a:rPr lang="en-US" b="1" dirty="0">
@@ -5100,7 +4920,7 @@
                 <a:ea typeface="Calibri"/>
                 <a:cs typeface="Calibri"/>
               </a:rPr>
-              <a:t>PWC (Price Waterhouse Coopers).</a:t>
+              <a:t>.</a:t>
             </a:r>
             <a:endParaRPr lang="en-US" b="1" i="0" u="none" strike="noStrike" kern="1200" cap="none" spc="0" normalizeH="0" baseline="0" noProof="0" dirty="0">
               <a:ln>
@@ -5136,19 +4956,16 @@
                 <a:ea typeface="Calibri"/>
                 <a:cs typeface="Calibri"/>
               </a:rPr>
-              <a:t>Duration : </a:t>
-            </a:r>
-            <a:r>
-              <a:rPr lang="en-US" b="1" dirty="0">
-                <a:solidFill>
-                  <a:prstClr val="black"/>
-                </a:solidFill>
-                <a:latin typeface="Calibri"/>
-                <a:ea typeface="Calibri"/>
-                <a:cs typeface="Calibri"/>
-              </a:rPr>
-              <a:t>Nov’2024 – Present</a:t>
-            </a:r>
+              <a:t>Duration : {DURATION_PROJECT1}</a:t>
+            </a:r>
+            <a:endParaRPr lang="en-US" b="1" dirty="0">
+              <a:solidFill>
+                <a:prstClr val="black"/>
+              </a:solidFill>
+              <a:latin typeface="Calibri"/>
+              <a:ea typeface="Calibri"/>
+              <a:cs typeface="Calibri"/>
+            </a:endParaRPr>
           </a:p>
           <a:p>
             <a:pPr>
@@ -5160,7 +4977,7 @@
             </a:r>
             <a:r>
               <a:rPr lang="en-US" dirty="0"/>
-              <a:t>: Sr Automation Tester</a:t>
+              <a:t>: {ROLE_PROJECT1}</a:t>
             </a:r>
             <a:endParaRPr lang="en-US" b="1" i="0" u="none" strike="noStrike" kern="1200" cap="none" spc="0" normalizeH="0" baseline="0" noProof="0" dirty="0">
               <a:ln>
@@ -5194,7 +5011,7 @@
         <p:spPr>
           <a:xfrm>
             <a:off x="304800" y="2132178"/>
-            <a:ext cx="11691257" cy="2800767"/>
+            <a:ext cx="11691257" cy="4524315"/>
           </a:xfrm>
           <a:prstGeom prst="rect">
             <a:avLst/>
@@ -5211,7 +5028,7 @@
               <a:defRPr/>
             </a:pPr>
             <a:r>
-              <a:rPr kumimoji="0" lang="en-US" sz="1600" i="0" u="none" strike="noStrike" kern="1200" cap="none" spc="0" normalizeH="0" baseline="0" noProof="0" dirty="0">
+              <a:rPr lang="en-US" sz="1600" i="0" u="none" strike="noStrike" kern="1200" cap="none" spc="0" normalizeH="0" baseline="0" noProof="0" dirty="0">
                 <a:ln>
                   <a:noFill/>
                 </a:ln>
@@ -5225,8 +5042,117 @@
                 <a:ea typeface="Calibri"/>
                 <a:cs typeface="Calibri"/>
               </a:rPr>
-              <a:t>PWC (price water house cooper’s) an international firm of accountants and management consultants that provides services to businesses, it is the second largest professional services firm in the world supports trade feeds from various upstream systems into Summit. My process: Incident management is all about incidents or interruption which are made as tickets. These tickets come with priority as critical or normal. SLA is the time fixed for the incident either to resolve or respond. In order to prevent tickets from breaching we had a team for ticket monitoring We monitor both US and UK territory tickets and resolution of tickets was also included in the tickets.</a:t>
-            </a:r>
+              <a:t>{Project1_Description}:</a:t>
+            </a:r>
+          </a:p>
+          <a:p>
+            <a:pPr algn="just" fontAlgn="base" hangingPunct="0">
+              <a:defRPr/>
+            </a:pPr>
+            <a:endParaRPr lang="en-US" sz="1600" dirty="0">
+              <a:solidFill>
+                <a:prstClr val="black"/>
+              </a:solidFill>
+              <a:latin typeface="Calibri"/>
+              <a:ea typeface="Calibri"/>
+              <a:cs typeface="Calibri"/>
+            </a:endParaRPr>
+          </a:p>
+          <a:p>
+            <a:pPr algn="just" fontAlgn="base" hangingPunct="0">
+              <a:defRPr/>
+            </a:pPr>
+            <a:endParaRPr lang="en-US" sz="1600" i="0" u="none" strike="noStrike" kern="1200" cap="none" spc="0" normalizeH="0" baseline="0" noProof="0" dirty="0">
+              <a:ln>
+                <a:noFill/>
+              </a:ln>
+              <a:solidFill>
+                <a:prstClr val="black"/>
+              </a:solidFill>
+              <a:effectLst/>
+              <a:uLnTx/>
+              <a:uFillTx/>
+              <a:latin typeface="Calibri"/>
+              <a:ea typeface="Calibri"/>
+              <a:cs typeface="Calibri"/>
+            </a:endParaRPr>
+          </a:p>
+          <a:p>
+            <a:pPr algn="just" fontAlgn="base" hangingPunct="0">
+              <a:defRPr/>
+            </a:pPr>
+            <a:endParaRPr lang="en-US" sz="1600" dirty="0">
+              <a:solidFill>
+                <a:prstClr val="black"/>
+              </a:solidFill>
+              <a:latin typeface="Calibri"/>
+              <a:ea typeface="Calibri"/>
+              <a:cs typeface="Calibri"/>
+            </a:endParaRPr>
+          </a:p>
+          <a:p>
+            <a:pPr algn="just" fontAlgn="base" hangingPunct="0">
+              <a:defRPr/>
+            </a:pPr>
+            <a:endParaRPr lang="en-US" sz="1600" i="0" u="none" strike="noStrike" kern="1200" cap="none" spc="0" normalizeH="0" baseline="0" noProof="0" dirty="0">
+              <a:ln>
+                <a:noFill/>
+              </a:ln>
+              <a:solidFill>
+                <a:prstClr val="black"/>
+              </a:solidFill>
+              <a:effectLst/>
+              <a:uLnTx/>
+              <a:uFillTx/>
+              <a:latin typeface="Calibri"/>
+              <a:ea typeface="Calibri"/>
+              <a:cs typeface="Calibri"/>
+            </a:endParaRPr>
+          </a:p>
+          <a:p>
+            <a:pPr algn="just" fontAlgn="base" hangingPunct="0">
+              <a:defRPr/>
+            </a:pPr>
+            <a:endParaRPr lang="en-US" sz="1600" dirty="0">
+              <a:solidFill>
+                <a:prstClr val="black"/>
+              </a:solidFill>
+              <a:latin typeface="Calibri"/>
+              <a:ea typeface="Calibri"/>
+              <a:cs typeface="Calibri"/>
+            </a:endParaRPr>
+          </a:p>
+          <a:p>
+            <a:pPr algn="just" fontAlgn="base" hangingPunct="0">
+              <a:defRPr/>
+            </a:pPr>
+            <a:endParaRPr lang="en-US" sz="1600" i="0" u="none" strike="noStrike" kern="1200" cap="none" spc="0" normalizeH="0" baseline="0" noProof="0" dirty="0">
+              <a:ln>
+                <a:noFill/>
+              </a:ln>
+              <a:solidFill>
+                <a:prstClr val="black"/>
+              </a:solidFill>
+              <a:effectLst/>
+              <a:uLnTx/>
+              <a:uFillTx/>
+              <a:latin typeface="Calibri"/>
+              <a:ea typeface="Calibri"/>
+              <a:cs typeface="Calibri"/>
+            </a:endParaRPr>
+          </a:p>
+          <a:p>
+            <a:pPr algn="just" fontAlgn="base" hangingPunct="0">
+              <a:defRPr/>
+            </a:pPr>
+            <a:endParaRPr lang="en-US" sz="1600" dirty="0">
+              <a:solidFill>
+                <a:prstClr val="black"/>
+              </a:solidFill>
+              <a:latin typeface="Calibri"/>
+              <a:ea typeface="Calibri"/>
+              <a:cs typeface="Calibri"/>
+            </a:endParaRPr>
           </a:p>
           <a:p>
             <a:pPr algn="just" fontAlgn="base" hangingPunct="0">
@@ -5278,88 +5204,223 @@
             </a:r>
           </a:p>
           <a:p>
-            <a:pPr marL="285750" indent="-285750" algn="just" fontAlgn="base" hangingPunct="0">
-              <a:buFont typeface="Arial" panose="020B0604020202020204" pitchFamily="34" charset="0"/>
-              <a:buChar char="•"/>
+            <a:pPr marL="0" marR="0" lvl="0" indent="0" algn="just" defTabSz="914400" rtl="0" eaLnBrk="1" fontAlgn="base" latinLnBrk="0" hangingPunct="0">
+              <a:lnSpc>
+                <a:spcPct val="100000"/>
+              </a:lnSpc>
+              <a:spcBef>
+                <a:spcPts val="0"/>
+              </a:spcBef>
+              <a:spcAft>
+                <a:spcPts val="0"/>
+              </a:spcAft>
+              <a:buClrTx/>
+              <a:buSzTx/>
+              <a:buFontTx/>
+              <a:buNone/>
+              <a:tabLst/>
               <a:defRPr/>
             </a:pPr>
             <a:r>
               <a:rPr lang="en-US" sz="1600" dirty="0">
                 <a:solidFill>
-                  <a:srgbClr val="0D0D0D"/>
+                  <a:prstClr val="black"/>
                 </a:solidFill>
-                <a:highlight>
-                  <a:srgbClr val="FFFFFF"/>
-                </a:highlight>
-                <a:latin typeface="Calibri"/>
-                <a:ea typeface="Calibri"/>
-                <a:cs typeface="Segoe UI"/>
+                <a:latin typeface="Calibri" panose="020F0502020204030204" pitchFamily="34" charset="0"/>
+                <a:ea typeface="Calibri" panose="020F0502020204030204" pitchFamily="34" charset="0"/>
+                <a:cs typeface="Calibri" panose="020F0502020204030204" pitchFamily="34" charset="0"/>
               </a:rPr>
-              <a:t>Worked in IT help desk for Price Waterhouse Cooper (PWC) client by providing best and valued IT service to customer.</a:t>
-            </a:r>
-          </a:p>
-          <a:p>
-            <a:pPr marL="285750" indent="-285750" algn="just" fontAlgn="base" hangingPunct="0">
-              <a:buFont typeface="Arial" panose="020B0604020202020204" pitchFamily="34" charset="0"/>
-              <a:buChar char="•"/>
-              <a:defRPr/>
-            </a:pPr>
-            <a:r>
-              <a:rPr lang="en-US" sz="1600" dirty="0">
-                <a:solidFill>
-                  <a:srgbClr val="0D0D0D"/>
-                </a:solidFill>
-                <a:highlight>
-                  <a:srgbClr val="FFFFFF"/>
-                </a:highlight>
-                <a:latin typeface="Calibri"/>
-                <a:ea typeface="Calibri"/>
-                <a:cs typeface="Segoe UI"/>
-              </a:rPr>
-              <a:t>Involved in providing IT solutions for infrastructure, internal Applications and Global finances services by resolving tickets.</a:t>
-            </a:r>
-          </a:p>
-          <a:p>
-            <a:pPr marL="285750" indent="-285750" algn="just" fontAlgn="base" hangingPunct="0">
-              <a:buFont typeface="Arial" panose="020B0604020202020204" pitchFamily="34" charset="0"/>
-              <a:buChar char="•"/>
-              <a:defRPr/>
-            </a:pPr>
-            <a:r>
-              <a:rPr lang="en-US" sz="1600" dirty="0">
-                <a:solidFill>
-                  <a:srgbClr val="0D0D0D"/>
-                </a:solidFill>
-                <a:highlight>
-                  <a:srgbClr val="FFFFFF"/>
-                </a:highlight>
-                <a:latin typeface="Calibri"/>
-                <a:ea typeface="Calibri"/>
-                <a:cs typeface="Segoe UI"/>
-              </a:rPr>
-              <a:t>Involved in creating Knowledge base (KB) article for providing IT solutions in a particular ORDER.</a:t>
-            </a:r>
-          </a:p>
-          <a:p>
-            <a:pPr marL="285750" indent="-285750" algn="just" fontAlgn="base" hangingPunct="0">
-              <a:buFont typeface="Arial" panose="020B0604020202020204" pitchFamily="34" charset="0"/>
-              <a:buChar char="•"/>
-              <a:defRPr/>
-            </a:pPr>
-            <a:r>
-              <a:rPr lang="en-US" sz="1600" dirty="0">
-                <a:solidFill>
-                  <a:srgbClr val="0D0D0D"/>
-                </a:solidFill>
-                <a:highlight>
-                  <a:srgbClr val="FFFFFF"/>
-                </a:highlight>
-                <a:latin typeface="Calibri"/>
-                <a:ea typeface="Calibri"/>
-                <a:cs typeface="Segoe UI"/>
-              </a:rPr>
-              <a:t>Took leadership and acted as a subject Matter Expert (SME) by leading a team.</a:t>
-            </a:r>
+              <a:t>{Responsibilities_Project1}</a:t>
+            </a:r>
+          </a:p>
+          <a:p>
+            <a:pPr marL="0" marR="0" lvl="0" indent="0" algn="just" defTabSz="914400" rtl="0" eaLnBrk="1" fontAlgn="base" latinLnBrk="0" hangingPunct="0">
+              <a:lnSpc>
+                <a:spcPct val="100000"/>
+              </a:lnSpc>
+              <a:spcBef>
+                <a:spcPts val="0"/>
+              </a:spcBef>
+              <a:spcAft>
+                <a:spcPts val="0"/>
+              </a:spcAft>
+              <a:buClrTx/>
+              <a:buSzTx/>
+              <a:buFontTx/>
+              <a:buNone/>
+              <a:tabLst/>
+              <a:defRPr/>
+            </a:pPr>
+            <a:endParaRPr lang="en-US" sz="1600" dirty="0">
+              <a:solidFill>
+                <a:prstClr val="black"/>
+              </a:solidFill>
+              <a:latin typeface="Calibri" panose="020F0502020204030204" pitchFamily="34" charset="0"/>
+              <a:ea typeface="Calibri" panose="020F0502020204030204" pitchFamily="34" charset="0"/>
+              <a:cs typeface="Calibri" panose="020F0502020204030204" pitchFamily="34" charset="0"/>
+            </a:endParaRPr>
+          </a:p>
+          <a:p>
+            <a:pPr marL="0" marR="0" lvl="0" indent="0" algn="just" defTabSz="914400" rtl="0" eaLnBrk="1" fontAlgn="base" latinLnBrk="0" hangingPunct="0">
+              <a:lnSpc>
+                <a:spcPct val="100000"/>
+              </a:lnSpc>
+              <a:spcBef>
+                <a:spcPts val="0"/>
+              </a:spcBef>
+              <a:spcAft>
+                <a:spcPts val="0"/>
+              </a:spcAft>
+              <a:buClrTx/>
+              <a:buSzTx/>
+              <a:buFontTx/>
+              <a:buNone/>
+              <a:tabLst/>
+              <a:defRPr/>
+            </a:pPr>
+            <a:endParaRPr lang="en-US" sz="1600" dirty="0">
+              <a:solidFill>
+                <a:prstClr val="black"/>
+              </a:solidFill>
+              <a:latin typeface="Calibri" panose="020F0502020204030204" pitchFamily="34" charset="0"/>
+              <a:ea typeface="Calibri" panose="020F0502020204030204" pitchFamily="34" charset="0"/>
+              <a:cs typeface="Calibri" panose="020F0502020204030204" pitchFamily="34" charset="0"/>
+            </a:endParaRPr>
+          </a:p>
+          <a:p>
+            <a:pPr marL="0" marR="0" lvl="0" indent="0" algn="just" defTabSz="914400" rtl="0" eaLnBrk="1" fontAlgn="base" latinLnBrk="0" hangingPunct="0">
+              <a:lnSpc>
+                <a:spcPct val="100000"/>
+              </a:lnSpc>
+              <a:spcBef>
+                <a:spcPts val="0"/>
+              </a:spcBef>
+              <a:spcAft>
+                <a:spcPts val="0"/>
+              </a:spcAft>
+              <a:buClrTx/>
+              <a:buSzTx/>
+              <a:buFontTx/>
+              <a:buNone/>
+              <a:tabLst/>
+              <a:defRPr/>
+            </a:pPr>
+            <a:endParaRPr lang="en-US" sz="1600" dirty="0">
+              <a:solidFill>
+                <a:prstClr val="black"/>
+              </a:solidFill>
+              <a:latin typeface="Calibri" panose="020F0502020204030204" pitchFamily="34" charset="0"/>
+              <a:ea typeface="Calibri" panose="020F0502020204030204" pitchFamily="34" charset="0"/>
+              <a:cs typeface="Calibri" panose="020F0502020204030204" pitchFamily="34" charset="0"/>
+            </a:endParaRPr>
+          </a:p>
+          <a:p>
+            <a:pPr marL="0" marR="0" lvl="0" indent="0" algn="just" defTabSz="914400" rtl="0" eaLnBrk="1" fontAlgn="base" latinLnBrk="0" hangingPunct="0">
+              <a:lnSpc>
+                <a:spcPct val="100000"/>
+              </a:lnSpc>
+              <a:spcBef>
+                <a:spcPts val="0"/>
+              </a:spcBef>
+              <a:spcAft>
+                <a:spcPts val="0"/>
+              </a:spcAft>
+              <a:buClrTx/>
+              <a:buSzTx/>
+              <a:buFontTx/>
+              <a:buNone/>
+              <a:tabLst/>
+              <a:defRPr/>
+            </a:pPr>
+            <a:endParaRPr lang="en-US" sz="1600" dirty="0">
+              <a:solidFill>
+                <a:prstClr val="black"/>
+              </a:solidFill>
+              <a:latin typeface="Calibri" panose="020F0502020204030204" pitchFamily="34" charset="0"/>
+              <a:ea typeface="Calibri" panose="020F0502020204030204" pitchFamily="34" charset="0"/>
+              <a:cs typeface="Calibri" panose="020F0502020204030204" pitchFamily="34" charset="0"/>
+            </a:endParaRPr>
+          </a:p>
+          <a:p>
+            <a:pPr marL="0" marR="0" lvl="0" indent="0" algn="just" defTabSz="914400" rtl="0" eaLnBrk="1" fontAlgn="base" latinLnBrk="0" hangingPunct="0">
+              <a:lnSpc>
+                <a:spcPct val="100000"/>
+              </a:lnSpc>
+              <a:spcBef>
+                <a:spcPts val="0"/>
+              </a:spcBef>
+              <a:spcAft>
+                <a:spcPts val="0"/>
+              </a:spcAft>
+              <a:buClrTx/>
+              <a:buSzTx/>
+              <a:buFontTx/>
+              <a:buNone/>
+              <a:tabLst/>
+              <a:defRPr/>
+            </a:pPr>
+            <a:endParaRPr lang="en-US" sz="1600" dirty="0">
+              <a:solidFill>
+                <a:prstClr val="black"/>
+              </a:solidFill>
+              <a:latin typeface="Calibri" panose="020F0502020204030204" pitchFamily="34" charset="0"/>
+              <a:ea typeface="Calibri" panose="020F0502020204030204" pitchFamily="34" charset="0"/>
+              <a:cs typeface="Calibri" panose="020F0502020204030204" pitchFamily="34" charset="0"/>
+            </a:endParaRPr>
+          </a:p>
+          <a:p>
+            <a:pPr marL="0" marR="0" lvl="0" indent="0" algn="just" defTabSz="914400" rtl="0" eaLnBrk="1" fontAlgn="base" latinLnBrk="0" hangingPunct="0">
+              <a:lnSpc>
+                <a:spcPct val="100000"/>
+              </a:lnSpc>
+              <a:spcBef>
+                <a:spcPts val="0"/>
+              </a:spcBef>
+              <a:spcAft>
+                <a:spcPts val="0"/>
+              </a:spcAft>
+              <a:buClrTx/>
+              <a:buSzTx/>
+              <a:buFontTx/>
+              <a:buNone/>
+              <a:tabLst/>
+              <a:defRPr/>
+            </a:pPr>
+            <a:endParaRPr lang="en-US" sz="1600" dirty="0">
+              <a:solidFill>
+                <a:prstClr val="black"/>
+              </a:solidFill>
+              <a:latin typeface="Calibri" panose="020F0502020204030204" pitchFamily="34" charset="0"/>
+              <a:ea typeface="Calibri" panose="020F0502020204030204" pitchFamily="34" charset="0"/>
+              <a:cs typeface="Calibri" panose="020F0502020204030204" pitchFamily="34" charset="0"/>
+            </a:endParaRPr>
+          </a:p>
+          <a:p>
+            <a:pPr marL="0" marR="0" lvl="0" indent="0" algn="just" defTabSz="914400" rtl="0" eaLnBrk="1" fontAlgn="base" latinLnBrk="0" hangingPunct="0">
+              <a:lnSpc>
+                <a:spcPct val="100000"/>
+              </a:lnSpc>
+              <a:spcBef>
+                <a:spcPts val="0"/>
+              </a:spcBef>
+              <a:spcAft>
+                <a:spcPts val="0"/>
+              </a:spcAft>
+              <a:buClrTx/>
+              <a:buSzTx/>
+              <a:buFontTx/>
+              <a:buNone/>
+              <a:tabLst/>
+              <a:defRPr/>
+            </a:pPr>
+            <a:endParaRPr lang="en-US" sz="1600" dirty="0">
+              <a:solidFill>
+                <a:prstClr val="black"/>
+              </a:solidFill>
+              <a:latin typeface="Calibri" panose="020F0502020204030204" pitchFamily="34" charset="0"/>
+              <a:ea typeface="Calibri" panose="020F0502020204030204" pitchFamily="34" charset="0"/>
+              <a:cs typeface="Calibri" panose="020F0502020204030204" pitchFamily="34" charset="0"/>
+            </a:endParaRPr>
           </a:p>
         </p:txBody>
       </p:sp>
@@ -5579,7 +5640,7 @@
         <p:cNvPr id="1" name="">
           <a:extLst>
             <a:ext uri="{FF2B5EF4-FFF2-40B4-BE49-F238E27FC236}">
-              <a16:creationId xmlns:a16="http://schemas.microsoft.com/office/drawing/2014/main" id="{DA9D82DC-B40F-499F-B2F1-D546FF566C02}"/>
+              <a16:creationId xmlns:a16="http://schemas.microsoft.com/office/drawing/2014/main" id="{14D6FA36-51EF-5596-4E03-98DBABC7CE7F}"/>
             </a:ext>
           </a:extLst>
         </p:cNvPr>
@@ -5599,7 +5660,7 @@
           <p:cNvPr id="5" name="Slide Number Placeholder 4">
             <a:extLst>
               <a:ext uri="{FF2B5EF4-FFF2-40B4-BE49-F238E27FC236}">
-                <a16:creationId xmlns:a16="http://schemas.microsoft.com/office/drawing/2014/main" id="{67290704-6EEE-D0AC-8291-BA48864B1AE5}"/>
+                <a16:creationId xmlns:a16="http://schemas.microsoft.com/office/drawing/2014/main" id="{C747274B-7E9D-C6F2-7E92-24BD1BA47B39}"/>
               </a:ext>
             </a:extLst>
           </p:cNvPr>
@@ -5692,7 +5753,7 @@
           <p:cNvPr id="7" name="TextBox 6">
             <a:extLst>
               <a:ext uri="{FF2B5EF4-FFF2-40B4-BE49-F238E27FC236}">
-                <a16:creationId xmlns:a16="http://schemas.microsoft.com/office/drawing/2014/main" id="{6BAA8868-FDEB-212D-0E84-B1B339220F85}"/>
+                <a16:creationId xmlns:a16="http://schemas.microsoft.com/office/drawing/2014/main" id="{281E5FE1-4888-CBDF-0DD5-A41BA5FEEA8D}"/>
               </a:ext>
             </a:extLst>
           </p:cNvPr>
@@ -5701,8 +5762,8 @@
         </p:nvSpPr>
         <p:spPr>
           <a:xfrm>
-            <a:off x="304798" y="403733"/>
-            <a:ext cx="10278256" cy="1754326"/>
+            <a:off x="304800" y="634824"/>
+            <a:ext cx="9954892" cy="923330"/>
           </a:xfrm>
           <a:prstGeom prst="rect">
             <a:avLst/>
@@ -5733,7 +5794,7 @@
                 <a:ea typeface="Calibri"/>
                 <a:cs typeface="Calibri"/>
               </a:rPr>
-              <a:t>Project:</a:t>
+              <a:t>Project: {PROJECT2_NAME}</a:t>
             </a:r>
             <a:r>
               <a:rPr lang="en-US" b="1" dirty="0">
@@ -5744,18 +5805,7 @@
                 <a:ea typeface="Calibri"/>
                 <a:cs typeface="Calibri"/>
               </a:rPr>
-              <a:t> </a:t>
-            </a:r>
-            <a:r>
-              <a:rPr lang="en-US" b="1" dirty="0">
-                <a:solidFill>
-                  <a:prstClr val="black"/>
-                </a:solidFill>
-                <a:latin typeface="Calibri"/>
-                <a:ea typeface="Calibri"/>
-                <a:cs typeface="Segoe UI"/>
-              </a:rPr>
-              <a:t>Information System</a:t>
+              <a:t>.</a:t>
             </a:r>
             <a:endParaRPr lang="en-US" b="1" i="0" u="none" strike="noStrike" kern="1200" cap="none" spc="0" normalizeH="0" baseline="0" noProof="0" dirty="0">
               <a:ln>
@@ -5791,19 +5841,16 @@
                 <a:ea typeface="Calibri"/>
                 <a:cs typeface="Calibri"/>
               </a:rPr>
-              <a:t>Duration : </a:t>
-            </a:r>
-            <a:r>
-              <a:rPr lang="en-US" b="1" dirty="0">
-                <a:solidFill>
-                  <a:prstClr val="black"/>
-                </a:solidFill>
-                <a:latin typeface="Calibri"/>
-                <a:ea typeface="Calibri"/>
-                <a:cs typeface="Segoe UI"/>
-              </a:rPr>
-              <a:t>May’2022 – Oct’2024</a:t>
-            </a:r>
+              <a:t>Duration : {DURATION_PROJECT2}</a:t>
+            </a:r>
+            <a:endParaRPr lang="en-US" b="1" dirty="0">
+              <a:solidFill>
+                <a:prstClr val="black"/>
+              </a:solidFill>
+              <a:latin typeface="Calibri"/>
+              <a:ea typeface="Calibri"/>
+              <a:cs typeface="Calibri"/>
+            </a:endParaRPr>
           </a:p>
           <a:p>
             <a:pPr>
@@ -5815,50 +5862,7 @@
             </a:r>
             <a:r>
               <a:rPr lang="en-US" dirty="0"/>
-              <a:t>: Automation Tester</a:t>
-            </a:r>
-            <a:endParaRPr lang="en-IN" dirty="0"/>
-          </a:p>
-          <a:p>
-            <a:pPr>
-              <a:defRPr/>
-            </a:pPr>
-            <a:endParaRPr lang="en-US" b="1" dirty="0">
-              <a:solidFill>
-                <a:prstClr val="black"/>
-              </a:solidFill>
-              <a:latin typeface="Calibri"/>
-              <a:ea typeface="Calibri"/>
-              <a:cs typeface="Segoe UI"/>
-            </a:endParaRPr>
-          </a:p>
-          <a:p>
-            <a:pPr>
-              <a:defRPr/>
-            </a:pPr>
-            <a:endParaRPr lang="en-US" b="1" dirty="0">
-              <a:solidFill>
-                <a:prstClr val="black"/>
-              </a:solidFill>
-              <a:latin typeface="Calibri"/>
-              <a:ea typeface="Calibri"/>
-              <a:cs typeface="Segoe UI"/>
-            </a:endParaRPr>
-          </a:p>
-          <a:p>
-            <a:pPr>
-              <a:defRPr/>
-            </a:pPr>
-            <a:r>
-              <a:rPr lang="en-US" b="1" dirty="0">
-                <a:solidFill>
-                  <a:prstClr val="black"/>
-                </a:solidFill>
-                <a:latin typeface="Calibri"/>
-                <a:ea typeface="Calibri"/>
-                <a:cs typeface="Segoe UI"/>
-              </a:rPr>
-              <a:t> </a:t>
+              <a:t>: {ROLE_PROJECT2}</a:t>
             </a:r>
             <a:endParaRPr lang="en-US" b="1" i="0" u="none" strike="noStrike" kern="1200" cap="none" spc="0" normalizeH="0" baseline="0" noProof="0" dirty="0">
               <a:ln>
@@ -5872,7 +5876,7 @@
               <a:uFillTx/>
               <a:latin typeface="Calibri"/>
               <a:ea typeface="Calibri"/>
-              <a:cs typeface="Segoe UI"/>
+              <a:cs typeface="Calibri"/>
             </a:endParaRPr>
           </a:p>
         </p:txBody>
@@ -5882,7 +5886,7 @@
           <p:cNvPr id="11" name="TextBox 10">
             <a:extLst>
               <a:ext uri="{FF2B5EF4-FFF2-40B4-BE49-F238E27FC236}">
-                <a16:creationId xmlns:a16="http://schemas.microsoft.com/office/drawing/2014/main" id="{3F56B683-987F-2AB2-3C43-65E5943B627C}"/>
+                <a16:creationId xmlns:a16="http://schemas.microsoft.com/office/drawing/2014/main" id="{901A2AF5-92CA-8F25-88FA-D406713C067E}"/>
               </a:ext>
             </a:extLst>
           </p:cNvPr>
@@ -5891,8 +5895,8 @@
         </p:nvSpPr>
         <p:spPr>
           <a:xfrm>
-            <a:off x="304798" y="1489273"/>
-            <a:ext cx="11582400" cy="5232202"/>
+            <a:off x="304800" y="2132178"/>
+            <a:ext cx="11691257" cy="4524315"/>
           </a:xfrm>
           <a:prstGeom prst="rect">
             <a:avLst/>
@@ -5905,92 +5909,11 @@
           </a:bodyPr>
           <a:lstStyle/>
           <a:p>
-            <a:pPr algn="just">
-              <a:defRPr/>
-            </a:pPr>
-            <a:r>
-              <a:rPr lang="en-US" sz="1600" b="1" dirty="0">
-                <a:solidFill>
-                  <a:prstClr val="black"/>
-                </a:solidFill>
-                <a:latin typeface="Calibri" panose="020F0502020204030204" pitchFamily="34" charset="0"/>
-                <a:ea typeface="Calibri" panose="020F0502020204030204" pitchFamily="34" charset="0"/>
-                <a:cs typeface="Calibri" panose="020F0502020204030204" pitchFamily="34" charset="0"/>
-              </a:rPr>
-              <a:t>Project Overview</a:t>
-            </a:r>
-            <a:r>
-              <a:rPr lang="en-US" sz="1600" dirty="0">
-                <a:solidFill>
-                  <a:prstClr val="black"/>
-                </a:solidFill>
-                <a:latin typeface="Calibri" panose="020F0502020204030204" pitchFamily="34" charset="0"/>
-                <a:ea typeface="Calibri" panose="020F0502020204030204" pitchFamily="34" charset="0"/>
-                <a:cs typeface="Calibri" panose="020F0502020204030204" pitchFamily="34" charset="0"/>
-              </a:rPr>
-              <a:t>:</a:t>
-            </a:r>
-            <a:endParaRPr lang="en-US" sz="1600" dirty="0">
-              <a:latin typeface="Calibri" panose="020F0502020204030204" pitchFamily="34" charset="0"/>
-              <a:ea typeface="Calibri" panose="020F0502020204030204" pitchFamily="34" charset="0"/>
-              <a:cs typeface="Calibri" panose="020F0502020204030204" pitchFamily="34" charset="0"/>
-            </a:endParaRPr>
-          </a:p>
-          <a:p>
-            <a:pPr algn="just">
-              <a:defRPr/>
-            </a:pPr>
-            <a:r>
-              <a:rPr lang="en-US" sz="1600" dirty="0">
-                <a:solidFill>
-                  <a:prstClr val="black"/>
-                </a:solidFill>
-                <a:latin typeface="Calibri" panose="020F0502020204030204" pitchFamily="34" charset="0"/>
-                <a:ea typeface="Calibri" panose="020F0502020204030204" pitchFamily="34" charset="0"/>
-                <a:cs typeface="Calibri" panose="020F0502020204030204" pitchFamily="34" charset="0"/>
-              </a:rPr>
-              <a:t>This is an internal project at Infosys focused on developing and maintaining web and mobile applications used by the company's employees. These applications support various business processes, such as Attendance, Health Insurance, and employee communication, aiming to improve efficiency and user experience. The project ensures that these tools are secure, user-friendly, and aligned with the company's internal policies and objectives.</a:t>
-            </a:r>
-          </a:p>
-          <a:p>
-            <a:pPr algn="just">
-              <a:defRPr/>
-            </a:pPr>
-            <a:endParaRPr lang="en-US" sz="1500" b="0" i="0" u="none" strike="noStrike" kern="1200" cap="none" spc="0" normalizeH="0" baseline="0" noProof="0" dirty="0">
-              <a:ln>
-                <a:noFill/>
-              </a:ln>
-              <a:solidFill>
-                <a:prstClr val="black"/>
-              </a:solidFill>
-              <a:effectLst/>
-              <a:uLnTx/>
-              <a:uFillTx/>
-              <a:latin typeface="Calibri" panose="020F0502020204030204" pitchFamily="34" charset="0"/>
-              <a:ea typeface="Calibri" panose="020F0502020204030204" pitchFamily="34" charset="0"/>
-              <a:cs typeface="Calibri" panose="020F0502020204030204" pitchFamily="34" charset="0"/>
-            </a:endParaRPr>
-          </a:p>
-          <a:p>
-            <a:pPr marL="0" marR="0" lvl="0" indent="0" algn="just" defTabSz="914400" rtl="0" eaLnBrk="1" fontAlgn="base" latinLnBrk="0" hangingPunct="0">
-              <a:lnSpc>
-                <a:spcPct val="100000"/>
-              </a:lnSpc>
-              <a:spcBef>
-                <a:spcPts val="0"/>
-              </a:spcBef>
-              <a:spcAft>
-                <a:spcPts val="0"/>
-              </a:spcAft>
-              <a:buClrTx/>
-              <a:buSzTx/>
-              <a:buFontTx/>
-              <a:buNone/>
-              <a:tabLst/>
-              <a:defRPr/>
-            </a:pPr>
-            <a:r>
-              <a:rPr kumimoji="0" lang="en-US" sz="1600" b="1" i="0" u="none" strike="noStrike" kern="1200" cap="none" spc="0" normalizeH="0" baseline="0" noProof="0" dirty="0">
+            <a:pPr algn="just" fontAlgn="base" hangingPunct="0">
+              <a:defRPr/>
+            </a:pPr>
+            <a:r>
+              <a:rPr lang="en-US" sz="1600" i="0" u="none" strike="noStrike" kern="1200" cap="none" spc="0" normalizeH="0" baseline="0" noProof="0" dirty="0">
                 <a:ln>
                   <a:noFill/>
                 </a:ln>
@@ -6000,64 +5923,188 @@
                 <a:effectLst/>
                 <a:uLnTx/>
                 <a:uFillTx/>
+                <a:latin typeface="Calibri"/>
+                <a:ea typeface="Calibri"/>
+                <a:cs typeface="Calibri"/>
+              </a:rPr>
+              <a:t>{Project2_Description}:</a:t>
+            </a:r>
+          </a:p>
+          <a:p>
+            <a:pPr algn="just" fontAlgn="base" hangingPunct="0">
+              <a:defRPr/>
+            </a:pPr>
+            <a:endParaRPr lang="en-US" sz="1600" dirty="0">
+              <a:solidFill>
+                <a:prstClr val="black"/>
+              </a:solidFill>
+              <a:latin typeface="Calibri"/>
+              <a:ea typeface="Calibri"/>
+              <a:cs typeface="Calibri"/>
+            </a:endParaRPr>
+          </a:p>
+          <a:p>
+            <a:pPr algn="just" fontAlgn="base" hangingPunct="0">
+              <a:defRPr/>
+            </a:pPr>
+            <a:endParaRPr lang="en-US" sz="1600" i="0" u="none" strike="noStrike" kern="1200" cap="none" spc="0" normalizeH="0" baseline="0" noProof="0" dirty="0">
+              <a:ln>
+                <a:noFill/>
+              </a:ln>
+              <a:solidFill>
+                <a:prstClr val="black"/>
+              </a:solidFill>
+              <a:effectLst/>
+              <a:uLnTx/>
+              <a:uFillTx/>
+              <a:latin typeface="Calibri"/>
+              <a:ea typeface="Calibri"/>
+              <a:cs typeface="Calibri"/>
+            </a:endParaRPr>
+          </a:p>
+          <a:p>
+            <a:pPr algn="just" fontAlgn="base" hangingPunct="0">
+              <a:defRPr/>
+            </a:pPr>
+            <a:endParaRPr lang="en-US" sz="1600" dirty="0">
+              <a:solidFill>
+                <a:prstClr val="black"/>
+              </a:solidFill>
+              <a:latin typeface="Calibri"/>
+              <a:ea typeface="Calibri"/>
+              <a:cs typeface="Calibri"/>
+            </a:endParaRPr>
+          </a:p>
+          <a:p>
+            <a:pPr algn="just" fontAlgn="base" hangingPunct="0">
+              <a:defRPr/>
+            </a:pPr>
+            <a:endParaRPr lang="en-US" sz="1600" i="0" u="none" strike="noStrike" kern="1200" cap="none" spc="0" normalizeH="0" baseline="0" noProof="0" dirty="0">
+              <a:ln>
+                <a:noFill/>
+              </a:ln>
+              <a:solidFill>
+                <a:prstClr val="black"/>
+              </a:solidFill>
+              <a:effectLst/>
+              <a:uLnTx/>
+              <a:uFillTx/>
+              <a:latin typeface="Calibri"/>
+              <a:ea typeface="Calibri"/>
+              <a:cs typeface="Calibri"/>
+            </a:endParaRPr>
+          </a:p>
+          <a:p>
+            <a:pPr algn="just" fontAlgn="base" hangingPunct="0">
+              <a:defRPr/>
+            </a:pPr>
+            <a:endParaRPr lang="en-US" sz="1600" dirty="0">
+              <a:solidFill>
+                <a:prstClr val="black"/>
+              </a:solidFill>
+              <a:latin typeface="Calibri"/>
+              <a:ea typeface="Calibri"/>
+              <a:cs typeface="Calibri"/>
+            </a:endParaRPr>
+          </a:p>
+          <a:p>
+            <a:pPr algn="just" fontAlgn="base" hangingPunct="0">
+              <a:defRPr/>
+            </a:pPr>
+            <a:endParaRPr lang="en-US" sz="1600" i="0" u="none" strike="noStrike" kern="1200" cap="none" spc="0" normalizeH="0" baseline="0" noProof="0" dirty="0">
+              <a:ln>
+                <a:noFill/>
+              </a:ln>
+              <a:solidFill>
+                <a:prstClr val="black"/>
+              </a:solidFill>
+              <a:effectLst/>
+              <a:uLnTx/>
+              <a:uFillTx/>
+              <a:latin typeface="Calibri"/>
+              <a:ea typeface="Calibri"/>
+              <a:cs typeface="Calibri"/>
+            </a:endParaRPr>
+          </a:p>
+          <a:p>
+            <a:pPr algn="just" fontAlgn="base" hangingPunct="0">
+              <a:defRPr/>
+            </a:pPr>
+            <a:endParaRPr lang="en-US" sz="1600" dirty="0">
+              <a:solidFill>
+                <a:prstClr val="black"/>
+              </a:solidFill>
+              <a:latin typeface="Calibri"/>
+              <a:ea typeface="Calibri"/>
+              <a:cs typeface="Calibri"/>
+            </a:endParaRPr>
+          </a:p>
+          <a:p>
+            <a:pPr algn="just" fontAlgn="base" hangingPunct="0">
+              <a:defRPr/>
+            </a:pPr>
+            <a:endParaRPr lang="en-US" sz="1600" i="0" u="none" strike="noStrike" kern="1200" cap="none" spc="0" normalizeH="0" baseline="0" noProof="0" dirty="0">
+              <a:ln>
+                <a:noFill/>
+              </a:ln>
+              <a:solidFill>
+                <a:prstClr val="black"/>
+              </a:solidFill>
+              <a:effectLst/>
+              <a:uLnTx/>
+              <a:uFillTx/>
+              <a:latin typeface="Calibri"/>
+              <a:ea typeface="Calibri"/>
+              <a:cs typeface="Calibri"/>
+            </a:endParaRPr>
+          </a:p>
+          <a:p>
+            <a:pPr marL="0" marR="0" lvl="0" indent="0" algn="just" defTabSz="914400" rtl="0" eaLnBrk="1" fontAlgn="base" latinLnBrk="0" hangingPunct="0">
+              <a:lnSpc>
+                <a:spcPct val="100000"/>
+              </a:lnSpc>
+              <a:spcBef>
+                <a:spcPts val="0"/>
+              </a:spcBef>
+              <a:spcAft>
+                <a:spcPts val="0"/>
+              </a:spcAft>
+              <a:buClrTx/>
+              <a:buSzTx/>
+              <a:buFontTx/>
+              <a:buNone/>
+              <a:tabLst/>
+              <a:defRPr/>
+            </a:pPr>
+            <a:r>
+              <a:rPr lang="en-US" sz="1600" b="1" dirty="0">
+                <a:solidFill>
+                  <a:prstClr val="black"/>
+                </a:solidFill>
                 <a:latin typeface="Calibri" panose="020F0502020204030204" pitchFamily="34" charset="0"/>
                 <a:ea typeface="Calibri" panose="020F0502020204030204" pitchFamily="34" charset="0"/>
                 <a:cs typeface="Calibri" panose="020F0502020204030204" pitchFamily="34" charset="0"/>
               </a:rPr>
-              <a:t>Responsibilities</a:t>
-            </a:r>
-            <a:r>
-              <a:rPr kumimoji="0" lang="en-US" sz="1600" b="0" i="0" u="none" strike="noStrike" kern="1200" cap="none" spc="0" normalizeH="0" baseline="0" noProof="0" dirty="0">
-                <a:ln>
-                  <a:noFill/>
-                </a:ln>
-                <a:solidFill>
-                  <a:prstClr val="black"/>
-                </a:solidFill>
-                <a:effectLst/>
-                <a:uLnTx/>
-                <a:uFillTx/>
-                <a:latin typeface="Calibri" panose="020F0502020204030204" pitchFamily="34" charset="0"/>
-                <a:ea typeface="Calibri" panose="020F0502020204030204" pitchFamily="34" charset="0"/>
-                <a:cs typeface="Calibri" panose="020F0502020204030204" pitchFamily="34" charset="0"/>
-              </a:rPr>
-              <a:t>: </a:t>
-            </a:r>
-            <a:endParaRPr lang="en-US" sz="1600" b="0" i="0" u="none" strike="noStrike" kern="1200" cap="none" spc="0" normalizeH="0" baseline="0" noProof="0" dirty="0">
-              <a:ln>
-                <a:noFill/>
-              </a:ln>
-              <a:solidFill>
-                <a:prstClr val="black"/>
-              </a:solidFill>
-              <a:effectLst/>
-              <a:uLnTx/>
-              <a:uFillTx/>
-              <a:latin typeface="Calibri" panose="020F0502020204030204" pitchFamily="34" charset="0"/>
-              <a:ea typeface="Calibri" panose="020F0502020204030204" pitchFamily="34" charset="0"/>
-              <a:cs typeface="Calibri" panose="020F0502020204030204" pitchFamily="34" charset="0"/>
-            </a:endParaRPr>
-          </a:p>
-          <a:p>
-            <a:pPr algn="just">
-              <a:defRPr/>
-            </a:pPr>
-            <a:endParaRPr lang="en-US" sz="1500" dirty="0">
-              <a:solidFill>
-                <a:srgbClr val="000000"/>
-              </a:solidFill>
-              <a:highlight>
-                <a:srgbClr val="FFFFFF"/>
-              </a:highlight>
-              <a:latin typeface="Calibri" panose="020F0502020204030204" pitchFamily="34" charset="0"/>
-              <a:ea typeface="Calibri" panose="020F0502020204030204" pitchFamily="34" charset="0"/>
-              <a:cs typeface="Calibri" panose="020F0502020204030204" pitchFamily="34" charset="0"/>
-            </a:endParaRPr>
-          </a:p>
-          <a:p>
-            <a:pPr marL="285750" lvl="0" indent="-285750">
-              <a:buFont typeface="Arial" panose="020B0604020202020204" pitchFamily="34" charset="0"/>
-              <a:buChar char="•"/>
+              <a:t>Responsibilities: </a:t>
+            </a:r>
+          </a:p>
+          <a:p>
+            <a:pPr marL="0" marR="0" lvl="0" indent="0" algn="just" defTabSz="914400" rtl="0" eaLnBrk="1" fontAlgn="base" latinLnBrk="0" hangingPunct="0">
+              <a:lnSpc>
+                <a:spcPct val="100000"/>
+              </a:lnSpc>
+              <a:spcBef>
+                <a:spcPts val="0"/>
+              </a:spcBef>
+              <a:spcAft>
+                <a:spcPts val="0"/>
+              </a:spcAft>
+              <a:buClrTx/>
+              <a:buSzTx/>
+              <a:buFontTx/>
+              <a:buNone/>
+              <a:tabLst/>
+              <a:defRPr/>
             </a:pPr>
             <a:r>
               <a:rPr lang="en-US" sz="1600" dirty="0">
@@ -6068,9 +6115,28 @@
                 <a:ea typeface="Calibri" panose="020F0502020204030204" pitchFamily="34" charset="0"/>
                 <a:cs typeface="Calibri" panose="020F0502020204030204" pitchFamily="34" charset="0"/>
               </a:rPr>
-              <a:t>Well experienced in Software Testing (Manual and Automation) for Web, Mobile, and REST APIs.</a:t>
-            </a:r>
-            <a:endParaRPr lang="en-IN" sz="1600" dirty="0">
+              <a:t>{Responsibilities_project2}</a:t>
+            </a:r>
+          </a:p>
+          <a:p>
+            <a:pPr marL="0" marR="0" lvl="0" indent="0" algn="just" defTabSz="914400" rtl="0" eaLnBrk="1" fontAlgn="base" latinLnBrk="0" hangingPunct="0">
+              <a:lnSpc>
+                <a:spcPct val="100000"/>
+              </a:lnSpc>
+              <a:spcBef>
+                <a:spcPts val="0"/>
+              </a:spcBef>
+              <a:spcAft>
+                <a:spcPts val="0"/>
+              </a:spcAft>
+              <a:buClrTx/>
+              <a:buSzTx/>
+              <a:buFontTx/>
+              <a:buNone/>
+              <a:tabLst/>
+              <a:defRPr/>
+            </a:pPr>
+            <a:endParaRPr lang="en-US" sz="1600" dirty="0">
               <a:solidFill>
                 <a:prstClr val="black"/>
               </a:solidFill>
@@ -6080,22 +6146,24 @@
             </a:endParaRPr>
           </a:p>
           <a:p>
-            <a:pPr marL="285750" lvl="0" indent="-285750">
-              <a:buFont typeface="Arial" panose="020B0604020202020204" pitchFamily="34" charset="0"/>
-              <a:buChar char="•"/>
-            </a:pPr>
-            <a:r>
-              <a:rPr lang="en-US" sz="1600" dirty="0">
-                <a:solidFill>
-                  <a:prstClr val="black"/>
-                </a:solidFill>
-                <a:latin typeface="Calibri" panose="020F0502020204030204" pitchFamily="34" charset="0"/>
-                <a:ea typeface="Calibri" panose="020F0502020204030204" pitchFamily="34" charset="0"/>
-                <a:cs typeface="Calibri" panose="020F0502020204030204" pitchFamily="34" charset="0"/>
-              </a:rPr>
-              <a:t>Proficient in SDLC, STLC with expertise in Test Plan, Test Case, and Test Execution.</a:t>
-            </a:r>
-            <a:endParaRPr lang="en-IN" sz="1600" dirty="0">
+            <a:pPr marL="0" marR="0" lvl="0" indent="0" algn="just" defTabSz="914400" rtl="0" eaLnBrk="1" fontAlgn="base" latinLnBrk="0" hangingPunct="0">
+              <a:lnSpc>
+                <a:spcPct val="100000"/>
+              </a:lnSpc>
+              <a:spcBef>
+                <a:spcPts val="0"/>
+              </a:spcBef>
+              <a:spcAft>
+                <a:spcPts val="0"/>
+              </a:spcAft>
+              <a:buClrTx/>
+              <a:buSzTx/>
+              <a:buFontTx/>
+              <a:buNone/>
+              <a:tabLst/>
+              <a:defRPr/>
+            </a:pPr>
+            <a:endParaRPr lang="en-US" sz="1600" dirty="0">
               <a:solidFill>
                 <a:prstClr val="black"/>
               </a:solidFill>
@@ -6105,22 +6173,24 @@
             </a:endParaRPr>
           </a:p>
           <a:p>
-            <a:pPr marL="285750" lvl="0" indent="-285750">
-              <a:buFont typeface="Arial" panose="020B0604020202020204" pitchFamily="34" charset="0"/>
-              <a:buChar char="•"/>
-            </a:pPr>
-            <a:r>
-              <a:rPr lang="en-US" sz="1600" dirty="0">
-                <a:solidFill>
-                  <a:prstClr val="black"/>
-                </a:solidFill>
-                <a:latin typeface="Calibri" panose="020F0502020204030204" pitchFamily="34" charset="0"/>
-                <a:ea typeface="Calibri" panose="020F0502020204030204" pitchFamily="34" charset="0"/>
-                <a:cs typeface="Calibri" panose="020F0502020204030204" pitchFamily="34" charset="0"/>
-              </a:rPr>
-              <a:t>Proficient knowledge of Defect Life Cycle and logging the defects along with defect tracking and report generation.</a:t>
-            </a:r>
-            <a:endParaRPr lang="en-IN" sz="1600" dirty="0">
+            <a:pPr marL="0" marR="0" lvl="0" indent="0" algn="just" defTabSz="914400" rtl="0" eaLnBrk="1" fontAlgn="base" latinLnBrk="0" hangingPunct="0">
+              <a:lnSpc>
+                <a:spcPct val="100000"/>
+              </a:lnSpc>
+              <a:spcBef>
+                <a:spcPts val="0"/>
+              </a:spcBef>
+              <a:spcAft>
+                <a:spcPts val="0"/>
+              </a:spcAft>
+              <a:buClrTx/>
+              <a:buSzTx/>
+              <a:buFontTx/>
+              <a:buNone/>
+              <a:tabLst/>
+              <a:defRPr/>
+            </a:pPr>
+            <a:endParaRPr lang="en-US" sz="1600" dirty="0">
               <a:solidFill>
                 <a:prstClr val="black"/>
               </a:solidFill>
@@ -6130,22 +6200,24 @@
             </a:endParaRPr>
           </a:p>
           <a:p>
-            <a:pPr marL="285750" lvl="0" indent="-285750">
-              <a:buFont typeface="Arial" panose="020B0604020202020204" pitchFamily="34" charset="0"/>
-              <a:buChar char="•"/>
-            </a:pPr>
-            <a:r>
-              <a:rPr lang="en-US" sz="1600" dirty="0">
-                <a:solidFill>
-                  <a:prstClr val="black"/>
-                </a:solidFill>
-                <a:latin typeface="Calibri" panose="020F0502020204030204" pitchFamily="34" charset="0"/>
-                <a:ea typeface="Calibri" panose="020F0502020204030204" pitchFamily="34" charset="0"/>
-                <a:cs typeface="Calibri" panose="020F0502020204030204" pitchFamily="34" charset="0"/>
-              </a:rPr>
-              <a:t>Skilled in Functional Testing (System, Regression, Integration &amp; Compatibility) and API Testing using Postman.</a:t>
-            </a:r>
-            <a:endParaRPr lang="en-IN" sz="1600" dirty="0">
+            <a:pPr marL="0" marR="0" lvl="0" indent="0" algn="just" defTabSz="914400" rtl="0" eaLnBrk="1" fontAlgn="base" latinLnBrk="0" hangingPunct="0">
+              <a:lnSpc>
+                <a:spcPct val="100000"/>
+              </a:lnSpc>
+              <a:spcBef>
+                <a:spcPts val="0"/>
+              </a:spcBef>
+              <a:spcAft>
+                <a:spcPts val="0"/>
+              </a:spcAft>
+              <a:buClrTx/>
+              <a:buSzTx/>
+              <a:buFontTx/>
+              <a:buNone/>
+              <a:tabLst/>
+              <a:defRPr/>
+            </a:pPr>
+            <a:endParaRPr lang="en-US" sz="1600" dirty="0">
               <a:solidFill>
                 <a:prstClr val="black"/>
               </a:solidFill>
@@ -6155,22 +6227,24 @@
             </a:endParaRPr>
           </a:p>
           <a:p>
-            <a:pPr marL="285750" lvl="0" indent="-285750">
-              <a:buFont typeface="Arial" panose="020B0604020202020204" pitchFamily="34" charset="0"/>
-              <a:buChar char="•"/>
-            </a:pPr>
-            <a:r>
-              <a:rPr lang="en-US" sz="1600" dirty="0">
-                <a:solidFill>
-                  <a:prstClr val="black"/>
-                </a:solidFill>
-                <a:latin typeface="Calibri" panose="020F0502020204030204" pitchFamily="34" charset="0"/>
-                <a:ea typeface="Calibri" panose="020F0502020204030204" pitchFamily="34" charset="0"/>
-                <a:cs typeface="Calibri" panose="020F0502020204030204" pitchFamily="34" charset="0"/>
-              </a:rPr>
-              <a:t>Extensive experience in Automation Testing with Selenium WebDriver using, and TestNG.</a:t>
-            </a:r>
-            <a:endParaRPr lang="en-IN" sz="1600" dirty="0">
+            <a:pPr marL="0" marR="0" lvl="0" indent="0" algn="just" defTabSz="914400" rtl="0" eaLnBrk="1" fontAlgn="base" latinLnBrk="0" hangingPunct="0">
+              <a:lnSpc>
+                <a:spcPct val="100000"/>
+              </a:lnSpc>
+              <a:spcBef>
+                <a:spcPts val="0"/>
+              </a:spcBef>
+              <a:spcAft>
+                <a:spcPts val="0"/>
+              </a:spcAft>
+              <a:buClrTx/>
+              <a:buSzTx/>
+              <a:buFontTx/>
+              <a:buNone/>
+              <a:tabLst/>
+              <a:defRPr/>
+            </a:pPr>
+            <a:endParaRPr lang="en-US" sz="1600" dirty="0">
               <a:solidFill>
                 <a:prstClr val="black"/>
               </a:solidFill>
@@ -6180,22 +6254,24 @@
             </a:endParaRPr>
           </a:p>
           <a:p>
-            <a:pPr marL="285750" lvl="0" indent="-285750">
-              <a:buFont typeface="Arial" panose="020B0604020202020204" pitchFamily="34" charset="0"/>
-              <a:buChar char="•"/>
-            </a:pPr>
-            <a:r>
-              <a:rPr lang="en-US" sz="1600" dirty="0">
-                <a:solidFill>
-                  <a:prstClr val="black"/>
-                </a:solidFill>
-                <a:latin typeface="Calibri" panose="020F0502020204030204" pitchFamily="34" charset="0"/>
-                <a:ea typeface="Calibri" panose="020F0502020204030204" pitchFamily="34" charset="0"/>
-                <a:cs typeface="Calibri" panose="020F0502020204030204" pitchFamily="34" charset="0"/>
-              </a:rPr>
-              <a:t>Hands-on experience in backend testing using SQL.</a:t>
-            </a:r>
-            <a:endParaRPr lang="en-IN" sz="1600" dirty="0">
+            <a:pPr marL="0" marR="0" lvl="0" indent="0" algn="just" defTabSz="914400" rtl="0" eaLnBrk="1" fontAlgn="base" latinLnBrk="0" hangingPunct="0">
+              <a:lnSpc>
+                <a:spcPct val="100000"/>
+              </a:lnSpc>
+              <a:spcBef>
+                <a:spcPts val="0"/>
+              </a:spcBef>
+              <a:spcAft>
+                <a:spcPts val="0"/>
+              </a:spcAft>
+              <a:buClrTx/>
+              <a:buSzTx/>
+              <a:buFontTx/>
+              <a:buNone/>
+              <a:tabLst/>
+              <a:defRPr/>
+            </a:pPr>
+            <a:endParaRPr lang="en-US" sz="1600" dirty="0">
               <a:solidFill>
                 <a:prstClr val="black"/>
               </a:solidFill>
@@ -6205,22 +6281,24 @@
             </a:endParaRPr>
           </a:p>
           <a:p>
-            <a:pPr marL="285750" lvl="0" indent="-285750">
-              <a:buFont typeface="Arial" panose="020B0604020202020204" pitchFamily="34" charset="0"/>
-              <a:buChar char="•"/>
-            </a:pPr>
-            <a:r>
-              <a:rPr lang="en-US" sz="1600" dirty="0">
-                <a:solidFill>
-                  <a:prstClr val="black"/>
-                </a:solidFill>
-                <a:latin typeface="Calibri" panose="020F0502020204030204" pitchFamily="34" charset="0"/>
-                <a:ea typeface="Calibri" panose="020F0502020204030204" pitchFamily="34" charset="0"/>
-                <a:cs typeface="Calibri" panose="020F0502020204030204" pitchFamily="34" charset="0"/>
-              </a:rPr>
-              <a:t>Knowledge of CI/CD pipelines, including configuring REST APIs for integration.</a:t>
-            </a:r>
-            <a:endParaRPr lang="en-IN" sz="1600" dirty="0">
+            <a:pPr marL="0" marR="0" lvl="0" indent="0" algn="just" defTabSz="914400" rtl="0" eaLnBrk="1" fontAlgn="base" latinLnBrk="0" hangingPunct="0">
+              <a:lnSpc>
+                <a:spcPct val="100000"/>
+              </a:lnSpc>
+              <a:spcBef>
+                <a:spcPts val="0"/>
+              </a:spcBef>
+              <a:spcAft>
+                <a:spcPts val="0"/>
+              </a:spcAft>
+              <a:buClrTx/>
+              <a:buSzTx/>
+              <a:buFontTx/>
+              <a:buNone/>
+              <a:tabLst/>
+              <a:defRPr/>
+            </a:pPr>
+            <a:endParaRPr lang="en-US" sz="1600" dirty="0">
               <a:solidFill>
                 <a:prstClr val="black"/>
               </a:solidFill>
@@ -6229,178 +6307,6 @@
               <a:cs typeface="Calibri" panose="020F0502020204030204" pitchFamily="34" charset="0"/>
             </a:endParaRPr>
           </a:p>
-          <a:p>
-            <a:pPr marL="285750" lvl="0" indent="-285750">
-              <a:buFont typeface="Arial" panose="020B0604020202020204" pitchFamily="34" charset="0"/>
-              <a:buChar char="•"/>
-            </a:pPr>
-            <a:r>
-              <a:rPr lang="en-US" sz="1600" dirty="0">
-                <a:solidFill>
-                  <a:prstClr val="black"/>
-                </a:solidFill>
-                <a:latin typeface="Calibri" panose="020F0502020204030204" pitchFamily="34" charset="0"/>
-                <a:ea typeface="Calibri" panose="020F0502020204030204" pitchFamily="34" charset="0"/>
-                <a:cs typeface="Calibri" panose="020F0502020204030204" pitchFamily="34" charset="0"/>
-              </a:rPr>
-              <a:t>Strong communicator, problem-solver, quick learner, and mentor for new team members.</a:t>
-            </a:r>
-            <a:endParaRPr lang="en-IN" sz="1600" dirty="0">
-              <a:solidFill>
-                <a:prstClr val="black"/>
-              </a:solidFill>
-              <a:latin typeface="Calibri" panose="020F0502020204030204" pitchFamily="34" charset="0"/>
-              <a:ea typeface="Calibri" panose="020F0502020204030204" pitchFamily="34" charset="0"/>
-              <a:cs typeface="Calibri" panose="020F0502020204030204" pitchFamily="34" charset="0"/>
-            </a:endParaRPr>
-          </a:p>
-          <a:p>
-            <a:pPr marL="285750" lvl="0" indent="-285750">
-              <a:buFont typeface="Arial" panose="020B0604020202020204" pitchFamily="34" charset="0"/>
-              <a:buChar char="•"/>
-            </a:pPr>
-            <a:r>
-              <a:rPr lang="en-US" sz="1600" dirty="0">
-                <a:solidFill>
-                  <a:prstClr val="black"/>
-                </a:solidFill>
-                <a:latin typeface="Calibri" panose="020F0502020204030204" pitchFamily="34" charset="0"/>
-                <a:ea typeface="Calibri" panose="020F0502020204030204" pitchFamily="34" charset="0"/>
-                <a:cs typeface="Calibri" panose="020F0502020204030204" pitchFamily="34" charset="0"/>
-              </a:rPr>
-              <a:t>Well-versed in Agile methodologies and collaborating with cross-functional teams.</a:t>
-            </a:r>
-            <a:endParaRPr lang="en-IN" sz="1600" dirty="0">
-              <a:solidFill>
-                <a:prstClr val="black"/>
-              </a:solidFill>
-              <a:latin typeface="Calibri" panose="020F0502020204030204" pitchFamily="34" charset="0"/>
-              <a:ea typeface="Calibri" panose="020F0502020204030204" pitchFamily="34" charset="0"/>
-              <a:cs typeface="Calibri" panose="020F0502020204030204" pitchFamily="34" charset="0"/>
-            </a:endParaRPr>
-          </a:p>
-          <a:p>
-            <a:pPr marL="285750" lvl="0" indent="-285750">
-              <a:buFont typeface="Arial" panose="020B0604020202020204" pitchFamily="34" charset="0"/>
-              <a:buChar char="•"/>
-            </a:pPr>
-            <a:r>
-              <a:rPr lang="en-US" sz="1600" dirty="0">
-                <a:solidFill>
-                  <a:prstClr val="black"/>
-                </a:solidFill>
-                <a:latin typeface="Calibri" panose="020F0502020204030204" pitchFamily="34" charset="0"/>
-                <a:ea typeface="Calibri" panose="020F0502020204030204" pitchFamily="34" charset="0"/>
-                <a:cs typeface="Calibri" panose="020F0502020204030204" pitchFamily="34" charset="0"/>
-              </a:rPr>
-              <a:t>Experienced with tools like Jira, TFS, Git, </a:t>
-            </a:r>
-            <a:r>
-              <a:rPr lang="en-US" sz="1600" dirty="0" err="1">
-                <a:solidFill>
-                  <a:prstClr val="black"/>
-                </a:solidFill>
-                <a:latin typeface="Calibri" panose="020F0502020204030204" pitchFamily="34" charset="0"/>
-                <a:ea typeface="Calibri" panose="020F0502020204030204" pitchFamily="34" charset="0"/>
-                <a:cs typeface="Calibri" panose="020F0502020204030204" pitchFamily="34" charset="0"/>
-              </a:rPr>
-              <a:t>iFast</a:t>
-            </a:r>
-            <a:r>
-              <a:rPr lang="en-US" sz="1600" dirty="0">
-                <a:solidFill>
-                  <a:prstClr val="black"/>
-                </a:solidFill>
-                <a:latin typeface="Calibri" panose="020F0502020204030204" pitchFamily="34" charset="0"/>
-                <a:ea typeface="Calibri" panose="020F0502020204030204" pitchFamily="34" charset="0"/>
-                <a:cs typeface="Calibri" panose="020F0502020204030204" pitchFamily="34" charset="0"/>
-              </a:rPr>
-              <a:t>, and Test Data Management tools.</a:t>
-            </a:r>
-            <a:endParaRPr lang="en-IN" sz="1600" dirty="0">
-              <a:solidFill>
-                <a:prstClr val="black"/>
-              </a:solidFill>
-              <a:latin typeface="Calibri" panose="020F0502020204030204" pitchFamily="34" charset="0"/>
-              <a:ea typeface="Calibri" panose="020F0502020204030204" pitchFamily="34" charset="0"/>
-              <a:cs typeface="Calibri" panose="020F0502020204030204" pitchFamily="34" charset="0"/>
-            </a:endParaRPr>
-          </a:p>
-          <a:p>
-            <a:pPr marL="285750" lvl="0" indent="-285750">
-              <a:buFont typeface="Arial" panose="020B0604020202020204" pitchFamily="34" charset="0"/>
-              <a:buChar char="•"/>
-            </a:pPr>
-            <a:r>
-              <a:rPr lang="en-US" sz="1600" dirty="0">
-                <a:solidFill>
-                  <a:prstClr val="black"/>
-                </a:solidFill>
-                <a:latin typeface="Calibri" panose="020F0502020204030204" pitchFamily="34" charset="0"/>
-                <a:ea typeface="Calibri" panose="020F0502020204030204" pitchFamily="34" charset="0"/>
-                <a:cs typeface="Calibri" panose="020F0502020204030204" pitchFamily="34" charset="0"/>
-              </a:rPr>
-              <a:t>Responsible for ensuring on-time delivery of high-quality product deliverables.</a:t>
-            </a:r>
-            <a:endParaRPr lang="en-IN" sz="1600" dirty="0">
-              <a:solidFill>
-                <a:prstClr val="black"/>
-              </a:solidFill>
-              <a:latin typeface="Calibri" panose="020F0502020204030204" pitchFamily="34" charset="0"/>
-              <a:ea typeface="Calibri" panose="020F0502020204030204" pitchFamily="34" charset="0"/>
-              <a:cs typeface="Calibri" panose="020F0502020204030204" pitchFamily="34" charset="0"/>
-            </a:endParaRPr>
-          </a:p>
-          <a:p>
-            <a:pPr marL="285750" lvl="0" indent="-285750">
-              <a:buFont typeface="Arial" panose="020B0604020202020204" pitchFamily="34" charset="0"/>
-              <a:buChar char="•"/>
-            </a:pPr>
-            <a:r>
-              <a:rPr lang="en-US" sz="1600" dirty="0">
-                <a:solidFill>
-                  <a:prstClr val="black"/>
-                </a:solidFill>
-                <a:latin typeface="Calibri" panose="020F0502020204030204" pitchFamily="34" charset="0"/>
-                <a:ea typeface="Calibri" panose="020F0502020204030204" pitchFamily="34" charset="0"/>
-                <a:cs typeface="Calibri" panose="020F0502020204030204" pitchFamily="34" charset="0"/>
-              </a:rPr>
-              <a:t>Having hands-on experience in java for developing selenium scripts</a:t>
-            </a:r>
-            <a:endParaRPr lang="en-IN" sz="1600" dirty="0">
-              <a:solidFill>
-                <a:prstClr val="black"/>
-              </a:solidFill>
-              <a:latin typeface="Calibri" panose="020F0502020204030204" pitchFamily="34" charset="0"/>
-              <a:ea typeface="Calibri" panose="020F0502020204030204" pitchFamily="34" charset="0"/>
-              <a:cs typeface="Calibri" panose="020F0502020204030204" pitchFamily="34" charset="0"/>
-            </a:endParaRPr>
-          </a:p>
-          <a:p>
-            <a:pPr marL="285750" lvl="0" indent="-285750">
-              <a:buFont typeface="Arial" panose="020B0604020202020204" pitchFamily="34" charset="0"/>
-              <a:buChar char="•"/>
-            </a:pPr>
-            <a:r>
-              <a:rPr lang="en-US" sz="1600" dirty="0">
-                <a:solidFill>
-                  <a:prstClr val="black"/>
-                </a:solidFill>
-                <a:latin typeface="Calibri" panose="020F0502020204030204" pitchFamily="34" charset="0"/>
-                <a:ea typeface="Calibri" panose="020F0502020204030204" pitchFamily="34" charset="0"/>
-                <a:cs typeface="Calibri" panose="020F0502020204030204" pitchFamily="34" charset="0"/>
-              </a:rPr>
-              <a:t>Designed and implemented XML schemas for data validation and integration between distributed systems.</a:t>
-            </a:r>
-            <a:endParaRPr lang="en-IN" sz="1600" dirty="0">
-              <a:solidFill>
-                <a:prstClr val="black"/>
-              </a:solidFill>
-              <a:latin typeface="Calibri" panose="020F0502020204030204" pitchFamily="34" charset="0"/>
-              <a:ea typeface="Calibri" panose="020F0502020204030204" pitchFamily="34" charset="0"/>
-              <a:cs typeface="Calibri" panose="020F0502020204030204" pitchFamily="34" charset="0"/>
-            </a:endParaRPr>
-          </a:p>
         </p:txBody>
       </p:sp>
       <p:sp>
@@ -6408,7 +6314,7 @@
           <p:cNvPr id="12" name="TextBox 11">
             <a:extLst>
               <a:ext uri="{FF2B5EF4-FFF2-40B4-BE49-F238E27FC236}">
-                <a16:creationId xmlns:a16="http://schemas.microsoft.com/office/drawing/2014/main" id="{FF5044C3-FB81-37EB-A51F-BF41E9D309C6}"/>
+                <a16:creationId xmlns:a16="http://schemas.microsoft.com/office/drawing/2014/main" id="{3263F006-1ED5-9F17-4832-5C4EDBCB139A}"/>
               </a:ext>
             </a:extLst>
           </p:cNvPr>
@@ -6417,8 +6323,8 @@
         </p:nvSpPr>
         <p:spPr>
           <a:xfrm>
-            <a:off x="304798" y="1204265"/>
-            <a:ext cx="1734311" cy="369332"/>
+            <a:off x="304800" y="1712950"/>
+            <a:ext cx="1470274" cy="369332"/>
           </a:xfrm>
           <a:prstGeom prst="rect">
             <a:avLst/>
@@ -6426,7 +6332,7 @@
           <a:noFill/>
         </p:spPr>
         <p:txBody>
-          <a:bodyPr wrap="square" rtlCol="0">
+          <a:bodyPr wrap="none" rtlCol="0">
             <a:spAutoFit/>
           </a:bodyPr>
           <a:lstStyle/>
@@ -6454,7 +6360,24 @@
             </a:r>
             <a:r>
               <a:rPr lang="en-IN" b="1" dirty="0"/>
-              <a:t>escription:</a:t>
+              <a:t>escription</a:t>
+            </a:r>
+            <a:r>
+              <a:rPr kumimoji="0" lang="en-IN" sz="1600" b="1" i="0" u="none" strike="noStrike" kern="1200" cap="none" spc="0" normalizeH="0" baseline="0" noProof="0" dirty="0">
+                <a:ln>
+                  <a:noFill/>
+                </a:ln>
+                <a:solidFill>
+                  <a:srgbClr val="002060"/>
+                </a:solidFill>
+                <a:effectLst/>
+                <a:uLnTx/>
+                <a:uFillTx/>
+                <a:latin typeface="Calibri"/>
+                <a:ea typeface="Calibri"/>
+                <a:cs typeface="Calibri"/>
+              </a:rPr>
+              <a:t>:</a:t>
             </a:r>
           </a:p>
         </p:txBody>
@@ -6464,7 +6387,7 @@
           <p:cNvPr id="14" name="TextBox 13">
             <a:extLst>
               <a:ext uri="{FF2B5EF4-FFF2-40B4-BE49-F238E27FC236}">
-                <a16:creationId xmlns:a16="http://schemas.microsoft.com/office/drawing/2014/main" id="{89669AE3-6766-99D8-8ECA-0B70DC087BDB}"/>
+                <a16:creationId xmlns:a16="http://schemas.microsoft.com/office/drawing/2014/main" id="{48FDA6FC-689D-3954-6C30-D499F8EA99D5}"/>
               </a:ext>
             </a:extLst>
           </p:cNvPr>
@@ -6473,7 +6396,7 @@
         </p:nvSpPr>
         <p:spPr>
           <a:xfrm>
-            <a:off x="304800" y="52355"/>
+            <a:off x="304800" y="278283"/>
             <a:ext cx="1734312" cy="369332"/>
           </a:xfrm>
           <a:prstGeom prst="rect">
@@ -6482,7 +6405,7 @@
           <a:noFill/>
         </p:spPr>
         <p:txBody>
-          <a:bodyPr wrap="square" lIns="91440" tIns="45720" rIns="91440" bIns="45720" anchor="t">
+          <a:bodyPr wrap="square">
             <a:spAutoFit/>
           </a:bodyPr>
           <a:lstStyle/>
@@ -6519,18 +6442,7 @@
                 <a:ea typeface="Calibri"/>
                 <a:cs typeface="Calibri"/>
               </a:rPr>
-              <a:t>Project </a:t>
-            </a:r>
-            <a:r>
-              <a:rPr lang="en-US" b="1" dirty="0">
-                <a:solidFill>
-                  <a:srgbClr val="002060"/>
-                </a:solidFill>
-                <a:latin typeface="Calibri"/>
-                <a:ea typeface="Calibri"/>
-                <a:cs typeface="Calibri"/>
-              </a:rPr>
-              <a:t>2</a:t>
+              <a:t>Project 2</a:t>
             </a:r>
             <a:endParaRPr kumimoji="0" lang="en-US" b="0" i="0" u="none" strike="noStrike" kern="1200" cap="none" spc="0" normalizeH="0" baseline="0" noProof="0" dirty="0">
               <a:ln>
@@ -6554,7 +6466,7 @@
           <p:cNvPr id="3" name="Picture 2">
             <a:extLst>
               <a:ext uri="{FF2B5EF4-FFF2-40B4-BE49-F238E27FC236}">
-                <a16:creationId xmlns:a16="http://schemas.microsoft.com/office/drawing/2014/main" id="{1A747B1B-4E88-A533-215F-D22CE3E5C5D6}"/>
+                <a16:creationId xmlns:a16="http://schemas.microsoft.com/office/drawing/2014/main" id="{EA499149-6F21-61C3-57D6-464B49022092}"/>
               </a:ext>
             </a:extLst>
           </p:cNvPr>
@@ -6573,7 +6485,7 @@
         </p:blipFill>
         <p:spPr>
           <a:xfrm>
-            <a:off x="9982200" y="179161"/>
+            <a:off x="9993086" y="75293"/>
             <a:ext cx="2066530" cy="587639"/>
           </a:xfrm>
           <a:prstGeom prst="rect">
@@ -6587,7 +6499,7 @@
     </p:spTree>
     <p:extLst>
       <p:ext uri="{BB962C8B-B14F-4D97-AF65-F5344CB8AC3E}">
-        <p14:creationId xmlns:p14="http://schemas.microsoft.com/office/powerpoint/2010/main" val="859413911"/>
+        <p14:creationId xmlns:p14="http://schemas.microsoft.com/office/powerpoint/2010/main" val="2821146086"/>
       </p:ext>
     </p:extLst>
   </p:cSld>
@@ -6613,7 +6525,7 @@
         <p:cNvPr id="1" name="">
           <a:extLst>
             <a:ext uri="{FF2B5EF4-FFF2-40B4-BE49-F238E27FC236}">
-              <a16:creationId xmlns:a16="http://schemas.microsoft.com/office/drawing/2014/main" id="{2AA1FEA4-F971-DBF9-AED6-FC31BA727305}"/>
+              <a16:creationId xmlns:a16="http://schemas.microsoft.com/office/drawing/2014/main" id="{D2BC4485-04EA-5964-A06F-7F50CAB1420D}"/>
             </a:ext>
           </a:extLst>
         </p:cNvPr>
@@ -6633,7 +6545,7 @@
           <p:cNvPr id="5" name="Slide Number Placeholder 4">
             <a:extLst>
               <a:ext uri="{FF2B5EF4-FFF2-40B4-BE49-F238E27FC236}">
-                <a16:creationId xmlns:a16="http://schemas.microsoft.com/office/drawing/2014/main" id="{81CD88D3-2A46-BC12-7671-0CA7629DFFFF}"/>
+                <a16:creationId xmlns:a16="http://schemas.microsoft.com/office/drawing/2014/main" id="{6F1ECAAF-5F5F-FF47-8797-93F45AD82AED}"/>
               </a:ext>
             </a:extLst>
           </p:cNvPr>
@@ -6726,7 +6638,7 @@
           <p:cNvPr id="7" name="TextBox 6">
             <a:extLst>
               <a:ext uri="{FF2B5EF4-FFF2-40B4-BE49-F238E27FC236}">
-                <a16:creationId xmlns:a16="http://schemas.microsoft.com/office/drawing/2014/main" id="{5643832E-FCE1-5E70-E193-C382AD3B85A3}"/>
+                <a16:creationId xmlns:a16="http://schemas.microsoft.com/office/drawing/2014/main" id="{5D00FC8E-1F2A-3890-1644-19DF13D3FFB6}"/>
               </a:ext>
             </a:extLst>
           </p:cNvPr>
@@ -6735,7 +6647,7 @@
         </p:nvSpPr>
         <p:spPr>
           <a:xfrm>
-            <a:off x="304800" y="647615"/>
+            <a:off x="304800" y="634824"/>
             <a:ext cx="9954892" cy="923330"/>
           </a:xfrm>
           <a:prstGeom prst="rect">
@@ -6767,7 +6679,7 @@
                 <a:ea typeface="Calibri"/>
                 <a:cs typeface="Calibri"/>
               </a:rPr>
-              <a:t>Project:</a:t>
+              <a:t>Project: {PROJECT3_NAME}</a:t>
             </a:r>
             <a:r>
               <a:rPr lang="en-US" b="1" dirty="0">
@@ -6778,18 +6690,7 @@
                 <a:ea typeface="Calibri"/>
                 <a:cs typeface="Calibri"/>
               </a:rPr>
-              <a:t> </a:t>
-            </a:r>
-            <a:r>
-              <a:rPr lang="en-US" b="1" dirty="0">
-                <a:solidFill>
-                  <a:prstClr val="black"/>
-                </a:solidFill>
-                <a:latin typeface="Calibri"/>
-                <a:ea typeface="Calibri"/>
-                <a:cs typeface="Segoe UI"/>
-              </a:rPr>
-              <a:t>Master Data Hub (MDH)</a:t>
+              <a:t>.</a:t>
             </a:r>
             <a:endParaRPr lang="en-US" b="1" i="0" u="none" strike="noStrike" kern="1200" cap="none" spc="0" normalizeH="0" baseline="0" noProof="0" dirty="0">
               <a:ln>
@@ -6825,44 +6726,28 @@
                 <a:ea typeface="Calibri"/>
                 <a:cs typeface="Calibri"/>
               </a:rPr>
-              <a:t>Duration : </a:t>
-            </a:r>
-            <a:r>
-              <a:rPr lang="en-US" b="1" dirty="0">
-                <a:solidFill>
-                  <a:prstClr val="black"/>
-                </a:solidFill>
-                <a:latin typeface="Calibri"/>
-                <a:ea typeface="Calibri"/>
-                <a:cs typeface="Segoe UI"/>
-              </a:rPr>
-              <a:t>Jan’2022 – April’2022</a:t>
-            </a:r>
+              <a:t>Duration : {DURATION_project3}</a:t>
+            </a:r>
+            <a:endParaRPr lang="en-US" b="1" dirty="0">
+              <a:solidFill>
+                <a:prstClr val="black"/>
+              </a:solidFill>
+              <a:latin typeface="Calibri"/>
+              <a:ea typeface="Calibri"/>
+              <a:cs typeface="Calibri"/>
+            </a:endParaRPr>
           </a:p>
           <a:p>
             <a:pPr>
               <a:defRPr/>
             </a:pPr>
             <a:r>
-              <a:rPr lang="en-US" b="1" i="0" u="none" strike="noStrike" kern="1200" cap="none" spc="0" normalizeH="0" baseline="0" noProof="0" dirty="0">
-                <a:ln>
-                  <a:noFill/>
-                </a:ln>
-                <a:solidFill>
-                  <a:prstClr val="black"/>
-                </a:solidFill>
-                <a:effectLst/>
-                <a:uLnTx/>
-                <a:uFillTx/>
-                <a:latin typeface="Calibri"/>
-                <a:ea typeface="Calibri"/>
-                <a:cs typeface="Segoe UI"/>
-              </a:rPr>
-              <a:t>Role: </a:t>
+              <a:rPr lang="en-US" b="1" dirty="0"/>
+              <a:t>Role</a:t>
             </a:r>
             <a:r>
               <a:rPr lang="en-US" dirty="0"/>
-              <a:t>QA Analyst</a:t>
+              <a:t>: {ROLE_project3}</a:t>
             </a:r>
             <a:endParaRPr lang="en-US" b="1" i="0" u="none" strike="noStrike" kern="1200" cap="none" spc="0" normalizeH="0" baseline="0" noProof="0" dirty="0">
               <a:ln>
@@ -6876,7 +6761,7 @@
               <a:uFillTx/>
               <a:latin typeface="Calibri"/>
               <a:ea typeface="Calibri"/>
-              <a:cs typeface="Segoe UI"/>
+              <a:cs typeface="Calibri"/>
             </a:endParaRPr>
           </a:p>
         </p:txBody>
@@ -6886,7 +6771,7 @@
           <p:cNvPr id="11" name="TextBox 10">
             <a:extLst>
               <a:ext uri="{FF2B5EF4-FFF2-40B4-BE49-F238E27FC236}">
-                <a16:creationId xmlns:a16="http://schemas.microsoft.com/office/drawing/2014/main" id="{5195D475-D617-D7E2-0AAE-F20B3E7BBCAA}"/>
+                <a16:creationId xmlns:a16="http://schemas.microsoft.com/office/drawing/2014/main" id="{8C183A66-42F8-F13C-795D-00913B38A72C}"/>
               </a:ext>
             </a:extLst>
           </p:cNvPr>
@@ -6895,8 +6780,8 @@
         </p:nvSpPr>
         <p:spPr>
           <a:xfrm>
-            <a:off x="304799" y="1841242"/>
-            <a:ext cx="11702143" cy="4524315"/>
+            <a:off x="304800" y="2132178"/>
+            <a:ext cx="11691257" cy="4524315"/>
           </a:xfrm>
           <a:prstGeom prst="rect">
             <a:avLst/>
@@ -6913,7 +6798,7 @@
               <a:defRPr/>
             </a:pPr>
             <a:r>
-              <a:rPr kumimoji="0" lang="en-US" sz="1600" b="1" i="0" u="none" strike="noStrike" kern="1200" cap="none" spc="0" normalizeH="0" baseline="0" noProof="0" dirty="0">
+              <a:rPr lang="en-US" sz="1600" i="0" u="none" strike="noStrike" kern="1200" cap="none" spc="0" normalizeH="0" baseline="0" noProof="0" dirty="0">
                 <a:ln>
                   <a:noFill/>
                 </a:ln>
@@ -6927,36 +6812,13 @@
                 <a:ea typeface="Calibri"/>
                 <a:cs typeface="Calibri"/>
               </a:rPr>
-              <a:t>Project Overview</a:t>
-            </a:r>
-            <a:r>
-              <a:rPr kumimoji="0" lang="en-US" sz="1600" b="0" i="0" u="none" strike="noStrike" kern="1200" cap="none" spc="0" normalizeH="0" baseline="0" noProof="0" dirty="0">
-                <a:ln>
-                  <a:noFill/>
-                </a:ln>
-                <a:solidFill>
-                  <a:prstClr val="black"/>
-                </a:solidFill>
-                <a:effectLst/>
-                <a:uLnTx/>
-                <a:uFillTx/>
-                <a:latin typeface="Calibri"/>
-                <a:ea typeface="Calibri"/>
-                <a:cs typeface="Calibri"/>
-              </a:rPr>
-              <a:t>: </a:t>
-            </a:r>
-            <a:r>
-              <a:rPr lang="en-US" sz="1600" dirty="0">
-                <a:solidFill>
-                  <a:prstClr val="black"/>
-                </a:solidFill>
-                <a:latin typeface="Calibri"/>
-                <a:ea typeface="+mn-lt"/>
-                <a:cs typeface="Segoe UI"/>
-              </a:rPr>
-              <a:t>Worked on a centralized platform designed to consolidate, manage, and synchronize master data across multiple enterprise systems (ERP, CRM, AWS and other platforms). Ensured data consistency, accuracy, and integrity for critical business entities such as Customer, Product, Supplier, Location, and Employee by automating and validating core MDH functionalities including data ingestion, validation, enrichment, deduplication, golden record creation, and downstream data publishing.</a:t>
-            </a:r>
+              <a:t>{Project3_Description}:</a:t>
+            </a:r>
+          </a:p>
+          <a:p>
+            <a:pPr algn="just" fontAlgn="base" hangingPunct="0">
+              <a:defRPr/>
+            </a:pPr>
             <a:endParaRPr lang="en-US" sz="1600" dirty="0">
               <a:solidFill>
                 <a:prstClr val="black"/>
@@ -6967,24 +6829,10 @@
             </a:endParaRPr>
           </a:p>
           <a:p>
-            <a:pPr marL="0" marR="0" lvl="0" indent="0" algn="just" defTabSz="914400" rtl="0" eaLnBrk="1" fontAlgn="base" latinLnBrk="0" hangingPunct="0">
-              <a:lnSpc>
-                <a:spcPct val="100000"/>
-              </a:lnSpc>
-              <a:spcBef>
-                <a:spcPts val="0"/>
-              </a:spcBef>
-              <a:spcAft>
-                <a:spcPts val="0"/>
-              </a:spcAft>
-              <a:buClrTx/>
-              <a:buSzTx/>
-              <a:buFontTx/>
-              <a:buNone/>
-              <a:tabLst/>
-              <a:defRPr/>
-            </a:pPr>
-            <a:endParaRPr kumimoji="0" lang="en-US" sz="1600" b="1" i="0" u="none" strike="noStrike" kern="1200" cap="none" spc="0" normalizeH="0" baseline="0" noProof="0" dirty="0">
+            <a:pPr algn="just" fontAlgn="base" hangingPunct="0">
+              <a:defRPr/>
+            </a:pPr>
+            <a:endParaRPr lang="en-US" sz="1600" i="0" u="none" strike="noStrike" kern="1200" cap="none" spc="0" normalizeH="0" baseline="0" noProof="0" dirty="0">
               <a:ln>
                 <a:noFill/>
               </a:ln>
@@ -7000,58 +6848,23 @@
             </a:endParaRPr>
           </a:p>
           <a:p>
-            <a:pPr marL="0" marR="0" lvl="0" indent="0" algn="just" defTabSz="914400" rtl="0" eaLnBrk="1" fontAlgn="base" latinLnBrk="0" hangingPunct="0">
-              <a:lnSpc>
-                <a:spcPct val="100000"/>
-              </a:lnSpc>
-              <a:spcBef>
-                <a:spcPts val="0"/>
-              </a:spcBef>
-              <a:spcAft>
-                <a:spcPts val="0"/>
-              </a:spcAft>
-              <a:buClrTx/>
-              <a:buSzTx/>
-              <a:buFontTx/>
-              <a:buNone/>
-              <a:tabLst/>
-              <a:defRPr/>
-            </a:pPr>
-            <a:r>
-              <a:rPr kumimoji="0" lang="en-US" sz="1600" b="1" i="0" u="none" strike="noStrike" kern="1200" cap="none" spc="0" normalizeH="0" baseline="0" noProof="0" dirty="0">
-                <a:ln>
-                  <a:noFill/>
-                </a:ln>
-                <a:solidFill>
-                  <a:prstClr val="black"/>
-                </a:solidFill>
-                <a:effectLst/>
-                <a:uLnTx/>
-                <a:uFillTx/>
-                <a:latin typeface="Calibri"/>
-                <a:ea typeface="Calibri"/>
-                <a:cs typeface="Calibri"/>
-              </a:rPr>
-              <a:t>Responsibilities</a:t>
-            </a:r>
-            <a:r>
-              <a:rPr kumimoji="0" lang="en-US" sz="1600" b="0" i="0" u="none" strike="noStrike" kern="1200" cap="none" spc="0" normalizeH="0" baseline="0" noProof="0" dirty="0">
-                <a:ln>
-                  <a:noFill/>
-                </a:ln>
-                <a:solidFill>
-                  <a:prstClr val="black"/>
-                </a:solidFill>
-                <a:effectLst/>
-                <a:uLnTx/>
-                <a:uFillTx/>
-                <a:latin typeface="Calibri"/>
-                <a:ea typeface="Calibri"/>
-                <a:cs typeface="Calibri"/>
-              </a:rPr>
-              <a:t>: </a:t>
-            </a:r>
-            <a:endParaRPr lang="en-US" sz="1600" b="0" i="0" u="none" strike="noStrike" kern="1200" cap="none" spc="0" normalizeH="0" baseline="0" noProof="0" dirty="0">
+            <a:pPr algn="just" fontAlgn="base" hangingPunct="0">
+              <a:defRPr/>
+            </a:pPr>
+            <a:endParaRPr lang="en-US" sz="1600" dirty="0">
+              <a:solidFill>
+                <a:prstClr val="black"/>
+              </a:solidFill>
+              <a:latin typeface="Calibri"/>
+              <a:ea typeface="Calibri"/>
+              <a:cs typeface="Calibri"/>
+            </a:endParaRPr>
+          </a:p>
+          <a:p>
+            <a:pPr algn="just" fontAlgn="base" hangingPunct="0">
+              <a:defRPr/>
+            </a:pPr>
+            <a:endParaRPr lang="en-US" sz="1600" i="0" u="none" strike="noStrike" kern="1200" cap="none" spc="0" normalizeH="0" baseline="0" noProof="0" dirty="0">
               <a:ln>
                 <a:noFill/>
               </a:ln>
@@ -7067,200 +6880,317 @@
             </a:endParaRPr>
           </a:p>
           <a:p>
-            <a:pPr marL="285750" indent="-285750" algn="just">
-              <a:buFont typeface="Arial" panose="020B0604020202020204" pitchFamily="34" charset="0"/>
-              <a:buChar char="•"/>
+            <a:pPr algn="just" fontAlgn="base" hangingPunct="0">
+              <a:defRPr/>
+            </a:pPr>
+            <a:endParaRPr lang="en-US" sz="1600" dirty="0">
+              <a:solidFill>
+                <a:prstClr val="black"/>
+              </a:solidFill>
+              <a:latin typeface="Calibri"/>
+              <a:ea typeface="Calibri"/>
+              <a:cs typeface="Calibri"/>
+            </a:endParaRPr>
+          </a:p>
+          <a:p>
+            <a:pPr algn="just" fontAlgn="base" hangingPunct="0">
+              <a:defRPr/>
+            </a:pPr>
+            <a:endParaRPr lang="en-US" sz="1600" i="0" u="none" strike="noStrike" kern="1200" cap="none" spc="0" normalizeH="0" baseline="0" noProof="0" dirty="0">
+              <a:ln>
+                <a:noFill/>
+              </a:ln>
+              <a:solidFill>
+                <a:prstClr val="black"/>
+              </a:solidFill>
+              <a:effectLst/>
+              <a:uLnTx/>
+              <a:uFillTx/>
+              <a:latin typeface="Calibri"/>
+              <a:ea typeface="Calibri"/>
+              <a:cs typeface="Calibri"/>
+            </a:endParaRPr>
+          </a:p>
+          <a:p>
+            <a:pPr algn="just" fontAlgn="base" hangingPunct="0">
+              <a:defRPr/>
+            </a:pPr>
+            <a:endParaRPr lang="en-US" sz="1600" dirty="0">
+              <a:solidFill>
+                <a:prstClr val="black"/>
+              </a:solidFill>
+              <a:latin typeface="Calibri"/>
+              <a:ea typeface="Calibri"/>
+              <a:cs typeface="Calibri"/>
+            </a:endParaRPr>
+          </a:p>
+          <a:p>
+            <a:pPr algn="just" fontAlgn="base" hangingPunct="0">
+              <a:defRPr/>
+            </a:pPr>
+            <a:endParaRPr lang="en-US" sz="1600" i="0" u="none" strike="noStrike" kern="1200" cap="none" spc="0" normalizeH="0" baseline="0" noProof="0" dirty="0">
+              <a:ln>
+                <a:noFill/>
+              </a:ln>
+              <a:solidFill>
+                <a:prstClr val="black"/>
+              </a:solidFill>
+              <a:effectLst/>
+              <a:uLnTx/>
+              <a:uFillTx/>
+              <a:latin typeface="Calibri"/>
+              <a:ea typeface="Calibri"/>
+              <a:cs typeface="Calibri"/>
+            </a:endParaRPr>
+          </a:p>
+          <a:p>
+            <a:pPr marL="0" marR="0" lvl="0" indent="0" algn="just" defTabSz="914400" rtl="0" eaLnBrk="1" fontAlgn="base" latinLnBrk="0" hangingPunct="0">
+              <a:lnSpc>
+                <a:spcPct val="100000"/>
+              </a:lnSpc>
+              <a:spcBef>
+                <a:spcPts val="0"/>
+              </a:spcBef>
+              <a:spcAft>
+                <a:spcPts val="0"/>
+              </a:spcAft>
+              <a:buClrTx/>
+              <a:buSzTx/>
+              <a:buFontTx/>
+              <a:buNone/>
+              <a:tabLst/>
+              <a:defRPr/>
+            </a:pPr>
+            <a:r>
+              <a:rPr lang="en-US" sz="1600" b="1" dirty="0">
+                <a:solidFill>
+                  <a:prstClr val="black"/>
+                </a:solidFill>
+                <a:latin typeface="Calibri" panose="020F0502020204030204" pitchFamily="34" charset="0"/>
+                <a:ea typeface="Calibri" panose="020F0502020204030204" pitchFamily="34" charset="0"/>
+                <a:cs typeface="Calibri" panose="020F0502020204030204" pitchFamily="34" charset="0"/>
+              </a:rPr>
+              <a:t>Responsibilities: </a:t>
+            </a:r>
+          </a:p>
+          <a:p>
+            <a:pPr marL="0" marR="0" lvl="0" indent="0" algn="just" defTabSz="914400" rtl="0" eaLnBrk="1" fontAlgn="base" latinLnBrk="0" hangingPunct="0">
+              <a:lnSpc>
+                <a:spcPct val="100000"/>
+              </a:lnSpc>
+              <a:spcBef>
+                <a:spcPts val="0"/>
+              </a:spcBef>
+              <a:spcAft>
+                <a:spcPts val="0"/>
+              </a:spcAft>
+              <a:buClrTx/>
+              <a:buSzTx/>
+              <a:buFontTx/>
+              <a:buNone/>
+              <a:tabLst/>
               <a:defRPr/>
             </a:pPr>
             <a:r>
               <a:rPr lang="en-US" sz="1600" dirty="0">
-                <a:latin typeface="Calibri"/>
-                <a:ea typeface="Calibri"/>
-                <a:cs typeface="Calibri"/>
+                <a:solidFill>
+                  <a:prstClr val="black"/>
+                </a:solidFill>
+                <a:latin typeface="Calibri" panose="020F0502020204030204" pitchFamily="34" charset="0"/>
+                <a:ea typeface="Calibri" panose="020F0502020204030204" pitchFamily="34" charset="0"/>
+                <a:cs typeface="Calibri" panose="020F0502020204030204" pitchFamily="34" charset="0"/>
               </a:rPr>
-              <a:t>Designed and implemented automation frameworks using Selenium WebDriver (Python), Playwright, and Robot Framework.</a:t>
-            </a:r>
-          </a:p>
-          <a:p>
-            <a:pPr marL="285750" indent="-285750" algn="just">
-              <a:buFont typeface="Arial" panose="020B0604020202020204" pitchFamily="34" charset="0"/>
-              <a:buChar char="•"/>
-              <a:defRPr/>
-            </a:pPr>
-            <a:r>
-              <a:rPr lang="en-US" sz="1600" dirty="0">
-                <a:latin typeface="Calibri"/>
-                <a:ea typeface="Calibri"/>
-                <a:cs typeface="Calibri"/>
-              </a:rPr>
-              <a:t>Developed custom library functions and integrated them into existing frameworks to enhance automation capabilities.</a:t>
-            </a:r>
-          </a:p>
-          <a:p>
-            <a:pPr marL="285750" indent="-285750" algn="just">
-              <a:buFont typeface="Arial" panose="020B0604020202020204" pitchFamily="34" charset="0"/>
-              <a:buChar char="•"/>
-              <a:defRPr/>
-            </a:pPr>
-            <a:r>
-              <a:rPr lang="en-US" sz="1600" dirty="0">
-                <a:latin typeface="Calibri"/>
-                <a:ea typeface="Calibri"/>
-                <a:cs typeface="Calibri"/>
-              </a:rPr>
-              <a:t>Automated regression and smoke test suites, ensuring high coverage and stability.</a:t>
-            </a:r>
-          </a:p>
-          <a:p>
-            <a:pPr marL="285750" indent="-285750" algn="just">
-              <a:buFont typeface="Arial" panose="020B0604020202020204" pitchFamily="34" charset="0"/>
-              <a:buChar char="•"/>
-              <a:defRPr/>
-            </a:pPr>
-            <a:r>
-              <a:rPr lang="en-US" sz="1600" dirty="0">
-                <a:latin typeface="Calibri"/>
-                <a:ea typeface="Calibri"/>
-                <a:cs typeface="Calibri"/>
-              </a:rPr>
-              <a:t>Migrated existing automation suites from Selenium to Playwright (Python) for improved performance and maintainability.</a:t>
-            </a:r>
-          </a:p>
-          <a:p>
-            <a:pPr marL="285750" indent="-285750" algn="just">
-              <a:buFont typeface="Arial" panose="020B0604020202020204" pitchFamily="34" charset="0"/>
-              <a:buChar char="•"/>
-              <a:defRPr/>
-            </a:pPr>
-            <a:r>
-              <a:rPr lang="en-US" sz="1600" dirty="0">
-                <a:latin typeface="Calibri"/>
-                <a:ea typeface="Calibri"/>
-                <a:cs typeface="Calibri"/>
-              </a:rPr>
-              <a:t>Performed functional, integration, system, and regression testing for large-scale master data workflows.</a:t>
-            </a:r>
-          </a:p>
-          <a:p>
-            <a:pPr marL="285750" indent="-285750" algn="just">
-              <a:buFont typeface="Arial" panose="020B0604020202020204" pitchFamily="34" charset="0"/>
-              <a:buChar char="•"/>
-              <a:defRPr/>
-            </a:pPr>
-            <a:r>
-              <a:rPr lang="en-US" sz="1600" dirty="0">
-                <a:latin typeface="Calibri"/>
-                <a:ea typeface="Calibri"/>
-                <a:cs typeface="Calibri"/>
-              </a:rPr>
-              <a:t>Validated RESTful APIs using Postman and integrated API tests into CI pipelines using Jenkins.</a:t>
-            </a:r>
-          </a:p>
-          <a:p>
-            <a:pPr marL="285750" indent="-285750" algn="just">
-              <a:buFont typeface="Arial" panose="020B0604020202020204" pitchFamily="34" charset="0"/>
-              <a:buChar char="•"/>
-              <a:defRPr/>
-            </a:pPr>
-            <a:r>
-              <a:rPr lang="en-US" sz="1600" dirty="0">
-                <a:latin typeface="Calibri"/>
-                <a:ea typeface="Calibri"/>
-                <a:cs typeface="Calibri"/>
-              </a:rPr>
-              <a:t>Monitored and </a:t>
-            </a:r>
-            <a:r>
-              <a:rPr lang="en-US" sz="1600" dirty="0" err="1">
-                <a:latin typeface="Calibri"/>
-                <a:ea typeface="Calibri"/>
-                <a:cs typeface="Calibri"/>
-              </a:rPr>
-              <a:t>analysed</a:t>
-            </a:r>
-            <a:r>
-              <a:rPr lang="en-US" sz="1600" dirty="0">
-                <a:latin typeface="Calibri"/>
-                <a:ea typeface="Calibri"/>
-                <a:cs typeface="Calibri"/>
-              </a:rPr>
-              <a:t> application performance using Splunk and New Relic.</a:t>
-            </a:r>
-          </a:p>
-          <a:p>
-            <a:pPr marL="285750" indent="-285750" algn="just">
-              <a:buFont typeface="Arial" panose="020B0604020202020204" pitchFamily="34" charset="0"/>
-              <a:buChar char="•"/>
-              <a:defRPr/>
-            </a:pPr>
-            <a:r>
-              <a:rPr lang="en-US" sz="1600" dirty="0">
-                <a:latin typeface="Calibri"/>
-                <a:ea typeface="Calibri"/>
-                <a:cs typeface="Calibri"/>
-              </a:rPr>
-              <a:t>Created and executed test plans, test scenarios, and test cases for performance, stress, and power testing.</a:t>
-            </a:r>
-          </a:p>
-          <a:p>
-            <a:pPr marL="285750" indent="-285750" algn="just">
-              <a:buFont typeface="Arial" panose="020B0604020202020204" pitchFamily="34" charset="0"/>
-              <a:buChar char="•"/>
-              <a:defRPr/>
-            </a:pPr>
-            <a:r>
-              <a:rPr lang="en-US" sz="1600" dirty="0">
-                <a:latin typeface="Calibri"/>
-                <a:ea typeface="Calibri"/>
-                <a:cs typeface="Calibri"/>
-              </a:rPr>
-              <a:t>Provided effort estimations for sprint test execution and collaborated with stakeholders on planning.</a:t>
-            </a:r>
-          </a:p>
-          <a:p>
-            <a:pPr marL="285750" indent="-285750" algn="just">
-              <a:buFont typeface="Arial" panose="020B0604020202020204" pitchFamily="34" charset="0"/>
-              <a:buChar char="•"/>
-              <a:defRPr/>
-            </a:pPr>
-            <a:r>
-              <a:rPr lang="en-US" sz="1600" dirty="0">
-                <a:latin typeface="Calibri"/>
-                <a:ea typeface="Calibri"/>
-                <a:cs typeface="Calibri"/>
-              </a:rPr>
-              <a:t>Reviewed and approved code changes in Gerrit, resolving merge conflicts where necessary.</a:t>
-            </a:r>
-          </a:p>
-          <a:p>
-            <a:pPr marL="285750" indent="-285750" algn="just">
-              <a:buFont typeface="Arial" panose="020B0604020202020204" pitchFamily="34" charset="0"/>
-              <a:buChar char="•"/>
-              <a:defRPr/>
-            </a:pPr>
-            <a:r>
-              <a:rPr lang="en-US" sz="1600" dirty="0">
-                <a:latin typeface="Calibri"/>
-                <a:ea typeface="Calibri"/>
-                <a:cs typeface="Calibri"/>
-              </a:rPr>
-              <a:t>Logged, tracked, and verified defects in JIRA, ensuring timely resolution.</a:t>
-            </a:r>
-          </a:p>
-          <a:p>
-            <a:pPr marL="285750" indent="-285750" algn="just">
-              <a:buFont typeface="Arial" panose="020B0604020202020204" pitchFamily="34" charset="0"/>
-              <a:buChar char="•"/>
-              <a:defRPr/>
-            </a:pPr>
-            <a:r>
-              <a:rPr lang="en-US" sz="1600" dirty="0">
-                <a:latin typeface="Calibri"/>
-                <a:ea typeface="Calibri"/>
-                <a:cs typeface="Calibri"/>
-              </a:rPr>
-              <a:t>Collaborated with cross-functional teams and actively participated in Agile ceremonies (daily standups, sprint planning, retrospectives).</a:t>
-            </a:r>
+              <a:t>{Responsibilities_project3}</a:t>
+            </a:r>
+          </a:p>
+          <a:p>
+            <a:pPr marL="0" marR="0" lvl="0" indent="0" algn="just" defTabSz="914400" rtl="0" eaLnBrk="1" fontAlgn="base" latinLnBrk="0" hangingPunct="0">
+              <a:lnSpc>
+                <a:spcPct val="100000"/>
+              </a:lnSpc>
+              <a:spcBef>
+                <a:spcPts val="0"/>
+              </a:spcBef>
+              <a:spcAft>
+                <a:spcPts val="0"/>
+              </a:spcAft>
+              <a:buClrTx/>
+              <a:buSzTx/>
+              <a:buFontTx/>
+              <a:buNone/>
+              <a:tabLst/>
+              <a:defRPr/>
+            </a:pPr>
+            <a:endParaRPr lang="en-US" sz="1600" dirty="0">
+              <a:solidFill>
+                <a:prstClr val="black"/>
+              </a:solidFill>
+              <a:latin typeface="Calibri" panose="020F0502020204030204" pitchFamily="34" charset="0"/>
+              <a:ea typeface="Calibri" panose="020F0502020204030204" pitchFamily="34" charset="0"/>
+              <a:cs typeface="Calibri" panose="020F0502020204030204" pitchFamily="34" charset="0"/>
+            </a:endParaRPr>
+          </a:p>
+          <a:p>
+            <a:pPr marL="0" marR="0" lvl="0" indent="0" algn="just" defTabSz="914400" rtl="0" eaLnBrk="1" fontAlgn="base" latinLnBrk="0" hangingPunct="0">
+              <a:lnSpc>
+                <a:spcPct val="100000"/>
+              </a:lnSpc>
+              <a:spcBef>
+                <a:spcPts val="0"/>
+              </a:spcBef>
+              <a:spcAft>
+                <a:spcPts val="0"/>
+              </a:spcAft>
+              <a:buClrTx/>
+              <a:buSzTx/>
+              <a:buFontTx/>
+              <a:buNone/>
+              <a:tabLst/>
+              <a:defRPr/>
+            </a:pPr>
+            <a:endParaRPr lang="en-US" sz="1600" dirty="0">
+              <a:solidFill>
+                <a:prstClr val="black"/>
+              </a:solidFill>
+              <a:latin typeface="Calibri" panose="020F0502020204030204" pitchFamily="34" charset="0"/>
+              <a:ea typeface="Calibri" panose="020F0502020204030204" pitchFamily="34" charset="0"/>
+              <a:cs typeface="Calibri" panose="020F0502020204030204" pitchFamily="34" charset="0"/>
+            </a:endParaRPr>
+          </a:p>
+          <a:p>
+            <a:pPr marL="0" marR="0" lvl="0" indent="0" algn="just" defTabSz="914400" rtl="0" eaLnBrk="1" fontAlgn="base" latinLnBrk="0" hangingPunct="0">
+              <a:lnSpc>
+                <a:spcPct val="100000"/>
+              </a:lnSpc>
+              <a:spcBef>
+                <a:spcPts val="0"/>
+              </a:spcBef>
+              <a:spcAft>
+                <a:spcPts val="0"/>
+              </a:spcAft>
+              <a:buClrTx/>
+              <a:buSzTx/>
+              <a:buFontTx/>
+              <a:buNone/>
+              <a:tabLst/>
+              <a:defRPr/>
+            </a:pPr>
+            <a:endParaRPr lang="en-US" sz="1600" dirty="0">
+              <a:solidFill>
+                <a:prstClr val="black"/>
+              </a:solidFill>
+              <a:latin typeface="Calibri" panose="020F0502020204030204" pitchFamily="34" charset="0"/>
+              <a:ea typeface="Calibri" panose="020F0502020204030204" pitchFamily="34" charset="0"/>
+              <a:cs typeface="Calibri" panose="020F0502020204030204" pitchFamily="34" charset="0"/>
+            </a:endParaRPr>
+          </a:p>
+          <a:p>
+            <a:pPr marL="0" marR="0" lvl="0" indent="0" algn="just" defTabSz="914400" rtl="0" eaLnBrk="1" fontAlgn="base" latinLnBrk="0" hangingPunct="0">
+              <a:lnSpc>
+                <a:spcPct val="100000"/>
+              </a:lnSpc>
+              <a:spcBef>
+                <a:spcPts val="0"/>
+              </a:spcBef>
+              <a:spcAft>
+                <a:spcPts val="0"/>
+              </a:spcAft>
+              <a:buClrTx/>
+              <a:buSzTx/>
+              <a:buFontTx/>
+              <a:buNone/>
+              <a:tabLst/>
+              <a:defRPr/>
+            </a:pPr>
+            <a:endParaRPr lang="en-US" sz="1600" dirty="0">
+              <a:solidFill>
+                <a:prstClr val="black"/>
+              </a:solidFill>
+              <a:latin typeface="Calibri" panose="020F0502020204030204" pitchFamily="34" charset="0"/>
+              <a:ea typeface="Calibri" panose="020F0502020204030204" pitchFamily="34" charset="0"/>
+              <a:cs typeface="Calibri" panose="020F0502020204030204" pitchFamily="34" charset="0"/>
+            </a:endParaRPr>
+          </a:p>
+          <a:p>
+            <a:pPr marL="0" marR="0" lvl="0" indent="0" algn="just" defTabSz="914400" rtl="0" eaLnBrk="1" fontAlgn="base" latinLnBrk="0" hangingPunct="0">
+              <a:lnSpc>
+                <a:spcPct val="100000"/>
+              </a:lnSpc>
+              <a:spcBef>
+                <a:spcPts val="0"/>
+              </a:spcBef>
+              <a:spcAft>
+                <a:spcPts val="0"/>
+              </a:spcAft>
+              <a:buClrTx/>
+              <a:buSzTx/>
+              <a:buFontTx/>
+              <a:buNone/>
+              <a:tabLst/>
+              <a:defRPr/>
+            </a:pPr>
+            <a:endParaRPr lang="en-US" sz="1600" dirty="0">
+              <a:solidFill>
+                <a:prstClr val="black"/>
+              </a:solidFill>
+              <a:latin typeface="Calibri" panose="020F0502020204030204" pitchFamily="34" charset="0"/>
+              <a:ea typeface="Calibri" panose="020F0502020204030204" pitchFamily="34" charset="0"/>
+              <a:cs typeface="Calibri" panose="020F0502020204030204" pitchFamily="34" charset="0"/>
+            </a:endParaRPr>
+          </a:p>
+          <a:p>
+            <a:pPr marL="0" marR="0" lvl="0" indent="0" algn="just" defTabSz="914400" rtl="0" eaLnBrk="1" fontAlgn="base" latinLnBrk="0" hangingPunct="0">
+              <a:lnSpc>
+                <a:spcPct val="100000"/>
+              </a:lnSpc>
+              <a:spcBef>
+                <a:spcPts val="0"/>
+              </a:spcBef>
+              <a:spcAft>
+                <a:spcPts val="0"/>
+              </a:spcAft>
+              <a:buClrTx/>
+              <a:buSzTx/>
+              <a:buFontTx/>
+              <a:buNone/>
+              <a:tabLst/>
+              <a:defRPr/>
+            </a:pPr>
+            <a:endParaRPr lang="en-US" sz="1600" dirty="0">
+              <a:solidFill>
+                <a:prstClr val="black"/>
+              </a:solidFill>
+              <a:latin typeface="Calibri" panose="020F0502020204030204" pitchFamily="34" charset="0"/>
+              <a:ea typeface="Calibri" panose="020F0502020204030204" pitchFamily="34" charset="0"/>
+              <a:cs typeface="Calibri" panose="020F0502020204030204" pitchFamily="34" charset="0"/>
+            </a:endParaRPr>
+          </a:p>
+          <a:p>
+            <a:pPr marL="0" marR="0" lvl="0" indent="0" algn="just" defTabSz="914400" rtl="0" eaLnBrk="1" fontAlgn="base" latinLnBrk="0" hangingPunct="0">
+              <a:lnSpc>
+                <a:spcPct val="100000"/>
+              </a:lnSpc>
+              <a:spcBef>
+                <a:spcPts val="0"/>
+              </a:spcBef>
+              <a:spcAft>
+                <a:spcPts val="0"/>
+              </a:spcAft>
+              <a:buClrTx/>
+              <a:buSzTx/>
+              <a:buFontTx/>
+              <a:buNone/>
+              <a:tabLst/>
+              <a:defRPr/>
+            </a:pPr>
+            <a:endParaRPr lang="en-US" sz="1600" dirty="0">
+              <a:solidFill>
+                <a:prstClr val="black"/>
+              </a:solidFill>
+              <a:latin typeface="Calibri" panose="020F0502020204030204" pitchFamily="34" charset="0"/>
+              <a:ea typeface="Calibri" panose="020F0502020204030204" pitchFamily="34" charset="0"/>
+              <a:cs typeface="Calibri" panose="020F0502020204030204" pitchFamily="34" charset="0"/>
+            </a:endParaRPr>
           </a:p>
         </p:txBody>
       </p:sp>
@@ -7269,7 +7199,7 @@
           <p:cNvPr id="12" name="TextBox 11">
             <a:extLst>
               <a:ext uri="{FF2B5EF4-FFF2-40B4-BE49-F238E27FC236}">
-                <a16:creationId xmlns:a16="http://schemas.microsoft.com/office/drawing/2014/main" id="{69E9817A-6332-5EC4-B2D4-E14B5EBDD257}"/>
+                <a16:creationId xmlns:a16="http://schemas.microsoft.com/office/drawing/2014/main" id="{DEEFE75C-7666-C01B-B99D-B88C12B9FC8F}"/>
               </a:ext>
             </a:extLst>
           </p:cNvPr>
@@ -7278,8 +7208,8 @@
         </p:nvSpPr>
         <p:spPr>
           <a:xfrm>
-            <a:off x="304800" y="1510628"/>
-            <a:ext cx="1341136" cy="369332"/>
+            <a:off x="304800" y="1712950"/>
+            <a:ext cx="1470274" cy="369332"/>
           </a:xfrm>
           <a:prstGeom prst="rect">
             <a:avLst/>
@@ -7310,83 +7240,15 @@
               <a:defRPr/>
             </a:pPr>
             <a:r>
-              <a:rPr kumimoji="0" lang="en-US" b="1" i="0" u="none" strike="noStrike" kern="1200" cap="none" spc="0" normalizeH="0" baseline="0" noProof="0" dirty="0">
-                <a:ln>
-                  <a:noFill/>
-                </a:ln>
-                <a:effectLst/>
-                <a:uLnTx/>
-                <a:uFillTx/>
-                <a:latin typeface="Calibri"/>
-                <a:ea typeface="Calibri"/>
-                <a:cs typeface="Calibri"/>
-              </a:rPr>
+              <a:rPr lang="en-US" b="1" dirty="0"/>
               <a:t>D</a:t>
             </a:r>
             <a:r>
-              <a:rPr kumimoji="0" lang="en-IN" b="1" i="0" u="none" strike="noStrike" kern="1200" cap="none" spc="0" normalizeH="0" baseline="0" noProof="0" dirty="0">
-                <a:ln>
-                  <a:noFill/>
-                </a:ln>
-                <a:effectLst/>
-                <a:uLnTx/>
-                <a:uFillTx/>
-                <a:latin typeface="Calibri"/>
-                <a:ea typeface="Calibri"/>
-                <a:cs typeface="Calibri"/>
-              </a:rPr>
-              <a:t>escription:</a:t>
-            </a:r>
-          </a:p>
-        </p:txBody>
-      </p:sp>
-      <p:sp>
-        <p:nvSpPr>
-          <p:cNvPr id="14" name="TextBox 13">
-            <a:extLst>
-              <a:ext uri="{FF2B5EF4-FFF2-40B4-BE49-F238E27FC236}">
-                <a16:creationId xmlns:a16="http://schemas.microsoft.com/office/drawing/2014/main" id="{7FA4A957-BEDD-F60C-ADA6-86EB8E004333}"/>
-              </a:ext>
-            </a:extLst>
-          </p:cNvPr>
-          <p:cNvSpPr txBox="1"/>
-          <p:nvPr/>
-        </p:nvSpPr>
-        <p:spPr>
-          <a:xfrm>
-            <a:off x="304800" y="278283"/>
-            <a:ext cx="1734312" cy="369332"/>
-          </a:xfrm>
-          <a:prstGeom prst="rect">
-            <a:avLst/>
-          </a:prstGeom>
-          <a:noFill/>
-        </p:spPr>
-        <p:txBody>
-          <a:bodyPr wrap="square" lIns="91440" tIns="45720" rIns="91440" bIns="45720" anchor="t">
-            <a:spAutoFit/>
-          </a:bodyPr>
-          <a:lstStyle/>
-          <a:p>
-            <a:pPr marL="0" marR="0" lvl="0" indent="0" algn="l" defTabSz="914400" rtl="0" eaLnBrk="1" fontAlgn="auto" latinLnBrk="0" hangingPunct="1">
-              <a:lnSpc>
-                <a:spcPct val="100000"/>
-              </a:lnSpc>
-              <a:spcBef>
-                <a:spcPts val="0"/>
-              </a:spcBef>
-              <a:spcAft>
-                <a:spcPts val="0"/>
-              </a:spcAft>
-              <a:buClrTx/>
-              <a:buSzTx/>
-              <a:buFontTx/>
-              <a:buNone/>
-              <a:tabLst/>
-              <a:defRPr/>
-            </a:pPr>
-            <a:r>
-              <a:rPr kumimoji="0" lang="en-US" b="1" i="0" u="none" strike="noStrike" kern="1200" cap="none" spc="0" normalizeH="0" baseline="0" noProof="0">
+              <a:rPr lang="en-IN" b="1" dirty="0"/>
+              <a:t>escription</a:t>
+            </a:r>
+            <a:r>
+              <a:rPr kumimoji="0" lang="en-IN" sz="1600" b="1" i="0" u="none" strike="noStrike" kern="1200" cap="none" spc="0" normalizeH="0" baseline="0" noProof="0" dirty="0">
                 <a:ln>
                   <a:noFill/>
                 </a:ln>
@@ -7400,20 +7262,74 @@
                 <a:ea typeface="Calibri"/>
                 <a:cs typeface="Calibri"/>
               </a:rPr>
-              <a:t>Project </a:t>
-            </a:r>
-            <a:r>
-              <a:rPr lang="en-US" b="1">
+              <a:t>:</a:t>
+            </a:r>
+          </a:p>
+        </p:txBody>
+      </p:sp>
+      <p:sp>
+        <p:nvSpPr>
+          <p:cNvPr id="14" name="TextBox 13">
+            <a:extLst>
+              <a:ext uri="{FF2B5EF4-FFF2-40B4-BE49-F238E27FC236}">
+                <a16:creationId xmlns:a16="http://schemas.microsoft.com/office/drawing/2014/main" id="{EEC00225-2649-E9A9-35FD-316C40ECD757}"/>
+              </a:ext>
+            </a:extLst>
+          </p:cNvPr>
+          <p:cNvSpPr txBox="1"/>
+          <p:nvPr/>
+        </p:nvSpPr>
+        <p:spPr>
+          <a:xfrm>
+            <a:off x="304800" y="278283"/>
+            <a:ext cx="1734312" cy="369332"/>
+          </a:xfrm>
+          <a:prstGeom prst="rect">
+            <a:avLst/>
+          </a:prstGeom>
+          <a:noFill/>
+        </p:spPr>
+        <p:txBody>
+          <a:bodyPr wrap="square">
+            <a:spAutoFit/>
+          </a:bodyPr>
+          <a:lstStyle/>
+          <a:p>
+            <a:pPr marL="0" marR="0" lvl="0" indent="0" algn="l" defTabSz="914400" rtl="0" eaLnBrk="1" fontAlgn="auto" latinLnBrk="0" hangingPunct="1">
+              <a:lnSpc>
+                <a:spcPct val="100000"/>
+              </a:lnSpc>
+              <a:spcBef>
+                <a:spcPts val="0"/>
+              </a:spcBef>
+              <a:spcAft>
+                <a:spcPts val="0"/>
+              </a:spcAft>
+              <a:buClrTx/>
+              <a:buSzTx/>
+              <a:buFontTx/>
+              <a:buNone/>
+              <a:tabLst/>
+              <a:defRPr/>
+            </a:pPr>
+            <a:r>
+              <a:rPr kumimoji="0" lang="en-US" b="1" i="0" u="none" strike="noStrike" kern="1200" cap="none" spc="0" normalizeH="0" baseline="0" noProof="0" dirty="0">
+                <a:ln>
+                  <a:noFill/>
+                </a:ln>
                 <a:solidFill>
                   <a:srgbClr val="002060"/>
                 </a:solidFill>
+                <a:effectLst/>
+                <a:uLnTx/>
+                <a:uFillTx/>
                 <a:latin typeface="Calibri"/>
                 <a:ea typeface="Calibri"/>
                 <a:cs typeface="Calibri"/>
               </a:rPr>
-              <a:t>3</a:t>
-            </a:r>
-            <a:endParaRPr kumimoji="0" lang="en-US" b="0" i="0" u="none" strike="noStrike" kern="1200" cap="none" spc="0" normalizeH="0" baseline="0" noProof="0">
+              <a:t>Project 3</a:t>
+            </a:r>
+            <a:endParaRPr kumimoji="0" lang="en-US" b="0" i="0" u="none" strike="noStrike" kern="1200" cap="none" spc="0" normalizeH="0" baseline="0" noProof="0" dirty="0">
               <a:ln>
                 <a:noFill/>
               </a:ln>
@@ -7435,7 +7351,7 @@
           <p:cNvPr id="3" name="Picture 2">
             <a:extLst>
               <a:ext uri="{FF2B5EF4-FFF2-40B4-BE49-F238E27FC236}">
-                <a16:creationId xmlns:a16="http://schemas.microsoft.com/office/drawing/2014/main" id="{089CF080-0376-3553-A31B-5AEDF3C651BE}"/>
+                <a16:creationId xmlns:a16="http://schemas.microsoft.com/office/drawing/2014/main" id="{9CE50D27-C285-DBAE-BAA1-12AE4060FDAB}"/>
               </a:ext>
             </a:extLst>
           </p:cNvPr>
@@ -7445,7 +7361,7 @@
           <p:nvPr/>
         </p:nvPicPr>
         <p:blipFill>
-          <a:blip r:embed="rId3">
+          <a:blip r:embed="rId2">
             <a:biLevel thresh="25000"/>
           </a:blip>
           <a:stretch>
@@ -7454,7 +7370,7 @@
         </p:blipFill>
         <p:spPr>
           <a:xfrm>
-            <a:off x="9940412" y="123053"/>
+            <a:off x="9993086" y="75293"/>
             <a:ext cx="2066530" cy="587639"/>
           </a:xfrm>
           <a:prstGeom prst="rect">
@@ -7468,7 +7384,7 @@
     </p:spTree>
     <p:extLst>
       <p:ext uri="{BB962C8B-B14F-4D97-AF65-F5344CB8AC3E}">
-        <p14:creationId xmlns:p14="http://schemas.microsoft.com/office/powerpoint/2010/main" val="2512149221"/>
+        <p14:creationId xmlns:p14="http://schemas.microsoft.com/office/powerpoint/2010/main" val="2262051643"/>
       </p:ext>
     </p:extLst>
   </p:cSld>
@@ -7494,7 +7410,7 @@
         <p:cNvPr id="1" name="">
           <a:extLst>
             <a:ext uri="{FF2B5EF4-FFF2-40B4-BE49-F238E27FC236}">
-              <a16:creationId xmlns:a16="http://schemas.microsoft.com/office/drawing/2014/main" id="{A6D0BE6B-9BA5-1D77-5855-DA1A7E434141}"/>
+              <a16:creationId xmlns:a16="http://schemas.microsoft.com/office/drawing/2014/main" id="{D5E09864-4992-3906-59DB-A4B1F9E76D09}"/>
             </a:ext>
           </a:extLst>
         </p:cNvPr>
@@ -7514,7 +7430,7 @@
           <p:cNvPr id="5" name="Slide Number Placeholder 4">
             <a:extLst>
               <a:ext uri="{FF2B5EF4-FFF2-40B4-BE49-F238E27FC236}">
-                <a16:creationId xmlns:a16="http://schemas.microsoft.com/office/drawing/2014/main" id="{79E39533-D777-E8D1-6568-C653AB3CDB71}"/>
+                <a16:creationId xmlns:a16="http://schemas.microsoft.com/office/drawing/2014/main" id="{7350FD1B-DFB6-DD01-EB80-6C652E530739}"/>
               </a:ext>
             </a:extLst>
           </p:cNvPr>
@@ -7607,7 +7523,7 @@
           <p:cNvPr id="7" name="TextBox 6">
             <a:extLst>
               <a:ext uri="{FF2B5EF4-FFF2-40B4-BE49-F238E27FC236}">
-                <a16:creationId xmlns:a16="http://schemas.microsoft.com/office/drawing/2014/main" id="{BB11E5DD-4B91-F731-B9FD-DC124FACD3DD}"/>
+                <a16:creationId xmlns:a16="http://schemas.microsoft.com/office/drawing/2014/main" id="{B9B22AF1-3840-9008-3CA4-0A6A790F3B2B}"/>
               </a:ext>
             </a:extLst>
           </p:cNvPr>
@@ -7616,7 +7532,7 @@
         </p:nvSpPr>
         <p:spPr>
           <a:xfrm>
-            <a:off x="304800" y="696071"/>
+            <a:off x="304800" y="634824"/>
             <a:ext cx="9954892" cy="923330"/>
           </a:xfrm>
           <a:prstGeom prst="rect">
@@ -7648,49 +7564,25 @@
                 <a:ea typeface="Calibri"/>
                 <a:cs typeface="Calibri"/>
               </a:rPr>
-              <a:t>Project:</a:t>
-            </a:r>
-            <a:r>
-              <a:rPr lang="en-US" b="1" dirty="0">
+              <a:t>Project: </a:t>
+            </a:r>
+            <a:r>
+              <a:rPr kumimoji="0" lang="en-US" b="1" i="0" u="none" strike="noStrike" kern="1200" cap="none" spc="0" normalizeH="0" baseline="0" noProof="0">
+                <a:ln>
+                  <a:noFill/>
+                </a:ln>
                 <a:solidFill>
                   <a:prstClr val="black"/>
                 </a:solidFill>
+                <a:effectLst/>
+                <a:uLnTx/>
+                <a:uFillTx/>
                 <a:latin typeface="Calibri"/>
                 <a:ea typeface="Calibri"/>
                 <a:cs typeface="Calibri"/>
               </a:rPr>
-              <a:t> </a:t>
-            </a:r>
-            <a:r>
-              <a:rPr lang="en-US" b="1" dirty="0">
-                <a:solidFill>
-                  <a:prstClr val="black"/>
-                </a:solidFill>
-                <a:latin typeface="Calibri"/>
-                <a:ea typeface="Calibri"/>
-                <a:cs typeface="Segoe UI"/>
-              </a:rPr>
-              <a:t>Hitachi Rail</a:t>
-            </a:r>
-            <a:endParaRPr lang="en-US" b="1" i="0" u="none" strike="noStrike" kern="1200" cap="none" spc="0" normalizeH="0" baseline="0" noProof="0" dirty="0">
-              <a:ln>
-                <a:noFill/>
-              </a:ln>
-              <a:solidFill>
-                <a:prstClr val="black"/>
-              </a:solidFill>
-              <a:effectLst/>
-              <a:uLnTx/>
-              <a:uFillTx/>
-              <a:latin typeface="Calibri"/>
-              <a:ea typeface="Calibri"/>
-              <a:cs typeface="Calibri"/>
-            </a:endParaRPr>
-          </a:p>
-          <a:p>
-            <a:pPr>
-              <a:defRPr/>
-            </a:pPr>
+              <a:t>{PROJECT4_</a:t>
+            </a:r>
             <a:r>
               <a:rPr kumimoji="0" lang="en-US" b="1" i="0" u="none" strike="noStrike" kern="1200" cap="none" spc="0" normalizeH="0" baseline="0" noProof="0" dirty="0">
                 <a:ln>
@@ -7706,7 +7598,7 @@
                 <a:ea typeface="Calibri"/>
                 <a:cs typeface="Calibri"/>
               </a:rPr>
-              <a:t>Duration : </a:t>
+              <a:t>NAME}</a:t>
             </a:r>
             <a:r>
               <a:rPr lang="en-US" b="1" dirty="0">
@@ -7714,69 +7606,32 @@
                   <a:prstClr val="black"/>
                 </a:solidFill>
                 <a:latin typeface="Calibri"/>
-                <a:ea typeface="+mn-lt"/>
-                <a:cs typeface="+mn-lt"/>
+                <a:ea typeface="Calibri"/>
+                <a:cs typeface="Calibri"/>
               </a:rPr>
-              <a:t>Jan’2020 – Dec’2021</a:t>
-            </a:r>
+              <a:t>.</a:t>
+            </a:r>
+            <a:endParaRPr lang="en-US" b="1" i="0" u="none" strike="noStrike" kern="1200" cap="none" spc="0" normalizeH="0" baseline="0" noProof="0" dirty="0">
+              <a:ln>
+                <a:noFill/>
+              </a:ln>
+              <a:solidFill>
+                <a:prstClr val="black"/>
+              </a:solidFill>
+              <a:effectLst/>
+              <a:uLnTx/>
+              <a:uFillTx/>
+              <a:latin typeface="Calibri"/>
+              <a:ea typeface="Calibri"/>
+              <a:cs typeface="Calibri"/>
+            </a:endParaRPr>
           </a:p>
           <a:p>
             <a:pPr>
               <a:defRPr/>
             </a:pPr>
             <a:r>
-              <a:rPr lang="en-US" b="1" i="0" u="none" strike="noStrike" kern="1200" cap="none" spc="0" normalizeH="0" baseline="0" noProof="0" dirty="0">
-                <a:ln>
-                  <a:noFill/>
-                </a:ln>
-                <a:solidFill>
-                  <a:prstClr val="black"/>
-                </a:solidFill>
-                <a:effectLst/>
-                <a:uLnTx/>
-                <a:uFillTx/>
-                <a:latin typeface="Calibri"/>
-                <a:ea typeface="+mn-lt"/>
-                <a:cs typeface="+mn-lt"/>
-              </a:rPr>
-              <a:t>Role: Associate consultant</a:t>
-            </a:r>
-          </a:p>
-        </p:txBody>
-      </p:sp>
-      <p:sp>
-        <p:nvSpPr>
-          <p:cNvPr id="11" name="TextBox 10">
-            <a:extLst>
-              <a:ext uri="{FF2B5EF4-FFF2-40B4-BE49-F238E27FC236}">
-                <a16:creationId xmlns:a16="http://schemas.microsoft.com/office/drawing/2014/main" id="{B7FE0190-4CB5-2F4F-C984-D5C304ED4B0A}"/>
-              </a:ext>
-            </a:extLst>
-          </p:cNvPr>
-          <p:cNvSpPr txBox="1"/>
-          <p:nvPr/>
-        </p:nvSpPr>
-        <p:spPr>
-          <a:xfrm>
-            <a:off x="304800" y="1995279"/>
-            <a:ext cx="11734800" cy="4478149"/>
-          </a:xfrm>
-          <a:prstGeom prst="rect">
-            <a:avLst/>
-          </a:prstGeom>
-          <a:noFill/>
-        </p:spPr>
-        <p:txBody>
-          <a:bodyPr wrap="square" lIns="91440" tIns="45720" rIns="91440" bIns="45720" anchor="t">
-            <a:spAutoFit/>
-          </a:bodyPr>
-          <a:lstStyle/>
-          <a:p>
-            <a:pPr algn="just" fontAlgn="base" hangingPunct="0">
-              <a:defRPr/>
-            </a:pPr>
-            <a:r>
-              <a:rPr kumimoji="0" lang="en-US" sz="1500" b="1" i="0" u="none" strike="noStrike" kern="1200" cap="none" spc="0" normalizeH="0" baseline="0" noProof="0" dirty="0">
+              <a:rPr kumimoji="0" lang="en-US" b="1" i="0" u="none" strike="noStrike" kern="1200" cap="none" spc="0" normalizeH="0" baseline="0" noProof="0" dirty="0">
                 <a:ln>
                   <a:noFill/>
                 </a:ln>
@@ -7790,10 +7645,79 @@
                 <a:ea typeface="Calibri"/>
                 <a:cs typeface="Calibri"/>
               </a:rPr>
-              <a:t>Project Overview</a:t>
-            </a:r>
-            <a:r>
-              <a:rPr kumimoji="0" lang="en-US" sz="1500" b="0" i="0" u="none" strike="noStrike" kern="1200" cap="none" spc="0" normalizeH="0" baseline="0" noProof="0" dirty="0">
+              <a:t>Duration : {DURATION_project4}</a:t>
+            </a:r>
+            <a:endParaRPr lang="en-US" b="1" dirty="0">
+              <a:solidFill>
+                <a:prstClr val="black"/>
+              </a:solidFill>
+              <a:latin typeface="Calibri"/>
+              <a:ea typeface="Calibri"/>
+              <a:cs typeface="Calibri"/>
+            </a:endParaRPr>
+          </a:p>
+          <a:p>
+            <a:pPr>
+              <a:defRPr/>
+            </a:pPr>
+            <a:r>
+              <a:rPr lang="en-US" b="1" dirty="0"/>
+              <a:t>Role</a:t>
+            </a:r>
+            <a:r>
+              <a:rPr lang="en-US" dirty="0"/>
+              <a:t>: {ROLE_project4}</a:t>
+            </a:r>
+            <a:endParaRPr lang="en-US" b="1" i="0" u="none" strike="noStrike" kern="1200" cap="none" spc="0" normalizeH="0" baseline="0" noProof="0" dirty="0">
+              <a:ln>
+                <a:noFill/>
+              </a:ln>
+              <a:solidFill>
+                <a:prstClr val="black"/>
+              </a:solidFill>
+              <a:effectLst/>
+              <a:uLnTx/>
+              <a:uFillTx/>
+              <a:latin typeface="Calibri"/>
+              <a:ea typeface="Calibri"/>
+              <a:cs typeface="Calibri"/>
+            </a:endParaRPr>
+          </a:p>
+        </p:txBody>
+      </p:sp>
+      <p:sp>
+        <p:nvSpPr>
+          <p:cNvPr id="11" name="TextBox 10">
+            <a:extLst>
+              <a:ext uri="{FF2B5EF4-FFF2-40B4-BE49-F238E27FC236}">
+                <a16:creationId xmlns:a16="http://schemas.microsoft.com/office/drawing/2014/main" id="{E710390A-553C-B68D-9AAF-E63341E911D8}"/>
+              </a:ext>
+            </a:extLst>
+          </p:cNvPr>
+          <p:cNvSpPr txBox="1"/>
+          <p:nvPr/>
+        </p:nvSpPr>
+        <p:spPr>
+          <a:xfrm>
+            <a:off x="304800" y="2132178"/>
+            <a:ext cx="11691257" cy="4524315"/>
+          </a:xfrm>
+          <a:prstGeom prst="rect">
+            <a:avLst/>
+          </a:prstGeom>
+          <a:noFill/>
+        </p:spPr>
+        <p:txBody>
+          <a:bodyPr wrap="square" lIns="91440" tIns="45720" rIns="91440" bIns="45720" anchor="t">
+            <a:spAutoFit/>
+          </a:bodyPr>
+          <a:lstStyle/>
+          <a:p>
+            <a:pPr algn="just" fontAlgn="base" hangingPunct="0">
+              <a:defRPr/>
+            </a:pPr>
+            <a:r>
+              <a:rPr lang="en-US" sz="1600" i="0" u="none" strike="noStrike" kern="1200" cap="none" spc="0" normalizeH="0" baseline="0" noProof="0" dirty="0">
                 <a:ln>
                   <a:noFill/>
                 </a:ln>
@@ -7807,28 +7731,132 @@
                 <a:ea typeface="Calibri"/>
                 <a:cs typeface="Calibri"/>
               </a:rPr>
-              <a:t>: </a:t>
-            </a:r>
-            <a:r>
-              <a:rPr lang="en-US" sz="1500" dirty="0">
-                <a:solidFill>
-                  <a:prstClr val="black"/>
-                </a:solidFill>
-                <a:latin typeface="Calibri"/>
-                <a:ea typeface="+mn-lt"/>
-                <a:cs typeface="+mn-lt"/>
-              </a:rPr>
-              <a:t>This is a Metro Rail project, main objective of this project is to develop solutions that enhance safety, real-time monitoring, real-time updates for train locations, passenger information for different metro rail operations. Mostly worked in ATS and CBC. ATS gets information from various external interfaces and displays on ATS screen. Worked on ATS with Modbus, FLDC, SCADA, PSIS simulators which helps for managing platform screen doors, fleet data collection, information about traction power, routing, vehicle regulations and passenger information etc.</a:t>
-            </a:r>
-          </a:p>
-          <a:p>
-            <a:pPr algn="just">
-              <a:defRPr/>
-            </a:pPr>
-            <a:endParaRPr lang="en-US" sz="1500" dirty="0">
+              <a:t>{Project4_Description}:</a:t>
+            </a:r>
+          </a:p>
+          <a:p>
+            <a:pPr algn="just" fontAlgn="base" hangingPunct="0">
+              <a:defRPr/>
+            </a:pPr>
+            <a:endParaRPr lang="en-US" sz="1600" dirty="0">
               <a:solidFill>
                 <a:prstClr val="black"/>
               </a:solidFill>
+              <a:latin typeface="Calibri"/>
+              <a:ea typeface="Calibri"/>
+              <a:cs typeface="Calibri"/>
+            </a:endParaRPr>
+          </a:p>
+          <a:p>
+            <a:pPr algn="just" fontAlgn="base" hangingPunct="0">
+              <a:defRPr/>
+            </a:pPr>
+            <a:endParaRPr lang="en-US" sz="1600" i="0" u="none" strike="noStrike" kern="1200" cap="none" spc="0" normalizeH="0" baseline="0" noProof="0" dirty="0">
+              <a:ln>
+                <a:noFill/>
+              </a:ln>
+              <a:solidFill>
+                <a:prstClr val="black"/>
+              </a:solidFill>
+              <a:effectLst/>
+              <a:uLnTx/>
+              <a:uFillTx/>
+              <a:latin typeface="Calibri"/>
+              <a:ea typeface="Calibri"/>
+              <a:cs typeface="Calibri"/>
+            </a:endParaRPr>
+          </a:p>
+          <a:p>
+            <a:pPr algn="just" fontAlgn="base" hangingPunct="0">
+              <a:defRPr/>
+            </a:pPr>
+            <a:endParaRPr lang="en-US" sz="1600" dirty="0">
+              <a:solidFill>
+                <a:prstClr val="black"/>
+              </a:solidFill>
+              <a:latin typeface="Calibri"/>
+              <a:ea typeface="Calibri"/>
+              <a:cs typeface="Calibri"/>
+            </a:endParaRPr>
+          </a:p>
+          <a:p>
+            <a:pPr algn="just" fontAlgn="base" hangingPunct="0">
+              <a:defRPr/>
+            </a:pPr>
+            <a:endParaRPr lang="en-US" sz="1600" i="0" u="none" strike="noStrike" kern="1200" cap="none" spc="0" normalizeH="0" baseline="0" noProof="0" dirty="0">
+              <a:ln>
+                <a:noFill/>
+              </a:ln>
+              <a:solidFill>
+                <a:prstClr val="black"/>
+              </a:solidFill>
+              <a:effectLst/>
+              <a:uLnTx/>
+              <a:uFillTx/>
+              <a:latin typeface="Calibri"/>
+              <a:ea typeface="Calibri"/>
+              <a:cs typeface="Calibri"/>
+            </a:endParaRPr>
+          </a:p>
+          <a:p>
+            <a:pPr algn="just" fontAlgn="base" hangingPunct="0">
+              <a:defRPr/>
+            </a:pPr>
+            <a:endParaRPr lang="en-US" sz="1600" dirty="0">
+              <a:solidFill>
+                <a:prstClr val="black"/>
+              </a:solidFill>
+              <a:latin typeface="Calibri"/>
+              <a:ea typeface="Calibri"/>
+              <a:cs typeface="Calibri"/>
+            </a:endParaRPr>
+          </a:p>
+          <a:p>
+            <a:pPr algn="just" fontAlgn="base" hangingPunct="0">
+              <a:defRPr/>
+            </a:pPr>
+            <a:endParaRPr lang="en-US" sz="1600" i="0" u="none" strike="noStrike" kern="1200" cap="none" spc="0" normalizeH="0" baseline="0" noProof="0" dirty="0">
+              <a:ln>
+                <a:noFill/>
+              </a:ln>
+              <a:solidFill>
+                <a:prstClr val="black"/>
+              </a:solidFill>
+              <a:effectLst/>
+              <a:uLnTx/>
+              <a:uFillTx/>
+              <a:latin typeface="Calibri"/>
+              <a:ea typeface="Calibri"/>
+              <a:cs typeface="Calibri"/>
+            </a:endParaRPr>
+          </a:p>
+          <a:p>
+            <a:pPr algn="just" fontAlgn="base" hangingPunct="0">
+              <a:defRPr/>
+            </a:pPr>
+            <a:endParaRPr lang="en-US" sz="1600" dirty="0">
+              <a:solidFill>
+                <a:prstClr val="black"/>
+              </a:solidFill>
+              <a:latin typeface="Calibri"/>
+              <a:ea typeface="Calibri"/>
+              <a:cs typeface="Calibri"/>
+            </a:endParaRPr>
+          </a:p>
+          <a:p>
+            <a:pPr algn="just" fontAlgn="base" hangingPunct="0">
+              <a:defRPr/>
+            </a:pPr>
+            <a:endParaRPr lang="en-US" sz="1600" i="0" u="none" strike="noStrike" kern="1200" cap="none" spc="0" normalizeH="0" baseline="0" noProof="0" dirty="0">
+              <a:ln>
+                <a:noFill/>
+              </a:ln>
+              <a:solidFill>
+                <a:prstClr val="black"/>
+              </a:solidFill>
+              <a:effectLst/>
+              <a:uLnTx/>
+              <a:uFillTx/>
               <a:latin typeface="Calibri"/>
               <a:ea typeface="Calibri"/>
               <a:cs typeface="Calibri"/>
@@ -7853,42 +7881,19 @@
               <a:defRPr/>
             </a:pPr>
             <a:r>
-              <a:rPr kumimoji="0" lang="en-US" sz="1500" b="1" i="0" u="none" strike="noStrike" kern="1200" cap="none" spc="0" normalizeH="0" baseline="0" noProof="0" dirty="0">
-                <a:ln>
-                  <a:noFill/>
-                </a:ln>
+              <a:rPr lang="en-US" sz="1600" b="1" dirty="0">
                 <a:solidFill>
                   <a:prstClr val="black"/>
                 </a:solidFill>
-                <a:effectLst/>
-                <a:uLnTx/>
-                <a:uFillTx/>
-                <a:latin typeface="Calibri"/>
-                <a:ea typeface="Calibri"/>
-                <a:cs typeface="Calibri"/>
+                <a:latin typeface="Calibri" panose="020F0502020204030204" pitchFamily="34" charset="0"/>
+                <a:ea typeface="Calibri" panose="020F0502020204030204" pitchFamily="34" charset="0"/>
+                <a:cs typeface="Calibri" panose="020F0502020204030204" pitchFamily="34" charset="0"/>
               </a:rPr>
-              <a:t>Responsibilities</a:t>
-            </a:r>
-            <a:r>
-              <a:rPr kumimoji="0" lang="en-US" sz="1500" b="0" i="0" u="none" strike="noStrike" kern="1200" cap="none" spc="0" normalizeH="0" baseline="0" noProof="0" dirty="0">
-                <a:ln>
-                  <a:noFill/>
-                </a:ln>
-                <a:solidFill>
-                  <a:prstClr val="black"/>
-                </a:solidFill>
-                <a:effectLst/>
-                <a:uLnTx/>
-                <a:uFillTx/>
-                <a:latin typeface="Calibri"/>
-                <a:ea typeface="Calibri"/>
-                <a:cs typeface="Calibri"/>
-              </a:rPr>
-              <a:t>: </a:t>
-            </a:r>
-          </a:p>
-          <a:p>
-            <a:pPr marL="285750" marR="0" lvl="0" indent="-285750" algn="just" defTabSz="914400" rtl="0" eaLnBrk="1" fontAlgn="base" latinLnBrk="0" hangingPunct="0">
+              <a:t>Responsibilities: </a:t>
+            </a:r>
+          </a:p>
+          <a:p>
+            <a:pPr marL="0" marR="0" lvl="0" indent="0" algn="just" defTabSz="914400" rtl="0" eaLnBrk="1" fontAlgn="base" latinLnBrk="0" hangingPunct="0">
               <a:lnSpc>
                 <a:spcPct val="100000"/>
               </a:lnSpc>
@@ -7900,28 +7905,25 @@
               </a:spcAft>
               <a:buClrTx/>
               <a:buSzTx/>
-              <a:buFont typeface="Arial" panose="020B0604020202020204" pitchFamily="34" charset="0"/>
-              <a:buChar char="•"/>
+              <a:buFontTx/>
+              <a:buNone/>
               <a:tabLst/>
               <a:defRPr/>
             </a:pPr>
             <a:r>
-              <a:rPr lang="en-US" sz="1500" b="0" i="0" u="none" strike="noStrike" kern="1200" cap="none" spc="0" normalizeH="0" baseline="0" noProof="0" dirty="0">
-                <a:ln>
-                  <a:noFill/>
-                </a:ln>
-                <a:effectLst/>
-                <a:uLnTx/>
-                <a:uFillTx/>
-                <a:latin typeface="Calibri"/>
-                <a:ea typeface="Calibri"/>
-                <a:cs typeface="Calibri"/>
+              <a:rPr lang="en-US" sz="1600" dirty="0">
+                <a:solidFill>
+                  <a:prstClr val="black"/>
+                </a:solidFill>
+                <a:latin typeface="Calibri" panose="020F0502020204030204" pitchFamily="34" charset="0"/>
+                <a:ea typeface="Calibri" panose="020F0502020204030204" pitchFamily="34" charset="0"/>
+                <a:cs typeface="Calibri" panose="020F0502020204030204" pitchFamily="34" charset="0"/>
               </a:rPr>
-              <a:t>Performed functional testing of IP address management solutions with multi-grid capabilities.</a:t>
-            </a:r>
-          </a:p>
-          <a:p>
-            <a:pPr marL="285750" marR="0" lvl="0" indent="-285750" algn="just" defTabSz="914400" rtl="0" eaLnBrk="1" fontAlgn="base" latinLnBrk="0" hangingPunct="0">
+              <a:t>{Responsibilities_project4}</a:t>
+            </a:r>
+          </a:p>
+          <a:p>
+            <a:pPr marL="0" marR="0" lvl="0" indent="0" algn="just" defTabSz="914400" rtl="0" eaLnBrk="1" fontAlgn="base" latinLnBrk="0" hangingPunct="0">
               <a:lnSpc>
                 <a:spcPct val="100000"/>
               </a:lnSpc>
@@ -7933,28 +7935,22 @@
               </a:spcAft>
               <a:buClrTx/>
               <a:buSzTx/>
-              <a:buFont typeface="Arial" panose="020B0604020202020204" pitchFamily="34" charset="0"/>
-              <a:buChar char="•"/>
+              <a:buFontTx/>
+              <a:buNone/>
               <a:tabLst/>
               <a:defRPr/>
             </a:pPr>
-            <a:r>
-              <a:rPr lang="en-US" sz="1500" b="0" i="0" u="none" strike="noStrike" kern="1200" cap="none" spc="0" normalizeH="0" baseline="0" noProof="0" dirty="0">
-                <a:ln>
-                  <a:noFill/>
-                </a:ln>
-                <a:effectLst/>
-                <a:uLnTx/>
-                <a:uFillTx/>
-                <a:latin typeface="Calibri"/>
-                <a:ea typeface="Calibri"/>
-                <a:cs typeface="Calibri"/>
-              </a:rPr>
-              <a:t>Validated features such as Network Discovery and integration with Microsoft DNS/DHCP.</a:t>
-            </a:r>
-          </a:p>
-          <a:p>
-            <a:pPr marL="285750" marR="0" lvl="0" indent="-285750" algn="just" defTabSz="914400" rtl="0" eaLnBrk="1" fontAlgn="base" latinLnBrk="0" hangingPunct="0">
+            <a:endParaRPr lang="en-US" sz="1600" dirty="0">
+              <a:solidFill>
+                <a:prstClr val="black"/>
+              </a:solidFill>
+              <a:latin typeface="Calibri" panose="020F0502020204030204" pitchFamily="34" charset="0"/>
+              <a:ea typeface="Calibri" panose="020F0502020204030204" pitchFamily="34" charset="0"/>
+              <a:cs typeface="Calibri" panose="020F0502020204030204" pitchFamily="34" charset="0"/>
+            </a:endParaRPr>
+          </a:p>
+          <a:p>
+            <a:pPr marL="0" marR="0" lvl="0" indent="0" algn="just" defTabSz="914400" rtl="0" eaLnBrk="1" fontAlgn="base" latinLnBrk="0" hangingPunct="0">
               <a:lnSpc>
                 <a:spcPct val="100000"/>
               </a:lnSpc>
@@ -7966,28 +7962,22 @@
               </a:spcAft>
               <a:buClrTx/>
               <a:buSzTx/>
-              <a:buFont typeface="Arial" panose="020B0604020202020204" pitchFamily="34" charset="0"/>
-              <a:buChar char="•"/>
+              <a:buFontTx/>
+              <a:buNone/>
               <a:tabLst/>
               <a:defRPr/>
             </a:pPr>
-            <a:r>
-              <a:rPr lang="en-US" sz="1500" b="0" i="0" u="none" strike="noStrike" kern="1200" cap="none" spc="0" normalizeH="0" baseline="0" noProof="0" dirty="0">
-                <a:ln>
-                  <a:noFill/>
-                </a:ln>
-                <a:effectLst/>
-                <a:uLnTx/>
-                <a:uFillTx/>
-                <a:latin typeface="Calibri"/>
-                <a:ea typeface="Calibri"/>
-                <a:cs typeface="Calibri"/>
-              </a:rPr>
-              <a:t>Logged and tracked defects in JIRA, ensuring prompt resolution.</a:t>
-            </a:r>
-          </a:p>
-          <a:p>
-            <a:pPr marL="285750" marR="0" lvl="0" indent="-285750" algn="just" defTabSz="914400" rtl="0" eaLnBrk="1" fontAlgn="base" latinLnBrk="0" hangingPunct="0">
+            <a:endParaRPr lang="en-US" sz="1600" dirty="0">
+              <a:solidFill>
+                <a:prstClr val="black"/>
+              </a:solidFill>
+              <a:latin typeface="Calibri" panose="020F0502020204030204" pitchFamily="34" charset="0"/>
+              <a:ea typeface="Calibri" panose="020F0502020204030204" pitchFamily="34" charset="0"/>
+              <a:cs typeface="Calibri" panose="020F0502020204030204" pitchFamily="34" charset="0"/>
+            </a:endParaRPr>
+          </a:p>
+          <a:p>
+            <a:pPr marL="0" marR="0" lvl="0" indent="0" algn="just" defTabSz="914400" rtl="0" eaLnBrk="1" fontAlgn="base" latinLnBrk="0" hangingPunct="0">
               <a:lnSpc>
                 <a:spcPct val="100000"/>
               </a:lnSpc>
@@ -7999,28 +7989,22 @@
               </a:spcAft>
               <a:buClrTx/>
               <a:buSzTx/>
-              <a:buFont typeface="Arial" panose="020B0604020202020204" pitchFamily="34" charset="0"/>
-              <a:buChar char="•"/>
+              <a:buFontTx/>
+              <a:buNone/>
               <a:tabLst/>
               <a:defRPr/>
             </a:pPr>
-            <a:r>
-              <a:rPr lang="en-US" sz="1500" b="0" i="0" u="none" strike="noStrike" kern="1200" cap="none" spc="0" normalizeH="0" baseline="0" noProof="0" dirty="0">
-                <a:ln>
-                  <a:noFill/>
-                </a:ln>
-                <a:effectLst/>
-                <a:uLnTx/>
-                <a:uFillTx/>
-                <a:latin typeface="Calibri"/>
-                <a:ea typeface="Calibri"/>
-                <a:cs typeface="Calibri"/>
-              </a:rPr>
-              <a:t>Executed tests in Linux environments for feature validation and defect verification.</a:t>
-            </a:r>
-          </a:p>
-          <a:p>
-            <a:pPr marL="285750" marR="0" lvl="0" indent="-285750" algn="just" defTabSz="914400" rtl="0" eaLnBrk="1" fontAlgn="base" latinLnBrk="0" hangingPunct="0">
+            <a:endParaRPr lang="en-US" sz="1600" dirty="0">
+              <a:solidFill>
+                <a:prstClr val="black"/>
+              </a:solidFill>
+              <a:latin typeface="Calibri" panose="020F0502020204030204" pitchFamily="34" charset="0"/>
+              <a:ea typeface="Calibri" panose="020F0502020204030204" pitchFamily="34" charset="0"/>
+              <a:cs typeface="Calibri" panose="020F0502020204030204" pitchFamily="34" charset="0"/>
+            </a:endParaRPr>
+          </a:p>
+          <a:p>
+            <a:pPr marL="0" marR="0" lvl="0" indent="0" algn="just" defTabSz="914400" rtl="0" eaLnBrk="1" fontAlgn="base" latinLnBrk="0" hangingPunct="0">
               <a:lnSpc>
                 <a:spcPct val="100000"/>
               </a:lnSpc>
@@ -8032,42 +8016,22 @@
               </a:spcAft>
               <a:buClrTx/>
               <a:buSzTx/>
-              <a:buFont typeface="Arial" panose="020B0604020202020204" pitchFamily="34" charset="0"/>
-              <a:buChar char="•"/>
+              <a:buFontTx/>
+              <a:buNone/>
               <a:tabLst/>
               <a:defRPr/>
             </a:pPr>
-            <a:r>
-              <a:rPr lang="en-US" sz="1500" b="0" i="0" u="none" strike="noStrike" kern="1200" cap="none" spc="0" normalizeH="0" baseline="0" noProof="0" dirty="0" err="1">
-                <a:ln>
-                  <a:noFill/>
-                </a:ln>
-                <a:effectLst/>
-                <a:uLnTx/>
-                <a:uFillTx/>
-                <a:latin typeface="Calibri"/>
-                <a:ea typeface="Calibri"/>
-                <a:cs typeface="Calibri"/>
-              </a:rPr>
-              <a:t>Analysed</a:t>
-            </a:r>
-            <a:r>
-              <a:rPr lang="en-US" sz="1500" b="0" i="0" u="none" strike="noStrike" kern="1200" cap="none" spc="0" normalizeH="0" baseline="0" noProof="0" dirty="0">
-                <a:ln>
-                  <a:noFill/>
-                </a:ln>
-                <a:effectLst/>
-                <a:uLnTx/>
-                <a:uFillTx/>
-                <a:latin typeface="Calibri"/>
-                <a:ea typeface="Calibri"/>
-                <a:cs typeface="Calibri"/>
-              </a:rPr>
-              <a:t> user stories and implemented functionality in alignment with story points.</a:t>
-            </a:r>
-          </a:p>
-          <a:p>
-            <a:pPr marL="285750" marR="0" lvl="0" indent="-285750" algn="just" defTabSz="914400" rtl="0" eaLnBrk="1" fontAlgn="base" latinLnBrk="0" hangingPunct="0">
+            <a:endParaRPr lang="en-US" sz="1600" dirty="0">
+              <a:solidFill>
+                <a:prstClr val="black"/>
+              </a:solidFill>
+              <a:latin typeface="Calibri" panose="020F0502020204030204" pitchFamily="34" charset="0"/>
+              <a:ea typeface="Calibri" panose="020F0502020204030204" pitchFamily="34" charset="0"/>
+              <a:cs typeface="Calibri" panose="020F0502020204030204" pitchFamily="34" charset="0"/>
+            </a:endParaRPr>
+          </a:p>
+          <a:p>
+            <a:pPr marL="0" marR="0" lvl="0" indent="0" algn="just" defTabSz="914400" rtl="0" eaLnBrk="1" fontAlgn="base" latinLnBrk="0" hangingPunct="0">
               <a:lnSpc>
                 <a:spcPct val="100000"/>
               </a:lnSpc>
@@ -8079,56 +8043,22 @@
               </a:spcAft>
               <a:buClrTx/>
               <a:buSzTx/>
-              <a:buFont typeface="Arial" panose="020B0604020202020204" pitchFamily="34" charset="0"/>
-              <a:buChar char="•"/>
+              <a:buFontTx/>
+              <a:buNone/>
               <a:tabLst/>
               <a:defRPr/>
             </a:pPr>
-            <a:r>
-              <a:rPr lang="en-US" sz="1500" b="0" i="0" u="none" strike="noStrike" kern="1200" cap="none" spc="0" normalizeH="0" baseline="0" noProof="0" dirty="0">
-                <a:ln>
-                  <a:noFill/>
-                </a:ln>
-                <a:effectLst/>
-                <a:uLnTx/>
-                <a:uFillTx/>
-                <a:latin typeface="Calibri"/>
-                <a:ea typeface="Calibri"/>
-                <a:cs typeface="Calibri"/>
-              </a:rPr>
-              <a:t>Designed and executed automation scripts using Selenium WebDriver, </a:t>
-            </a:r>
-            <a:r>
-              <a:rPr lang="en-US" sz="1500" b="0" i="0" u="none" strike="noStrike" kern="1200" cap="none" spc="0" normalizeH="0" baseline="0" noProof="0" dirty="0" err="1">
-                <a:ln>
-                  <a:noFill/>
-                </a:ln>
-                <a:effectLst/>
-                <a:uLnTx/>
-                <a:uFillTx/>
-                <a:latin typeface="Calibri"/>
-                <a:ea typeface="Calibri"/>
-                <a:cs typeface="Calibri"/>
-              </a:rPr>
-              <a:t>Pytest</a:t>
-            </a:r>
-            <a:r>
-              <a:rPr lang="en-US" sz="1500" b="0" i="0" u="none" strike="noStrike" kern="1200" cap="none" spc="0" normalizeH="0" baseline="0" noProof="0" dirty="0">
-                <a:ln>
-                  <a:noFill/>
-                </a:ln>
-                <a:effectLst/>
-                <a:uLnTx/>
-                <a:uFillTx/>
-                <a:latin typeface="Calibri"/>
-                <a:ea typeface="Calibri"/>
-                <a:cs typeface="Calibri"/>
-              </a:rPr>
-              <a:t>, and Python, following a Hybrid Framework with Data-Driven and Page Object Model (POM) approaches.</a:t>
-            </a:r>
-          </a:p>
-          <a:p>
-            <a:pPr marL="285750" marR="0" lvl="0" indent="-285750" algn="just" defTabSz="914400" rtl="0" eaLnBrk="1" fontAlgn="base" latinLnBrk="0" hangingPunct="0">
+            <a:endParaRPr lang="en-US" sz="1600" dirty="0">
+              <a:solidFill>
+                <a:prstClr val="black"/>
+              </a:solidFill>
+              <a:latin typeface="Calibri" panose="020F0502020204030204" pitchFamily="34" charset="0"/>
+              <a:ea typeface="Calibri" panose="020F0502020204030204" pitchFamily="34" charset="0"/>
+              <a:cs typeface="Calibri" panose="020F0502020204030204" pitchFamily="34" charset="0"/>
+            </a:endParaRPr>
+          </a:p>
+          <a:p>
+            <a:pPr marL="0" marR="0" lvl="0" indent="0" algn="just" defTabSz="914400" rtl="0" eaLnBrk="1" fontAlgn="base" latinLnBrk="0" hangingPunct="0">
               <a:lnSpc>
                 <a:spcPct val="100000"/>
               </a:lnSpc>
@@ -8140,28 +8070,22 @@
               </a:spcAft>
               <a:buClrTx/>
               <a:buSzTx/>
-              <a:buFont typeface="Arial" panose="020B0604020202020204" pitchFamily="34" charset="0"/>
-              <a:buChar char="•"/>
+              <a:buFontTx/>
+              <a:buNone/>
               <a:tabLst/>
               <a:defRPr/>
             </a:pPr>
-            <a:r>
-              <a:rPr lang="en-US" sz="1500" b="0" i="0" u="none" strike="noStrike" kern="1200" cap="none" spc="0" normalizeH="0" baseline="0" noProof="0" dirty="0">
-                <a:ln>
-                  <a:noFill/>
-                </a:ln>
-                <a:effectLst/>
-                <a:uLnTx/>
-                <a:uFillTx/>
-                <a:latin typeface="Calibri"/>
-                <a:ea typeface="Calibri"/>
-                <a:cs typeface="Calibri"/>
-              </a:rPr>
-              <a:t>Conducted failure analysis for regression test results and prepared detailed reports.</a:t>
-            </a:r>
-          </a:p>
-          <a:p>
-            <a:pPr marL="285750" marR="0" lvl="0" indent="-285750" algn="just" defTabSz="914400" rtl="0" eaLnBrk="1" fontAlgn="base" latinLnBrk="0" hangingPunct="0">
+            <a:endParaRPr lang="en-US" sz="1600" dirty="0">
+              <a:solidFill>
+                <a:prstClr val="black"/>
+              </a:solidFill>
+              <a:latin typeface="Calibri" panose="020F0502020204030204" pitchFamily="34" charset="0"/>
+              <a:ea typeface="Calibri" panose="020F0502020204030204" pitchFamily="34" charset="0"/>
+              <a:cs typeface="Calibri" panose="020F0502020204030204" pitchFamily="34" charset="0"/>
+            </a:endParaRPr>
+          </a:p>
+          <a:p>
+            <a:pPr marL="0" marR="0" lvl="0" indent="0" algn="just" defTabSz="914400" rtl="0" eaLnBrk="1" fontAlgn="base" latinLnBrk="0" hangingPunct="0">
               <a:lnSpc>
                 <a:spcPct val="100000"/>
               </a:lnSpc>
@@ -8173,157 +8097,19 @@
               </a:spcAft>
               <a:buClrTx/>
               <a:buSzTx/>
-              <a:buFont typeface="Arial" panose="020B0604020202020204" pitchFamily="34" charset="0"/>
-              <a:buChar char="•"/>
+              <a:buFontTx/>
+              <a:buNone/>
               <a:tabLst/>
               <a:defRPr/>
             </a:pPr>
-            <a:r>
-              <a:rPr lang="en-US" sz="1500" b="0" i="0" u="none" strike="noStrike" kern="1200" cap="none" spc="0" normalizeH="0" baseline="0" noProof="0" dirty="0">
-                <a:ln>
-                  <a:noFill/>
-                </a:ln>
-                <a:effectLst/>
-                <a:uLnTx/>
-                <a:uFillTx/>
-                <a:latin typeface="Calibri"/>
-                <a:ea typeface="Calibri"/>
-                <a:cs typeface="Calibri"/>
-              </a:rPr>
-              <a:t>Reported, tracked, and verified defects in JIRA, coordinating closely with the development team.</a:t>
-            </a:r>
-          </a:p>
-          <a:p>
-            <a:pPr marL="285750" marR="0" lvl="0" indent="-285750" algn="just" defTabSz="914400" rtl="0" eaLnBrk="1" fontAlgn="base" latinLnBrk="0" hangingPunct="0">
-              <a:lnSpc>
-                <a:spcPct val="100000"/>
-              </a:lnSpc>
-              <a:spcBef>
-                <a:spcPts val="0"/>
-              </a:spcBef>
-              <a:spcAft>
-                <a:spcPts val="0"/>
-              </a:spcAft>
-              <a:buClrTx/>
-              <a:buSzTx/>
-              <a:buFont typeface="Arial" panose="020B0604020202020204" pitchFamily="34" charset="0"/>
-              <a:buChar char="•"/>
-              <a:tabLst/>
-              <a:defRPr/>
-            </a:pPr>
-            <a:r>
-              <a:rPr lang="en-US" sz="1500" b="0" i="0" u="none" strike="noStrike" kern="1200" cap="none" spc="0" normalizeH="0" baseline="0" noProof="0" dirty="0">
-                <a:ln>
-                  <a:noFill/>
-                </a:ln>
-                <a:effectLst/>
-                <a:uLnTx/>
-                <a:uFillTx/>
-                <a:latin typeface="Calibri"/>
-                <a:ea typeface="Calibri"/>
-                <a:cs typeface="Calibri"/>
-              </a:rPr>
-              <a:t>Executed batch test runs in Jenkins and communicated results to management.</a:t>
-            </a:r>
-          </a:p>
-          <a:p>
-            <a:pPr marL="285750" marR="0" lvl="0" indent="-285750" algn="just" defTabSz="914400" rtl="0" eaLnBrk="1" fontAlgn="base" latinLnBrk="0" hangingPunct="0">
-              <a:lnSpc>
-                <a:spcPct val="100000"/>
-              </a:lnSpc>
-              <a:spcBef>
-                <a:spcPts val="0"/>
-              </a:spcBef>
-              <a:spcAft>
-                <a:spcPts val="0"/>
-              </a:spcAft>
-              <a:buClrTx/>
-              <a:buSzTx/>
-              <a:buFont typeface="Arial" panose="020B0604020202020204" pitchFamily="34" charset="0"/>
-              <a:buChar char="•"/>
-              <a:tabLst/>
-              <a:defRPr/>
-            </a:pPr>
-            <a:r>
-              <a:rPr lang="en-US" sz="1500" b="0" i="0" u="none" strike="noStrike" kern="1200" cap="none" spc="0" normalizeH="0" baseline="0" noProof="0" dirty="0">
-                <a:ln>
-                  <a:noFill/>
-                </a:ln>
-                <a:effectLst/>
-                <a:uLnTx/>
-                <a:uFillTx/>
-                <a:latin typeface="Calibri"/>
-                <a:ea typeface="Calibri"/>
-                <a:cs typeface="Calibri"/>
-              </a:rPr>
-              <a:t>Collaborated with developers and stakeholders to clarify requirements for testability, consistency, and completeness.</a:t>
-            </a:r>
-          </a:p>
-          <a:p>
-            <a:pPr marL="285750" marR="0" lvl="0" indent="-285750" algn="just" defTabSz="914400" rtl="0" eaLnBrk="1" fontAlgn="base" latinLnBrk="0" hangingPunct="0">
-              <a:lnSpc>
-                <a:spcPct val="100000"/>
-              </a:lnSpc>
-              <a:spcBef>
-                <a:spcPts val="0"/>
-              </a:spcBef>
-              <a:spcAft>
-                <a:spcPts val="0"/>
-              </a:spcAft>
-              <a:buClrTx/>
-              <a:buSzTx/>
-              <a:buFont typeface="Arial" panose="020B0604020202020204" pitchFamily="34" charset="0"/>
-              <a:buChar char="•"/>
-              <a:tabLst/>
-              <a:defRPr/>
-            </a:pPr>
-            <a:r>
-              <a:rPr lang="en-US" sz="1500" b="0" i="0" u="none" strike="noStrike" kern="1200" cap="none" spc="0" normalizeH="0" baseline="0" noProof="0" dirty="0">
-                <a:ln>
-                  <a:noFill/>
-                </a:ln>
-                <a:effectLst/>
-                <a:uLnTx/>
-                <a:uFillTx/>
-                <a:latin typeface="Calibri"/>
-                <a:ea typeface="Calibri"/>
-                <a:cs typeface="Calibri"/>
-              </a:rPr>
-              <a:t>Actively participated in Agile ceremonies including daily stand-up’s, story grooming,</a:t>
-            </a:r>
-          </a:p>
-          <a:p>
-            <a:pPr marL="285750" marR="0" lvl="0" indent="-285750" algn="just" defTabSz="914400" rtl="0" eaLnBrk="1" fontAlgn="base" latinLnBrk="0" hangingPunct="0">
-              <a:lnSpc>
-                <a:spcPct val="100000"/>
-              </a:lnSpc>
-              <a:spcBef>
-                <a:spcPts val="0"/>
-              </a:spcBef>
-              <a:spcAft>
-                <a:spcPts val="0"/>
-              </a:spcAft>
-              <a:buClrTx/>
-              <a:buSzTx/>
-              <a:buFont typeface="Arial" panose="020B0604020202020204" pitchFamily="34" charset="0"/>
-              <a:buChar char="•"/>
-              <a:tabLst/>
-              <a:defRPr/>
-            </a:pPr>
-            <a:r>
-              <a:rPr lang="en-US" sz="1500" b="0" i="0" u="none" strike="noStrike" kern="1200" cap="none" spc="0" normalizeH="0" baseline="0" noProof="0" dirty="0">
-                <a:ln>
-                  <a:noFill/>
-                </a:ln>
-                <a:effectLst/>
-                <a:uLnTx/>
-                <a:uFillTx/>
-                <a:latin typeface="Calibri"/>
-                <a:ea typeface="Calibri"/>
-                <a:cs typeface="Calibri"/>
-              </a:rPr>
-              <a:t>retrospectives, and process improvement initiatives.</a:t>
-            </a:r>
+            <a:endParaRPr lang="en-US" sz="1600" dirty="0">
+              <a:solidFill>
+                <a:prstClr val="black"/>
+              </a:solidFill>
+              <a:latin typeface="Calibri" panose="020F0502020204030204" pitchFamily="34" charset="0"/>
+              <a:ea typeface="Calibri" panose="020F0502020204030204" pitchFamily="34" charset="0"/>
+              <a:cs typeface="Calibri" panose="020F0502020204030204" pitchFamily="34" charset="0"/>
+            </a:endParaRPr>
           </a:p>
         </p:txBody>
       </p:sp>
@@ -8332,7 +8118,7 @@
           <p:cNvPr id="12" name="TextBox 11">
             <a:extLst>
               <a:ext uri="{FF2B5EF4-FFF2-40B4-BE49-F238E27FC236}">
-                <a16:creationId xmlns:a16="http://schemas.microsoft.com/office/drawing/2014/main" id="{19720054-5A3B-212F-B9D3-BD19B3C4FC12}"/>
+                <a16:creationId xmlns:a16="http://schemas.microsoft.com/office/drawing/2014/main" id="{EC4B05AF-5824-1070-33D3-B60F3671B346}"/>
               </a:ext>
             </a:extLst>
           </p:cNvPr>
@@ -8341,8 +8127,8 @@
         </p:nvSpPr>
         <p:spPr>
           <a:xfrm>
-            <a:off x="304800" y="1588014"/>
-            <a:ext cx="1216167" cy="338554"/>
+            <a:off x="304800" y="1712950"/>
+            <a:ext cx="1470274" cy="369332"/>
           </a:xfrm>
           <a:prstGeom prst="rect">
             <a:avLst/>
@@ -8373,21 +8159,12 @@
               <a:defRPr/>
             </a:pPr>
             <a:r>
-              <a:rPr kumimoji="0" lang="en-US" sz="1600" b="1" i="0" u="none" strike="noStrike" kern="1200" cap="none" spc="0" normalizeH="0" baseline="0" noProof="0" dirty="0">
-                <a:ln>
-                  <a:noFill/>
-                </a:ln>
-                <a:solidFill>
-                  <a:srgbClr val="002060"/>
-                </a:solidFill>
-                <a:effectLst/>
-                <a:uLnTx/>
-                <a:uFillTx/>
-                <a:latin typeface="Calibri"/>
-                <a:ea typeface="Calibri"/>
-                <a:cs typeface="Calibri"/>
-              </a:rPr>
+              <a:rPr lang="en-US" b="1" dirty="0"/>
               <a:t>D</a:t>
+            </a:r>
+            <a:r>
+              <a:rPr lang="en-IN" b="1" dirty="0"/>
+              <a:t>escription</a:t>
             </a:r>
             <a:r>
               <a:rPr kumimoji="0" lang="en-IN" sz="1600" b="1" i="0" u="none" strike="noStrike" kern="1200" cap="none" spc="0" normalizeH="0" baseline="0" noProof="0" dirty="0">
@@ -8404,7 +8181,7 @@
                 <a:ea typeface="Calibri"/>
                 <a:cs typeface="Calibri"/>
               </a:rPr>
-              <a:t>escription:</a:t>
+              <a:t>:</a:t>
             </a:r>
           </a:p>
         </p:txBody>
@@ -8414,7 +8191,7 @@
           <p:cNvPr id="14" name="TextBox 13">
             <a:extLst>
               <a:ext uri="{FF2B5EF4-FFF2-40B4-BE49-F238E27FC236}">
-                <a16:creationId xmlns:a16="http://schemas.microsoft.com/office/drawing/2014/main" id="{CB36D734-3700-F0BC-46F5-7626E61D151F}"/>
+                <a16:creationId xmlns:a16="http://schemas.microsoft.com/office/drawing/2014/main" id="{E089050A-F255-FD90-6361-53F439F04326}"/>
               </a:ext>
             </a:extLst>
           </p:cNvPr>
@@ -8432,7 +8209,7 @@
           <a:noFill/>
         </p:spPr>
         <p:txBody>
-          <a:bodyPr wrap="square" lIns="91440" tIns="45720" rIns="91440" bIns="45720" anchor="t">
+          <a:bodyPr wrap="square">
             <a:spAutoFit/>
           </a:bodyPr>
           <a:lstStyle/>
@@ -8455,7 +8232,7 @@
               <a:defRPr/>
             </a:pPr>
             <a:r>
-              <a:rPr kumimoji="0" lang="en-US" b="1" i="0" u="none" strike="noStrike" kern="1200" cap="none" spc="0" normalizeH="0" baseline="0" noProof="0">
+              <a:rPr kumimoji="0" lang="en-US" b="1" i="0" u="none" strike="noStrike" kern="1200" cap="none" spc="0" normalizeH="0" baseline="0" noProof="0" dirty="0">
                 <a:ln>
                   <a:noFill/>
                 </a:ln>
@@ -8469,20 +8246,9 @@
                 <a:ea typeface="Calibri"/>
                 <a:cs typeface="Calibri"/>
               </a:rPr>
-              <a:t>Project </a:t>
-            </a:r>
-            <a:r>
-              <a:rPr lang="en-US" b="1">
-                <a:solidFill>
-                  <a:srgbClr val="002060"/>
-                </a:solidFill>
-                <a:latin typeface="Calibri"/>
-                <a:ea typeface="Calibri"/>
-                <a:cs typeface="Calibri"/>
-              </a:rPr>
-              <a:t>4</a:t>
-            </a:r>
-            <a:endParaRPr kumimoji="0" lang="en-US" b="0" i="0" u="none" strike="noStrike" kern="1200" cap="none" spc="0" normalizeH="0" baseline="0" noProof="0">
+              <a:t>Project 4</a:t>
+            </a:r>
+            <a:endParaRPr kumimoji="0" lang="en-US" b="0" i="0" u="none" strike="noStrike" kern="1200" cap="none" spc="0" normalizeH="0" baseline="0" noProof="0" dirty="0">
               <a:ln>
                 <a:noFill/>
               </a:ln>
@@ -8501,10 +8267,10 @@
       </p:sp>
       <p:pic>
         <p:nvPicPr>
-          <p:cNvPr id="10" name="Picture 9">
-            <a:extLst>
-              <a:ext uri="{FF2B5EF4-FFF2-40B4-BE49-F238E27FC236}">
-                <a16:creationId xmlns:a16="http://schemas.microsoft.com/office/drawing/2014/main" id="{75977308-28D1-4B39-8C9C-977D2A6A28DD}"/>
+          <p:cNvPr id="3" name="Picture 2">
+            <a:extLst>
+              <a:ext uri="{FF2B5EF4-FFF2-40B4-BE49-F238E27FC236}">
+                <a16:creationId xmlns:a16="http://schemas.microsoft.com/office/drawing/2014/main" id="{6DF6DC0A-A01D-A51B-4BE2-9C419BBD790F}"/>
               </a:ext>
             </a:extLst>
           </p:cNvPr>
@@ -8523,7 +8289,7 @@
         </p:blipFill>
         <p:spPr>
           <a:xfrm>
-            <a:off x="9973070" y="136525"/>
+            <a:off x="9993086" y="75293"/>
             <a:ext cx="2066530" cy="587639"/>
           </a:xfrm>
           <a:prstGeom prst="rect">
@@ -8537,7 +8303,7 @@
     </p:spTree>
     <p:extLst>
       <p:ext uri="{BB962C8B-B14F-4D97-AF65-F5344CB8AC3E}">
-        <p14:creationId xmlns:p14="http://schemas.microsoft.com/office/powerpoint/2010/main" val="88817511"/>
+        <p14:creationId xmlns:p14="http://schemas.microsoft.com/office/powerpoint/2010/main" val="119268449"/>
       </p:ext>
     </p:extLst>
   </p:cSld>

</xml_diff>

<commit_message>
Login to Microsoft Account Fixed.
</commit_message>
<xml_diff>
--- a/templates/sample_ppt_template.pptx
+++ b/templates/sample_ppt_template.pptx
@@ -10,9 +10,9 @@
   <p:sldIdLst>
     <p:sldId id="263" r:id="rId2"/>
     <p:sldId id="270" r:id="rId3"/>
-    <p:sldId id="281" r:id="rId4"/>
-    <p:sldId id="282" r:id="rId5"/>
-    <p:sldId id="283" r:id="rId6"/>
+    <p:sldId id="279" r:id="rId4"/>
+    <p:sldId id="280" r:id="rId5"/>
+    <p:sldId id="278" r:id="rId6"/>
   </p:sldIdLst>
   <p:sldSz cx="12192000" cy="6858000"/>
   <p:notesSz cx="6858000" cy="9144000"/>
@@ -122,51 +122,59 @@
 <file path=ppt/changesInfos/changesInfo1.xml><?xml version="1.0" encoding="utf-8"?>
 <pc:chgInfo xmlns:a="http://schemas.openxmlformats.org/drawingml/2006/main" xmlns:r="http://schemas.openxmlformats.org/officeDocument/2006/relationships" xmlns:ac="http://schemas.microsoft.com/office/drawing/2013/main/command" xmlns:pc="http://schemas.microsoft.com/office/powerpoint/2013/main/command">
   <pc:docChgLst>
-    <pc:chgData name="jennis rufina" userId="82f03a850a9f00a2" providerId="LiveId" clId="{FAA1ECB5-B8B8-4660-8381-16C5214360E0}"/>
-    <pc:docChg chg="modSld">
-      <pc:chgData name="jennis rufina" userId="82f03a850a9f00a2" providerId="LiveId" clId="{FAA1ECB5-B8B8-4660-8381-16C5214360E0}" dt="2026-03-10T10:44:36.489" v="284" actId="20577"/>
+    <pc:chgData name="Swetha  Akkala" userId="29270fab-d501-4f7b-a920-3b1278439804" providerId="ADAL" clId="{17097428-0DAC-400A-9866-F07FECCE981B}"/>
+    <pc:docChg chg="undo custSel modSld">
+      <pc:chgData name="Swetha  Akkala" userId="29270fab-d501-4f7b-a920-3b1278439804" providerId="ADAL" clId="{17097428-0DAC-400A-9866-F07FECCE981B}" dt="2026-02-11T15:06:05.758" v="84" actId="208"/>
       <pc:docMkLst>
         <pc:docMk/>
       </pc:docMkLst>
       <pc:sldChg chg="modSp mod">
-        <pc:chgData name="jennis rufina" userId="82f03a850a9f00a2" providerId="LiveId" clId="{FAA1ECB5-B8B8-4660-8381-16C5214360E0}" dt="2026-03-10T10:43:21.274" v="254" actId="20577"/>
+        <pc:chgData name="Swetha  Akkala" userId="29270fab-d501-4f7b-a920-3b1278439804" providerId="ADAL" clId="{17097428-0DAC-400A-9866-F07FECCE981B}" dt="2026-02-11T15:06:05.758" v="84" actId="208"/>
         <pc:sldMkLst>
           <pc:docMk/>
           <pc:sldMk cId="2663611645" sldId="263"/>
         </pc:sldMkLst>
         <pc:spChg chg="mod">
-          <ac:chgData name="jennis rufina" userId="82f03a850a9f00a2" providerId="LiveId" clId="{FAA1ECB5-B8B8-4660-8381-16C5214360E0}" dt="2026-03-10T10:43:21.274" v="254" actId="20577"/>
+          <ac:chgData name="Swetha  Akkala" userId="29270fab-d501-4f7b-a920-3b1278439804" providerId="ADAL" clId="{17097428-0DAC-400A-9866-F07FECCE981B}" dt="2026-02-11T15:06:05.758" v="84" actId="208"/>
           <ac:spMkLst>
             <pc:docMk/>
             <pc:sldMk cId="2663611645" sldId="263"/>
-            <ac:spMk id="2" creationId="{F4D74AF3-3042-C613-21D4-BDECAE090733}"/>
+            <ac:spMk id="5" creationId="{00000000-0000-0000-0000-000000000000}"/>
           </ac:spMkLst>
         </pc:spChg>
         <pc:spChg chg="mod">
-          <ac:chgData name="jennis rufina" userId="82f03a850a9f00a2" providerId="LiveId" clId="{FAA1ECB5-B8B8-4660-8381-16C5214360E0}" dt="2026-03-10T10:43:15.498" v="247" actId="20577"/>
+          <ac:chgData name="Swetha  Akkala" userId="29270fab-d501-4f7b-a920-3b1278439804" providerId="ADAL" clId="{17097428-0DAC-400A-9866-F07FECCE981B}" dt="2026-02-11T15:06:05.758" v="84" actId="208"/>
           <ac:spMkLst>
             <pc:docMk/>
             <pc:sldMk cId="2663611645" sldId="263"/>
             <ac:spMk id="7" creationId="{DFFA6C3A-1489-8B4F-A83F-028609D5F052}"/>
           </ac:spMkLst>
         </pc:spChg>
+        <pc:spChg chg="mod">
+          <ac:chgData name="Swetha  Akkala" userId="29270fab-d501-4f7b-a920-3b1278439804" providerId="ADAL" clId="{17097428-0DAC-400A-9866-F07FECCE981B}" dt="2026-02-11T15:06:05.758" v="84" actId="208"/>
+          <ac:spMkLst>
+            <pc:docMk/>
+            <pc:sldMk cId="2663611645" sldId="263"/>
+            <ac:spMk id="10" creationId="{120A1E06-2121-84D8-8A75-138438476A5A}"/>
+          </ac:spMkLst>
+        </pc:spChg>
+        <pc:spChg chg="mod">
+          <ac:chgData name="Swetha  Akkala" userId="29270fab-d501-4f7b-a920-3b1278439804" providerId="ADAL" clId="{17097428-0DAC-400A-9866-F07FECCE981B}" dt="2026-02-11T15:06:05.758" v="84" actId="208"/>
+          <ac:spMkLst>
+            <pc:docMk/>
+            <pc:sldMk cId="2663611645" sldId="263"/>
+            <ac:spMk id="16" creationId="{F4243315-F4CA-C185-99AF-A0AEEDA89C38}"/>
+          </ac:spMkLst>
+        </pc:spChg>
       </pc:sldChg>
       <pc:sldChg chg="modSp mod">
-        <pc:chgData name="jennis rufina" userId="82f03a850a9f00a2" providerId="LiveId" clId="{FAA1ECB5-B8B8-4660-8381-16C5214360E0}" dt="2026-02-25T08:07:54.699" v="42" actId="20577"/>
+        <pc:chgData name="Swetha  Akkala" userId="29270fab-d501-4f7b-a920-3b1278439804" providerId="ADAL" clId="{17097428-0DAC-400A-9866-F07FECCE981B}" dt="2026-02-11T15:00:41.857" v="75" actId="108"/>
         <pc:sldMkLst>
           <pc:docMk/>
           <pc:sldMk cId="4121649048" sldId="270"/>
         </pc:sldMkLst>
         <pc:spChg chg="mod">
-          <ac:chgData name="jennis rufina" userId="82f03a850a9f00a2" providerId="LiveId" clId="{FAA1ECB5-B8B8-4660-8381-16C5214360E0}" dt="2026-02-25T08:07:39.331" v="32" actId="20577"/>
-          <ac:spMkLst>
-            <pc:docMk/>
-            <pc:sldMk cId="4121649048" sldId="270"/>
-            <ac:spMk id="7" creationId="{CBC7D05A-9F91-615D-CE48-576F37B0F8CA}"/>
-          </ac:spMkLst>
-        </pc:spChg>
-        <pc:spChg chg="mod">
-          <ac:chgData name="jennis rufina" userId="82f03a850a9f00a2" providerId="LiveId" clId="{FAA1ECB5-B8B8-4660-8381-16C5214360E0}" dt="2026-02-25T08:07:54.699" v="42" actId="20577"/>
+          <ac:chgData name="Swetha  Akkala" userId="29270fab-d501-4f7b-a920-3b1278439804" providerId="ADAL" clId="{17097428-0DAC-400A-9866-F07FECCE981B}" dt="2026-02-11T15:00:41.857" v="75" actId="108"/>
           <ac:spMkLst>
             <pc:docMk/>
             <pc:sldMk cId="4121649048" sldId="270"/>
@@ -175,71 +183,168 @@
         </pc:spChg>
       </pc:sldChg>
       <pc:sldChg chg="modSp mod">
-        <pc:chgData name="jennis rufina" userId="82f03a850a9f00a2" providerId="LiveId" clId="{FAA1ECB5-B8B8-4660-8381-16C5214360E0}" dt="2026-03-10T10:44:36.489" v="284" actId="20577"/>
+        <pc:chgData name="Swetha  Akkala" userId="29270fab-d501-4f7b-a920-3b1278439804" providerId="ADAL" clId="{17097428-0DAC-400A-9866-F07FECCE981B}" dt="2026-02-11T14:59:39.496" v="66" actId="20577"/>
         <pc:sldMkLst>
           <pc:docMk/>
-          <pc:sldMk cId="2821146086" sldId="281"/>
+          <pc:sldMk cId="648717608" sldId="271"/>
         </pc:sldMkLst>
         <pc:spChg chg="mod">
-          <ac:chgData name="jennis rufina" userId="82f03a850a9f00a2" providerId="LiveId" clId="{FAA1ECB5-B8B8-4660-8381-16C5214360E0}" dt="2026-03-10T10:44:36.489" v="284" actId="20577"/>
+          <ac:chgData name="Swetha  Akkala" userId="29270fab-d501-4f7b-a920-3b1278439804" providerId="ADAL" clId="{17097428-0DAC-400A-9866-F07FECCE981B}" dt="2026-02-11T14:59:39.496" v="66" actId="20577"/>
           <ac:spMkLst>
             <pc:docMk/>
-            <pc:sldMk cId="2821146086" sldId="281"/>
-            <ac:spMk id="7" creationId="{281E5FE1-4888-CBDF-0DD5-A41BA5FEEA8D}"/>
-          </ac:spMkLst>
-        </pc:spChg>
-        <pc:spChg chg="mod">
-          <ac:chgData name="jennis rufina" userId="82f03a850a9f00a2" providerId="LiveId" clId="{FAA1ECB5-B8B8-4660-8381-16C5214360E0}" dt="2026-02-25T08:08:28.423" v="73" actId="20577"/>
-          <ac:spMkLst>
-            <pc:docMk/>
-            <pc:sldMk cId="2821146086" sldId="281"/>
-            <ac:spMk id="11" creationId="{901A2AF5-92CA-8F25-88FA-D406713C067E}"/>
+            <pc:sldMk cId="648717608" sldId="271"/>
+            <ac:spMk id="11" creationId="{D8323F5C-39A1-9D33-A961-82D37EBD9A6B}"/>
           </ac:spMkLst>
         </pc:spChg>
       </pc:sldChg>
       <pc:sldChg chg="modSp mod">
-        <pc:chgData name="jennis rufina" userId="82f03a850a9f00a2" providerId="LiveId" clId="{FAA1ECB5-B8B8-4660-8381-16C5214360E0}" dt="2026-02-25T08:09:04.057" v="104" actId="20577"/>
+        <pc:chgData name="Swetha  Akkala" userId="29270fab-d501-4f7b-a920-3b1278439804" providerId="ADAL" clId="{17097428-0DAC-400A-9866-F07FECCE981B}" dt="2026-02-11T14:59:56.105" v="70" actId="6549"/>
         <pc:sldMkLst>
           <pc:docMk/>
-          <pc:sldMk cId="2262051643" sldId="282"/>
+          <pc:sldMk cId="805950796" sldId="272"/>
         </pc:sldMkLst>
         <pc:spChg chg="mod">
-          <ac:chgData name="jennis rufina" userId="82f03a850a9f00a2" providerId="LiveId" clId="{FAA1ECB5-B8B8-4660-8381-16C5214360E0}" dt="2026-02-25T08:08:51.255" v="94" actId="20577"/>
+          <ac:chgData name="Swetha  Akkala" userId="29270fab-d501-4f7b-a920-3b1278439804" providerId="ADAL" clId="{17097428-0DAC-400A-9866-F07FECCE981B}" dt="2026-02-11T14:59:56.105" v="70" actId="6549"/>
           <ac:spMkLst>
             <pc:docMk/>
-            <pc:sldMk cId="2262051643" sldId="282"/>
-            <ac:spMk id="7" creationId="{5D00FC8E-1F2A-3890-1644-19DF13D3FFB6}"/>
-          </ac:spMkLst>
-        </pc:spChg>
-        <pc:spChg chg="mod">
-          <ac:chgData name="jennis rufina" userId="82f03a850a9f00a2" providerId="LiveId" clId="{FAA1ECB5-B8B8-4660-8381-16C5214360E0}" dt="2026-02-25T08:09:04.057" v="104" actId="20577"/>
-          <ac:spMkLst>
-            <pc:docMk/>
-            <pc:sldMk cId="2262051643" sldId="282"/>
-            <ac:spMk id="11" creationId="{8C183A66-42F8-F13C-795D-00913B38A72C}"/>
+            <pc:sldMk cId="805950796" sldId="272"/>
+            <ac:spMk id="11" creationId="{C0DBFA1B-D25D-D84D-F693-39645FDCE4DE}"/>
           </ac:spMkLst>
         </pc:spChg>
       </pc:sldChg>
       <pc:sldChg chg="modSp mod">
-        <pc:chgData name="jennis rufina" userId="82f03a850a9f00a2" providerId="LiveId" clId="{FAA1ECB5-B8B8-4660-8381-16C5214360E0}" dt="2026-03-03T14:13:17.818" v="203" actId="20577"/>
+        <pc:chgData name="Swetha  Akkala" userId="29270fab-d501-4f7b-a920-3b1278439804" providerId="ADAL" clId="{17097428-0DAC-400A-9866-F07FECCE981B}" dt="2026-02-11T15:00:02.525" v="71" actId="20577"/>
         <pc:sldMkLst>
           <pc:docMk/>
-          <pc:sldMk cId="119268449" sldId="283"/>
+          <pc:sldMk cId="1816062349" sldId="273"/>
         </pc:sldMkLst>
         <pc:spChg chg="mod">
-          <ac:chgData name="jennis rufina" userId="82f03a850a9f00a2" providerId="LiveId" clId="{FAA1ECB5-B8B8-4660-8381-16C5214360E0}" dt="2026-03-03T14:13:17.818" v="203" actId="20577"/>
+          <ac:chgData name="Swetha  Akkala" userId="29270fab-d501-4f7b-a920-3b1278439804" providerId="ADAL" clId="{17097428-0DAC-400A-9866-F07FECCE981B}" dt="2026-02-11T15:00:02.525" v="71" actId="20577"/>
           <ac:spMkLst>
             <pc:docMk/>
-            <pc:sldMk cId="119268449" sldId="283"/>
-            <ac:spMk id="7" creationId="{B9B22AF1-3840-9008-3CA4-0A6A790F3B2B}"/>
+            <pc:sldMk cId="1816062349" sldId="273"/>
+            <ac:spMk id="11" creationId="{5B6841F3-EE42-62A4-E730-5C5DD6C5042B}"/>
+          </ac:spMkLst>
+        </pc:spChg>
+      </pc:sldChg>
+      <pc:sldChg chg="modSp mod">
+        <pc:chgData name="Swetha  Akkala" userId="29270fab-d501-4f7b-a920-3b1278439804" providerId="ADAL" clId="{17097428-0DAC-400A-9866-F07FECCE981B}" dt="2026-02-11T15:00:08.086" v="72" actId="20577"/>
+        <pc:sldMkLst>
+          <pc:docMk/>
+          <pc:sldMk cId="1407599107" sldId="274"/>
+        </pc:sldMkLst>
+        <pc:spChg chg="mod">
+          <ac:chgData name="Swetha  Akkala" userId="29270fab-d501-4f7b-a920-3b1278439804" providerId="ADAL" clId="{17097428-0DAC-400A-9866-F07FECCE981B}" dt="2026-02-11T15:00:08.086" v="72" actId="20577"/>
+          <ac:spMkLst>
+            <pc:docMk/>
+            <pc:sldMk cId="1407599107" sldId="274"/>
+            <ac:spMk id="11" creationId="{A401934D-905F-324B-9C99-DCEA3E134CC1}"/>
+          </ac:spMkLst>
+        </pc:spChg>
+      </pc:sldChg>
+      <pc:sldChg chg="modSp mod">
+        <pc:chgData name="Swetha  Akkala" userId="29270fab-d501-4f7b-a920-3b1278439804" providerId="ADAL" clId="{17097428-0DAC-400A-9866-F07FECCE981B}" dt="2026-02-11T14:56:53.277" v="27" actId="20577"/>
+        <pc:sldMkLst>
+          <pc:docMk/>
+          <pc:sldMk cId="926711311" sldId="275"/>
+        </pc:sldMkLst>
+        <pc:spChg chg="mod">
+          <ac:chgData name="Swetha  Akkala" userId="29270fab-d501-4f7b-a920-3b1278439804" providerId="ADAL" clId="{17097428-0DAC-400A-9866-F07FECCE981B}" dt="2026-02-11T14:56:53.277" v="27" actId="20577"/>
+          <ac:spMkLst>
+            <pc:docMk/>
+            <pc:sldMk cId="926711311" sldId="275"/>
+            <ac:spMk id="11" creationId="{EFF2B2A6-C3FC-1FFA-F104-2AB7E11CB6F4}"/>
+          </ac:spMkLst>
+        </pc:spChg>
+      </pc:sldChg>
+      <pc:sldChg chg="modSp mod">
+        <pc:chgData name="Swetha  Akkala" userId="29270fab-d501-4f7b-a920-3b1278439804" providerId="ADAL" clId="{17097428-0DAC-400A-9866-F07FECCE981B}" dt="2026-02-11T14:56:40.726" v="25" actId="20577"/>
+        <pc:sldMkLst>
+          <pc:docMk/>
+          <pc:sldMk cId="3146498507" sldId="276"/>
+        </pc:sldMkLst>
+        <pc:spChg chg="mod">
+          <ac:chgData name="Swetha  Akkala" userId="29270fab-d501-4f7b-a920-3b1278439804" providerId="ADAL" clId="{17097428-0DAC-400A-9866-F07FECCE981B}" dt="2026-02-11T14:56:40.726" v="25" actId="20577"/>
+          <ac:spMkLst>
+            <pc:docMk/>
+            <pc:sldMk cId="3146498507" sldId="276"/>
+            <ac:spMk id="11" creationId="{CEC959A5-A1C1-02A7-3318-467F21764977}"/>
+          </ac:spMkLst>
+        </pc:spChg>
+      </pc:sldChg>
+      <pc:sldChg chg="modSp mod">
+        <pc:chgData name="Swetha  Akkala" userId="29270fab-d501-4f7b-a920-3b1278439804" providerId="ADAL" clId="{17097428-0DAC-400A-9866-F07FECCE981B}" dt="2026-02-11T14:58:14.414" v="59" actId="255"/>
+        <pc:sldMkLst>
+          <pc:docMk/>
+          <pc:sldMk cId="2977330921" sldId="277"/>
+        </pc:sldMkLst>
+        <pc:spChg chg="mod">
+          <ac:chgData name="Swetha  Akkala" userId="29270fab-d501-4f7b-a920-3b1278439804" providerId="ADAL" clId="{17097428-0DAC-400A-9866-F07FECCE981B}" dt="2026-02-11T14:58:14.414" v="59" actId="255"/>
+          <ac:spMkLst>
+            <pc:docMk/>
+            <pc:sldMk cId="2977330921" sldId="277"/>
+            <ac:spMk id="11" creationId="{5C1D1234-F87E-33E0-0BD2-0D1863584470}"/>
+          </ac:spMkLst>
+        </pc:spChg>
+      </pc:sldChg>
+      <pc:sldChg chg="modSp mod">
+        <pc:chgData name="Swetha  Akkala" userId="29270fab-d501-4f7b-a920-3b1278439804" providerId="ADAL" clId="{17097428-0DAC-400A-9866-F07FECCE981B}" dt="2026-02-11T14:56:25.326" v="21" actId="123"/>
+        <pc:sldMkLst>
+          <pc:docMk/>
+          <pc:sldMk cId="88817511" sldId="278"/>
+        </pc:sldMkLst>
+        <pc:spChg chg="mod">
+          <ac:chgData name="Swetha  Akkala" userId="29270fab-d501-4f7b-a920-3b1278439804" providerId="ADAL" clId="{17097428-0DAC-400A-9866-F07FECCE981B}" dt="2026-02-11T14:56:25.326" v="21" actId="123"/>
+          <ac:spMkLst>
+            <pc:docMk/>
+            <pc:sldMk cId="88817511" sldId="278"/>
+            <ac:spMk id="11" creationId="{B7FE0190-4CB5-2F4F-C984-D5C304ED4B0A}"/>
+          </ac:spMkLst>
+        </pc:spChg>
+      </pc:sldChg>
+      <pc:sldChg chg="modSp mod">
+        <pc:chgData name="Swetha  Akkala" userId="29270fab-d501-4f7b-a920-3b1278439804" providerId="ADAL" clId="{17097428-0DAC-400A-9866-F07FECCE981B}" dt="2026-02-11T15:02:34.323" v="83" actId="255"/>
+        <pc:sldMkLst>
+          <pc:docMk/>
+          <pc:sldMk cId="859413911" sldId="279"/>
+        </pc:sldMkLst>
+        <pc:spChg chg="mod">
+          <ac:chgData name="Swetha  Akkala" userId="29270fab-d501-4f7b-a920-3b1278439804" providerId="ADAL" clId="{17097428-0DAC-400A-9866-F07FECCE981B}" dt="2026-02-11T15:02:02.166" v="81" actId="20577"/>
+          <ac:spMkLst>
+            <pc:docMk/>
+            <pc:sldMk cId="859413911" sldId="279"/>
+            <ac:spMk id="7" creationId="{6BAA8868-FDEB-212D-0E84-B1B339220F85}"/>
           </ac:spMkLst>
         </pc:spChg>
         <pc:spChg chg="mod">
-          <ac:chgData name="jennis rufina" userId="82f03a850a9f00a2" providerId="LiveId" clId="{FAA1ECB5-B8B8-4660-8381-16C5214360E0}" dt="2026-02-25T08:09:51.622" v="137" actId="20577"/>
+          <ac:chgData name="Swetha  Akkala" userId="29270fab-d501-4f7b-a920-3b1278439804" providerId="ADAL" clId="{17097428-0DAC-400A-9866-F07FECCE981B}" dt="2026-02-11T15:00:24.435" v="74" actId="20577"/>
           <ac:spMkLst>
             <pc:docMk/>
-            <pc:sldMk cId="119268449" sldId="283"/>
-            <ac:spMk id="11" creationId="{E710390A-553C-B68D-9AAF-E63341E911D8}"/>
+            <pc:sldMk cId="859413911" sldId="279"/>
+            <ac:spMk id="11" creationId="{3F56B683-987F-2AB2-3C43-65E5943B627C}"/>
+          </ac:spMkLst>
+        </pc:spChg>
+        <pc:spChg chg="mod">
+          <ac:chgData name="Swetha  Akkala" userId="29270fab-d501-4f7b-a920-3b1278439804" providerId="ADAL" clId="{17097428-0DAC-400A-9866-F07FECCE981B}" dt="2026-02-11T15:02:34.323" v="83" actId="255"/>
+          <ac:spMkLst>
+            <pc:docMk/>
+            <pc:sldMk cId="859413911" sldId="279"/>
+            <ac:spMk id="12" creationId="{FF5044C3-FB81-37EB-A51F-BF41E9D309C6}"/>
+          </ac:spMkLst>
+        </pc:spChg>
+      </pc:sldChg>
+      <pc:sldChg chg="modSp mod">
+        <pc:chgData name="Swetha  Akkala" userId="29270fab-d501-4f7b-a920-3b1278439804" providerId="ADAL" clId="{17097428-0DAC-400A-9866-F07FECCE981B}" dt="2026-02-11T14:56:20.029" v="20" actId="123"/>
+        <pc:sldMkLst>
+          <pc:docMk/>
+          <pc:sldMk cId="2512149221" sldId="280"/>
+        </pc:sldMkLst>
+        <pc:spChg chg="mod">
+          <ac:chgData name="Swetha  Akkala" userId="29270fab-d501-4f7b-a920-3b1278439804" providerId="ADAL" clId="{17097428-0DAC-400A-9866-F07FECCE981B}" dt="2026-02-11T14:56:20.029" v="20" actId="123"/>
+          <ac:spMkLst>
+            <pc:docMk/>
+            <pc:sldMk cId="2512149221" sldId="280"/>
+            <ac:spMk id="11" creationId="{5195D475-D617-D7E2-0AAE-F20B3E7BBCAA}"/>
           </ac:spMkLst>
         </pc:spChg>
       </pc:sldChg>
@@ -330,7 +435,7 @@
           <a:p>
             <a:fld id="{E40DDB01-B6F6-4D19-B7EB-82B79169DABA}" type="datetimeFigureOut">
               <a:rPr lang="en-IN" smtClean="0"/>
-              <a:t>10-03-2026</a:t>
+              <a:t>16-02-2026</a:t>
             </a:fld>
             <a:endParaRPr lang="en-IN"/>
           </a:p>
@@ -598,6 +703,90 @@
 </p:notesMaster>
 </file>
 
+<file path=ppt/notesSlides/notesSlide1.xml><?xml version="1.0" encoding="utf-8"?>
+<p:notes xmlns:a="http://schemas.openxmlformats.org/drawingml/2006/main" xmlns:r="http://schemas.openxmlformats.org/officeDocument/2006/relationships" xmlns:p="http://schemas.openxmlformats.org/presentationml/2006/main">
+  <p:cSld>
+    <p:spTree>
+      <p:nvGrpSpPr>
+        <p:cNvPr id="1" name=""/>
+        <p:cNvGrpSpPr/>
+        <p:nvPr/>
+      </p:nvGrpSpPr>
+      <p:grpSpPr>
+        <a:xfrm>
+          <a:off x="0" y="0"/>
+          <a:ext cx="0" cy="0"/>
+          <a:chOff x="0" y="0"/>
+          <a:chExt cx="0" cy="0"/>
+        </a:xfrm>
+      </p:grpSpPr>
+      <p:sp>
+        <p:nvSpPr>
+          <p:cNvPr id="2" name="Slide Image Placeholder 1"/>
+          <p:cNvSpPr>
+            <a:spLocks noGrp="1" noRot="1" noChangeAspect="1"/>
+          </p:cNvSpPr>
+          <p:nvPr>
+            <p:ph type="sldImg"/>
+          </p:nvPr>
+        </p:nvSpPr>
+        <p:spPr/>
+      </p:sp>
+      <p:sp>
+        <p:nvSpPr>
+          <p:cNvPr id="3" name="Notes Placeholder 2"/>
+          <p:cNvSpPr>
+            <a:spLocks noGrp="1"/>
+          </p:cNvSpPr>
+          <p:nvPr>
+            <p:ph type="body" idx="1"/>
+          </p:nvPr>
+        </p:nvSpPr>
+        <p:spPr/>
+        <p:txBody>
+          <a:bodyPr/>
+          <a:lstStyle/>
+          <a:p>
+            <a:endParaRPr lang="en-IN" dirty="0"/>
+          </a:p>
+        </p:txBody>
+      </p:sp>
+      <p:sp>
+        <p:nvSpPr>
+          <p:cNvPr id="4" name="Slide Number Placeholder 3"/>
+          <p:cNvSpPr>
+            <a:spLocks noGrp="1"/>
+          </p:cNvSpPr>
+          <p:nvPr>
+            <p:ph type="sldNum" sz="quarter" idx="5"/>
+          </p:nvPr>
+        </p:nvSpPr>
+        <p:spPr/>
+        <p:txBody>
+          <a:bodyPr/>
+          <a:lstStyle/>
+          <a:p>
+            <a:fld id="{E681C110-5E53-4DE7-B91B-A84D7659A2DC}" type="slidenum">
+              <a:rPr lang="en-IN" smtClean="0"/>
+              <a:t>4</a:t>
+            </a:fld>
+            <a:endParaRPr lang="en-IN"/>
+          </a:p>
+        </p:txBody>
+      </p:sp>
+    </p:spTree>
+    <p:extLst>
+      <p:ext uri="{BB962C8B-B14F-4D97-AF65-F5344CB8AC3E}">
+        <p14:creationId xmlns:p14="http://schemas.microsoft.com/office/powerpoint/2010/main" val="985720059"/>
+      </p:ext>
+    </p:extLst>
+  </p:cSld>
+  <p:clrMapOvr>
+    <a:masterClrMapping/>
+  </p:clrMapOvr>
+</p:notes>
+</file>
+
 <file path=ppt/slideLayouts/slideLayout1.xml><?xml version="1.0" encoding="utf-8"?>
 <p:sldLayout xmlns:a="http://schemas.openxmlformats.org/drawingml/2006/main" xmlns:r="http://schemas.openxmlformats.org/officeDocument/2006/relationships" xmlns:p="http://schemas.openxmlformats.org/presentationml/2006/main" type="title" preserve="1">
   <p:cSld name="Title Slide">
@@ -747,7 +936,7 @@
           <a:p>
             <a:fld id="{C456AD15-A154-4F8D-9983-D4D8643F4F81}" type="datetimeFigureOut">
               <a:rPr lang="en-IN" smtClean="0"/>
-              <a:t>10-03-2026</a:t>
+              <a:t>16-02-2026</a:t>
             </a:fld>
             <a:endParaRPr lang="en-IN"/>
           </a:p>
@@ -947,7 +1136,7 @@
           <a:p>
             <a:fld id="{C456AD15-A154-4F8D-9983-D4D8643F4F81}" type="datetimeFigureOut">
               <a:rPr lang="en-IN" smtClean="0"/>
-              <a:t>10-03-2026</a:t>
+              <a:t>16-02-2026</a:t>
             </a:fld>
             <a:endParaRPr lang="en-IN"/>
           </a:p>
@@ -1157,7 +1346,7 @@
           <a:p>
             <a:fld id="{C456AD15-A154-4F8D-9983-D4D8643F4F81}" type="datetimeFigureOut">
               <a:rPr lang="en-IN" smtClean="0"/>
-              <a:t>10-03-2026</a:t>
+              <a:t>16-02-2026</a:t>
             </a:fld>
             <a:endParaRPr lang="en-IN"/>
           </a:p>
@@ -1357,7 +1546,7 @@
           <a:p>
             <a:fld id="{C456AD15-A154-4F8D-9983-D4D8643F4F81}" type="datetimeFigureOut">
               <a:rPr lang="en-IN" smtClean="0"/>
-              <a:t>10-03-2026</a:t>
+              <a:t>16-02-2026</a:t>
             </a:fld>
             <a:endParaRPr lang="en-IN"/>
           </a:p>
@@ -1633,7 +1822,7 @@
           <a:p>
             <a:fld id="{C456AD15-A154-4F8D-9983-D4D8643F4F81}" type="datetimeFigureOut">
               <a:rPr lang="en-IN" smtClean="0"/>
-              <a:t>10-03-2026</a:t>
+              <a:t>16-02-2026</a:t>
             </a:fld>
             <a:endParaRPr lang="en-IN"/>
           </a:p>
@@ -1901,7 +2090,7 @@
           <a:p>
             <a:fld id="{C456AD15-A154-4F8D-9983-D4D8643F4F81}" type="datetimeFigureOut">
               <a:rPr lang="en-IN" smtClean="0"/>
-              <a:t>10-03-2026</a:t>
+              <a:t>16-02-2026</a:t>
             </a:fld>
             <a:endParaRPr lang="en-IN"/>
           </a:p>
@@ -2316,7 +2505,7 @@
           <a:p>
             <a:fld id="{C456AD15-A154-4F8D-9983-D4D8643F4F81}" type="datetimeFigureOut">
               <a:rPr lang="en-IN" smtClean="0"/>
-              <a:t>10-03-2026</a:t>
+              <a:t>16-02-2026</a:t>
             </a:fld>
             <a:endParaRPr lang="en-IN"/>
           </a:p>
@@ -2458,7 +2647,7 @@
           <a:p>
             <a:fld id="{C456AD15-A154-4F8D-9983-D4D8643F4F81}" type="datetimeFigureOut">
               <a:rPr lang="en-IN" smtClean="0"/>
-              <a:t>10-03-2026</a:t>
+              <a:t>16-02-2026</a:t>
             </a:fld>
             <a:endParaRPr lang="en-IN"/>
           </a:p>
@@ -2571,7 +2760,7 @@
           <a:p>
             <a:fld id="{C456AD15-A154-4F8D-9983-D4D8643F4F81}" type="datetimeFigureOut">
               <a:rPr lang="en-IN" smtClean="0"/>
-              <a:t>10-03-2026</a:t>
+              <a:t>16-02-2026</a:t>
             </a:fld>
             <a:endParaRPr lang="en-IN"/>
           </a:p>
@@ -2884,7 +3073,7 @@
           <a:p>
             <a:fld id="{C456AD15-A154-4F8D-9983-D4D8643F4F81}" type="datetimeFigureOut">
               <a:rPr lang="en-IN" smtClean="0"/>
-              <a:t>10-03-2026</a:t>
+              <a:t>16-02-2026</a:t>
             </a:fld>
             <a:endParaRPr lang="en-IN"/>
           </a:p>
@@ -3173,7 +3362,7 @@
           <a:p>
             <a:fld id="{C456AD15-A154-4F8D-9983-D4D8643F4F81}" type="datetimeFigureOut">
               <a:rPr lang="en-IN" smtClean="0"/>
-              <a:t>10-03-2026</a:t>
+              <a:t>16-02-2026</a:t>
             </a:fld>
             <a:endParaRPr lang="en-IN"/>
           </a:p>
@@ -3416,7 +3605,7 @@
           <a:p>
             <a:fld id="{C456AD15-A154-4F8D-9983-D4D8643F4F81}" type="datetimeFigureOut">
               <a:rPr lang="en-IN" smtClean="0"/>
-              <a:t>10-03-2026</a:t>
+              <a:t>16-02-2026</a:t>
             </a:fld>
             <a:endParaRPr lang="en-IN"/>
           </a:p>
@@ -3936,7 +4125,7 @@
                 <a:ea typeface="Calibri" panose="020F0502020204030204" pitchFamily="34" charset="0"/>
                 <a:cs typeface="Calibri" panose="020F0502020204030204" pitchFamily="34" charset="0"/>
               </a:rPr>
-              <a:t>{PROFESSIONAL_SUMMARY} :</a:t>
+              <a:t>Automation Test Engineer with 6+ years of experience in Software Quality Assurance, encompassing both Manual and Automation Testing for web applications. </a:t>
             </a:r>
           </a:p>
           <a:p>
@@ -3950,14 +4139,39 @@
               <a:buSzPts val="1150"/>
               <a:buNone/>
             </a:pPr>
-            <a:endParaRPr lang="en-US" sz="1500" dirty="0">
-              <a:solidFill>
-                <a:schemeClr val="tx1"/>
-              </a:solidFill>
-              <a:latin typeface="Calibri" panose="020F0502020204030204" pitchFamily="34" charset="0"/>
-              <a:ea typeface="Calibri" panose="020F0502020204030204" pitchFamily="34" charset="0"/>
-              <a:cs typeface="Calibri" panose="020F0502020204030204" pitchFamily="34" charset="0"/>
-            </a:endParaRPr>
+            <a:r>
+              <a:rPr lang="en-US" sz="1500" dirty="0">
+                <a:solidFill>
+                  <a:schemeClr val="tx1"/>
+                </a:solidFill>
+                <a:latin typeface="Calibri" panose="020F0502020204030204" pitchFamily="34" charset="0"/>
+                <a:ea typeface="Calibri" panose="020F0502020204030204" pitchFamily="34" charset="0"/>
+                <a:cs typeface="Calibri" panose="020F0502020204030204" pitchFamily="34" charset="0"/>
+              </a:rPr>
+              <a:t>Strong expertise in Selenium with Python and Playwright with Python, with hands-on experience in designing, developing, and maintaining scalable automation frameworks using </a:t>
+            </a:r>
+            <a:r>
+              <a:rPr lang="en-US" sz="1500" dirty="0" err="1">
+                <a:solidFill>
+                  <a:schemeClr val="tx1"/>
+                </a:solidFill>
+                <a:latin typeface="Calibri" panose="020F0502020204030204" pitchFamily="34" charset="0"/>
+                <a:ea typeface="Calibri" panose="020F0502020204030204" pitchFamily="34" charset="0"/>
+                <a:cs typeface="Calibri" panose="020F0502020204030204" pitchFamily="34" charset="0"/>
+              </a:rPr>
+              <a:t>PyTest</a:t>
+            </a:r>
+            <a:r>
+              <a:rPr lang="en-US" sz="1500" dirty="0">
+                <a:solidFill>
+                  <a:schemeClr val="tx1"/>
+                </a:solidFill>
+                <a:latin typeface="Calibri" panose="020F0502020204030204" pitchFamily="34" charset="0"/>
+                <a:ea typeface="Calibri" panose="020F0502020204030204" pitchFamily="34" charset="0"/>
+                <a:cs typeface="Calibri" panose="020F0502020204030204" pitchFamily="34" charset="0"/>
+              </a:rPr>
+              <a:t>, Robot Framework, and Page Object Model (POM). </a:t>
+            </a:r>
           </a:p>
           <a:p>
             <a:pPr marL="88900" marR="0" indent="0">
@@ -3970,14 +4184,17 @@
               <a:buSzPts val="1150"/>
               <a:buNone/>
             </a:pPr>
-            <a:endParaRPr lang="en-US" sz="1500" dirty="0">
-              <a:solidFill>
-                <a:schemeClr val="tx1"/>
-              </a:solidFill>
-              <a:latin typeface="Calibri" panose="020F0502020204030204" pitchFamily="34" charset="0"/>
-              <a:ea typeface="Calibri" panose="020F0502020204030204" pitchFamily="34" charset="0"/>
-              <a:cs typeface="Calibri" panose="020F0502020204030204" pitchFamily="34" charset="0"/>
-            </a:endParaRPr>
+            <a:r>
+              <a:rPr lang="en-US" sz="1500" dirty="0">
+                <a:solidFill>
+                  <a:schemeClr val="tx1"/>
+                </a:solidFill>
+                <a:latin typeface="Calibri" panose="020F0502020204030204" pitchFamily="34" charset="0"/>
+                <a:ea typeface="Calibri" panose="020F0502020204030204" pitchFamily="34" charset="0"/>
+                <a:cs typeface="Calibri" panose="020F0502020204030204" pitchFamily="34" charset="0"/>
+              </a:rPr>
+              <a:t>Proficient in API testing using Postman and Python Requests, with exposure to CI/CD integration using Jenkins for continuous test execution. Possess solid programming skills in Python, including Object-Oriented Programming concepts, along with strong experience in writing XPath and CSS selectors for dynamic web elements. </a:t>
+            </a:r>
           </a:p>
           <a:p>
             <a:pPr marL="88900" marR="0" indent="0">
@@ -3990,114 +4207,17 @@
               <a:buSzPts val="1150"/>
               <a:buNone/>
             </a:pPr>
-            <a:endParaRPr lang="en-US" sz="1500" dirty="0">
-              <a:solidFill>
-                <a:schemeClr val="tx1"/>
-              </a:solidFill>
-              <a:latin typeface="Calibri" panose="020F0502020204030204" pitchFamily="34" charset="0"/>
-              <a:ea typeface="Calibri" panose="020F0502020204030204" pitchFamily="34" charset="0"/>
-              <a:cs typeface="Calibri" panose="020F0502020204030204" pitchFamily="34" charset="0"/>
-            </a:endParaRPr>
-          </a:p>
-          <a:p>
-            <a:pPr marL="88900" marR="0" indent="0">
-              <a:spcBef>
-                <a:spcPct val="0"/>
-              </a:spcBef>
-              <a:spcAft>
-                <a:spcPct val="0"/>
-              </a:spcAft>
-              <a:buSzPts val="1150"/>
-              <a:buNone/>
-            </a:pPr>
-            <a:endParaRPr lang="en-US" sz="1500" dirty="0">
-              <a:solidFill>
-                <a:schemeClr val="tx1"/>
-              </a:solidFill>
-              <a:latin typeface="Calibri" panose="020F0502020204030204" pitchFamily="34" charset="0"/>
-              <a:ea typeface="Calibri" panose="020F0502020204030204" pitchFamily="34" charset="0"/>
-              <a:cs typeface="Calibri" panose="020F0502020204030204" pitchFamily="34" charset="0"/>
-            </a:endParaRPr>
-          </a:p>
-          <a:p>
-            <a:pPr marL="88900" marR="0" indent="0">
-              <a:spcBef>
-                <a:spcPct val="0"/>
-              </a:spcBef>
-              <a:spcAft>
-                <a:spcPct val="0"/>
-              </a:spcAft>
-              <a:buSzPts val="1150"/>
-              <a:buNone/>
-            </a:pPr>
-            <a:endParaRPr lang="en-US" sz="1500" dirty="0">
-              <a:solidFill>
-                <a:schemeClr val="tx1"/>
-              </a:solidFill>
-              <a:latin typeface="Calibri" panose="020F0502020204030204" pitchFamily="34" charset="0"/>
-              <a:ea typeface="Calibri" panose="020F0502020204030204" pitchFamily="34" charset="0"/>
-              <a:cs typeface="Calibri" panose="020F0502020204030204" pitchFamily="34" charset="0"/>
-            </a:endParaRPr>
-          </a:p>
-          <a:p>
-            <a:pPr marL="88900" marR="0" indent="0">
-              <a:spcBef>
-                <a:spcPct val="0"/>
-              </a:spcBef>
-              <a:spcAft>
-                <a:spcPct val="0"/>
-              </a:spcAft>
-              <a:buSzPts val="1150"/>
-              <a:buNone/>
-            </a:pPr>
-            <a:endParaRPr lang="en-US" sz="1500" dirty="0">
-              <a:solidFill>
-                <a:schemeClr val="tx1"/>
-              </a:solidFill>
-              <a:latin typeface="Calibri" panose="020F0502020204030204" pitchFamily="34" charset="0"/>
-              <a:ea typeface="Calibri" panose="020F0502020204030204" pitchFamily="34" charset="0"/>
-              <a:cs typeface="Calibri" panose="020F0502020204030204" pitchFamily="34" charset="0"/>
-            </a:endParaRPr>
-          </a:p>
-          <a:p>
-            <a:pPr marL="88900" marR="0" indent="0">
-              <a:spcBef>
-                <a:spcPct val="0"/>
-              </a:spcBef>
-              <a:spcAft>
-                <a:spcPct val="0"/>
-              </a:spcAft>
-              <a:buSzPts val="1150"/>
-              <a:buNone/>
-            </a:pPr>
-            <a:endParaRPr lang="en-US" sz="1500" dirty="0">
-              <a:solidFill>
-                <a:schemeClr val="tx1"/>
-              </a:solidFill>
-              <a:latin typeface="Calibri" panose="020F0502020204030204" pitchFamily="34" charset="0"/>
-              <a:ea typeface="Calibri" panose="020F0502020204030204" pitchFamily="34" charset="0"/>
-              <a:cs typeface="Calibri" panose="020F0502020204030204" pitchFamily="34" charset="0"/>
-            </a:endParaRPr>
-          </a:p>
-          <a:p>
-            <a:pPr marL="88900" marR="0" indent="0">
-              <a:spcBef>
-                <a:spcPct val="0"/>
-              </a:spcBef>
-              <a:spcAft>
-                <a:spcPct val="0"/>
-              </a:spcAft>
-              <a:buSzPts val="1150"/>
-              <a:buNone/>
-            </a:pPr>
-            <a:endParaRPr lang="en-US" sz="1500" dirty="0">
-              <a:solidFill>
-                <a:schemeClr val="tx1"/>
-              </a:solidFill>
-              <a:latin typeface="Calibri" panose="020F0502020204030204" pitchFamily="34" charset="0"/>
-              <a:ea typeface="Calibri" panose="020F0502020204030204" pitchFamily="34" charset="0"/>
-              <a:cs typeface="Calibri" panose="020F0502020204030204" pitchFamily="34" charset="0"/>
-            </a:endParaRPr>
+            <a:r>
+              <a:rPr lang="en-US" sz="1500" dirty="0">
+                <a:solidFill>
+                  <a:schemeClr val="tx1"/>
+                </a:solidFill>
+                <a:latin typeface="Calibri" panose="020F0502020204030204" pitchFamily="34" charset="0"/>
+                <a:ea typeface="Calibri" panose="020F0502020204030204" pitchFamily="34" charset="0"/>
+                <a:cs typeface="Calibri" panose="020F0502020204030204" pitchFamily="34" charset="0"/>
+              </a:rPr>
+              <a:t>Well-versed in SDLC, STLC, Defect Life Cycle, Agile methodologies, and defect management using JIRA, with additional knowledge of SQL, version control tools (Git, GitHub, GitLab, Bitbucket), and modern testing practices.  </a:t>
+            </a:r>
           </a:p>
         </p:txBody>
       </p:sp>
@@ -4116,7 +4236,7 @@
         <p:spPr>
           <a:xfrm>
             <a:off x="7620000" y="2935271"/>
-            <a:ext cx="4288748" cy="1613903"/>
+            <a:ext cx="4288748" cy="244298"/>
           </a:xfrm>
           <a:prstGeom prst="rect">
             <a:avLst/>
@@ -4161,7 +4281,7 @@
               <a:buNone/>
             </a:pPr>
             <a:r>
-              <a:rPr lang="en-US" sz="1400" dirty="0">
+              <a:rPr lang="en-IN" sz="1400" dirty="0">
                 <a:solidFill>
                   <a:schemeClr val="tx1"/>
                 </a:solidFill>
@@ -4170,119 +4290,8 @@
                 <a:cs typeface="Calibri" panose="020F0502020204030204" pitchFamily="34" charset="0"/>
                 <a:sym typeface="Calibri"/>
               </a:rPr>
-              <a:t>{EDUCATION_DETAILS}</a:t>
-            </a:r>
-            <a:endParaRPr lang="en-IN" sz="1400" dirty="0">
-              <a:solidFill>
-                <a:schemeClr val="tx1"/>
-              </a:solidFill>
-              <a:latin typeface="Calibri" panose="020F0502020204030204" pitchFamily="34" charset="0"/>
-              <a:ea typeface="Calibri" panose="020F0502020204030204" pitchFamily="34" charset="0"/>
-              <a:cs typeface="Calibri" panose="020F0502020204030204" pitchFamily="34" charset="0"/>
-              <a:sym typeface="Calibri"/>
-            </a:endParaRPr>
-          </a:p>
-          <a:p>
-            <a:pPr marL="72390" indent="0">
-              <a:spcBef>
-                <a:spcPts val="133"/>
-              </a:spcBef>
-              <a:buNone/>
-            </a:pPr>
-            <a:endParaRPr lang="en-IN" sz="1400" dirty="0">
-              <a:solidFill>
-                <a:schemeClr val="tx1"/>
-              </a:solidFill>
-              <a:latin typeface="Calibri" panose="020F0502020204030204" pitchFamily="34" charset="0"/>
-              <a:ea typeface="Calibri" panose="020F0502020204030204" pitchFamily="34" charset="0"/>
-              <a:cs typeface="Calibri" panose="020F0502020204030204" pitchFamily="34" charset="0"/>
-              <a:sym typeface="Calibri"/>
-            </a:endParaRPr>
-          </a:p>
-          <a:p>
-            <a:pPr marL="72390" indent="0">
-              <a:spcBef>
-                <a:spcPts val="133"/>
-              </a:spcBef>
-              <a:buNone/>
-            </a:pPr>
-            <a:endParaRPr lang="en-IN" sz="1400" dirty="0">
-              <a:solidFill>
-                <a:schemeClr val="tx1"/>
-              </a:solidFill>
-              <a:latin typeface="Calibri" panose="020F0502020204030204" pitchFamily="34" charset="0"/>
-              <a:ea typeface="Calibri" panose="020F0502020204030204" pitchFamily="34" charset="0"/>
-              <a:cs typeface="Calibri" panose="020F0502020204030204" pitchFamily="34" charset="0"/>
-              <a:sym typeface="Calibri"/>
-            </a:endParaRPr>
-          </a:p>
-          <a:p>
-            <a:pPr marL="72390" indent="0">
-              <a:spcBef>
-                <a:spcPts val="133"/>
-              </a:spcBef>
-              <a:buNone/>
-            </a:pPr>
-            <a:endParaRPr lang="en-IN" sz="1400" dirty="0">
-              <a:solidFill>
-                <a:schemeClr val="tx1"/>
-              </a:solidFill>
-              <a:latin typeface="Calibri" panose="020F0502020204030204" pitchFamily="34" charset="0"/>
-              <a:ea typeface="Calibri" panose="020F0502020204030204" pitchFamily="34" charset="0"/>
-              <a:cs typeface="Calibri" panose="020F0502020204030204" pitchFamily="34" charset="0"/>
-              <a:sym typeface="Calibri"/>
-            </a:endParaRPr>
-          </a:p>
-          <a:p>
-            <a:pPr marL="72390" indent="0">
-              <a:spcBef>
-                <a:spcPts val="133"/>
-              </a:spcBef>
-              <a:buNone/>
-            </a:pPr>
-            <a:endParaRPr lang="en-IN" sz="1400" dirty="0">
-              <a:solidFill>
-                <a:schemeClr val="tx1"/>
-              </a:solidFill>
-              <a:latin typeface="Calibri" panose="020F0502020204030204" pitchFamily="34" charset="0"/>
-              <a:ea typeface="Calibri" panose="020F0502020204030204" pitchFamily="34" charset="0"/>
-              <a:cs typeface="Calibri" panose="020F0502020204030204" pitchFamily="34" charset="0"/>
-              <a:sym typeface="Calibri"/>
-            </a:endParaRPr>
-          </a:p>
-          <a:p>
-            <a:pPr marL="72390" indent="0">
-              <a:spcBef>
-                <a:spcPts val="133"/>
-              </a:spcBef>
-              <a:buNone/>
-            </a:pPr>
-            <a:endParaRPr lang="en-IN" sz="1400" dirty="0">
-              <a:solidFill>
-                <a:schemeClr val="tx1"/>
-              </a:solidFill>
-              <a:latin typeface="Calibri" panose="020F0502020204030204" pitchFamily="34" charset="0"/>
-              <a:ea typeface="Calibri" panose="020F0502020204030204" pitchFamily="34" charset="0"/>
-              <a:cs typeface="Calibri" panose="020F0502020204030204" pitchFamily="34" charset="0"/>
-              <a:sym typeface="Calibri"/>
-            </a:endParaRPr>
-          </a:p>
-          <a:p>
-            <a:pPr marL="72390" indent="0">
-              <a:spcBef>
-                <a:spcPts val="133"/>
-              </a:spcBef>
-              <a:buNone/>
-            </a:pPr>
-            <a:endParaRPr lang="en-IN" sz="1400" dirty="0">
-              <a:solidFill>
-                <a:schemeClr val="tx1"/>
-              </a:solidFill>
-              <a:latin typeface="Calibri" panose="020F0502020204030204" pitchFamily="34" charset="0"/>
-              <a:ea typeface="Calibri" panose="020F0502020204030204" pitchFamily="34" charset="0"/>
-              <a:cs typeface="Calibri" panose="020F0502020204030204" pitchFamily="34" charset="0"/>
-              <a:sym typeface="Calibri"/>
-            </a:endParaRPr>
+              <a:t>B.E – SSN Engineering College (2019) </a:t>
+            </a:r>
           </a:p>
         </p:txBody>
       </p:sp>
@@ -4372,7 +4381,7 @@
           <p:spPr>
             <a:xfrm>
               <a:off x="1044680" y="1990412"/>
-              <a:ext cx="1677725" cy="388067"/>
+              <a:ext cx="1677725" cy="388068"/>
             </a:xfrm>
             <a:prstGeom prst="rect">
               <a:avLst/>
@@ -4415,7 +4424,7 @@
         <p:spPr>
           <a:xfrm>
             <a:off x="250371" y="2943376"/>
-            <a:ext cx="7242137" cy="2655214"/>
+            <a:ext cx="7242137" cy="3835024"/>
           </a:xfrm>
           <a:prstGeom prst="rect">
             <a:avLst/>
@@ -4457,49 +4466,196 @@
               <a:buNone/>
             </a:pPr>
             <a:r>
-              <a:rPr lang="en-US" sz="1400" dirty="0">
+              <a:rPr lang="en-US" sz="1400" b="1" dirty="0">
                 <a:solidFill>
                   <a:schemeClr val="tx1"/>
                 </a:solidFill>
               </a:rPr>
-              <a:t>{TECHNICAL_SKILLS}</a:t>
-            </a:r>
-          </a:p>
-          <a:p>
-            <a:pPr marL="88900" indent="0">
-              <a:buNone/>
-            </a:pPr>
-            <a:endParaRPr lang="en-US" sz="1400" dirty="0">
+              <a:t>Testing Skills</a:t>
+            </a:r>
+            <a:endParaRPr lang="en-IN" sz="1400" b="1" dirty="0">
               <a:solidFill>
                 <a:schemeClr val="tx1"/>
               </a:solidFill>
             </a:endParaRPr>
           </a:p>
           <a:p>
+            <a:pPr marL="374650" marR="83820" lvl="1" indent="-285750">
+              <a:spcBef>
+                <a:spcPts val="225"/>
+              </a:spcBef>
+              <a:buFont typeface="Arial" panose="020B0604020202020204" pitchFamily="34" charset="0"/>
+              <a:buChar char="•"/>
+            </a:pPr>
+            <a:r>
+              <a:rPr lang="en-US" sz="1400" spc="-5" dirty="0"/>
+              <a:t>Manual Testing: Functional, Regression, Smoke, Sanity, System, Integration, UAT</a:t>
+            </a:r>
+            <a:endParaRPr lang="en-IN" sz="1400" spc="-5" dirty="0"/>
+          </a:p>
+          <a:p>
+            <a:pPr marL="374650" marR="83820" lvl="1" indent="-285750">
+              <a:spcBef>
+                <a:spcPts val="225"/>
+              </a:spcBef>
+              <a:buFont typeface="Arial" panose="020B0604020202020204" pitchFamily="34" charset="0"/>
+              <a:buChar char="•"/>
+            </a:pPr>
+            <a:r>
+              <a:rPr lang="en-US" sz="1400" spc="-5" dirty="0"/>
+              <a:t>Automation Testing: Selenium WebDriver with Python Test Case Design using BVA &amp; Equivalence Partitioning</a:t>
+            </a:r>
+            <a:endParaRPr lang="en-IN" sz="1400" spc="-5" dirty="0"/>
+          </a:p>
+          <a:p>
+            <a:pPr marL="374650" marR="83820" lvl="1" indent="-285750">
+              <a:spcBef>
+                <a:spcPts val="225"/>
+              </a:spcBef>
+              <a:buFont typeface="Arial" panose="020B0604020202020204" pitchFamily="34" charset="0"/>
+              <a:buChar char="•"/>
+            </a:pPr>
+            <a:r>
+              <a:rPr lang="en-US" sz="1400" spc="-5" dirty="0"/>
+              <a:t>Defect Tracking &amp; Management (Defect Life Cycle)</a:t>
+            </a:r>
+            <a:endParaRPr lang="en-IN" sz="1400" spc="-5" dirty="0"/>
+          </a:p>
+          <a:p>
             <a:pPr marL="88900" indent="0">
               <a:buNone/>
             </a:pPr>
-            <a:endParaRPr lang="en-US" sz="1400" dirty="0">
+            <a:r>
+              <a:rPr lang="en-US" sz="1400" b="1" dirty="0">
+                <a:solidFill>
+                  <a:schemeClr val="tx1"/>
+                </a:solidFill>
+              </a:rPr>
+              <a:t>Automation Frameworks &amp; Tools</a:t>
+            </a:r>
+          </a:p>
+          <a:p>
+            <a:r>
+              <a:rPr lang="en-US" sz="1400" dirty="0">
+                <a:solidFill>
+                  <a:schemeClr val="tx1"/>
+                </a:solidFill>
+                <a:latin typeface="+mn-lt"/>
+                <a:cs typeface="+mn-cs"/>
+              </a:rPr>
+              <a:t>Selenium WebDriver, </a:t>
+            </a:r>
+            <a:r>
+              <a:rPr lang="en-US" sz="1400" dirty="0" err="1">
+                <a:solidFill>
+                  <a:schemeClr val="tx1"/>
+                </a:solidFill>
+                <a:latin typeface="+mn-lt"/>
+                <a:cs typeface="+mn-cs"/>
+              </a:rPr>
+              <a:t>PyTest</a:t>
+            </a:r>
+            <a:r>
+              <a:rPr lang="en-US" sz="1400" dirty="0">
+                <a:solidFill>
+                  <a:schemeClr val="tx1"/>
+                </a:solidFill>
+                <a:latin typeface="+mn-lt"/>
+                <a:cs typeface="+mn-cs"/>
+              </a:rPr>
+              <a:t>, Page Object Model (POM)</a:t>
+            </a:r>
+            <a:endParaRPr lang="en-IN" sz="1400" dirty="0">
+              <a:solidFill>
+                <a:schemeClr val="tx1"/>
+              </a:solidFill>
+              <a:latin typeface="+mn-lt"/>
+              <a:cs typeface="+mn-cs"/>
+            </a:endParaRPr>
+          </a:p>
+          <a:p>
+            <a:r>
+              <a:rPr lang="en-US" sz="1400" dirty="0">
+                <a:solidFill>
+                  <a:schemeClr val="tx1"/>
+                </a:solidFill>
+                <a:latin typeface="+mn-lt"/>
+                <a:cs typeface="+mn-cs"/>
+              </a:rPr>
+              <a:t>Data-driven &amp; Keyword-driven testing (basic)</a:t>
+            </a:r>
+            <a:endParaRPr lang="en-IN" sz="1400" dirty="0">
+              <a:solidFill>
+                <a:schemeClr val="tx1"/>
+              </a:solidFill>
+              <a:latin typeface="+mn-lt"/>
+              <a:cs typeface="+mn-cs"/>
+            </a:endParaRPr>
+          </a:p>
+          <a:p>
+            <a:r>
+              <a:rPr lang="en-US" sz="1400" dirty="0">
+                <a:solidFill>
+                  <a:schemeClr val="tx1"/>
+                </a:solidFill>
+                <a:latin typeface="+mn-lt"/>
+                <a:cs typeface="+mn-cs"/>
+              </a:rPr>
+              <a:t>Git (Version Control) &amp; Jenkins (CI/CD pipeline integration for automation test execution)</a:t>
+            </a:r>
+            <a:endParaRPr lang="en-IN" sz="1400" dirty="0">
+              <a:solidFill>
+                <a:schemeClr val="tx1"/>
+              </a:solidFill>
+              <a:latin typeface="+mn-lt"/>
+              <a:cs typeface="+mn-cs"/>
+            </a:endParaRPr>
+          </a:p>
+          <a:p>
+            <a:pPr marL="88900" indent="0">
+              <a:buNone/>
+            </a:pPr>
+            <a:r>
+              <a:rPr lang="en-US" sz="1400" b="1" dirty="0">
+                <a:solidFill>
+                  <a:schemeClr val="tx1"/>
+                </a:solidFill>
+              </a:rPr>
+              <a:t>Programming &amp; Scripting</a:t>
+            </a:r>
+            <a:endParaRPr lang="en-IN" sz="1400" b="1" dirty="0">
               <a:solidFill>
                 <a:schemeClr val="tx1"/>
               </a:solidFill>
             </a:endParaRPr>
           </a:p>
           <a:p>
-            <a:pPr marL="88900" indent="0">
-              <a:buNone/>
-            </a:pPr>
-            <a:endParaRPr lang="en-US" sz="1400" dirty="0">
+            <a:pPr lvl="0"/>
+            <a:r>
+              <a:rPr lang="en-US" sz="1400" dirty="0">
+                <a:solidFill>
+                  <a:schemeClr val="tx1"/>
+                </a:solidFill>
+              </a:rPr>
+              <a:t>Core Python (OOPs, Functions, Exception Handling), Python requests library for API testing</a:t>
+            </a:r>
+            <a:endParaRPr lang="en-IN" sz="1400" dirty="0">
               <a:solidFill>
                 <a:schemeClr val="tx1"/>
               </a:solidFill>
             </a:endParaRPr>
           </a:p>
           <a:p>
-            <a:pPr marL="88900" indent="0">
-              <a:buNone/>
-            </a:pPr>
-            <a:endParaRPr lang="en-US" sz="1400" dirty="0">
+            <a:pPr lvl="0"/>
+            <a:r>
+              <a:rPr lang="en-US" sz="1400" dirty="0">
+                <a:solidFill>
+                  <a:schemeClr val="tx1"/>
+                </a:solidFill>
+              </a:rPr>
+              <a:t>SQL &amp; Snowflake SQL</a:t>
+            </a:r>
+            <a:endParaRPr lang="en-IN" sz="1400" dirty="0">
               <a:solidFill>
                 <a:schemeClr val="tx1"/>
               </a:solidFill>
@@ -4509,17 +4665,31 @@
             <a:pPr marL="88900" indent="0">
               <a:buNone/>
             </a:pPr>
-            <a:endParaRPr lang="en-US" sz="1400" dirty="0">
+            <a:r>
+              <a:rPr lang="en-US" sz="1400" b="1" dirty="0">
+                <a:solidFill>
+                  <a:schemeClr val="tx1"/>
+                </a:solidFill>
+              </a:rPr>
+              <a:t>Web Technologies</a:t>
+            </a:r>
+            <a:endParaRPr lang="en-IN" sz="1400" b="1" dirty="0">
               <a:solidFill>
                 <a:schemeClr val="tx1"/>
               </a:solidFill>
             </a:endParaRPr>
           </a:p>
           <a:p>
-            <a:pPr marL="88900" indent="0">
-              <a:buNone/>
-            </a:pPr>
-            <a:endParaRPr lang="en-US" sz="1400" dirty="0">
+            <a:pPr lvl="0"/>
+            <a:r>
+              <a:rPr lang="en-US" sz="1400" dirty="0">
+                <a:solidFill>
+                  <a:schemeClr val="tx1"/>
+                </a:solidFill>
+              </a:rPr>
+              <a:t>HTML, CSS, DOM,  XPath (Absolute, Relative, Dynamic XPath)</a:t>
+            </a:r>
+            <a:endParaRPr lang="en-IN" sz="1400" dirty="0">
               <a:solidFill>
                 <a:schemeClr val="tx1"/>
               </a:solidFill>
@@ -4529,36 +4699,30 @@
             <a:pPr marL="88900" indent="0">
               <a:buNone/>
             </a:pPr>
-            <a:endParaRPr lang="en-US" sz="1400" dirty="0">
+            <a:r>
+              <a:rPr lang="en-US" sz="1400" b="1" dirty="0">
+                <a:solidFill>
+                  <a:schemeClr val="tx1"/>
+                </a:solidFill>
+              </a:rPr>
+              <a:t>Test &amp; Project Management Tools</a:t>
+            </a:r>
+            <a:endParaRPr lang="en-IN" sz="1400" b="1" dirty="0">
               <a:solidFill>
                 <a:schemeClr val="tx1"/>
               </a:solidFill>
             </a:endParaRPr>
           </a:p>
           <a:p>
-            <a:pPr marL="88900" indent="0">
-              <a:buNone/>
-            </a:pPr>
-            <a:endParaRPr lang="en-US" sz="1400" dirty="0">
-              <a:solidFill>
-                <a:schemeClr val="tx1"/>
-              </a:solidFill>
-            </a:endParaRPr>
-          </a:p>
-          <a:p>
-            <a:pPr marL="88900" indent="0">
-              <a:buNone/>
-            </a:pPr>
-            <a:endParaRPr lang="en-US" sz="1400" dirty="0">
-              <a:solidFill>
-                <a:schemeClr val="tx1"/>
-              </a:solidFill>
-            </a:endParaRPr>
-          </a:p>
-          <a:p>
-            <a:pPr marL="88900" indent="0">
-              <a:buNone/>
-            </a:pPr>
+            <a:pPr lvl="0"/>
+            <a:r>
+              <a:rPr lang="en-US" sz="1400" dirty="0">
+                <a:solidFill>
+                  <a:schemeClr val="tx1"/>
+                </a:solidFill>
+              </a:rPr>
+              <a:t>JIRA (Defect &amp; Story Tracking),  Postman (API Testing)</a:t>
+            </a:r>
             <a:endParaRPr lang="en-IN" sz="1400" dirty="0">
               <a:solidFill>
                 <a:schemeClr val="tx1"/>
@@ -4686,7 +4850,23 @@
                 <a:ea typeface="Calibri" panose="020F0502020204030204" pitchFamily="34" charset="0"/>
                 <a:cs typeface="Calibri" panose="020F0502020204030204" pitchFamily="34" charset="0"/>
               </a:rPr>
-              <a:t>{FULL_NAME}– {CURRENT_ROLE} </a:t>
+              <a:t>Prasad </a:t>
+            </a:r>
+            <a:r>
+              <a:rPr lang="en-US" sz="2400" b="1" dirty="0" err="1">
+                <a:latin typeface="Calibri" panose="020F0502020204030204" pitchFamily="34" charset="0"/>
+                <a:ea typeface="Calibri" panose="020F0502020204030204" pitchFamily="34" charset="0"/>
+                <a:cs typeface="Calibri" panose="020F0502020204030204" pitchFamily="34" charset="0"/>
+              </a:rPr>
+              <a:t>Chittiboina</a:t>
+            </a:r>
+            <a:r>
+              <a:rPr lang="en-US" sz="2400" b="1" dirty="0">
+                <a:latin typeface="Calibri" panose="020F0502020204030204" pitchFamily="34" charset="0"/>
+                <a:ea typeface="Calibri" panose="020F0502020204030204" pitchFamily="34" charset="0"/>
+                <a:cs typeface="Calibri" panose="020F0502020204030204" pitchFamily="34" charset="0"/>
+              </a:rPr>
+              <a:t>– Senior Automation Test Engineer </a:t>
             </a:r>
           </a:p>
         </p:txBody>
@@ -4909,7 +5089,7 @@
                 <a:ea typeface="Calibri"/>
                 <a:cs typeface="Calibri"/>
               </a:rPr>
-              <a:t>Project: {PROJECT1_NAME}</a:t>
+              <a:t>Project:</a:t>
             </a:r>
             <a:r>
               <a:rPr lang="en-US" b="1" dirty="0">
@@ -4920,7 +5100,7 @@
                 <a:ea typeface="Calibri"/>
                 <a:cs typeface="Calibri"/>
               </a:rPr>
-              <a:t>.</a:t>
+              <a:t>PWC (Price Waterhouse Coopers).</a:t>
             </a:r>
             <a:endParaRPr lang="en-US" b="1" i="0" u="none" strike="noStrike" kern="1200" cap="none" spc="0" normalizeH="0" baseline="0" noProof="0" dirty="0">
               <a:ln>
@@ -4956,16 +5136,19 @@
                 <a:ea typeface="Calibri"/>
                 <a:cs typeface="Calibri"/>
               </a:rPr>
-              <a:t>Duration : {DURATION_PROJECT1}</a:t>
-            </a:r>
-            <a:endParaRPr lang="en-US" b="1" dirty="0">
-              <a:solidFill>
-                <a:prstClr val="black"/>
-              </a:solidFill>
-              <a:latin typeface="Calibri"/>
-              <a:ea typeface="Calibri"/>
-              <a:cs typeface="Calibri"/>
-            </a:endParaRPr>
+              <a:t>Duration : </a:t>
+            </a:r>
+            <a:r>
+              <a:rPr lang="en-US" b="1" dirty="0">
+                <a:solidFill>
+                  <a:prstClr val="black"/>
+                </a:solidFill>
+                <a:latin typeface="Calibri"/>
+                <a:ea typeface="Calibri"/>
+                <a:cs typeface="Calibri"/>
+              </a:rPr>
+              <a:t>Nov’2024 – Present</a:t>
+            </a:r>
           </a:p>
           <a:p>
             <a:pPr>
@@ -4977,7 +5160,7 @@
             </a:r>
             <a:r>
               <a:rPr lang="en-US" dirty="0"/>
-              <a:t>: {ROLE_PROJECT1}</a:t>
+              <a:t>: Sr Automation Tester</a:t>
             </a:r>
             <a:endParaRPr lang="en-US" b="1" i="0" u="none" strike="noStrike" kern="1200" cap="none" spc="0" normalizeH="0" baseline="0" noProof="0" dirty="0">
               <a:ln>
@@ -5011,7 +5194,7 @@
         <p:spPr>
           <a:xfrm>
             <a:off x="304800" y="2132178"/>
-            <a:ext cx="11691257" cy="4524315"/>
+            <a:ext cx="11691257" cy="2800767"/>
           </a:xfrm>
           <a:prstGeom prst="rect">
             <a:avLst/>
@@ -5028,7 +5211,7 @@
               <a:defRPr/>
             </a:pPr>
             <a:r>
-              <a:rPr lang="en-US" sz="1600" i="0" u="none" strike="noStrike" kern="1200" cap="none" spc="0" normalizeH="0" baseline="0" noProof="0" dirty="0">
+              <a:rPr kumimoji="0" lang="en-US" sz="1600" i="0" u="none" strike="noStrike" kern="1200" cap="none" spc="0" normalizeH="0" baseline="0" noProof="0" dirty="0">
                 <a:ln>
                   <a:noFill/>
                 </a:ln>
@@ -5042,117 +5225,8 @@
                 <a:ea typeface="Calibri"/>
                 <a:cs typeface="Calibri"/>
               </a:rPr>
-              <a:t>{Project1_Description}:</a:t>
-            </a:r>
-          </a:p>
-          <a:p>
-            <a:pPr algn="just" fontAlgn="base" hangingPunct="0">
-              <a:defRPr/>
-            </a:pPr>
-            <a:endParaRPr lang="en-US" sz="1600" dirty="0">
-              <a:solidFill>
-                <a:prstClr val="black"/>
-              </a:solidFill>
-              <a:latin typeface="Calibri"/>
-              <a:ea typeface="Calibri"/>
-              <a:cs typeface="Calibri"/>
-            </a:endParaRPr>
-          </a:p>
-          <a:p>
-            <a:pPr algn="just" fontAlgn="base" hangingPunct="0">
-              <a:defRPr/>
-            </a:pPr>
-            <a:endParaRPr lang="en-US" sz="1600" i="0" u="none" strike="noStrike" kern="1200" cap="none" spc="0" normalizeH="0" baseline="0" noProof="0" dirty="0">
-              <a:ln>
-                <a:noFill/>
-              </a:ln>
-              <a:solidFill>
-                <a:prstClr val="black"/>
-              </a:solidFill>
-              <a:effectLst/>
-              <a:uLnTx/>
-              <a:uFillTx/>
-              <a:latin typeface="Calibri"/>
-              <a:ea typeface="Calibri"/>
-              <a:cs typeface="Calibri"/>
-            </a:endParaRPr>
-          </a:p>
-          <a:p>
-            <a:pPr algn="just" fontAlgn="base" hangingPunct="0">
-              <a:defRPr/>
-            </a:pPr>
-            <a:endParaRPr lang="en-US" sz="1600" dirty="0">
-              <a:solidFill>
-                <a:prstClr val="black"/>
-              </a:solidFill>
-              <a:latin typeface="Calibri"/>
-              <a:ea typeface="Calibri"/>
-              <a:cs typeface="Calibri"/>
-            </a:endParaRPr>
-          </a:p>
-          <a:p>
-            <a:pPr algn="just" fontAlgn="base" hangingPunct="0">
-              <a:defRPr/>
-            </a:pPr>
-            <a:endParaRPr lang="en-US" sz="1600" i="0" u="none" strike="noStrike" kern="1200" cap="none" spc="0" normalizeH="0" baseline="0" noProof="0" dirty="0">
-              <a:ln>
-                <a:noFill/>
-              </a:ln>
-              <a:solidFill>
-                <a:prstClr val="black"/>
-              </a:solidFill>
-              <a:effectLst/>
-              <a:uLnTx/>
-              <a:uFillTx/>
-              <a:latin typeface="Calibri"/>
-              <a:ea typeface="Calibri"/>
-              <a:cs typeface="Calibri"/>
-            </a:endParaRPr>
-          </a:p>
-          <a:p>
-            <a:pPr algn="just" fontAlgn="base" hangingPunct="0">
-              <a:defRPr/>
-            </a:pPr>
-            <a:endParaRPr lang="en-US" sz="1600" dirty="0">
-              <a:solidFill>
-                <a:prstClr val="black"/>
-              </a:solidFill>
-              <a:latin typeface="Calibri"/>
-              <a:ea typeface="Calibri"/>
-              <a:cs typeface="Calibri"/>
-            </a:endParaRPr>
-          </a:p>
-          <a:p>
-            <a:pPr algn="just" fontAlgn="base" hangingPunct="0">
-              <a:defRPr/>
-            </a:pPr>
-            <a:endParaRPr lang="en-US" sz="1600" i="0" u="none" strike="noStrike" kern="1200" cap="none" spc="0" normalizeH="0" baseline="0" noProof="0" dirty="0">
-              <a:ln>
-                <a:noFill/>
-              </a:ln>
-              <a:solidFill>
-                <a:prstClr val="black"/>
-              </a:solidFill>
-              <a:effectLst/>
-              <a:uLnTx/>
-              <a:uFillTx/>
-              <a:latin typeface="Calibri"/>
-              <a:ea typeface="Calibri"/>
-              <a:cs typeface="Calibri"/>
-            </a:endParaRPr>
-          </a:p>
-          <a:p>
-            <a:pPr algn="just" fontAlgn="base" hangingPunct="0">
-              <a:defRPr/>
-            </a:pPr>
-            <a:endParaRPr lang="en-US" sz="1600" dirty="0">
-              <a:solidFill>
-                <a:prstClr val="black"/>
-              </a:solidFill>
-              <a:latin typeface="Calibri"/>
-              <a:ea typeface="Calibri"/>
-              <a:cs typeface="Calibri"/>
-            </a:endParaRPr>
+              <a:t>PWC (price water house cooper’s) an international firm of accountants and management consultants that provides services to businesses, it is the second largest professional services firm in the world supports trade feeds from various upstream systems into Summit. My process: Incident management is all about incidents or interruption which are made as tickets. These tickets come with priority as critical or normal. SLA is the time fixed for the incident either to resolve or respond. In order to prevent tickets from breaching we had a team for ticket monitoring We monitor both US and UK territory tickets and resolution of tickets was also included in the tickets.</a:t>
+            </a:r>
           </a:p>
           <a:p>
             <a:pPr algn="just" fontAlgn="base" hangingPunct="0">
@@ -5204,223 +5278,88 @@
             </a:r>
           </a:p>
           <a:p>
-            <a:pPr marL="0" marR="0" lvl="0" indent="0" algn="just" defTabSz="914400" rtl="0" eaLnBrk="1" fontAlgn="base" latinLnBrk="0" hangingPunct="0">
-              <a:lnSpc>
-                <a:spcPct val="100000"/>
-              </a:lnSpc>
-              <a:spcBef>
-                <a:spcPts val="0"/>
-              </a:spcBef>
-              <a:spcAft>
-                <a:spcPts val="0"/>
-              </a:spcAft>
-              <a:buClrTx/>
-              <a:buSzTx/>
-              <a:buFontTx/>
-              <a:buNone/>
-              <a:tabLst/>
+            <a:pPr marL="285750" indent="-285750" algn="just" fontAlgn="base" hangingPunct="0">
+              <a:buFont typeface="Arial" panose="020B0604020202020204" pitchFamily="34" charset="0"/>
+              <a:buChar char="•"/>
               <a:defRPr/>
             </a:pPr>
             <a:r>
               <a:rPr lang="en-US" sz="1600" dirty="0">
                 <a:solidFill>
-                  <a:prstClr val="black"/>
-                </a:solidFill>
-                <a:latin typeface="Calibri" panose="020F0502020204030204" pitchFamily="34" charset="0"/>
-                <a:ea typeface="Calibri" panose="020F0502020204030204" pitchFamily="34" charset="0"/>
-                <a:cs typeface="Calibri" panose="020F0502020204030204" pitchFamily="34" charset="0"/>
-              </a:rPr>
-              <a:t>{Responsibilities_Project1}</a:t>
-            </a:r>
-          </a:p>
-          <a:p>
-            <a:pPr marL="0" marR="0" lvl="0" indent="0" algn="just" defTabSz="914400" rtl="0" eaLnBrk="1" fontAlgn="base" latinLnBrk="0" hangingPunct="0">
-              <a:lnSpc>
-                <a:spcPct val="100000"/>
-              </a:lnSpc>
-              <a:spcBef>
-                <a:spcPts val="0"/>
-              </a:spcBef>
-              <a:spcAft>
-                <a:spcPts val="0"/>
-              </a:spcAft>
-              <a:buClrTx/>
-              <a:buSzTx/>
-              <a:buFontTx/>
-              <a:buNone/>
-              <a:tabLst/>
+                  <a:srgbClr val="0D0D0D"/>
+                </a:solidFill>
+                <a:highlight>
+                  <a:srgbClr val="FFFFFF"/>
+                </a:highlight>
+                <a:latin typeface="Calibri"/>
+                <a:ea typeface="Calibri"/>
+                <a:cs typeface="Segoe UI"/>
+              </a:rPr>
+              <a:t>Worked in IT help desk for Price Waterhouse Cooper (PWC) client by providing best and valued IT service to customer.</a:t>
+            </a:r>
+          </a:p>
+          <a:p>
+            <a:pPr marL="285750" indent="-285750" algn="just" fontAlgn="base" hangingPunct="0">
+              <a:buFont typeface="Arial" panose="020B0604020202020204" pitchFamily="34" charset="0"/>
+              <a:buChar char="•"/>
               <a:defRPr/>
             </a:pPr>
-            <a:endParaRPr lang="en-US" sz="1600" dirty="0">
-              <a:solidFill>
-                <a:prstClr val="black"/>
-              </a:solidFill>
-              <a:latin typeface="Calibri" panose="020F0502020204030204" pitchFamily="34" charset="0"/>
-              <a:ea typeface="Calibri" panose="020F0502020204030204" pitchFamily="34" charset="0"/>
-              <a:cs typeface="Calibri" panose="020F0502020204030204" pitchFamily="34" charset="0"/>
-            </a:endParaRPr>
-          </a:p>
-          <a:p>
-            <a:pPr marL="0" marR="0" lvl="0" indent="0" algn="just" defTabSz="914400" rtl="0" eaLnBrk="1" fontAlgn="base" latinLnBrk="0" hangingPunct="0">
-              <a:lnSpc>
-                <a:spcPct val="100000"/>
-              </a:lnSpc>
-              <a:spcBef>
-                <a:spcPts val="0"/>
-              </a:spcBef>
-              <a:spcAft>
-                <a:spcPts val="0"/>
-              </a:spcAft>
-              <a:buClrTx/>
-              <a:buSzTx/>
-              <a:buFontTx/>
-              <a:buNone/>
-              <a:tabLst/>
+            <a:r>
+              <a:rPr lang="en-US" sz="1600" dirty="0">
+                <a:solidFill>
+                  <a:srgbClr val="0D0D0D"/>
+                </a:solidFill>
+                <a:highlight>
+                  <a:srgbClr val="FFFFFF"/>
+                </a:highlight>
+                <a:latin typeface="Calibri"/>
+                <a:ea typeface="Calibri"/>
+                <a:cs typeface="Segoe UI"/>
+              </a:rPr>
+              <a:t>Involved in providing IT solutions for infrastructure, internal Applications and Global finances services by resolving tickets.</a:t>
+            </a:r>
+          </a:p>
+          <a:p>
+            <a:pPr marL="285750" indent="-285750" algn="just" fontAlgn="base" hangingPunct="0">
+              <a:buFont typeface="Arial" panose="020B0604020202020204" pitchFamily="34" charset="0"/>
+              <a:buChar char="•"/>
               <a:defRPr/>
             </a:pPr>
-            <a:endParaRPr lang="en-US" sz="1600" dirty="0">
-              <a:solidFill>
-                <a:prstClr val="black"/>
-              </a:solidFill>
-              <a:latin typeface="Calibri" panose="020F0502020204030204" pitchFamily="34" charset="0"/>
-              <a:ea typeface="Calibri" panose="020F0502020204030204" pitchFamily="34" charset="0"/>
-              <a:cs typeface="Calibri" panose="020F0502020204030204" pitchFamily="34" charset="0"/>
-            </a:endParaRPr>
-          </a:p>
-          <a:p>
-            <a:pPr marL="0" marR="0" lvl="0" indent="0" algn="just" defTabSz="914400" rtl="0" eaLnBrk="1" fontAlgn="base" latinLnBrk="0" hangingPunct="0">
-              <a:lnSpc>
-                <a:spcPct val="100000"/>
-              </a:lnSpc>
-              <a:spcBef>
-                <a:spcPts val="0"/>
-              </a:spcBef>
-              <a:spcAft>
-                <a:spcPts val="0"/>
-              </a:spcAft>
-              <a:buClrTx/>
-              <a:buSzTx/>
-              <a:buFontTx/>
-              <a:buNone/>
-              <a:tabLst/>
+            <a:r>
+              <a:rPr lang="en-US" sz="1600" dirty="0">
+                <a:solidFill>
+                  <a:srgbClr val="0D0D0D"/>
+                </a:solidFill>
+                <a:highlight>
+                  <a:srgbClr val="FFFFFF"/>
+                </a:highlight>
+                <a:latin typeface="Calibri"/>
+                <a:ea typeface="Calibri"/>
+                <a:cs typeface="Segoe UI"/>
+              </a:rPr>
+              <a:t>Involved in creating Knowledge base (KB) article for providing IT solutions in a particular ORDER.</a:t>
+            </a:r>
+          </a:p>
+          <a:p>
+            <a:pPr marL="285750" indent="-285750" algn="just" fontAlgn="base" hangingPunct="0">
+              <a:buFont typeface="Arial" panose="020B0604020202020204" pitchFamily="34" charset="0"/>
+              <a:buChar char="•"/>
               <a:defRPr/>
             </a:pPr>
-            <a:endParaRPr lang="en-US" sz="1600" dirty="0">
-              <a:solidFill>
-                <a:prstClr val="black"/>
-              </a:solidFill>
-              <a:latin typeface="Calibri" panose="020F0502020204030204" pitchFamily="34" charset="0"/>
-              <a:ea typeface="Calibri" panose="020F0502020204030204" pitchFamily="34" charset="0"/>
-              <a:cs typeface="Calibri" panose="020F0502020204030204" pitchFamily="34" charset="0"/>
-            </a:endParaRPr>
-          </a:p>
-          <a:p>
-            <a:pPr marL="0" marR="0" lvl="0" indent="0" algn="just" defTabSz="914400" rtl="0" eaLnBrk="1" fontAlgn="base" latinLnBrk="0" hangingPunct="0">
-              <a:lnSpc>
-                <a:spcPct val="100000"/>
-              </a:lnSpc>
-              <a:spcBef>
-                <a:spcPts val="0"/>
-              </a:spcBef>
-              <a:spcAft>
-                <a:spcPts val="0"/>
-              </a:spcAft>
-              <a:buClrTx/>
-              <a:buSzTx/>
-              <a:buFontTx/>
-              <a:buNone/>
-              <a:tabLst/>
-              <a:defRPr/>
-            </a:pPr>
-            <a:endParaRPr lang="en-US" sz="1600" dirty="0">
-              <a:solidFill>
-                <a:prstClr val="black"/>
-              </a:solidFill>
-              <a:latin typeface="Calibri" panose="020F0502020204030204" pitchFamily="34" charset="0"/>
-              <a:ea typeface="Calibri" panose="020F0502020204030204" pitchFamily="34" charset="0"/>
-              <a:cs typeface="Calibri" panose="020F0502020204030204" pitchFamily="34" charset="0"/>
-            </a:endParaRPr>
-          </a:p>
-          <a:p>
-            <a:pPr marL="0" marR="0" lvl="0" indent="0" algn="just" defTabSz="914400" rtl="0" eaLnBrk="1" fontAlgn="base" latinLnBrk="0" hangingPunct="0">
-              <a:lnSpc>
-                <a:spcPct val="100000"/>
-              </a:lnSpc>
-              <a:spcBef>
-                <a:spcPts val="0"/>
-              </a:spcBef>
-              <a:spcAft>
-                <a:spcPts val="0"/>
-              </a:spcAft>
-              <a:buClrTx/>
-              <a:buSzTx/>
-              <a:buFontTx/>
-              <a:buNone/>
-              <a:tabLst/>
-              <a:defRPr/>
-            </a:pPr>
-            <a:endParaRPr lang="en-US" sz="1600" dirty="0">
-              <a:solidFill>
-                <a:prstClr val="black"/>
-              </a:solidFill>
-              <a:latin typeface="Calibri" panose="020F0502020204030204" pitchFamily="34" charset="0"/>
-              <a:ea typeface="Calibri" panose="020F0502020204030204" pitchFamily="34" charset="0"/>
-              <a:cs typeface="Calibri" panose="020F0502020204030204" pitchFamily="34" charset="0"/>
-            </a:endParaRPr>
-          </a:p>
-          <a:p>
-            <a:pPr marL="0" marR="0" lvl="0" indent="0" algn="just" defTabSz="914400" rtl="0" eaLnBrk="1" fontAlgn="base" latinLnBrk="0" hangingPunct="0">
-              <a:lnSpc>
-                <a:spcPct val="100000"/>
-              </a:lnSpc>
-              <a:spcBef>
-                <a:spcPts val="0"/>
-              </a:spcBef>
-              <a:spcAft>
-                <a:spcPts val="0"/>
-              </a:spcAft>
-              <a:buClrTx/>
-              <a:buSzTx/>
-              <a:buFontTx/>
-              <a:buNone/>
-              <a:tabLst/>
-              <a:defRPr/>
-            </a:pPr>
-            <a:endParaRPr lang="en-US" sz="1600" dirty="0">
-              <a:solidFill>
-                <a:prstClr val="black"/>
-              </a:solidFill>
-              <a:latin typeface="Calibri" panose="020F0502020204030204" pitchFamily="34" charset="0"/>
-              <a:ea typeface="Calibri" panose="020F0502020204030204" pitchFamily="34" charset="0"/>
-              <a:cs typeface="Calibri" panose="020F0502020204030204" pitchFamily="34" charset="0"/>
-            </a:endParaRPr>
-          </a:p>
-          <a:p>
-            <a:pPr marL="0" marR="0" lvl="0" indent="0" algn="just" defTabSz="914400" rtl="0" eaLnBrk="1" fontAlgn="base" latinLnBrk="0" hangingPunct="0">
-              <a:lnSpc>
-                <a:spcPct val="100000"/>
-              </a:lnSpc>
-              <a:spcBef>
-                <a:spcPts val="0"/>
-              </a:spcBef>
-              <a:spcAft>
-                <a:spcPts val="0"/>
-              </a:spcAft>
-              <a:buClrTx/>
-              <a:buSzTx/>
-              <a:buFontTx/>
-              <a:buNone/>
-              <a:tabLst/>
-              <a:defRPr/>
-            </a:pPr>
-            <a:endParaRPr lang="en-US" sz="1600" dirty="0">
-              <a:solidFill>
-                <a:prstClr val="black"/>
-              </a:solidFill>
-              <a:latin typeface="Calibri" panose="020F0502020204030204" pitchFamily="34" charset="0"/>
-              <a:ea typeface="Calibri" panose="020F0502020204030204" pitchFamily="34" charset="0"/>
-              <a:cs typeface="Calibri" panose="020F0502020204030204" pitchFamily="34" charset="0"/>
-            </a:endParaRPr>
+            <a:r>
+              <a:rPr lang="en-US" sz="1600" dirty="0">
+                <a:solidFill>
+                  <a:srgbClr val="0D0D0D"/>
+                </a:solidFill>
+                <a:highlight>
+                  <a:srgbClr val="FFFFFF"/>
+                </a:highlight>
+                <a:latin typeface="Calibri"/>
+                <a:ea typeface="Calibri"/>
+                <a:cs typeface="Segoe UI"/>
+              </a:rPr>
+              <a:t>Took leadership and acted as a subject Matter Expert (SME) by leading a team.</a:t>
+            </a:r>
           </a:p>
         </p:txBody>
       </p:sp>
@@ -5640,7 +5579,7 @@
         <p:cNvPr id="1" name="">
           <a:extLst>
             <a:ext uri="{FF2B5EF4-FFF2-40B4-BE49-F238E27FC236}">
-              <a16:creationId xmlns:a16="http://schemas.microsoft.com/office/drawing/2014/main" id="{14D6FA36-51EF-5596-4E03-98DBABC7CE7F}"/>
+              <a16:creationId xmlns:a16="http://schemas.microsoft.com/office/drawing/2014/main" id="{DA9D82DC-B40F-499F-B2F1-D546FF566C02}"/>
             </a:ext>
           </a:extLst>
         </p:cNvPr>
@@ -5660,7 +5599,7 @@
           <p:cNvPr id="5" name="Slide Number Placeholder 4">
             <a:extLst>
               <a:ext uri="{FF2B5EF4-FFF2-40B4-BE49-F238E27FC236}">
-                <a16:creationId xmlns:a16="http://schemas.microsoft.com/office/drawing/2014/main" id="{C747274B-7E9D-C6F2-7E92-24BD1BA47B39}"/>
+                <a16:creationId xmlns:a16="http://schemas.microsoft.com/office/drawing/2014/main" id="{67290704-6EEE-D0AC-8291-BA48864B1AE5}"/>
               </a:ext>
             </a:extLst>
           </p:cNvPr>
@@ -5753,7 +5692,7 @@
           <p:cNvPr id="7" name="TextBox 6">
             <a:extLst>
               <a:ext uri="{FF2B5EF4-FFF2-40B4-BE49-F238E27FC236}">
-                <a16:creationId xmlns:a16="http://schemas.microsoft.com/office/drawing/2014/main" id="{281E5FE1-4888-CBDF-0DD5-A41BA5FEEA8D}"/>
+                <a16:creationId xmlns:a16="http://schemas.microsoft.com/office/drawing/2014/main" id="{6BAA8868-FDEB-212D-0E84-B1B339220F85}"/>
               </a:ext>
             </a:extLst>
           </p:cNvPr>
@@ -5762,8 +5701,8 @@
         </p:nvSpPr>
         <p:spPr>
           <a:xfrm>
-            <a:off x="304800" y="634824"/>
-            <a:ext cx="9954892" cy="923330"/>
+            <a:off x="304798" y="403733"/>
+            <a:ext cx="10278256" cy="1754326"/>
           </a:xfrm>
           <a:prstGeom prst="rect">
             <a:avLst/>
@@ -5794,7 +5733,7 @@
                 <a:ea typeface="Calibri"/>
                 <a:cs typeface="Calibri"/>
               </a:rPr>
-              <a:t>Project: {PROJECT2_NAME}</a:t>
+              <a:t>Project:</a:t>
             </a:r>
             <a:r>
               <a:rPr lang="en-US" b="1" dirty="0">
@@ -5805,7 +5744,18 @@
                 <a:ea typeface="Calibri"/>
                 <a:cs typeface="Calibri"/>
               </a:rPr>
-              <a:t>.</a:t>
+              <a:t> </a:t>
+            </a:r>
+            <a:r>
+              <a:rPr lang="en-US" b="1" dirty="0">
+                <a:solidFill>
+                  <a:prstClr val="black"/>
+                </a:solidFill>
+                <a:latin typeface="Calibri"/>
+                <a:ea typeface="Calibri"/>
+                <a:cs typeface="Segoe UI"/>
+              </a:rPr>
+              <a:t>Information System</a:t>
             </a:r>
             <a:endParaRPr lang="en-US" b="1" i="0" u="none" strike="noStrike" kern="1200" cap="none" spc="0" normalizeH="0" baseline="0" noProof="0" dirty="0">
               <a:ln>
@@ -5841,28 +5791,74 @@
                 <a:ea typeface="Calibri"/>
                 <a:cs typeface="Calibri"/>
               </a:rPr>
-              <a:t>Duration : {DURATION_PROJECT2}</a:t>
-            </a:r>
+              <a:t>Duration : </a:t>
+            </a:r>
+            <a:r>
+              <a:rPr lang="en-US" b="1" dirty="0">
+                <a:solidFill>
+                  <a:prstClr val="black"/>
+                </a:solidFill>
+                <a:latin typeface="Calibri"/>
+                <a:ea typeface="Calibri"/>
+                <a:cs typeface="Segoe UI"/>
+              </a:rPr>
+              <a:t>May’2022 – Oct’2024</a:t>
+            </a:r>
+          </a:p>
+          <a:p>
+            <a:pPr>
+              <a:defRPr/>
+            </a:pPr>
+            <a:r>
+              <a:rPr lang="en-US" b="1" dirty="0"/>
+              <a:t>Role</a:t>
+            </a:r>
+            <a:r>
+              <a:rPr lang="en-US" dirty="0"/>
+              <a:t>: Automation Tester</a:t>
+            </a:r>
+            <a:endParaRPr lang="en-IN" dirty="0"/>
+          </a:p>
+          <a:p>
+            <a:pPr>
+              <a:defRPr/>
+            </a:pPr>
             <a:endParaRPr lang="en-US" b="1" dirty="0">
               <a:solidFill>
                 <a:prstClr val="black"/>
               </a:solidFill>
               <a:latin typeface="Calibri"/>
               <a:ea typeface="Calibri"/>
-              <a:cs typeface="Calibri"/>
+              <a:cs typeface="Segoe UI"/>
             </a:endParaRPr>
           </a:p>
           <a:p>
             <a:pPr>
               <a:defRPr/>
             </a:pPr>
-            <a:r>
-              <a:rPr lang="en-US" b="1" dirty="0"/>
-              <a:t>Role</a:t>
-            </a:r>
-            <a:r>
-              <a:rPr lang="en-US" dirty="0"/>
-              <a:t>: {ROLE_PROJECT2}</a:t>
+            <a:endParaRPr lang="en-US" b="1" dirty="0">
+              <a:solidFill>
+                <a:prstClr val="black"/>
+              </a:solidFill>
+              <a:latin typeface="Calibri"/>
+              <a:ea typeface="Calibri"/>
+              <a:cs typeface="Segoe UI"/>
+            </a:endParaRPr>
+          </a:p>
+          <a:p>
+            <a:pPr>
+              <a:defRPr/>
+            </a:pPr>
+            <a:r>
+              <a:rPr lang="en-US" b="1" dirty="0">
+                <a:solidFill>
+                  <a:prstClr val="black"/>
+                </a:solidFill>
+                <a:latin typeface="Calibri"/>
+                <a:ea typeface="Calibri"/>
+                <a:cs typeface="Segoe UI"/>
+              </a:rPr>
+              <a:t> </a:t>
             </a:r>
             <a:endParaRPr lang="en-US" b="1" i="0" u="none" strike="noStrike" kern="1200" cap="none" spc="0" normalizeH="0" baseline="0" noProof="0" dirty="0">
               <a:ln>
@@ -5876,7 +5872,7 @@
               <a:uFillTx/>
               <a:latin typeface="Calibri"/>
               <a:ea typeface="Calibri"/>
-              <a:cs typeface="Calibri"/>
+              <a:cs typeface="Segoe UI"/>
             </a:endParaRPr>
           </a:p>
         </p:txBody>
@@ -5886,7 +5882,7 @@
           <p:cNvPr id="11" name="TextBox 10">
             <a:extLst>
               <a:ext uri="{FF2B5EF4-FFF2-40B4-BE49-F238E27FC236}">
-                <a16:creationId xmlns:a16="http://schemas.microsoft.com/office/drawing/2014/main" id="{901A2AF5-92CA-8F25-88FA-D406713C067E}"/>
+                <a16:creationId xmlns:a16="http://schemas.microsoft.com/office/drawing/2014/main" id="{3F56B683-987F-2AB2-3C43-65E5943B627C}"/>
               </a:ext>
             </a:extLst>
           </p:cNvPr>
@@ -5895,8 +5891,8 @@
         </p:nvSpPr>
         <p:spPr>
           <a:xfrm>
-            <a:off x="304800" y="2132178"/>
-            <a:ext cx="11691257" cy="4524315"/>
+            <a:off x="304798" y="1489273"/>
+            <a:ext cx="11582400" cy="5232202"/>
           </a:xfrm>
           <a:prstGeom prst="rect">
             <a:avLst/>
@@ -5909,45 +5905,58 @@
           </a:bodyPr>
           <a:lstStyle/>
           <a:p>
-            <a:pPr algn="just" fontAlgn="base" hangingPunct="0">
+            <a:pPr algn="just">
               <a:defRPr/>
             </a:pPr>
             <a:r>
-              <a:rPr lang="en-US" sz="1600" i="0" u="none" strike="noStrike" kern="1200" cap="none" spc="0" normalizeH="0" baseline="0" noProof="0" dirty="0">
-                <a:ln>
-                  <a:noFill/>
-                </a:ln>
+              <a:rPr lang="en-US" sz="1600" b="1" dirty="0">
                 <a:solidFill>
                   <a:prstClr val="black"/>
                 </a:solidFill>
-                <a:effectLst/>
-                <a:uLnTx/>
-                <a:uFillTx/>
-                <a:latin typeface="Calibri"/>
-                <a:ea typeface="Calibri"/>
-                <a:cs typeface="Calibri"/>
-              </a:rPr>
-              <a:t>{Project2_Description}:</a:t>
-            </a:r>
-          </a:p>
-          <a:p>
-            <a:pPr algn="just" fontAlgn="base" hangingPunct="0">
+                <a:latin typeface="Calibri" panose="020F0502020204030204" pitchFamily="34" charset="0"/>
+                <a:ea typeface="Calibri" panose="020F0502020204030204" pitchFamily="34" charset="0"/>
+                <a:cs typeface="Calibri" panose="020F0502020204030204" pitchFamily="34" charset="0"/>
+              </a:rPr>
+              <a:t>Project Overview</a:t>
+            </a:r>
+            <a:r>
+              <a:rPr lang="en-US" sz="1600" dirty="0">
+                <a:solidFill>
+                  <a:prstClr val="black"/>
+                </a:solidFill>
+                <a:latin typeface="Calibri" panose="020F0502020204030204" pitchFamily="34" charset="0"/>
+                <a:ea typeface="Calibri" panose="020F0502020204030204" pitchFamily="34" charset="0"/>
+                <a:cs typeface="Calibri" panose="020F0502020204030204" pitchFamily="34" charset="0"/>
+              </a:rPr>
+              <a:t>:</a:t>
+            </a:r>
+            <a:endParaRPr lang="en-US" sz="1600" dirty="0">
+              <a:latin typeface="Calibri" panose="020F0502020204030204" pitchFamily="34" charset="0"/>
+              <a:ea typeface="Calibri" panose="020F0502020204030204" pitchFamily="34" charset="0"/>
+              <a:cs typeface="Calibri" panose="020F0502020204030204" pitchFamily="34" charset="0"/>
+            </a:endParaRPr>
+          </a:p>
+          <a:p>
+            <a:pPr algn="just">
               <a:defRPr/>
             </a:pPr>
-            <a:endParaRPr lang="en-US" sz="1600" dirty="0">
-              <a:solidFill>
-                <a:prstClr val="black"/>
-              </a:solidFill>
-              <a:latin typeface="Calibri"/>
-              <a:ea typeface="Calibri"/>
-              <a:cs typeface="Calibri"/>
-            </a:endParaRPr>
-          </a:p>
-          <a:p>
-            <a:pPr algn="just" fontAlgn="base" hangingPunct="0">
+            <a:r>
+              <a:rPr lang="en-US" sz="1600" dirty="0">
+                <a:solidFill>
+                  <a:prstClr val="black"/>
+                </a:solidFill>
+                <a:latin typeface="Calibri" panose="020F0502020204030204" pitchFamily="34" charset="0"/>
+                <a:ea typeface="Calibri" panose="020F0502020204030204" pitchFamily="34" charset="0"/>
+                <a:cs typeface="Calibri" panose="020F0502020204030204" pitchFamily="34" charset="0"/>
+              </a:rPr>
+              <a:t>This is an internal project at Infosys focused on developing and maintaining web and mobile applications used by the company's employees. These applications support various business processes, such as Attendance, Health Insurance, and employee communication, aiming to improve efficiency and user experience. The project ensures that these tools are secure, user-friendly, and aligned with the company's internal policies and objectives.</a:t>
+            </a:r>
+          </a:p>
+          <a:p>
+            <a:pPr algn="just">
               <a:defRPr/>
             </a:pPr>
-            <a:endParaRPr lang="en-US" sz="1600" i="0" u="none" strike="noStrike" kern="1200" cap="none" spc="0" normalizeH="0" baseline="0" noProof="0" dirty="0">
+            <a:endParaRPr lang="en-US" sz="1500" b="0" i="0" u="none" strike="noStrike" kern="1200" cap="none" spc="0" normalizeH="0" baseline="0" noProof="0" dirty="0">
               <a:ln>
                 <a:noFill/>
               </a:ln>
@@ -5957,105 +5966,9 @@
               <a:effectLst/>
               <a:uLnTx/>
               <a:uFillTx/>
-              <a:latin typeface="Calibri"/>
-              <a:ea typeface="Calibri"/>
-              <a:cs typeface="Calibri"/>
-            </a:endParaRPr>
-          </a:p>
-          <a:p>
-            <a:pPr algn="just" fontAlgn="base" hangingPunct="0">
-              <a:defRPr/>
-            </a:pPr>
-            <a:endParaRPr lang="en-US" sz="1600" dirty="0">
-              <a:solidFill>
-                <a:prstClr val="black"/>
-              </a:solidFill>
-              <a:latin typeface="Calibri"/>
-              <a:ea typeface="Calibri"/>
-              <a:cs typeface="Calibri"/>
-            </a:endParaRPr>
-          </a:p>
-          <a:p>
-            <a:pPr algn="just" fontAlgn="base" hangingPunct="0">
-              <a:defRPr/>
-            </a:pPr>
-            <a:endParaRPr lang="en-US" sz="1600" i="0" u="none" strike="noStrike" kern="1200" cap="none" spc="0" normalizeH="0" baseline="0" noProof="0" dirty="0">
-              <a:ln>
-                <a:noFill/>
-              </a:ln>
-              <a:solidFill>
-                <a:prstClr val="black"/>
-              </a:solidFill>
-              <a:effectLst/>
-              <a:uLnTx/>
-              <a:uFillTx/>
-              <a:latin typeface="Calibri"/>
-              <a:ea typeface="Calibri"/>
-              <a:cs typeface="Calibri"/>
-            </a:endParaRPr>
-          </a:p>
-          <a:p>
-            <a:pPr algn="just" fontAlgn="base" hangingPunct="0">
-              <a:defRPr/>
-            </a:pPr>
-            <a:endParaRPr lang="en-US" sz="1600" dirty="0">
-              <a:solidFill>
-                <a:prstClr val="black"/>
-              </a:solidFill>
-              <a:latin typeface="Calibri"/>
-              <a:ea typeface="Calibri"/>
-              <a:cs typeface="Calibri"/>
-            </a:endParaRPr>
-          </a:p>
-          <a:p>
-            <a:pPr algn="just" fontAlgn="base" hangingPunct="0">
-              <a:defRPr/>
-            </a:pPr>
-            <a:endParaRPr lang="en-US" sz="1600" i="0" u="none" strike="noStrike" kern="1200" cap="none" spc="0" normalizeH="0" baseline="0" noProof="0" dirty="0">
-              <a:ln>
-                <a:noFill/>
-              </a:ln>
-              <a:solidFill>
-                <a:prstClr val="black"/>
-              </a:solidFill>
-              <a:effectLst/>
-              <a:uLnTx/>
-              <a:uFillTx/>
-              <a:latin typeface="Calibri"/>
-              <a:ea typeface="Calibri"/>
-              <a:cs typeface="Calibri"/>
-            </a:endParaRPr>
-          </a:p>
-          <a:p>
-            <a:pPr algn="just" fontAlgn="base" hangingPunct="0">
-              <a:defRPr/>
-            </a:pPr>
-            <a:endParaRPr lang="en-US" sz="1600" dirty="0">
-              <a:solidFill>
-                <a:prstClr val="black"/>
-              </a:solidFill>
-              <a:latin typeface="Calibri"/>
-              <a:ea typeface="Calibri"/>
-              <a:cs typeface="Calibri"/>
-            </a:endParaRPr>
-          </a:p>
-          <a:p>
-            <a:pPr algn="just" fontAlgn="base" hangingPunct="0">
-              <a:defRPr/>
-            </a:pPr>
-            <a:endParaRPr lang="en-US" sz="1600" i="0" u="none" strike="noStrike" kern="1200" cap="none" spc="0" normalizeH="0" baseline="0" noProof="0" dirty="0">
-              <a:ln>
-                <a:noFill/>
-              </a:ln>
-              <a:solidFill>
-                <a:prstClr val="black"/>
-              </a:solidFill>
-              <a:effectLst/>
-              <a:uLnTx/>
-              <a:uFillTx/>
-              <a:latin typeface="Calibri"/>
-              <a:ea typeface="Calibri"/>
-              <a:cs typeface="Calibri"/>
+              <a:latin typeface="Calibri" panose="020F0502020204030204" pitchFamily="34" charset="0"/>
+              <a:ea typeface="Calibri" panose="020F0502020204030204" pitchFamily="34" charset="0"/>
+              <a:cs typeface="Calibri" panose="020F0502020204030204" pitchFamily="34" charset="0"/>
             </a:endParaRPr>
           </a:p>
           <a:p>
@@ -6077,66 +5990,87 @@
               <a:defRPr/>
             </a:pPr>
             <a:r>
-              <a:rPr lang="en-US" sz="1600" b="1" dirty="0">
+              <a:rPr kumimoji="0" lang="en-US" sz="1600" b="1" i="0" u="none" strike="noStrike" kern="1200" cap="none" spc="0" normalizeH="0" baseline="0" noProof="0" dirty="0">
+                <a:ln>
+                  <a:noFill/>
+                </a:ln>
                 <a:solidFill>
                   <a:prstClr val="black"/>
                 </a:solidFill>
+                <a:effectLst/>
+                <a:uLnTx/>
+                <a:uFillTx/>
                 <a:latin typeface="Calibri" panose="020F0502020204030204" pitchFamily="34" charset="0"/>
                 <a:ea typeface="Calibri" panose="020F0502020204030204" pitchFamily="34" charset="0"/>
                 <a:cs typeface="Calibri" panose="020F0502020204030204" pitchFamily="34" charset="0"/>
               </a:rPr>
-              <a:t>Responsibilities: </a:t>
-            </a:r>
-          </a:p>
-          <a:p>
-            <a:pPr marL="0" marR="0" lvl="0" indent="0" algn="just" defTabSz="914400" rtl="0" eaLnBrk="1" fontAlgn="base" latinLnBrk="0" hangingPunct="0">
-              <a:lnSpc>
-                <a:spcPct val="100000"/>
-              </a:lnSpc>
-              <a:spcBef>
-                <a:spcPts val="0"/>
-              </a:spcBef>
-              <a:spcAft>
-                <a:spcPts val="0"/>
-              </a:spcAft>
-              <a:buClrTx/>
-              <a:buSzTx/>
-              <a:buFontTx/>
-              <a:buNone/>
-              <a:tabLst/>
-              <a:defRPr/>
-            </a:pPr>
-            <a:r>
-              <a:rPr lang="en-US" sz="1600" dirty="0">
+              <a:t>Responsibilities</a:t>
+            </a:r>
+            <a:r>
+              <a:rPr kumimoji="0" lang="en-US" sz="1600" b="0" i="0" u="none" strike="noStrike" kern="1200" cap="none" spc="0" normalizeH="0" baseline="0" noProof="0" dirty="0">
+                <a:ln>
+                  <a:noFill/>
+                </a:ln>
                 <a:solidFill>
                   <a:prstClr val="black"/>
                 </a:solidFill>
+                <a:effectLst/>
+                <a:uLnTx/>
+                <a:uFillTx/>
                 <a:latin typeface="Calibri" panose="020F0502020204030204" pitchFamily="34" charset="0"/>
                 <a:ea typeface="Calibri" panose="020F0502020204030204" pitchFamily="34" charset="0"/>
                 <a:cs typeface="Calibri" panose="020F0502020204030204" pitchFamily="34" charset="0"/>
               </a:rPr>
-              <a:t>{Responsibilities_project2}</a:t>
-            </a:r>
-          </a:p>
-          <a:p>
-            <a:pPr marL="0" marR="0" lvl="0" indent="0" algn="just" defTabSz="914400" rtl="0" eaLnBrk="1" fontAlgn="base" latinLnBrk="0" hangingPunct="0">
-              <a:lnSpc>
-                <a:spcPct val="100000"/>
-              </a:lnSpc>
-              <a:spcBef>
-                <a:spcPts val="0"/>
-              </a:spcBef>
-              <a:spcAft>
-                <a:spcPts val="0"/>
-              </a:spcAft>
-              <a:buClrTx/>
-              <a:buSzTx/>
-              <a:buFontTx/>
-              <a:buNone/>
-              <a:tabLst/>
+              <a:t>: </a:t>
+            </a:r>
+            <a:endParaRPr lang="en-US" sz="1600" b="0" i="0" u="none" strike="noStrike" kern="1200" cap="none" spc="0" normalizeH="0" baseline="0" noProof="0" dirty="0">
+              <a:ln>
+                <a:noFill/>
+              </a:ln>
+              <a:solidFill>
+                <a:prstClr val="black"/>
+              </a:solidFill>
+              <a:effectLst/>
+              <a:uLnTx/>
+              <a:uFillTx/>
+              <a:latin typeface="Calibri" panose="020F0502020204030204" pitchFamily="34" charset="0"/>
+              <a:ea typeface="Calibri" panose="020F0502020204030204" pitchFamily="34" charset="0"/>
+              <a:cs typeface="Calibri" panose="020F0502020204030204" pitchFamily="34" charset="0"/>
+            </a:endParaRPr>
+          </a:p>
+          <a:p>
+            <a:pPr algn="just">
               <a:defRPr/>
             </a:pPr>
-            <a:endParaRPr lang="en-US" sz="1600" dirty="0">
+            <a:endParaRPr lang="en-US" sz="1500" dirty="0">
+              <a:solidFill>
+                <a:srgbClr val="000000"/>
+              </a:solidFill>
+              <a:highlight>
+                <a:srgbClr val="FFFFFF"/>
+              </a:highlight>
+              <a:latin typeface="Calibri" panose="020F0502020204030204" pitchFamily="34" charset="0"/>
+              <a:ea typeface="Calibri" panose="020F0502020204030204" pitchFamily="34" charset="0"/>
+              <a:cs typeface="Calibri" panose="020F0502020204030204" pitchFamily="34" charset="0"/>
+            </a:endParaRPr>
+          </a:p>
+          <a:p>
+            <a:pPr marL="285750" lvl="0" indent="-285750">
+              <a:buFont typeface="Arial" panose="020B0604020202020204" pitchFamily="34" charset="0"/>
+              <a:buChar char="•"/>
+            </a:pPr>
+            <a:r>
+              <a:rPr lang="en-US" sz="1600" dirty="0">
+                <a:solidFill>
+                  <a:prstClr val="black"/>
+                </a:solidFill>
+                <a:latin typeface="Calibri" panose="020F0502020204030204" pitchFamily="34" charset="0"/>
+                <a:ea typeface="Calibri" panose="020F0502020204030204" pitchFamily="34" charset="0"/>
+                <a:cs typeface="Calibri" panose="020F0502020204030204" pitchFamily="34" charset="0"/>
+              </a:rPr>
+              <a:t>Well experienced in Software Testing (Manual and Automation) for Web, Mobile, and REST APIs.</a:t>
+            </a:r>
+            <a:endParaRPr lang="en-IN" sz="1600" dirty="0">
               <a:solidFill>
                 <a:prstClr val="black"/>
               </a:solidFill>
@@ -6146,24 +6080,22 @@
             </a:endParaRPr>
           </a:p>
           <a:p>
-            <a:pPr marL="0" marR="0" lvl="0" indent="0" algn="just" defTabSz="914400" rtl="0" eaLnBrk="1" fontAlgn="base" latinLnBrk="0" hangingPunct="0">
-              <a:lnSpc>
-                <a:spcPct val="100000"/>
-              </a:lnSpc>
-              <a:spcBef>
-                <a:spcPts val="0"/>
-              </a:spcBef>
-              <a:spcAft>
-                <a:spcPts val="0"/>
-              </a:spcAft>
-              <a:buClrTx/>
-              <a:buSzTx/>
-              <a:buFontTx/>
-              <a:buNone/>
-              <a:tabLst/>
-              <a:defRPr/>
-            </a:pPr>
-            <a:endParaRPr lang="en-US" sz="1600" dirty="0">
+            <a:pPr marL="285750" lvl="0" indent="-285750">
+              <a:buFont typeface="Arial" panose="020B0604020202020204" pitchFamily="34" charset="0"/>
+              <a:buChar char="•"/>
+            </a:pPr>
+            <a:r>
+              <a:rPr lang="en-US" sz="1600" dirty="0">
+                <a:solidFill>
+                  <a:prstClr val="black"/>
+                </a:solidFill>
+                <a:latin typeface="Calibri" panose="020F0502020204030204" pitchFamily="34" charset="0"/>
+                <a:ea typeface="Calibri" panose="020F0502020204030204" pitchFamily="34" charset="0"/>
+                <a:cs typeface="Calibri" panose="020F0502020204030204" pitchFamily="34" charset="0"/>
+              </a:rPr>
+              <a:t>Proficient in SDLC, STLC with expertise in Test Plan, Test Case, and Test Execution.</a:t>
+            </a:r>
+            <a:endParaRPr lang="en-IN" sz="1600" dirty="0">
               <a:solidFill>
                 <a:prstClr val="black"/>
               </a:solidFill>
@@ -6173,24 +6105,22 @@
             </a:endParaRPr>
           </a:p>
           <a:p>
-            <a:pPr marL="0" marR="0" lvl="0" indent="0" algn="just" defTabSz="914400" rtl="0" eaLnBrk="1" fontAlgn="base" latinLnBrk="0" hangingPunct="0">
-              <a:lnSpc>
-                <a:spcPct val="100000"/>
-              </a:lnSpc>
-              <a:spcBef>
-                <a:spcPts val="0"/>
-              </a:spcBef>
-              <a:spcAft>
-                <a:spcPts val="0"/>
-              </a:spcAft>
-              <a:buClrTx/>
-              <a:buSzTx/>
-              <a:buFontTx/>
-              <a:buNone/>
-              <a:tabLst/>
-              <a:defRPr/>
-            </a:pPr>
-            <a:endParaRPr lang="en-US" sz="1600" dirty="0">
+            <a:pPr marL="285750" lvl="0" indent="-285750">
+              <a:buFont typeface="Arial" panose="020B0604020202020204" pitchFamily="34" charset="0"/>
+              <a:buChar char="•"/>
+            </a:pPr>
+            <a:r>
+              <a:rPr lang="en-US" sz="1600" dirty="0">
+                <a:solidFill>
+                  <a:prstClr val="black"/>
+                </a:solidFill>
+                <a:latin typeface="Calibri" panose="020F0502020204030204" pitchFamily="34" charset="0"/>
+                <a:ea typeface="Calibri" panose="020F0502020204030204" pitchFamily="34" charset="0"/>
+                <a:cs typeface="Calibri" panose="020F0502020204030204" pitchFamily="34" charset="0"/>
+              </a:rPr>
+              <a:t>Proficient knowledge of Defect Life Cycle and logging the defects along with defect tracking and report generation.</a:t>
+            </a:r>
+            <a:endParaRPr lang="en-IN" sz="1600" dirty="0">
               <a:solidFill>
                 <a:prstClr val="black"/>
               </a:solidFill>
@@ -6200,24 +6130,22 @@
             </a:endParaRPr>
           </a:p>
           <a:p>
-            <a:pPr marL="0" marR="0" lvl="0" indent="0" algn="just" defTabSz="914400" rtl="0" eaLnBrk="1" fontAlgn="base" latinLnBrk="0" hangingPunct="0">
-              <a:lnSpc>
-                <a:spcPct val="100000"/>
-              </a:lnSpc>
-              <a:spcBef>
-                <a:spcPts val="0"/>
-              </a:spcBef>
-              <a:spcAft>
-                <a:spcPts val="0"/>
-              </a:spcAft>
-              <a:buClrTx/>
-              <a:buSzTx/>
-              <a:buFontTx/>
-              <a:buNone/>
-              <a:tabLst/>
-              <a:defRPr/>
-            </a:pPr>
-            <a:endParaRPr lang="en-US" sz="1600" dirty="0">
+            <a:pPr marL="285750" lvl="0" indent="-285750">
+              <a:buFont typeface="Arial" panose="020B0604020202020204" pitchFamily="34" charset="0"/>
+              <a:buChar char="•"/>
+            </a:pPr>
+            <a:r>
+              <a:rPr lang="en-US" sz="1600" dirty="0">
+                <a:solidFill>
+                  <a:prstClr val="black"/>
+                </a:solidFill>
+                <a:latin typeface="Calibri" panose="020F0502020204030204" pitchFamily="34" charset="0"/>
+                <a:ea typeface="Calibri" panose="020F0502020204030204" pitchFamily="34" charset="0"/>
+                <a:cs typeface="Calibri" panose="020F0502020204030204" pitchFamily="34" charset="0"/>
+              </a:rPr>
+              <a:t>Skilled in Functional Testing (System, Regression, Integration &amp; Compatibility) and API Testing using Postman.</a:t>
+            </a:r>
+            <a:endParaRPr lang="en-IN" sz="1600" dirty="0">
               <a:solidFill>
                 <a:prstClr val="black"/>
               </a:solidFill>
@@ -6227,24 +6155,22 @@
             </a:endParaRPr>
           </a:p>
           <a:p>
-            <a:pPr marL="0" marR="0" lvl="0" indent="0" algn="just" defTabSz="914400" rtl="0" eaLnBrk="1" fontAlgn="base" latinLnBrk="0" hangingPunct="0">
-              <a:lnSpc>
-                <a:spcPct val="100000"/>
-              </a:lnSpc>
-              <a:spcBef>
-                <a:spcPts val="0"/>
-              </a:spcBef>
-              <a:spcAft>
-                <a:spcPts val="0"/>
-              </a:spcAft>
-              <a:buClrTx/>
-              <a:buSzTx/>
-              <a:buFontTx/>
-              <a:buNone/>
-              <a:tabLst/>
-              <a:defRPr/>
-            </a:pPr>
-            <a:endParaRPr lang="en-US" sz="1600" dirty="0">
+            <a:pPr marL="285750" lvl="0" indent="-285750">
+              <a:buFont typeface="Arial" panose="020B0604020202020204" pitchFamily="34" charset="0"/>
+              <a:buChar char="•"/>
+            </a:pPr>
+            <a:r>
+              <a:rPr lang="en-US" sz="1600" dirty="0">
+                <a:solidFill>
+                  <a:prstClr val="black"/>
+                </a:solidFill>
+                <a:latin typeface="Calibri" panose="020F0502020204030204" pitchFamily="34" charset="0"/>
+                <a:ea typeface="Calibri" panose="020F0502020204030204" pitchFamily="34" charset="0"/>
+                <a:cs typeface="Calibri" panose="020F0502020204030204" pitchFamily="34" charset="0"/>
+              </a:rPr>
+              <a:t>Extensive experience in Automation Testing with Selenium WebDriver using, and TestNG.</a:t>
+            </a:r>
+            <a:endParaRPr lang="en-IN" sz="1600" dirty="0">
               <a:solidFill>
                 <a:prstClr val="black"/>
               </a:solidFill>
@@ -6254,24 +6180,22 @@
             </a:endParaRPr>
           </a:p>
           <a:p>
-            <a:pPr marL="0" marR="0" lvl="0" indent="0" algn="just" defTabSz="914400" rtl="0" eaLnBrk="1" fontAlgn="base" latinLnBrk="0" hangingPunct="0">
-              <a:lnSpc>
-                <a:spcPct val="100000"/>
-              </a:lnSpc>
-              <a:spcBef>
-                <a:spcPts val="0"/>
-              </a:spcBef>
-              <a:spcAft>
-                <a:spcPts val="0"/>
-              </a:spcAft>
-              <a:buClrTx/>
-              <a:buSzTx/>
-              <a:buFontTx/>
-              <a:buNone/>
-              <a:tabLst/>
-              <a:defRPr/>
-            </a:pPr>
-            <a:endParaRPr lang="en-US" sz="1600" dirty="0">
+            <a:pPr marL="285750" lvl="0" indent="-285750">
+              <a:buFont typeface="Arial" panose="020B0604020202020204" pitchFamily="34" charset="0"/>
+              <a:buChar char="•"/>
+            </a:pPr>
+            <a:r>
+              <a:rPr lang="en-US" sz="1600" dirty="0">
+                <a:solidFill>
+                  <a:prstClr val="black"/>
+                </a:solidFill>
+                <a:latin typeface="Calibri" panose="020F0502020204030204" pitchFamily="34" charset="0"/>
+                <a:ea typeface="Calibri" panose="020F0502020204030204" pitchFamily="34" charset="0"/>
+                <a:cs typeface="Calibri" panose="020F0502020204030204" pitchFamily="34" charset="0"/>
+              </a:rPr>
+              <a:t>Hands-on experience in backend testing using SQL.</a:t>
+            </a:r>
+            <a:endParaRPr lang="en-IN" sz="1600" dirty="0">
               <a:solidFill>
                 <a:prstClr val="black"/>
               </a:solidFill>
@@ -6281,24 +6205,22 @@
             </a:endParaRPr>
           </a:p>
           <a:p>
-            <a:pPr marL="0" marR="0" lvl="0" indent="0" algn="just" defTabSz="914400" rtl="0" eaLnBrk="1" fontAlgn="base" latinLnBrk="0" hangingPunct="0">
-              <a:lnSpc>
-                <a:spcPct val="100000"/>
-              </a:lnSpc>
-              <a:spcBef>
-                <a:spcPts val="0"/>
-              </a:spcBef>
-              <a:spcAft>
-                <a:spcPts val="0"/>
-              </a:spcAft>
-              <a:buClrTx/>
-              <a:buSzTx/>
-              <a:buFontTx/>
-              <a:buNone/>
-              <a:tabLst/>
-              <a:defRPr/>
-            </a:pPr>
-            <a:endParaRPr lang="en-US" sz="1600" dirty="0">
+            <a:pPr marL="285750" lvl="0" indent="-285750">
+              <a:buFont typeface="Arial" panose="020B0604020202020204" pitchFamily="34" charset="0"/>
+              <a:buChar char="•"/>
+            </a:pPr>
+            <a:r>
+              <a:rPr lang="en-US" sz="1600" dirty="0">
+                <a:solidFill>
+                  <a:prstClr val="black"/>
+                </a:solidFill>
+                <a:latin typeface="Calibri" panose="020F0502020204030204" pitchFamily="34" charset="0"/>
+                <a:ea typeface="Calibri" panose="020F0502020204030204" pitchFamily="34" charset="0"/>
+                <a:cs typeface="Calibri" panose="020F0502020204030204" pitchFamily="34" charset="0"/>
+              </a:rPr>
+              <a:t>Knowledge of CI/CD pipelines, including configuring REST APIs for integration.</a:t>
+            </a:r>
+            <a:endParaRPr lang="en-IN" sz="1600" dirty="0">
               <a:solidFill>
                 <a:prstClr val="black"/>
               </a:solidFill>
@@ -6307,6 +6229,178 @@
               <a:cs typeface="Calibri" panose="020F0502020204030204" pitchFamily="34" charset="0"/>
             </a:endParaRPr>
           </a:p>
+          <a:p>
+            <a:pPr marL="285750" lvl="0" indent="-285750">
+              <a:buFont typeface="Arial" panose="020B0604020202020204" pitchFamily="34" charset="0"/>
+              <a:buChar char="•"/>
+            </a:pPr>
+            <a:r>
+              <a:rPr lang="en-US" sz="1600" dirty="0">
+                <a:solidFill>
+                  <a:prstClr val="black"/>
+                </a:solidFill>
+                <a:latin typeface="Calibri" panose="020F0502020204030204" pitchFamily="34" charset="0"/>
+                <a:ea typeface="Calibri" panose="020F0502020204030204" pitchFamily="34" charset="0"/>
+                <a:cs typeface="Calibri" panose="020F0502020204030204" pitchFamily="34" charset="0"/>
+              </a:rPr>
+              <a:t>Strong communicator, problem-solver, quick learner, and mentor for new team members.</a:t>
+            </a:r>
+            <a:endParaRPr lang="en-IN" sz="1600" dirty="0">
+              <a:solidFill>
+                <a:prstClr val="black"/>
+              </a:solidFill>
+              <a:latin typeface="Calibri" panose="020F0502020204030204" pitchFamily="34" charset="0"/>
+              <a:ea typeface="Calibri" panose="020F0502020204030204" pitchFamily="34" charset="0"/>
+              <a:cs typeface="Calibri" panose="020F0502020204030204" pitchFamily="34" charset="0"/>
+            </a:endParaRPr>
+          </a:p>
+          <a:p>
+            <a:pPr marL="285750" lvl="0" indent="-285750">
+              <a:buFont typeface="Arial" panose="020B0604020202020204" pitchFamily="34" charset="0"/>
+              <a:buChar char="•"/>
+            </a:pPr>
+            <a:r>
+              <a:rPr lang="en-US" sz="1600" dirty="0">
+                <a:solidFill>
+                  <a:prstClr val="black"/>
+                </a:solidFill>
+                <a:latin typeface="Calibri" panose="020F0502020204030204" pitchFamily="34" charset="0"/>
+                <a:ea typeface="Calibri" panose="020F0502020204030204" pitchFamily="34" charset="0"/>
+                <a:cs typeface="Calibri" panose="020F0502020204030204" pitchFamily="34" charset="0"/>
+              </a:rPr>
+              <a:t>Well-versed in Agile methodologies and collaborating with cross-functional teams.</a:t>
+            </a:r>
+            <a:endParaRPr lang="en-IN" sz="1600" dirty="0">
+              <a:solidFill>
+                <a:prstClr val="black"/>
+              </a:solidFill>
+              <a:latin typeface="Calibri" panose="020F0502020204030204" pitchFamily="34" charset="0"/>
+              <a:ea typeface="Calibri" panose="020F0502020204030204" pitchFamily="34" charset="0"/>
+              <a:cs typeface="Calibri" panose="020F0502020204030204" pitchFamily="34" charset="0"/>
+            </a:endParaRPr>
+          </a:p>
+          <a:p>
+            <a:pPr marL="285750" lvl="0" indent="-285750">
+              <a:buFont typeface="Arial" panose="020B0604020202020204" pitchFamily="34" charset="0"/>
+              <a:buChar char="•"/>
+            </a:pPr>
+            <a:r>
+              <a:rPr lang="en-US" sz="1600" dirty="0">
+                <a:solidFill>
+                  <a:prstClr val="black"/>
+                </a:solidFill>
+                <a:latin typeface="Calibri" panose="020F0502020204030204" pitchFamily="34" charset="0"/>
+                <a:ea typeface="Calibri" panose="020F0502020204030204" pitchFamily="34" charset="0"/>
+                <a:cs typeface="Calibri" panose="020F0502020204030204" pitchFamily="34" charset="0"/>
+              </a:rPr>
+              <a:t>Experienced with tools like Jira, TFS, Git, </a:t>
+            </a:r>
+            <a:r>
+              <a:rPr lang="en-US" sz="1600" dirty="0" err="1">
+                <a:solidFill>
+                  <a:prstClr val="black"/>
+                </a:solidFill>
+                <a:latin typeface="Calibri" panose="020F0502020204030204" pitchFamily="34" charset="0"/>
+                <a:ea typeface="Calibri" panose="020F0502020204030204" pitchFamily="34" charset="0"/>
+                <a:cs typeface="Calibri" panose="020F0502020204030204" pitchFamily="34" charset="0"/>
+              </a:rPr>
+              <a:t>iFast</a:t>
+            </a:r>
+            <a:r>
+              <a:rPr lang="en-US" sz="1600" dirty="0">
+                <a:solidFill>
+                  <a:prstClr val="black"/>
+                </a:solidFill>
+                <a:latin typeface="Calibri" panose="020F0502020204030204" pitchFamily="34" charset="0"/>
+                <a:ea typeface="Calibri" panose="020F0502020204030204" pitchFamily="34" charset="0"/>
+                <a:cs typeface="Calibri" panose="020F0502020204030204" pitchFamily="34" charset="0"/>
+              </a:rPr>
+              <a:t>, and Test Data Management tools.</a:t>
+            </a:r>
+            <a:endParaRPr lang="en-IN" sz="1600" dirty="0">
+              <a:solidFill>
+                <a:prstClr val="black"/>
+              </a:solidFill>
+              <a:latin typeface="Calibri" panose="020F0502020204030204" pitchFamily="34" charset="0"/>
+              <a:ea typeface="Calibri" panose="020F0502020204030204" pitchFamily="34" charset="0"/>
+              <a:cs typeface="Calibri" panose="020F0502020204030204" pitchFamily="34" charset="0"/>
+            </a:endParaRPr>
+          </a:p>
+          <a:p>
+            <a:pPr marL="285750" lvl="0" indent="-285750">
+              <a:buFont typeface="Arial" panose="020B0604020202020204" pitchFamily="34" charset="0"/>
+              <a:buChar char="•"/>
+            </a:pPr>
+            <a:r>
+              <a:rPr lang="en-US" sz="1600" dirty="0">
+                <a:solidFill>
+                  <a:prstClr val="black"/>
+                </a:solidFill>
+                <a:latin typeface="Calibri" panose="020F0502020204030204" pitchFamily="34" charset="0"/>
+                <a:ea typeface="Calibri" panose="020F0502020204030204" pitchFamily="34" charset="0"/>
+                <a:cs typeface="Calibri" panose="020F0502020204030204" pitchFamily="34" charset="0"/>
+              </a:rPr>
+              <a:t>Responsible for ensuring on-time delivery of high-quality product deliverables.</a:t>
+            </a:r>
+            <a:endParaRPr lang="en-IN" sz="1600" dirty="0">
+              <a:solidFill>
+                <a:prstClr val="black"/>
+              </a:solidFill>
+              <a:latin typeface="Calibri" panose="020F0502020204030204" pitchFamily="34" charset="0"/>
+              <a:ea typeface="Calibri" panose="020F0502020204030204" pitchFamily="34" charset="0"/>
+              <a:cs typeface="Calibri" panose="020F0502020204030204" pitchFamily="34" charset="0"/>
+            </a:endParaRPr>
+          </a:p>
+          <a:p>
+            <a:pPr marL="285750" lvl="0" indent="-285750">
+              <a:buFont typeface="Arial" panose="020B0604020202020204" pitchFamily="34" charset="0"/>
+              <a:buChar char="•"/>
+            </a:pPr>
+            <a:r>
+              <a:rPr lang="en-US" sz="1600" dirty="0">
+                <a:solidFill>
+                  <a:prstClr val="black"/>
+                </a:solidFill>
+                <a:latin typeface="Calibri" panose="020F0502020204030204" pitchFamily="34" charset="0"/>
+                <a:ea typeface="Calibri" panose="020F0502020204030204" pitchFamily="34" charset="0"/>
+                <a:cs typeface="Calibri" panose="020F0502020204030204" pitchFamily="34" charset="0"/>
+              </a:rPr>
+              <a:t>Having hands-on experience in java for developing selenium scripts</a:t>
+            </a:r>
+            <a:endParaRPr lang="en-IN" sz="1600" dirty="0">
+              <a:solidFill>
+                <a:prstClr val="black"/>
+              </a:solidFill>
+              <a:latin typeface="Calibri" panose="020F0502020204030204" pitchFamily="34" charset="0"/>
+              <a:ea typeface="Calibri" panose="020F0502020204030204" pitchFamily="34" charset="0"/>
+              <a:cs typeface="Calibri" panose="020F0502020204030204" pitchFamily="34" charset="0"/>
+            </a:endParaRPr>
+          </a:p>
+          <a:p>
+            <a:pPr marL="285750" lvl="0" indent="-285750">
+              <a:buFont typeface="Arial" panose="020B0604020202020204" pitchFamily="34" charset="0"/>
+              <a:buChar char="•"/>
+            </a:pPr>
+            <a:r>
+              <a:rPr lang="en-US" sz="1600" dirty="0">
+                <a:solidFill>
+                  <a:prstClr val="black"/>
+                </a:solidFill>
+                <a:latin typeface="Calibri" panose="020F0502020204030204" pitchFamily="34" charset="0"/>
+                <a:ea typeface="Calibri" panose="020F0502020204030204" pitchFamily="34" charset="0"/>
+                <a:cs typeface="Calibri" panose="020F0502020204030204" pitchFamily="34" charset="0"/>
+              </a:rPr>
+              <a:t>Designed and implemented XML schemas for data validation and integration between distributed systems.</a:t>
+            </a:r>
+            <a:endParaRPr lang="en-IN" sz="1600" dirty="0">
+              <a:solidFill>
+                <a:prstClr val="black"/>
+              </a:solidFill>
+              <a:latin typeface="Calibri" panose="020F0502020204030204" pitchFamily="34" charset="0"/>
+              <a:ea typeface="Calibri" panose="020F0502020204030204" pitchFamily="34" charset="0"/>
+              <a:cs typeface="Calibri" panose="020F0502020204030204" pitchFamily="34" charset="0"/>
+            </a:endParaRPr>
+          </a:p>
         </p:txBody>
       </p:sp>
       <p:sp>
@@ -6314,7 +6408,7 @@
           <p:cNvPr id="12" name="TextBox 11">
             <a:extLst>
               <a:ext uri="{FF2B5EF4-FFF2-40B4-BE49-F238E27FC236}">
-                <a16:creationId xmlns:a16="http://schemas.microsoft.com/office/drawing/2014/main" id="{3263F006-1ED5-9F17-4832-5C4EDBCB139A}"/>
+                <a16:creationId xmlns:a16="http://schemas.microsoft.com/office/drawing/2014/main" id="{FF5044C3-FB81-37EB-A51F-BF41E9D309C6}"/>
               </a:ext>
             </a:extLst>
           </p:cNvPr>
@@ -6323,8 +6417,8 @@
         </p:nvSpPr>
         <p:spPr>
           <a:xfrm>
-            <a:off x="304800" y="1712950"/>
-            <a:ext cx="1470274" cy="369332"/>
+            <a:off x="304798" y="1204265"/>
+            <a:ext cx="1734311" cy="369332"/>
           </a:xfrm>
           <a:prstGeom prst="rect">
             <a:avLst/>
@@ -6332,7 +6426,7 @@
           <a:noFill/>
         </p:spPr>
         <p:txBody>
-          <a:bodyPr wrap="none" rtlCol="0">
+          <a:bodyPr wrap="square" rtlCol="0">
             <a:spAutoFit/>
           </a:bodyPr>
           <a:lstStyle/>
@@ -6360,24 +6454,7 @@
             </a:r>
             <a:r>
               <a:rPr lang="en-IN" b="1" dirty="0"/>
-              <a:t>escription</a:t>
-            </a:r>
-            <a:r>
-              <a:rPr kumimoji="0" lang="en-IN" sz="1600" b="1" i="0" u="none" strike="noStrike" kern="1200" cap="none" spc="0" normalizeH="0" baseline="0" noProof="0" dirty="0">
-                <a:ln>
-                  <a:noFill/>
-                </a:ln>
-                <a:solidFill>
-                  <a:srgbClr val="002060"/>
-                </a:solidFill>
-                <a:effectLst/>
-                <a:uLnTx/>
-                <a:uFillTx/>
-                <a:latin typeface="Calibri"/>
-                <a:ea typeface="Calibri"/>
-                <a:cs typeface="Calibri"/>
-              </a:rPr>
-              <a:t>:</a:t>
+              <a:t>escription:</a:t>
             </a:r>
           </a:p>
         </p:txBody>
@@ -6387,7 +6464,7 @@
           <p:cNvPr id="14" name="TextBox 13">
             <a:extLst>
               <a:ext uri="{FF2B5EF4-FFF2-40B4-BE49-F238E27FC236}">
-                <a16:creationId xmlns:a16="http://schemas.microsoft.com/office/drawing/2014/main" id="{48FDA6FC-689D-3954-6C30-D499F8EA99D5}"/>
+                <a16:creationId xmlns:a16="http://schemas.microsoft.com/office/drawing/2014/main" id="{89669AE3-6766-99D8-8ECA-0B70DC087BDB}"/>
               </a:ext>
             </a:extLst>
           </p:cNvPr>
@@ -6396,7 +6473,7 @@
         </p:nvSpPr>
         <p:spPr>
           <a:xfrm>
-            <a:off x="304800" y="278283"/>
+            <a:off x="304800" y="52355"/>
             <a:ext cx="1734312" cy="369332"/>
           </a:xfrm>
           <a:prstGeom prst="rect">
@@ -6405,7 +6482,7 @@
           <a:noFill/>
         </p:spPr>
         <p:txBody>
-          <a:bodyPr wrap="square">
+          <a:bodyPr wrap="square" lIns="91440" tIns="45720" rIns="91440" bIns="45720" anchor="t">
             <a:spAutoFit/>
           </a:bodyPr>
           <a:lstStyle/>
@@ -6442,7 +6519,18 @@
                 <a:ea typeface="Calibri"/>
                 <a:cs typeface="Calibri"/>
               </a:rPr>
-              <a:t>Project 2</a:t>
+              <a:t>Project </a:t>
+            </a:r>
+            <a:r>
+              <a:rPr lang="en-US" b="1" dirty="0">
+                <a:solidFill>
+                  <a:srgbClr val="002060"/>
+                </a:solidFill>
+                <a:latin typeface="Calibri"/>
+                <a:ea typeface="Calibri"/>
+                <a:cs typeface="Calibri"/>
+              </a:rPr>
+              <a:t>2</a:t>
             </a:r>
             <a:endParaRPr kumimoji="0" lang="en-US" b="0" i="0" u="none" strike="noStrike" kern="1200" cap="none" spc="0" normalizeH="0" baseline="0" noProof="0" dirty="0">
               <a:ln>
@@ -6466,7 +6554,7 @@
           <p:cNvPr id="3" name="Picture 2">
             <a:extLst>
               <a:ext uri="{FF2B5EF4-FFF2-40B4-BE49-F238E27FC236}">
-                <a16:creationId xmlns:a16="http://schemas.microsoft.com/office/drawing/2014/main" id="{EA499149-6F21-61C3-57D6-464B49022092}"/>
+                <a16:creationId xmlns:a16="http://schemas.microsoft.com/office/drawing/2014/main" id="{1A747B1B-4E88-A533-215F-D22CE3E5C5D6}"/>
               </a:ext>
             </a:extLst>
           </p:cNvPr>
@@ -6485,7 +6573,7 @@
         </p:blipFill>
         <p:spPr>
           <a:xfrm>
-            <a:off x="9993086" y="75293"/>
+            <a:off x="9982200" y="179161"/>
             <a:ext cx="2066530" cy="587639"/>
           </a:xfrm>
           <a:prstGeom prst="rect">
@@ -6499,7 +6587,7 @@
     </p:spTree>
     <p:extLst>
       <p:ext uri="{BB962C8B-B14F-4D97-AF65-F5344CB8AC3E}">
-        <p14:creationId xmlns:p14="http://schemas.microsoft.com/office/powerpoint/2010/main" val="2821146086"/>
+        <p14:creationId xmlns:p14="http://schemas.microsoft.com/office/powerpoint/2010/main" val="859413911"/>
       </p:ext>
     </p:extLst>
   </p:cSld>
@@ -6525,7 +6613,7 @@
         <p:cNvPr id="1" name="">
           <a:extLst>
             <a:ext uri="{FF2B5EF4-FFF2-40B4-BE49-F238E27FC236}">
-              <a16:creationId xmlns:a16="http://schemas.microsoft.com/office/drawing/2014/main" id="{D2BC4485-04EA-5964-A06F-7F50CAB1420D}"/>
+              <a16:creationId xmlns:a16="http://schemas.microsoft.com/office/drawing/2014/main" id="{2AA1FEA4-F971-DBF9-AED6-FC31BA727305}"/>
             </a:ext>
           </a:extLst>
         </p:cNvPr>
@@ -6545,7 +6633,7 @@
           <p:cNvPr id="5" name="Slide Number Placeholder 4">
             <a:extLst>
               <a:ext uri="{FF2B5EF4-FFF2-40B4-BE49-F238E27FC236}">
-                <a16:creationId xmlns:a16="http://schemas.microsoft.com/office/drawing/2014/main" id="{6F1ECAAF-5F5F-FF47-8797-93F45AD82AED}"/>
+                <a16:creationId xmlns:a16="http://schemas.microsoft.com/office/drawing/2014/main" id="{81CD88D3-2A46-BC12-7671-0CA7629DFFFF}"/>
               </a:ext>
             </a:extLst>
           </p:cNvPr>
@@ -6638,7 +6726,7 @@
           <p:cNvPr id="7" name="TextBox 6">
             <a:extLst>
               <a:ext uri="{FF2B5EF4-FFF2-40B4-BE49-F238E27FC236}">
-                <a16:creationId xmlns:a16="http://schemas.microsoft.com/office/drawing/2014/main" id="{5D00FC8E-1F2A-3890-1644-19DF13D3FFB6}"/>
+                <a16:creationId xmlns:a16="http://schemas.microsoft.com/office/drawing/2014/main" id="{5643832E-FCE1-5E70-E193-C382AD3B85A3}"/>
               </a:ext>
             </a:extLst>
           </p:cNvPr>
@@ -6647,7 +6735,7 @@
         </p:nvSpPr>
         <p:spPr>
           <a:xfrm>
-            <a:off x="304800" y="634824"/>
+            <a:off x="304800" y="647615"/>
             <a:ext cx="9954892" cy="923330"/>
           </a:xfrm>
           <a:prstGeom prst="rect">
@@ -6679,7 +6767,7 @@
                 <a:ea typeface="Calibri"/>
                 <a:cs typeface="Calibri"/>
               </a:rPr>
-              <a:t>Project: {PROJECT3_NAME}</a:t>
+              <a:t>Project:</a:t>
             </a:r>
             <a:r>
               <a:rPr lang="en-US" b="1" dirty="0">
@@ -6690,7 +6778,18 @@
                 <a:ea typeface="Calibri"/>
                 <a:cs typeface="Calibri"/>
               </a:rPr>
-              <a:t>.</a:t>
+              <a:t> </a:t>
+            </a:r>
+            <a:r>
+              <a:rPr lang="en-US" b="1" dirty="0">
+                <a:solidFill>
+                  <a:prstClr val="black"/>
+                </a:solidFill>
+                <a:latin typeface="Calibri"/>
+                <a:ea typeface="Calibri"/>
+                <a:cs typeface="Segoe UI"/>
+              </a:rPr>
+              <a:t>Master Data Hub (MDH)</a:t>
             </a:r>
             <a:endParaRPr lang="en-US" b="1" i="0" u="none" strike="noStrike" kern="1200" cap="none" spc="0" normalizeH="0" baseline="0" noProof="0" dirty="0">
               <a:ln>
@@ -6726,28 +6825,44 @@
                 <a:ea typeface="Calibri"/>
                 <a:cs typeface="Calibri"/>
               </a:rPr>
-              <a:t>Duration : {DURATION_project3}</a:t>
-            </a:r>
-            <a:endParaRPr lang="en-US" b="1" dirty="0">
-              <a:solidFill>
-                <a:prstClr val="black"/>
-              </a:solidFill>
-              <a:latin typeface="Calibri"/>
-              <a:ea typeface="Calibri"/>
-              <a:cs typeface="Calibri"/>
-            </a:endParaRPr>
+              <a:t>Duration : </a:t>
+            </a:r>
+            <a:r>
+              <a:rPr lang="en-US" b="1" dirty="0">
+                <a:solidFill>
+                  <a:prstClr val="black"/>
+                </a:solidFill>
+                <a:latin typeface="Calibri"/>
+                <a:ea typeface="Calibri"/>
+                <a:cs typeface="Segoe UI"/>
+              </a:rPr>
+              <a:t>Jan’2022 – April’2022</a:t>
+            </a:r>
           </a:p>
           <a:p>
             <a:pPr>
               <a:defRPr/>
             </a:pPr>
             <a:r>
-              <a:rPr lang="en-US" b="1" dirty="0"/>
-              <a:t>Role</a:t>
+              <a:rPr lang="en-US" b="1" i="0" u="none" strike="noStrike" kern="1200" cap="none" spc="0" normalizeH="0" baseline="0" noProof="0" dirty="0">
+                <a:ln>
+                  <a:noFill/>
+                </a:ln>
+                <a:solidFill>
+                  <a:prstClr val="black"/>
+                </a:solidFill>
+                <a:effectLst/>
+                <a:uLnTx/>
+                <a:uFillTx/>
+                <a:latin typeface="Calibri"/>
+                <a:ea typeface="Calibri"/>
+                <a:cs typeface="Segoe UI"/>
+              </a:rPr>
+              <a:t>Role: </a:t>
             </a:r>
             <a:r>
               <a:rPr lang="en-US" dirty="0"/>
-              <a:t>: {ROLE_project3}</a:t>
+              <a:t>QA Analyst</a:t>
             </a:r>
             <a:endParaRPr lang="en-US" b="1" i="0" u="none" strike="noStrike" kern="1200" cap="none" spc="0" normalizeH="0" baseline="0" noProof="0" dirty="0">
               <a:ln>
@@ -6761,7 +6876,7 @@
               <a:uFillTx/>
               <a:latin typeface="Calibri"/>
               <a:ea typeface="Calibri"/>
-              <a:cs typeface="Calibri"/>
+              <a:cs typeface="Segoe UI"/>
             </a:endParaRPr>
           </a:p>
         </p:txBody>
@@ -6771,7 +6886,7 @@
           <p:cNvPr id="11" name="TextBox 10">
             <a:extLst>
               <a:ext uri="{FF2B5EF4-FFF2-40B4-BE49-F238E27FC236}">
-                <a16:creationId xmlns:a16="http://schemas.microsoft.com/office/drawing/2014/main" id="{8C183A66-42F8-F13C-795D-00913B38A72C}"/>
+                <a16:creationId xmlns:a16="http://schemas.microsoft.com/office/drawing/2014/main" id="{5195D475-D617-D7E2-0AAE-F20B3E7BBCAA}"/>
               </a:ext>
             </a:extLst>
           </p:cNvPr>
@@ -6780,8 +6895,8 @@
         </p:nvSpPr>
         <p:spPr>
           <a:xfrm>
-            <a:off x="304800" y="2132178"/>
-            <a:ext cx="11691257" cy="4524315"/>
+            <a:off x="304799" y="1841242"/>
+            <a:ext cx="11702143" cy="4524315"/>
           </a:xfrm>
           <a:prstGeom prst="rect">
             <a:avLst/>
@@ -6798,7 +6913,7 @@
               <a:defRPr/>
             </a:pPr>
             <a:r>
-              <a:rPr lang="en-US" sz="1600" i="0" u="none" strike="noStrike" kern="1200" cap="none" spc="0" normalizeH="0" baseline="0" noProof="0" dirty="0">
+              <a:rPr kumimoji="0" lang="en-US" sz="1600" b="1" i="0" u="none" strike="noStrike" kern="1200" cap="none" spc="0" normalizeH="0" baseline="0" noProof="0" dirty="0">
                 <a:ln>
                   <a:noFill/>
                 </a:ln>
@@ -6812,132 +6927,40 @@
                 <a:ea typeface="Calibri"/>
                 <a:cs typeface="Calibri"/>
               </a:rPr>
-              <a:t>{Project3_Description}:</a:t>
-            </a:r>
-          </a:p>
-          <a:p>
-            <a:pPr algn="just" fontAlgn="base" hangingPunct="0">
-              <a:defRPr/>
-            </a:pPr>
+              <a:t>Project Overview</a:t>
+            </a:r>
+            <a:r>
+              <a:rPr kumimoji="0" lang="en-US" sz="1600" b="0" i="0" u="none" strike="noStrike" kern="1200" cap="none" spc="0" normalizeH="0" baseline="0" noProof="0" dirty="0">
+                <a:ln>
+                  <a:noFill/>
+                </a:ln>
+                <a:solidFill>
+                  <a:prstClr val="black"/>
+                </a:solidFill>
+                <a:effectLst/>
+                <a:uLnTx/>
+                <a:uFillTx/>
+                <a:latin typeface="Calibri"/>
+                <a:ea typeface="Calibri"/>
+                <a:cs typeface="Calibri"/>
+              </a:rPr>
+              <a:t>: </a:t>
+            </a:r>
+            <a:r>
+              <a:rPr lang="en-US" sz="1600" dirty="0">
+                <a:solidFill>
+                  <a:prstClr val="black"/>
+                </a:solidFill>
+                <a:latin typeface="Calibri"/>
+                <a:ea typeface="+mn-lt"/>
+                <a:cs typeface="Segoe UI"/>
+              </a:rPr>
+              <a:t>Worked on a centralized platform designed to consolidate, manage, and synchronize master data across multiple enterprise systems (ERP, CRM, AWS and other platforms). Ensured data consistency, accuracy, and integrity for critical business entities such as Customer, Product, Supplier, Location, and Employee by automating and validating core MDH functionalities including data ingestion, validation, enrichment, deduplication, golden record creation, and downstream data publishing.</a:t>
+            </a:r>
             <a:endParaRPr lang="en-US" sz="1600" dirty="0">
               <a:solidFill>
                 <a:prstClr val="black"/>
               </a:solidFill>
-              <a:latin typeface="Calibri"/>
-              <a:ea typeface="Calibri"/>
-              <a:cs typeface="Calibri"/>
-            </a:endParaRPr>
-          </a:p>
-          <a:p>
-            <a:pPr algn="just" fontAlgn="base" hangingPunct="0">
-              <a:defRPr/>
-            </a:pPr>
-            <a:endParaRPr lang="en-US" sz="1600" i="0" u="none" strike="noStrike" kern="1200" cap="none" spc="0" normalizeH="0" baseline="0" noProof="0" dirty="0">
-              <a:ln>
-                <a:noFill/>
-              </a:ln>
-              <a:solidFill>
-                <a:prstClr val="black"/>
-              </a:solidFill>
-              <a:effectLst/>
-              <a:uLnTx/>
-              <a:uFillTx/>
-              <a:latin typeface="Calibri"/>
-              <a:ea typeface="Calibri"/>
-              <a:cs typeface="Calibri"/>
-            </a:endParaRPr>
-          </a:p>
-          <a:p>
-            <a:pPr algn="just" fontAlgn="base" hangingPunct="0">
-              <a:defRPr/>
-            </a:pPr>
-            <a:endParaRPr lang="en-US" sz="1600" dirty="0">
-              <a:solidFill>
-                <a:prstClr val="black"/>
-              </a:solidFill>
-              <a:latin typeface="Calibri"/>
-              <a:ea typeface="Calibri"/>
-              <a:cs typeface="Calibri"/>
-            </a:endParaRPr>
-          </a:p>
-          <a:p>
-            <a:pPr algn="just" fontAlgn="base" hangingPunct="0">
-              <a:defRPr/>
-            </a:pPr>
-            <a:endParaRPr lang="en-US" sz="1600" i="0" u="none" strike="noStrike" kern="1200" cap="none" spc="0" normalizeH="0" baseline="0" noProof="0" dirty="0">
-              <a:ln>
-                <a:noFill/>
-              </a:ln>
-              <a:solidFill>
-                <a:prstClr val="black"/>
-              </a:solidFill>
-              <a:effectLst/>
-              <a:uLnTx/>
-              <a:uFillTx/>
-              <a:latin typeface="Calibri"/>
-              <a:ea typeface="Calibri"/>
-              <a:cs typeface="Calibri"/>
-            </a:endParaRPr>
-          </a:p>
-          <a:p>
-            <a:pPr algn="just" fontAlgn="base" hangingPunct="0">
-              <a:defRPr/>
-            </a:pPr>
-            <a:endParaRPr lang="en-US" sz="1600" dirty="0">
-              <a:solidFill>
-                <a:prstClr val="black"/>
-              </a:solidFill>
-              <a:latin typeface="Calibri"/>
-              <a:ea typeface="Calibri"/>
-              <a:cs typeface="Calibri"/>
-            </a:endParaRPr>
-          </a:p>
-          <a:p>
-            <a:pPr algn="just" fontAlgn="base" hangingPunct="0">
-              <a:defRPr/>
-            </a:pPr>
-            <a:endParaRPr lang="en-US" sz="1600" i="0" u="none" strike="noStrike" kern="1200" cap="none" spc="0" normalizeH="0" baseline="0" noProof="0" dirty="0">
-              <a:ln>
-                <a:noFill/>
-              </a:ln>
-              <a:solidFill>
-                <a:prstClr val="black"/>
-              </a:solidFill>
-              <a:effectLst/>
-              <a:uLnTx/>
-              <a:uFillTx/>
-              <a:latin typeface="Calibri"/>
-              <a:ea typeface="Calibri"/>
-              <a:cs typeface="Calibri"/>
-            </a:endParaRPr>
-          </a:p>
-          <a:p>
-            <a:pPr algn="just" fontAlgn="base" hangingPunct="0">
-              <a:defRPr/>
-            </a:pPr>
-            <a:endParaRPr lang="en-US" sz="1600" dirty="0">
-              <a:solidFill>
-                <a:prstClr val="black"/>
-              </a:solidFill>
-              <a:latin typeface="Calibri"/>
-              <a:ea typeface="Calibri"/>
-              <a:cs typeface="Calibri"/>
-            </a:endParaRPr>
-          </a:p>
-          <a:p>
-            <a:pPr algn="just" fontAlgn="base" hangingPunct="0">
-              <a:defRPr/>
-            </a:pPr>
-            <a:endParaRPr lang="en-US" sz="1600" i="0" u="none" strike="noStrike" kern="1200" cap="none" spc="0" normalizeH="0" baseline="0" noProof="0" dirty="0">
-              <a:ln>
-                <a:noFill/>
-              </a:ln>
-              <a:solidFill>
-                <a:prstClr val="black"/>
-              </a:solidFill>
-              <a:effectLst/>
-              <a:uLnTx/>
-              <a:uFillTx/>
               <a:latin typeface="Calibri"/>
               <a:ea typeface="Calibri"/>
               <a:cs typeface="Calibri"/>
@@ -6961,17 +6984,20 @@
               <a:tabLst/>
               <a:defRPr/>
             </a:pPr>
-            <a:r>
-              <a:rPr lang="en-US" sz="1600" b="1" dirty="0">
-                <a:solidFill>
-                  <a:prstClr val="black"/>
-                </a:solidFill>
-                <a:latin typeface="Calibri" panose="020F0502020204030204" pitchFamily="34" charset="0"/>
-                <a:ea typeface="Calibri" panose="020F0502020204030204" pitchFamily="34" charset="0"/>
-                <a:cs typeface="Calibri" panose="020F0502020204030204" pitchFamily="34" charset="0"/>
-              </a:rPr>
-              <a:t>Responsibilities: </a:t>
-            </a:r>
+            <a:endParaRPr kumimoji="0" lang="en-US" sz="1600" b="1" i="0" u="none" strike="noStrike" kern="1200" cap="none" spc="0" normalizeH="0" baseline="0" noProof="0" dirty="0">
+              <a:ln>
+                <a:noFill/>
+              </a:ln>
+              <a:solidFill>
+                <a:prstClr val="black"/>
+              </a:solidFill>
+              <a:effectLst/>
+              <a:uLnTx/>
+              <a:uFillTx/>
+              <a:latin typeface="Calibri"/>
+              <a:ea typeface="Calibri"/>
+              <a:cs typeface="Calibri"/>
+            </a:endParaRPr>
           </a:p>
           <a:p>
             <a:pPr marL="0" marR="0" lvl="0" indent="0" algn="just" defTabSz="914400" rtl="0" eaLnBrk="1" fontAlgn="base" latinLnBrk="0" hangingPunct="0">
@@ -6992,205 +7018,249 @@
               <a:defRPr/>
             </a:pPr>
             <a:r>
-              <a:rPr lang="en-US" sz="1600" dirty="0">
+              <a:rPr kumimoji="0" lang="en-US" sz="1600" b="1" i="0" u="none" strike="noStrike" kern="1200" cap="none" spc="0" normalizeH="0" baseline="0" noProof="0" dirty="0">
+                <a:ln>
+                  <a:noFill/>
+                </a:ln>
                 <a:solidFill>
                   <a:prstClr val="black"/>
                 </a:solidFill>
-                <a:latin typeface="Calibri" panose="020F0502020204030204" pitchFamily="34" charset="0"/>
-                <a:ea typeface="Calibri" panose="020F0502020204030204" pitchFamily="34" charset="0"/>
-                <a:cs typeface="Calibri" panose="020F0502020204030204" pitchFamily="34" charset="0"/>
-              </a:rPr>
-              <a:t>{Responsibilities_project3}</a:t>
-            </a:r>
-          </a:p>
-          <a:p>
-            <a:pPr marL="0" marR="0" lvl="0" indent="0" algn="just" defTabSz="914400" rtl="0" eaLnBrk="1" fontAlgn="base" latinLnBrk="0" hangingPunct="0">
-              <a:lnSpc>
-                <a:spcPct val="100000"/>
-              </a:lnSpc>
-              <a:spcBef>
-                <a:spcPts val="0"/>
-              </a:spcBef>
-              <a:spcAft>
-                <a:spcPts val="0"/>
-              </a:spcAft>
-              <a:buClrTx/>
-              <a:buSzTx/>
-              <a:buFontTx/>
-              <a:buNone/>
-              <a:tabLst/>
-              <a:defRPr/>
-            </a:pPr>
-            <a:endParaRPr lang="en-US" sz="1600" dirty="0">
+                <a:effectLst/>
+                <a:uLnTx/>
+                <a:uFillTx/>
+                <a:latin typeface="Calibri"/>
+                <a:ea typeface="Calibri"/>
+                <a:cs typeface="Calibri"/>
+              </a:rPr>
+              <a:t>Responsibilities</a:t>
+            </a:r>
+            <a:r>
+              <a:rPr kumimoji="0" lang="en-US" sz="1600" b="0" i="0" u="none" strike="noStrike" kern="1200" cap="none" spc="0" normalizeH="0" baseline="0" noProof="0" dirty="0">
+                <a:ln>
+                  <a:noFill/>
+                </a:ln>
+                <a:solidFill>
+                  <a:prstClr val="black"/>
+                </a:solidFill>
+                <a:effectLst/>
+                <a:uLnTx/>
+                <a:uFillTx/>
+                <a:latin typeface="Calibri"/>
+                <a:ea typeface="Calibri"/>
+                <a:cs typeface="Calibri"/>
+              </a:rPr>
+              <a:t>: </a:t>
+            </a:r>
+            <a:endParaRPr lang="en-US" sz="1600" b="0" i="0" u="none" strike="noStrike" kern="1200" cap="none" spc="0" normalizeH="0" baseline="0" noProof="0" dirty="0">
+              <a:ln>
+                <a:noFill/>
+              </a:ln>
               <a:solidFill>
                 <a:prstClr val="black"/>
               </a:solidFill>
-              <a:latin typeface="Calibri" panose="020F0502020204030204" pitchFamily="34" charset="0"/>
-              <a:ea typeface="Calibri" panose="020F0502020204030204" pitchFamily="34" charset="0"/>
-              <a:cs typeface="Calibri" panose="020F0502020204030204" pitchFamily="34" charset="0"/>
+              <a:effectLst/>
+              <a:uLnTx/>
+              <a:uFillTx/>
+              <a:latin typeface="Calibri"/>
+              <a:ea typeface="Calibri"/>
+              <a:cs typeface="Calibri"/>
             </a:endParaRPr>
           </a:p>
           <a:p>
-            <a:pPr marL="0" marR="0" lvl="0" indent="0" algn="just" defTabSz="914400" rtl="0" eaLnBrk="1" fontAlgn="base" latinLnBrk="0" hangingPunct="0">
-              <a:lnSpc>
-                <a:spcPct val="100000"/>
-              </a:lnSpc>
-              <a:spcBef>
-                <a:spcPts val="0"/>
-              </a:spcBef>
-              <a:spcAft>
-                <a:spcPts val="0"/>
-              </a:spcAft>
-              <a:buClrTx/>
-              <a:buSzTx/>
-              <a:buFontTx/>
-              <a:buNone/>
-              <a:tabLst/>
+            <a:pPr marL="285750" indent="-285750" algn="just">
+              <a:buFont typeface="Arial" panose="020B0604020202020204" pitchFamily="34" charset="0"/>
+              <a:buChar char="•"/>
               <a:defRPr/>
             </a:pPr>
-            <a:endParaRPr lang="en-US" sz="1600" dirty="0">
-              <a:solidFill>
-                <a:prstClr val="black"/>
-              </a:solidFill>
-              <a:latin typeface="Calibri" panose="020F0502020204030204" pitchFamily="34" charset="0"/>
-              <a:ea typeface="Calibri" panose="020F0502020204030204" pitchFamily="34" charset="0"/>
-              <a:cs typeface="Calibri" panose="020F0502020204030204" pitchFamily="34" charset="0"/>
-            </a:endParaRPr>
-          </a:p>
-          <a:p>
-            <a:pPr marL="0" marR="0" lvl="0" indent="0" algn="just" defTabSz="914400" rtl="0" eaLnBrk="1" fontAlgn="base" latinLnBrk="0" hangingPunct="0">
-              <a:lnSpc>
-                <a:spcPct val="100000"/>
-              </a:lnSpc>
-              <a:spcBef>
-                <a:spcPts val="0"/>
-              </a:spcBef>
-              <a:spcAft>
-                <a:spcPts val="0"/>
-              </a:spcAft>
-              <a:buClrTx/>
-              <a:buSzTx/>
-              <a:buFontTx/>
-              <a:buNone/>
-              <a:tabLst/>
+            <a:r>
+              <a:rPr lang="en-US" sz="1600" dirty="0">
+                <a:latin typeface="Calibri"/>
+                <a:ea typeface="Calibri"/>
+                <a:cs typeface="Calibri"/>
+              </a:rPr>
+              <a:t>Designed and implemented automation frameworks using Selenium WebDriver (Python), Playwright, and Robot Framework.</a:t>
+            </a:r>
+          </a:p>
+          <a:p>
+            <a:pPr marL="285750" indent="-285750" algn="just">
+              <a:buFont typeface="Arial" panose="020B0604020202020204" pitchFamily="34" charset="0"/>
+              <a:buChar char="•"/>
               <a:defRPr/>
             </a:pPr>
-            <a:endParaRPr lang="en-US" sz="1600" dirty="0">
-              <a:solidFill>
-                <a:prstClr val="black"/>
-              </a:solidFill>
-              <a:latin typeface="Calibri" panose="020F0502020204030204" pitchFamily="34" charset="0"/>
-              <a:ea typeface="Calibri" panose="020F0502020204030204" pitchFamily="34" charset="0"/>
-              <a:cs typeface="Calibri" panose="020F0502020204030204" pitchFamily="34" charset="0"/>
-            </a:endParaRPr>
-          </a:p>
-          <a:p>
-            <a:pPr marL="0" marR="0" lvl="0" indent="0" algn="just" defTabSz="914400" rtl="0" eaLnBrk="1" fontAlgn="base" latinLnBrk="0" hangingPunct="0">
-              <a:lnSpc>
-                <a:spcPct val="100000"/>
-              </a:lnSpc>
-              <a:spcBef>
-                <a:spcPts val="0"/>
-              </a:spcBef>
-              <a:spcAft>
-                <a:spcPts val="0"/>
-              </a:spcAft>
-              <a:buClrTx/>
-              <a:buSzTx/>
-              <a:buFontTx/>
-              <a:buNone/>
-              <a:tabLst/>
+            <a:r>
+              <a:rPr lang="en-US" sz="1600" dirty="0">
+                <a:latin typeface="Calibri"/>
+                <a:ea typeface="Calibri"/>
+                <a:cs typeface="Calibri"/>
+              </a:rPr>
+              <a:t>Developed custom library functions and integrated them into existing frameworks to enhance automation capabilities.</a:t>
+            </a:r>
+          </a:p>
+          <a:p>
+            <a:pPr marL="285750" indent="-285750" algn="just">
+              <a:buFont typeface="Arial" panose="020B0604020202020204" pitchFamily="34" charset="0"/>
+              <a:buChar char="•"/>
               <a:defRPr/>
             </a:pPr>
-            <a:endParaRPr lang="en-US" sz="1600" dirty="0">
-              <a:solidFill>
-                <a:prstClr val="black"/>
-              </a:solidFill>
-              <a:latin typeface="Calibri" panose="020F0502020204030204" pitchFamily="34" charset="0"/>
-              <a:ea typeface="Calibri" panose="020F0502020204030204" pitchFamily="34" charset="0"/>
-              <a:cs typeface="Calibri" panose="020F0502020204030204" pitchFamily="34" charset="0"/>
-            </a:endParaRPr>
-          </a:p>
-          <a:p>
-            <a:pPr marL="0" marR="0" lvl="0" indent="0" algn="just" defTabSz="914400" rtl="0" eaLnBrk="1" fontAlgn="base" latinLnBrk="0" hangingPunct="0">
-              <a:lnSpc>
-                <a:spcPct val="100000"/>
-              </a:lnSpc>
-              <a:spcBef>
-                <a:spcPts val="0"/>
-              </a:spcBef>
-              <a:spcAft>
-                <a:spcPts val="0"/>
-              </a:spcAft>
-              <a:buClrTx/>
-              <a:buSzTx/>
-              <a:buFontTx/>
-              <a:buNone/>
-              <a:tabLst/>
+            <a:r>
+              <a:rPr lang="en-US" sz="1600" dirty="0">
+                <a:latin typeface="Calibri"/>
+                <a:ea typeface="Calibri"/>
+                <a:cs typeface="Calibri"/>
+              </a:rPr>
+              <a:t>Automated regression and smoke test suites, ensuring high coverage and stability.</a:t>
+            </a:r>
+          </a:p>
+          <a:p>
+            <a:pPr marL="285750" indent="-285750" algn="just">
+              <a:buFont typeface="Arial" panose="020B0604020202020204" pitchFamily="34" charset="0"/>
+              <a:buChar char="•"/>
               <a:defRPr/>
             </a:pPr>
-            <a:endParaRPr lang="en-US" sz="1600" dirty="0">
-              <a:solidFill>
-                <a:prstClr val="black"/>
-              </a:solidFill>
-              <a:latin typeface="Calibri" panose="020F0502020204030204" pitchFamily="34" charset="0"/>
-              <a:ea typeface="Calibri" panose="020F0502020204030204" pitchFamily="34" charset="0"/>
-              <a:cs typeface="Calibri" panose="020F0502020204030204" pitchFamily="34" charset="0"/>
-            </a:endParaRPr>
-          </a:p>
-          <a:p>
-            <a:pPr marL="0" marR="0" lvl="0" indent="0" algn="just" defTabSz="914400" rtl="0" eaLnBrk="1" fontAlgn="base" latinLnBrk="0" hangingPunct="0">
-              <a:lnSpc>
-                <a:spcPct val="100000"/>
-              </a:lnSpc>
-              <a:spcBef>
-                <a:spcPts val="0"/>
-              </a:spcBef>
-              <a:spcAft>
-                <a:spcPts val="0"/>
-              </a:spcAft>
-              <a:buClrTx/>
-              <a:buSzTx/>
-              <a:buFontTx/>
-              <a:buNone/>
-              <a:tabLst/>
+            <a:r>
+              <a:rPr lang="en-US" sz="1600" dirty="0">
+                <a:latin typeface="Calibri"/>
+                <a:ea typeface="Calibri"/>
+                <a:cs typeface="Calibri"/>
+              </a:rPr>
+              <a:t>Migrated existing automation suites from Selenium to Playwright (Python) for improved performance and maintainability.</a:t>
+            </a:r>
+          </a:p>
+          <a:p>
+            <a:pPr marL="285750" indent="-285750" algn="just">
+              <a:buFont typeface="Arial" panose="020B0604020202020204" pitchFamily="34" charset="0"/>
+              <a:buChar char="•"/>
               <a:defRPr/>
             </a:pPr>
-            <a:endParaRPr lang="en-US" sz="1600" dirty="0">
-              <a:solidFill>
-                <a:prstClr val="black"/>
-              </a:solidFill>
-              <a:latin typeface="Calibri" panose="020F0502020204030204" pitchFamily="34" charset="0"/>
-              <a:ea typeface="Calibri" panose="020F0502020204030204" pitchFamily="34" charset="0"/>
-              <a:cs typeface="Calibri" panose="020F0502020204030204" pitchFamily="34" charset="0"/>
-            </a:endParaRPr>
-          </a:p>
-          <a:p>
-            <a:pPr marL="0" marR="0" lvl="0" indent="0" algn="just" defTabSz="914400" rtl="0" eaLnBrk="1" fontAlgn="base" latinLnBrk="0" hangingPunct="0">
-              <a:lnSpc>
-                <a:spcPct val="100000"/>
-              </a:lnSpc>
-              <a:spcBef>
-                <a:spcPts val="0"/>
-              </a:spcBef>
-              <a:spcAft>
-                <a:spcPts val="0"/>
-              </a:spcAft>
-              <a:buClrTx/>
-              <a:buSzTx/>
-              <a:buFontTx/>
-              <a:buNone/>
-              <a:tabLst/>
+            <a:r>
+              <a:rPr lang="en-US" sz="1600" dirty="0">
+                <a:latin typeface="Calibri"/>
+                <a:ea typeface="Calibri"/>
+                <a:cs typeface="Calibri"/>
+              </a:rPr>
+              <a:t>Performed functional, integration, system, and regression testing for large-scale master data workflows.</a:t>
+            </a:r>
+          </a:p>
+          <a:p>
+            <a:pPr marL="285750" indent="-285750" algn="just">
+              <a:buFont typeface="Arial" panose="020B0604020202020204" pitchFamily="34" charset="0"/>
+              <a:buChar char="•"/>
               <a:defRPr/>
             </a:pPr>
-            <a:endParaRPr lang="en-US" sz="1600" dirty="0">
-              <a:solidFill>
-                <a:prstClr val="black"/>
-              </a:solidFill>
-              <a:latin typeface="Calibri" panose="020F0502020204030204" pitchFamily="34" charset="0"/>
-              <a:ea typeface="Calibri" panose="020F0502020204030204" pitchFamily="34" charset="0"/>
-              <a:cs typeface="Calibri" panose="020F0502020204030204" pitchFamily="34" charset="0"/>
-            </a:endParaRPr>
+            <a:r>
+              <a:rPr lang="en-US" sz="1600" dirty="0">
+                <a:latin typeface="Calibri"/>
+                <a:ea typeface="Calibri"/>
+                <a:cs typeface="Calibri"/>
+              </a:rPr>
+              <a:t>Validated RESTful APIs using Postman and integrated API tests into CI pipelines using Jenkins.</a:t>
+            </a:r>
+          </a:p>
+          <a:p>
+            <a:pPr marL="285750" indent="-285750" algn="just">
+              <a:buFont typeface="Arial" panose="020B0604020202020204" pitchFamily="34" charset="0"/>
+              <a:buChar char="•"/>
+              <a:defRPr/>
+            </a:pPr>
+            <a:r>
+              <a:rPr lang="en-US" sz="1600" dirty="0">
+                <a:latin typeface="Calibri"/>
+                <a:ea typeface="Calibri"/>
+                <a:cs typeface="Calibri"/>
+              </a:rPr>
+              <a:t>Monitored and </a:t>
+            </a:r>
+            <a:r>
+              <a:rPr lang="en-US" sz="1600" dirty="0" err="1">
+                <a:latin typeface="Calibri"/>
+                <a:ea typeface="Calibri"/>
+                <a:cs typeface="Calibri"/>
+              </a:rPr>
+              <a:t>analysed</a:t>
+            </a:r>
+            <a:r>
+              <a:rPr lang="en-US" sz="1600" dirty="0">
+                <a:latin typeface="Calibri"/>
+                <a:ea typeface="Calibri"/>
+                <a:cs typeface="Calibri"/>
+              </a:rPr>
+              <a:t> application performance using Splunk and New Relic.</a:t>
+            </a:r>
+          </a:p>
+          <a:p>
+            <a:pPr marL="285750" indent="-285750" algn="just">
+              <a:buFont typeface="Arial" panose="020B0604020202020204" pitchFamily="34" charset="0"/>
+              <a:buChar char="•"/>
+              <a:defRPr/>
+            </a:pPr>
+            <a:r>
+              <a:rPr lang="en-US" sz="1600" dirty="0">
+                <a:latin typeface="Calibri"/>
+                <a:ea typeface="Calibri"/>
+                <a:cs typeface="Calibri"/>
+              </a:rPr>
+              <a:t>Created and executed test plans, test scenarios, and test cases for performance, stress, and power testing.</a:t>
+            </a:r>
+          </a:p>
+          <a:p>
+            <a:pPr marL="285750" indent="-285750" algn="just">
+              <a:buFont typeface="Arial" panose="020B0604020202020204" pitchFamily="34" charset="0"/>
+              <a:buChar char="•"/>
+              <a:defRPr/>
+            </a:pPr>
+            <a:r>
+              <a:rPr lang="en-US" sz="1600" dirty="0">
+                <a:latin typeface="Calibri"/>
+                <a:ea typeface="Calibri"/>
+                <a:cs typeface="Calibri"/>
+              </a:rPr>
+              <a:t>Provided effort estimations for sprint test execution and collaborated with stakeholders on planning.</a:t>
+            </a:r>
+          </a:p>
+          <a:p>
+            <a:pPr marL="285750" indent="-285750" algn="just">
+              <a:buFont typeface="Arial" panose="020B0604020202020204" pitchFamily="34" charset="0"/>
+              <a:buChar char="•"/>
+              <a:defRPr/>
+            </a:pPr>
+            <a:r>
+              <a:rPr lang="en-US" sz="1600" dirty="0">
+                <a:latin typeface="Calibri"/>
+                <a:ea typeface="Calibri"/>
+                <a:cs typeface="Calibri"/>
+              </a:rPr>
+              <a:t>Reviewed and approved code changes in Gerrit, resolving merge conflicts where necessary.</a:t>
+            </a:r>
+          </a:p>
+          <a:p>
+            <a:pPr marL="285750" indent="-285750" algn="just">
+              <a:buFont typeface="Arial" panose="020B0604020202020204" pitchFamily="34" charset="0"/>
+              <a:buChar char="•"/>
+              <a:defRPr/>
+            </a:pPr>
+            <a:r>
+              <a:rPr lang="en-US" sz="1600" dirty="0">
+                <a:latin typeface="Calibri"/>
+                <a:ea typeface="Calibri"/>
+                <a:cs typeface="Calibri"/>
+              </a:rPr>
+              <a:t>Logged, tracked, and verified defects in JIRA, ensuring timely resolution.</a:t>
+            </a:r>
+          </a:p>
+          <a:p>
+            <a:pPr marL="285750" indent="-285750" algn="just">
+              <a:buFont typeface="Arial" panose="020B0604020202020204" pitchFamily="34" charset="0"/>
+              <a:buChar char="•"/>
+              <a:defRPr/>
+            </a:pPr>
+            <a:r>
+              <a:rPr lang="en-US" sz="1600" dirty="0">
+                <a:latin typeface="Calibri"/>
+                <a:ea typeface="Calibri"/>
+                <a:cs typeface="Calibri"/>
+              </a:rPr>
+              <a:t>Collaborated with cross-functional teams and actively participated in Agile ceremonies (daily standups, sprint planning, retrospectives).</a:t>
+            </a:r>
           </a:p>
         </p:txBody>
       </p:sp>
@@ -7199,7 +7269,7 @@
           <p:cNvPr id="12" name="TextBox 11">
             <a:extLst>
               <a:ext uri="{FF2B5EF4-FFF2-40B4-BE49-F238E27FC236}">
-                <a16:creationId xmlns:a16="http://schemas.microsoft.com/office/drawing/2014/main" id="{DEEFE75C-7666-C01B-B99D-B88C12B9FC8F}"/>
+                <a16:creationId xmlns:a16="http://schemas.microsoft.com/office/drawing/2014/main" id="{69E9817A-6332-5EC4-B2D4-E14B5EBDD257}"/>
               </a:ext>
             </a:extLst>
           </p:cNvPr>
@@ -7208,8 +7278,8 @@
         </p:nvSpPr>
         <p:spPr>
           <a:xfrm>
-            <a:off x="304800" y="1712950"/>
-            <a:ext cx="1470274" cy="369332"/>
+            <a:off x="304800" y="1510628"/>
+            <a:ext cx="1341136" cy="369332"/>
           </a:xfrm>
           <a:prstGeom prst="rect">
             <a:avLst/>
@@ -7240,21 +7310,10 @@
               <a:defRPr/>
             </a:pPr>
             <a:r>
-              <a:rPr lang="en-US" b="1" dirty="0"/>
-              <a:t>D</a:t>
-            </a:r>
-            <a:r>
-              <a:rPr lang="en-IN" b="1" dirty="0"/>
-              <a:t>escription</a:t>
-            </a:r>
-            <a:r>
-              <a:rPr kumimoji="0" lang="en-IN" sz="1600" b="1" i="0" u="none" strike="noStrike" kern="1200" cap="none" spc="0" normalizeH="0" baseline="0" noProof="0" dirty="0">
+              <a:rPr kumimoji="0" lang="en-US" b="1" i="0" u="none" strike="noStrike" kern="1200" cap="none" spc="0" normalizeH="0" baseline="0" noProof="0" dirty="0">
                 <a:ln>
                   <a:noFill/>
                 </a:ln>
-                <a:solidFill>
-                  <a:srgbClr val="002060"/>
-                </a:solidFill>
                 <a:effectLst/>
                 <a:uLnTx/>
                 <a:uFillTx/>
@@ -7262,7 +7321,21 @@
                 <a:ea typeface="Calibri"/>
                 <a:cs typeface="Calibri"/>
               </a:rPr>
-              <a:t>:</a:t>
+              <a:t>D</a:t>
+            </a:r>
+            <a:r>
+              <a:rPr kumimoji="0" lang="en-IN" b="1" i="0" u="none" strike="noStrike" kern="1200" cap="none" spc="0" normalizeH="0" baseline="0" noProof="0" dirty="0">
+                <a:ln>
+                  <a:noFill/>
+                </a:ln>
+                <a:effectLst/>
+                <a:uLnTx/>
+                <a:uFillTx/>
+                <a:latin typeface="Calibri"/>
+                <a:ea typeface="Calibri"/>
+                <a:cs typeface="Calibri"/>
+              </a:rPr>
+              <a:t>escription:</a:t>
             </a:r>
           </a:p>
         </p:txBody>
@@ -7272,7 +7345,7 @@
           <p:cNvPr id="14" name="TextBox 13">
             <a:extLst>
               <a:ext uri="{FF2B5EF4-FFF2-40B4-BE49-F238E27FC236}">
-                <a16:creationId xmlns:a16="http://schemas.microsoft.com/office/drawing/2014/main" id="{EEC00225-2649-E9A9-35FD-316C40ECD757}"/>
+                <a16:creationId xmlns:a16="http://schemas.microsoft.com/office/drawing/2014/main" id="{7FA4A957-BEDD-F60C-ADA6-86EB8E004333}"/>
               </a:ext>
             </a:extLst>
           </p:cNvPr>
@@ -7290,7 +7363,7 @@
           <a:noFill/>
         </p:spPr>
         <p:txBody>
-          <a:bodyPr wrap="square">
+          <a:bodyPr wrap="square" lIns="91440" tIns="45720" rIns="91440" bIns="45720" anchor="t">
             <a:spAutoFit/>
           </a:bodyPr>
           <a:lstStyle/>
@@ -7313,7 +7386,7 @@
               <a:defRPr/>
             </a:pPr>
             <a:r>
-              <a:rPr kumimoji="0" lang="en-US" b="1" i="0" u="none" strike="noStrike" kern="1200" cap="none" spc="0" normalizeH="0" baseline="0" noProof="0" dirty="0">
+              <a:rPr kumimoji="0" lang="en-US" b="1" i="0" u="none" strike="noStrike" kern="1200" cap="none" spc="0" normalizeH="0" baseline="0" noProof="0">
                 <a:ln>
                   <a:noFill/>
                 </a:ln>
@@ -7327,9 +7400,20 @@
                 <a:ea typeface="Calibri"/>
                 <a:cs typeface="Calibri"/>
               </a:rPr>
-              <a:t>Project 3</a:t>
-            </a:r>
-            <a:endParaRPr kumimoji="0" lang="en-US" b="0" i="0" u="none" strike="noStrike" kern="1200" cap="none" spc="0" normalizeH="0" baseline="0" noProof="0" dirty="0">
+              <a:t>Project </a:t>
+            </a:r>
+            <a:r>
+              <a:rPr lang="en-US" b="1">
+                <a:solidFill>
+                  <a:srgbClr val="002060"/>
+                </a:solidFill>
+                <a:latin typeface="Calibri"/>
+                <a:ea typeface="Calibri"/>
+                <a:cs typeface="Calibri"/>
+              </a:rPr>
+              <a:t>3</a:t>
+            </a:r>
+            <a:endParaRPr kumimoji="0" lang="en-US" b="0" i="0" u="none" strike="noStrike" kern="1200" cap="none" spc="0" normalizeH="0" baseline="0" noProof="0">
               <a:ln>
                 <a:noFill/>
               </a:ln>
@@ -7351,7 +7435,7 @@
           <p:cNvPr id="3" name="Picture 2">
             <a:extLst>
               <a:ext uri="{FF2B5EF4-FFF2-40B4-BE49-F238E27FC236}">
-                <a16:creationId xmlns:a16="http://schemas.microsoft.com/office/drawing/2014/main" id="{9CE50D27-C285-DBAE-BAA1-12AE4060FDAB}"/>
+                <a16:creationId xmlns:a16="http://schemas.microsoft.com/office/drawing/2014/main" id="{089CF080-0376-3553-A31B-5AEDF3C651BE}"/>
               </a:ext>
             </a:extLst>
           </p:cNvPr>
@@ -7361,7 +7445,7 @@
           <p:nvPr/>
         </p:nvPicPr>
         <p:blipFill>
-          <a:blip r:embed="rId2">
+          <a:blip r:embed="rId3">
             <a:biLevel thresh="25000"/>
           </a:blip>
           <a:stretch>
@@ -7370,7 +7454,7 @@
         </p:blipFill>
         <p:spPr>
           <a:xfrm>
-            <a:off x="9993086" y="75293"/>
+            <a:off x="9940412" y="123053"/>
             <a:ext cx="2066530" cy="587639"/>
           </a:xfrm>
           <a:prstGeom prst="rect">
@@ -7384,7 +7468,7 @@
     </p:spTree>
     <p:extLst>
       <p:ext uri="{BB962C8B-B14F-4D97-AF65-F5344CB8AC3E}">
-        <p14:creationId xmlns:p14="http://schemas.microsoft.com/office/powerpoint/2010/main" val="2262051643"/>
+        <p14:creationId xmlns:p14="http://schemas.microsoft.com/office/powerpoint/2010/main" val="2512149221"/>
       </p:ext>
     </p:extLst>
   </p:cSld>
@@ -7410,7 +7494,7 @@
         <p:cNvPr id="1" name="">
           <a:extLst>
             <a:ext uri="{FF2B5EF4-FFF2-40B4-BE49-F238E27FC236}">
-              <a16:creationId xmlns:a16="http://schemas.microsoft.com/office/drawing/2014/main" id="{D5E09864-4992-3906-59DB-A4B1F9E76D09}"/>
+              <a16:creationId xmlns:a16="http://schemas.microsoft.com/office/drawing/2014/main" id="{A6D0BE6B-9BA5-1D77-5855-DA1A7E434141}"/>
             </a:ext>
           </a:extLst>
         </p:cNvPr>
@@ -7430,7 +7514,7 @@
           <p:cNvPr id="5" name="Slide Number Placeholder 4">
             <a:extLst>
               <a:ext uri="{FF2B5EF4-FFF2-40B4-BE49-F238E27FC236}">
-                <a16:creationId xmlns:a16="http://schemas.microsoft.com/office/drawing/2014/main" id="{7350FD1B-DFB6-DD01-EB80-6C652E530739}"/>
+                <a16:creationId xmlns:a16="http://schemas.microsoft.com/office/drawing/2014/main" id="{79E39533-D777-E8D1-6568-C653AB3CDB71}"/>
               </a:ext>
             </a:extLst>
           </p:cNvPr>
@@ -7523,7 +7607,7 @@
           <p:cNvPr id="7" name="TextBox 6">
             <a:extLst>
               <a:ext uri="{FF2B5EF4-FFF2-40B4-BE49-F238E27FC236}">
-                <a16:creationId xmlns:a16="http://schemas.microsoft.com/office/drawing/2014/main" id="{B9B22AF1-3840-9008-3CA4-0A6A790F3B2B}"/>
+                <a16:creationId xmlns:a16="http://schemas.microsoft.com/office/drawing/2014/main" id="{BB11E5DD-4B91-F731-B9FD-DC124FACD3DD}"/>
               </a:ext>
             </a:extLst>
           </p:cNvPr>
@@ -7532,7 +7616,7 @@
         </p:nvSpPr>
         <p:spPr>
           <a:xfrm>
-            <a:off x="304800" y="634824"/>
+            <a:off x="304800" y="696071"/>
             <a:ext cx="9954892" cy="923330"/>
           </a:xfrm>
           <a:prstGeom prst="rect">
@@ -7564,52 +7648,29 @@
                 <a:ea typeface="Calibri"/>
                 <a:cs typeface="Calibri"/>
               </a:rPr>
-              <a:t>Project: </a:t>
-            </a:r>
-            <a:r>
-              <a:rPr kumimoji="0" lang="en-US" b="1" i="0" u="none" strike="noStrike" kern="1200" cap="none" spc="0" normalizeH="0" baseline="0" noProof="0">
-                <a:ln>
-                  <a:noFill/>
-                </a:ln>
+              <a:t>Project:</a:t>
+            </a:r>
+            <a:r>
+              <a:rPr lang="en-US" b="1" dirty="0">
                 <a:solidFill>
                   <a:prstClr val="black"/>
                 </a:solidFill>
-                <a:effectLst/>
-                <a:uLnTx/>
-                <a:uFillTx/>
                 <a:latin typeface="Calibri"/>
                 <a:ea typeface="Calibri"/>
                 <a:cs typeface="Calibri"/>
               </a:rPr>
-              <a:t>{PROJECT4_</a:t>
-            </a:r>
-            <a:r>
-              <a:rPr kumimoji="0" lang="en-US" b="1" i="0" u="none" strike="noStrike" kern="1200" cap="none" spc="0" normalizeH="0" baseline="0" noProof="0" dirty="0">
-                <a:ln>
-                  <a:noFill/>
-                </a:ln>
+              <a:t> </a:t>
+            </a:r>
+            <a:r>
+              <a:rPr lang="en-US" b="1" dirty="0">
                 <a:solidFill>
                   <a:prstClr val="black"/>
                 </a:solidFill>
-                <a:effectLst/>
-                <a:uLnTx/>
-                <a:uFillTx/>
                 <a:latin typeface="Calibri"/>
                 <a:ea typeface="Calibri"/>
-                <a:cs typeface="Calibri"/>
-              </a:rPr>
-              <a:t>NAME}</a:t>
-            </a:r>
-            <a:r>
-              <a:rPr lang="en-US" b="1" dirty="0">
-                <a:solidFill>
-                  <a:prstClr val="black"/>
-                </a:solidFill>
-                <a:latin typeface="Calibri"/>
-                <a:ea typeface="Calibri"/>
-                <a:cs typeface="Calibri"/>
-              </a:rPr>
-              <a:t>.</a:t>
+                <a:cs typeface="Segoe UI"/>
+              </a:rPr>
+              <a:t>Hitachi Rail</a:t>
             </a:r>
             <a:endParaRPr lang="en-US" b="1" i="0" u="none" strike="noStrike" kern="1200" cap="none" spc="0" normalizeH="0" baseline="0" noProof="0" dirty="0">
               <a:ln>
@@ -7645,43 +7706,41 @@
                 <a:ea typeface="Calibri"/>
                 <a:cs typeface="Calibri"/>
               </a:rPr>
-              <a:t>Duration : {DURATION_project4}</a:t>
-            </a:r>
-            <a:endParaRPr lang="en-US" b="1" dirty="0">
-              <a:solidFill>
-                <a:prstClr val="black"/>
-              </a:solidFill>
-              <a:latin typeface="Calibri"/>
-              <a:ea typeface="Calibri"/>
-              <a:cs typeface="Calibri"/>
-            </a:endParaRPr>
+              <a:t>Duration : </a:t>
+            </a:r>
+            <a:r>
+              <a:rPr lang="en-US" b="1" dirty="0">
+                <a:solidFill>
+                  <a:prstClr val="black"/>
+                </a:solidFill>
+                <a:latin typeface="Calibri"/>
+                <a:ea typeface="+mn-lt"/>
+                <a:cs typeface="+mn-lt"/>
+              </a:rPr>
+              <a:t>Jan’2020 – Dec’2021</a:t>
+            </a:r>
           </a:p>
           <a:p>
             <a:pPr>
               <a:defRPr/>
             </a:pPr>
             <a:r>
-              <a:rPr lang="en-US" b="1" dirty="0"/>
-              <a:t>Role</a:t>
-            </a:r>
-            <a:r>
-              <a:rPr lang="en-US" dirty="0"/>
-              <a:t>: {ROLE_project4}</a:t>
-            </a:r>
-            <a:endParaRPr lang="en-US" b="1" i="0" u="none" strike="noStrike" kern="1200" cap="none" spc="0" normalizeH="0" baseline="0" noProof="0" dirty="0">
-              <a:ln>
-                <a:noFill/>
-              </a:ln>
-              <a:solidFill>
-                <a:prstClr val="black"/>
-              </a:solidFill>
-              <a:effectLst/>
-              <a:uLnTx/>
-              <a:uFillTx/>
-              <a:latin typeface="Calibri"/>
-              <a:ea typeface="Calibri"/>
-              <a:cs typeface="Calibri"/>
-            </a:endParaRPr>
+              <a:rPr lang="en-US" b="1" i="0" u="none" strike="noStrike" kern="1200" cap="none" spc="0" normalizeH="0" baseline="0" noProof="0" dirty="0">
+                <a:ln>
+                  <a:noFill/>
+                </a:ln>
+                <a:solidFill>
+                  <a:prstClr val="black"/>
+                </a:solidFill>
+                <a:effectLst/>
+                <a:uLnTx/>
+                <a:uFillTx/>
+                <a:latin typeface="Calibri"/>
+                <a:ea typeface="+mn-lt"/>
+                <a:cs typeface="+mn-lt"/>
+              </a:rPr>
+              <a:t>Role: Associate consultant</a:t>
+            </a:r>
           </a:p>
         </p:txBody>
       </p:sp>
@@ -7690,7 +7749,7 @@
           <p:cNvPr id="11" name="TextBox 10">
             <a:extLst>
               <a:ext uri="{FF2B5EF4-FFF2-40B4-BE49-F238E27FC236}">
-                <a16:creationId xmlns:a16="http://schemas.microsoft.com/office/drawing/2014/main" id="{E710390A-553C-B68D-9AAF-E63341E911D8}"/>
+                <a16:creationId xmlns:a16="http://schemas.microsoft.com/office/drawing/2014/main" id="{B7FE0190-4CB5-2F4F-C984-D5C304ED4B0A}"/>
               </a:ext>
             </a:extLst>
           </p:cNvPr>
@@ -7699,8 +7758,8 @@
         </p:nvSpPr>
         <p:spPr>
           <a:xfrm>
-            <a:off x="304800" y="2132178"/>
-            <a:ext cx="11691257" cy="4524315"/>
+            <a:off x="304800" y="1995279"/>
+            <a:ext cx="11734800" cy="4478149"/>
           </a:xfrm>
           <a:prstGeom prst="rect">
             <a:avLst/>
@@ -7717,7 +7776,7 @@
               <a:defRPr/>
             </a:pPr>
             <a:r>
-              <a:rPr lang="en-US" sz="1600" i="0" u="none" strike="noStrike" kern="1200" cap="none" spc="0" normalizeH="0" baseline="0" noProof="0" dirty="0">
+              <a:rPr kumimoji="0" lang="en-US" sz="1500" b="1" i="0" u="none" strike="noStrike" kern="1200" cap="none" spc="0" normalizeH="0" baseline="0" noProof="0" dirty="0">
                 <a:ln>
                   <a:noFill/>
                 </a:ln>
@@ -7731,132 +7790,45 @@
                 <a:ea typeface="Calibri"/>
                 <a:cs typeface="Calibri"/>
               </a:rPr>
-              <a:t>{Project4_Description}:</a:t>
-            </a:r>
-          </a:p>
-          <a:p>
-            <a:pPr algn="just" fontAlgn="base" hangingPunct="0">
+              <a:t>Project Overview</a:t>
+            </a:r>
+            <a:r>
+              <a:rPr kumimoji="0" lang="en-US" sz="1500" b="0" i="0" u="none" strike="noStrike" kern="1200" cap="none" spc="0" normalizeH="0" baseline="0" noProof="0" dirty="0">
+                <a:ln>
+                  <a:noFill/>
+                </a:ln>
+                <a:solidFill>
+                  <a:prstClr val="black"/>
+                </a:solidFill>
+                <a:effectLst/>
+                <a:uLnTx/>
+                <a:uFillTx/>
+                <a:latin typeface="Calibri"/>
+                <a:ea typeface="Calibri"/>
+                <a:cs typeface="Calibri"/>
+              </a:rPr>
+              <a:t>: </a:t>
+            </a:r>
+            <a:r>
+              <a:rPr lang="en-US" sz="1500" dirty="0">
+                <a:solidFill>
+                  <a:prstClr val="black"/>
+                </a:solidFill>
+                <a:latin typeface="Calibri"/>
+                <a:ea typeface="+mn-lt"/>
+                <a:cs typeface="+mn-lt"/>
+              </a:rPr>
+              <a:t>This is a Metro Rail project, main objective of this project is to develop solutions that enhance safety, real-time monitoring, real-time updates for train locations, passenger information for different metro rail operations. Mostly worked in ATS and CBC. ATS gets information from various external interfaces and displays on ATS screen. Worked on ATS with Modbus, FLDC, SCADA, PSIS simulators which helps for managing platform screen doors, fleet data collection, information about traction power, routing, vehicle regulations and passenger information etc.</a:t>
+            </a:r>
+          </a:p>
+          <a:p>
+            <a:pPr algn="just">
               <a:defRPr/>
             </a:pPr>
-            <a:endParaRPr lang="en-US" sz="1600" dirty="0">
+            <a:endParaRPr lang="en-US" sz="1500" dirty="0">
               <a:solidFill>
                 <a:prstClr val="black"/>
               </a:solidFill>
-              <a:latin typeface="Calibri"/>
-              <a:ea typeface="Calibri"/>
-              <a:cs typeface="Calibri"/>
-            </a:endParaRPr>
-          </a:p>
-          <a:p>
-            <a:pPr algn="just" fontAlgn="base" hangingPunct="0">
-              <a:defRPr/>
-            </a:pPr>
-            <a:endParaRPr lang="en-US" sz="1600" i="0" u="none" strike="noStrike" kern="1200" cap="none" spc="0" normalizeH="0" baseline="0" noProof="0" dirty="0">
-              <a:ln>
-                <a:noFill/>
-              </a:ln>
-              <a:solidFill>
-                <a:prstClr val="black"/>
-              </a:solidFill>
-              <a:effectLst/>
-              <a:uLnTx/>
-              <a:uFillTx/>
-              <a:latin typeface="Calibri"/>
-              <a:ea typeface="Calibri"/>
-              <a:cs typeface="Calibri"/>
-            </a:endParaRPr>
-          </a:p>
-          <a:p>
-            <a:pPr algn="just" fontAlgn="base" hangingPunct="0">
-              <a:defRPr/>
-            </a:pPr>
-            <a:endParaRPr lang="en-US" sz="1600" dirty="0">
-              <a:solidFill>
-                <a:prstClr val="black"/>
-              </a:solidFill>
-              <a:latin typeface="Calibri"/>
-              <a:ea typeface="Calibri"/>
-              <a:cs typeface="Calibri"/>
-            </a:endParaRPr>
-          </a:p>
-          <a:p>
-            <a:pPr algn="just" fontAlgn="base" hangingPunct="0">
-              <a:defRPr/>
-            </a:pPr>
-            <a:endParaRPr lang="en-US" sz="1600" i="0" u="none" strike="noStrike" kern="1200" cap="none" spc="0" normalizeH="0" baseline="0" noProof="0" dirty="0">
-              <a:ln>
-                <a:noFill/>
-              </a:ln>
-              <a:solidFill>
-                <a:prstClr val="black"/>
-              </a:solidFill>
-              <a:effectLst/>
-              <a:uLnTx/>
-              <a:uFillTx/>
-              <a:latin typeface="Calibri"/>
-              <a:ea typeface="Calibri"/>
-              <a:cs typeface="Calibri"/>
-            </a:endParaRPr>
-          </a:p>
-          <a:p>
-            <a:pPr algn="just" fontAlgn="base" hangingPunct="0">
-              <a:defRPr/>
-            </a:pPr>
-            <a:endParaRPr lang="en-US" sz="1600" dirty="0">
-              <a:solidFill>
-                <a:prstClr val="black"/>
-              </a:solidFill>
-              <a:latin typeface="Calibri"/>
-              <a:ea typeface="Calibri"/>
-              <a:cs typeface="Calibri"/>
-            </a:endParaRPr>
-          </a:p>
-          <a:p>
-            <a:pPr algn="just" fontAlgn="base" hangingPunct="0">
-              <a:defRPr/>
-            </a:pPr>
-            <a:endParaRPr lang="en-US" sz="1600" i="0" u="none" strike="noStrike" kern="1200" cap="none" spc="0" normalizeH="0" baseline="0" noProof="0" dirty="0">
-              <a:ln>
-                <a:noFill/>
-              </a:ln>
-              <a:solidFill>
-                <a:prstClr val="black"/>
-              </a:solidFill>
-              <a:effectLst/>
-              <a:uLnTx/>
-              <a:uFillTx/>
-              <a:latin typeface="Calibri"/>
-              <a:ea typeface="Calibri"/>
-              <a:cs typeface="Calibri"/>
-            </a:endParaRPr>
-          </a:p>
-          <a:p>
-            <a:pPr algn="just" fontAlgn="base" hangingPunct="0">
-              <a:defRPr/>
-            </a:pPr>
-            <a:endParaRPr lang="en-US" sz="1600" dirty="0">
-              <a:solidFill>
-                <a:prstClr val="black"/>
-              </a:solidFill>
-              <a:latin typeface="Calibri"/>
-              <a:ea typeface="Calibri"/>
-              <a:cs typeface="Calibri"/>
-            </a:endParaRPr>
-          </a:p>
-          <a:p>
-            <a:pPr algn="just" fontAlgn="base" hangingPunct="0">
-              <a:defRPr/>
-            </a:pPr>
-            <a:endParaRPr lang="en-US" sz="1600" i="0" u="none" strike="noStrike" kern="1200" cap="none" spc="0" normalizeH="0" baseline="0" noProof="0" dirty="0">
-              <a:ln>
-                <a:noFill/>
-              </a:ln>
-              <a:solidFill>
-                <a:prstClr val="black"/>
-              </a:solidFill>
-              <a:effectLst/>
-              <a:uLnTx/>
-              <a:uFillTx/>
               <a:latin typeface="Calibri"/>
               <a:ea typeface="Calibri"/>
               <a:cs typeface="Calibri"/>
@@ -7881,19 +7853,42 @@
               <a:defRPr/>
             </a:pPr>
             <a:r>
-              <a:rPr lang="en-US" sz="1600" b="1" dirty="0">
+              <a:rPr kumimoji="0" lang="en-US" sz="1500" b="1" i="0" u="none" strike="noStrike" kern="1200" cap="none" spc="0" normalizeH="0" baseline="0" noProof="0" dirty="0">
+                <a:ln>
+                  <a:noFill/>
+                </a:ln>
                 <a:solidFill>
                   <a:prstClr val="black"/>
                 </a:solidFill>
-                <a:latin typeface="Calibri" panose="020F0502020204030204" pitchFamily="34" charset="0"/>
-                <a:ea typeface="Calibri" panose="020F0502020204030204" pitchFamily="34" charset="0"/>
-                <a:cs typeface="Calibri" panose="020F0502020204030204" pitchFamily="34" charset="0"/>
-              </a:rPr>
-              <a:t>Responsibilities: </a:t>
-            </a:r>
-          </a:p>
-          <a:p>
-            <a:pPr marL="0" marR="0" lvl="0" indent="0" algn="just" defTabSz="914400" rtl="0" eaLnBrk="1" fontAlgn="base" latinLnBrk="0" hangingPunct="0">
+                <a:effectLst/>
+                <a:uLnTx/>
+                <a:uFillTx/>
+                <a:latin typeface="Calibri"/>
+                <a:ea typeface="Calibri"/>
+                <a:cs typeface="Calibri"/>
+              </a:rPr>
+              <a:t>Responsibilities</a:t>
+            </a:r>
+            <a:r>
+              <a:rPr kumimoji="0" lang="en-US" sz="1500" b="0" i="0" u="none" strike="noStrike" kern="1200" cap="none" spc="0" normalizeH="0" baseline="0" noProof="0" dirty="0">
+                <a:ln>
+                  <a:noFill/>
+                </a:ln>
+                <a:solidFill>
+                  <a:prstClr val="black"/>
+                </a:solidFill>
+                <a:effectLst/>
+                <a:uLnTx/>
+                <a:uFillTx/>
+                <a:latin typeface="Calibri"/>
+                <a:ea typeface="Calibri"/>
+                <a:cs typeface="Calibri"/>
+              </a:rPr>
+              <a:t>: </a:t>
+            </a:r>
+          </a:p>
+          <a:p>
+            <a:pPr marL="285750" marR="0" lvl="0" indent="-285750" algn="just" defTabSz="914400" rtl="0" eaLnBrk="1" fontAlgn="base" latinLnBrk="0" hangingPunct="0">
               <a:lnSpc>
                 <a:spcPct val="100000"/>
               </a:lnSpc>
@@ -7905,25 +7900,28 @@
               </a:spcAft>
               <a:buClrTx/>
               <a:buSzTx/>
-              <a:buFontTx/>
-              <a:buNone/>
+              <a:buFont typeface="Arial" panose="020B0604020202020204" pitchFamily="34" charset="0"/>
+              <a:buChar char="•"/>
               <a:tabLst/>
               <a:defRPr/>
             </a:pPr>
             <a:r>
-              <a:rPr lang="en-US" sz="1600" dirty="0">
-                <a:solidFill>
-                  <a:prstClr val="black"/>
-                </a:solidFill>
-                <a:latin typeface="Calibri" panose="020F0502020204030204" pitchFamily="34" charset="0"/>
-                <a:ea typeface="Calibri" panose="020F0502020204030204" pitchFamily="34" charset="0"/>
-                <a:cs typeface="Calibri" panose="020F0502020204030204" pitchFamily="34" charset="0"/>
-              </a:rPr>
-              <a:t>{Responsibilities_project4}</a:t>
-            </a:r>
-          </a:p>
-          <a:p>
-            <a:pPr marL="0" marR="0" lvl="0" indent="0" algn="just" defTabSz="914400" rtl="0" eaLnBrk="1" fontAlgn="base" latinLnBrk="0" hangingPunct="0">
+              <a:rPr lang="en-US" sz="1500" b="0" i="0" u="none" strike="noStrike" kern="1200" cap="none" spc="0" normalizeH="0" baseline="0" noProof="0" dirty="0">
+                <a:ln>
+                  <a:noFill/>
+                </a:ln>
+                <a:effectLst/>
+                <a:uLnTx/>
+                <a:uFillTx/>
+                <a:latin typeface="Calibri"/>
+                <a:ea typeface="Calibri"/>
+                <a:cs typeface="Calibri"/>
+              </a:rPr>
+              <a:t>Performed functional testing of IP address management solutions with multi-grid capabilities.</a:t>
+            </a:r>
+          </a:p>
+          <a:p>
+            <a:pPr marL="285750" marR="0" lvl="0" indent="-285750" algn="just" defTabSz="914400" rtl="0" eaLnBrk="1" fontAlgn="base" latinLnBrk="0" hangingPunct="0">
               <a:lnSpc>
                 <a:spcPct val="100000"/>
               </a:lnSpc>
@@ -7935,22 +7933,28 @@
               </a:spcAft>
               <a:buClrTx/>
               <a:buSzTx/>
-              <a:buFontTx/>
-              <a:buNone/>
+              <a:buFont typeface="Arial" panose="020B0604020202020204" pitchFamily="34" charset="0"/>
+              <a:buChar char="•"/>
               <a:tabLst/>
               <a:defRPr/>
             </a:pPr>
-            <a:endParaRPr lang="en-US" sz="1600" dirty="0">
-              <a:solidFill>
-                <a:prstClr val="black"/>
-              </a:solidFill>
-              <a:latin typeface="Calibri" panose="020F0502020204030204" pitchFamily="34" charset="0"/>
-              <a:ea typeface="Calibri" panose="020F0502020204030204" pitchFamily="34" charset="0"/>
-              <a:cs typeface="Calibri" panose="020F0502020204030204" pitchFamily="34" charset="0"/>
-            </a:endParaRPr>
-          </a:p>
-          <a:p>
-            <a:pPr marL="0" marR="0" lvl="0" indent="0" algn="just" defTabSz="914400" rtl="0" eaLnBrk="1" fontAlgn="base" latinLnBrk="0" hangingPunct="0">
+            <a:r>
+              <a:rPr lang="en-US" sz="1500" b="0" i="0" u="none" strike="noStrike" kern="1200" cap="none" spc="0" normalizeH="0" baseline="0" noProof="0" dirty="0">
+                <a:ln>
+                  <a:noFill/>
+                </a:ln>
+                <a:effectLst/>
+                <a:uLnTx/>
+                <a:uFillTx/>
+                <a:latin typeface="Calibri"/>
+                <a:ea typeface="Calibri"/>
+                <a:cs typeface="Calibri"/>
+              </a:rPr>
+              <a:t>Validated features such as Network Discovery and integration with Microsoft DNS/DHCP.</a:t>
+            </a:r>
+          </a:p>
+          <a:p>
+            <a:pPr marL="285750" marR="0" lvl="0" indent="-285750" algn="just" defTabSz="914400" rtl="0" eaLnBrk="1" fontAlgn="base" latinLnBrk="0" hangingPunct="0">
               <a:lnSpc>
                 <a:spcPct val="100000"/>
               </a:lnSpc>
@@ -7962,22 +7966,28 @@
               </a:spcAft>
               <a:buClrTx/>
               <a:buSzTx/>
-              <a:buFontTx/>
-              <a:buNone/>
+              <a:buFont typeface="Arial" panose="020B0604020202020204" pitchFamily="34" charset="0"/>
+              <a:buChar char="•"/>
               <a:tabLst/>
               <a:defRPr/>
             </a:pPr>
-            <a:endParaRPr lang="en-US" sz="1600" dirty="0">
-              <a:solidFill>
-                <a:prstClr val="black"/>
-              </a:solidFill>
-              <a:latin typeface="Calibri" panose="020F0502020204030204" pitchFamily="34" charset="0"/>
-              <a:ea typeface="Calibri" panose="020F0502020204030204" pitchFamily="34" charset="0"/>
-              <a:cs typeface="Calibri" panose="020F0502020204030204" pitchFamily="34" charset="0"/>
-            </a:endParaRPr>
-          </a:p>
-          <a:p>
-            <a:pPr marL="0" marR="0" lvl="0" indent="0" algn="just" defTabSz="914400" rtl="0" eaLnBrk="1" fontAlgn="base" latinLnBrk="0" hangingPunct="0">
+            <a:r>
+              <a:rPr lang="en-US" sz="1500" b="0" i="0" u="none" strike="noStrike" kern="1200" cap="none" spc="0" normalizeH="0" baseline="0" noProof="0" dirty="0">
+                <a:ln>
+                  <a:noFill/>
+                </a:ln>
+                <a:effectLst/>
+                <a:uLnTx/>
+                <a:uFillTx/>
+                <a:latin typeface="Calibri"/>
+                <a:ea typeface="Calibri"/>
+                <a:cs typeface="Calibri"/>
+              </a:rPr>
+              <a:t>Logged and tracked defects in JIRA, ensuring prompt resolution.</a:t>
+            </a:r>
+          </a:p>
+          <a:p>
+            <a:pPr marL="285750" marR="0" lvl="0" indent="-285750" algn="just" defTabSz="914400" rtl="0" eaLnBrk="1" fontAlgn="base" latinLnBrk="0" hangingPunct="0">
               <a:lnSpc>
                 <a:spcPct val="100000"/>
               </a:lnSpc>
@@ -7989,22 +7999,28 @@
               </a:spcAft>
               <a:buClrTx/>
               <a:buSzTx/>
-              <a:buFontTx/>
-              <a:buNone/>
+              <a:buFont typeface="Arial" panose="020B0604020202020204" pitchFamily="34" charset="0"/>
+              <a:buChar char="•"/>
               <a:tabLst/>
               <a:defRPr/>
             </a:pPr>
-            <a:endParaRPr lang="en-US" sz="1600" dirty="0">
-              <a:solidFill>
-                <a:prstClr val="black"/>
-              </a:solidFill>
-              <a:latin typeface="Calibri" panose="020F0502020204030204" pitchFamily="34" charset="0"/>
-              <a:ea typeface="Calibri" panose="020F0502020204030204" pitchFamily="34" charset="0"/>
-              <a:cs typeface="Calibri" panose="020F0502020204030204" pitchFamily="34" charset="0"/>
-            </a:endParaRPr>
-          </a:p>
-          <a:p>
-            <a:pPr marL="0" marR="0" lvl="0" indent="0" algn="just" defTabSz="914400" rtl="0" eaLnBrk="1" fontAlgn="base" latinLnBrk="0" hangingPunct="0">
+            <a:r>
+              <a:rPr lang="en-US" sz="1500" b="0" i="0" u="none" strike="noStrike" kern="1200" cap="none" spc="0" normalizeH="0" baseline="0" noProof="0" dirty="0">
+                <a:ln>
+                  <a:noFill/>
+                </a:ln>
+                <a:effectLst/>
+                <a:uLnTx/>
+                <a:uFillTx/>
+                <a:latin typeface="Calibri"/>
+                <a:ea typeface="Calibri"/>
+                <a:cs typeface="Calibri"/>
+              </a:rPr>
+              <a:t>Executed tests in Linux environments for feature validation and defect verification.</a:t>
+            </a:r>
+          </a:p>
+          <a:p>
+            <a:pPr marL="285750" marR="0" lvl="0" indent="-285750" algn="just" defTabSz="914400" rtl="0" eaLnBrk="1" fontAlgn="base" latinLnBrk="0" hangingPunct="0">
               <a:lnSpc>
                 <a:spcPct val="100000"/>
               </a:lnSpc>
@@ -8016,22 +8032,42 @@
               </a:spcAft>
               <a:buClrTx/>
               <a:buSzTx/>
-              <a:buFontTx/>
-              <a:buNone/>
+              <a:buFont typeface="Arial" panose="020B0604020202020204" pitchFamily="34" charset="0"/>
+              <a:buChar char="•"/>
               <a:tabLst/>
               <a:defRPr/>
             </a:pPr>
-            <a:endParaRPr lang="en-US" sz="1600" dirty="0">
-              <a:solidFill>
-                <a:prstClr val="black"/>
-              </a:solidFill>
-              <a:latin typeface="Calibri" panose="020F0502020204030204" pitchFamily="34" charset="0"/>
-              <a:ea typeface="Calibri" panose="020F0502020204030204" pitchFamily="34" charset="0"/>
-              <a:cs typeface="Calibri" panose="020F0502020204030204" pitchFamily="34" charset="0"/>
-            </a:endParaRPr>
-          </a:p>
-          <a:p>
-            <a:pPr marL="0" marR="0" lvl="0" indent="0" algn="just" defTabSz="914400" rtl="0" eaLnBrk="1" fontAlgn="base" latinLnBrk="0" hangingPunct="0">
+            <a:r>
+              <a:rPr lang="en-US" sz="1500" b="0" i="0" u="none" strike="noStrike" kern="1200" cap="none" spc="0" normalizeH="0" baseline="0" noProof="0" dirty="0" err="1">
+                <a:ln>
+                  <a:noFill/>
+                </a:ln>
+                <a:effectLst/>
+                <a:uLnTx/>
+                <a:uFillTx/>
+                <a:latin typeface="Calibri"/>
+                <a:ea typeface="Calibri"/>
+                <a:cs typeface="Calibri"/>
+              </a:rPr>
+              <a:t>Analysed</a:t>
+            </a:r>
+            <a:r>
+              <a:rPr lang="en-US" sz="1500" b="0" i="0" u="none" strike="noStrike" kern="1200" cap="none" spc="0" normalizeH="0" baseline="0" noProof="0" dirty="0">
+                <a:ln>
+                  <a:noFill/>
+                </a:ln>
+                <a:effectLst/>
+                <a:uLnTx/>
+                <a:uFillTx/>
+                <a:latin typeface="Calibri"/>
+                <a:ea typeface="Calibri"/>
+                <a:cs typeface="Calibri"/>
+              </a:rPr>
+              <a:t> user stories and implemented functionality in alignment with story points.</a:t>
+            </a:r>
+          </a:p>
+          <a:p>
+            <a:pPr marL="285750" marR="0" lvl="0" indent="-285750" algn="just" defTabSz="914400" rtl="0" eaLnBrk="1" fontAlgn="base" latinLnBrk="0" hangingPunct="0">
               <a:lnSpc>
                 <a:spcPct val="100000"/>
               </a:lnSpc>
@@ -8043,22 +8079,56 @@
               </a:spcAft>
               <a:buClrTx/>
               <a:buSzTx/>
-              <a:buFontTx/>
-              <a:buNone/>
+              <a:buFont typeface="Arial" panose="020B0604020202020204" pitchFamily="34" charset="0"/>
+              <a:buChar char="•"/>
               <a:tabLst/>
               <a:defRPr/>
             </a:pPr>
-            <a:endParaRPr lang="en-US" sz="1600" dirty="0">
-              <a:solidFill>
-                <a:prstClr val="black"/>
-              </a:solidFill>
-              <a:latin typeface="Calibri" panose="020F0502020204030204" pitchFamily="34" charset="0"/>
-              <a:ea typeface="Calibri" panose="020F0502020204030204" pitchFamily="34" charset="0"/>
-              <a:cs typeface="Calibri" panose="020F0502020204030204" pitchFamily="34" charset="0"/>
-            </a:endParaRPr>
-          </a:p>
-          <a:p>
-            <a:pPr marL="0" marR="0" lvl="0" indent="0" algn="just" defTabSz="914400" rtl="0" eaLnBrk="1" fontAlgn="base" latinLnBrk="0" hangingPunct="0">
+            <a:r>
+              <a:rPr lang="en-US" sz="1500" b="0" i="0" u="none" strike="noStrike" kern="1200" cap="none" spc="0" normalizeH="0" baseline="0" noProof="0" dirty="0">
+                <a:ln>
+                  <a:noFill/>
+                </a:ln>
+                <a:effectLst/>
+                <a:uLnTx/>
+                <a:uFillTx/>
+                <a:latin typeface="Calibri"/>
+                <a:ea typeface="Calibri"/>
+                <a:cs typeface="Calibri"/>
+              </a:rPr>
+              <a:t>Designed and executed automation scripts using Selenium WebDriver, </a:t>
+            </a:r>
+            <a:r>
+              <a:rPr lang="en-US" sz="1500" b="0" i="0" u="none" strike="noStrike" kern="1200" cap="none" spc="0" normalizeH="0" baseline="0" noProof="0" dirty="0" err="1">
+                <a:ln>
+                  <a:noFill/>
+                </a:ln>
+                <a:effectLst/>
+                <a:uLnTx/>
+                <a:uFillTx/>
+                <a:latin typeface="Calibri"/>
+                <a:ea typeface="Calibri"/>
+                <a:cs typeface="Calibri"/>
+              </a:rPr>
+              <a:t>Pytest</a:t>
+            </a:r>
+            <a:r>
+              <a:rPr lang="en-US" sz="1500" b="0" i="0" u="none" strike="noStrike" kern="1200" cap="none" spc="0" normalizeH="0" baseline="0" noProof="0" dirty="0">
+                <a:ln>
+                  <a:noFill/>
+                </a:ln>
+                <a:effectLst/>
+                <a:uLnTx/>
+                <a:uFillTx/>
+                <a:latin typeface="Calibri"/>
+                <a:ea typeface="Calibri"/>
+                <a:cs typeface="Calibri"/>
+              </a:rPr>
+              <a:t>, and Python, following a Hybrid Framework with Data-Driven and Page Object Model (POM) approaches.</a:t>
+            </a:r>
+          </a:p>
+          <a:p>
+            <a:pPr marL="285750" marR="0" lvl="0" indent="-285750" algn="just" defTabSz="914400" rtl="0" eaLnBrk="1" fontAlgn="base" latinLnBrk="0" hangingPunct="0">
               <a:lnSpc>
                 <a:spcPct val="100000"/>
               </a:lnSpc>
@@ -8070,22 +8140,28 @@
               </a:spcAft>
               <a:buClrTx/>
               <a:buSzTx/>
-              <a:buFontTx/>
-              <a:buNone/>
+              <a:buFont typeface="Arial" panose="020B0604020202020204" pitchFamily="34" charset="0"/>
+              <a:buChar char="•"/>
               <a:tabLst/>
               <a:defRPr/>
             </a:pPr>
-            <a:endParaRPr lang="en-US" sz="1600" dirty="0">
-              <a:solidFill>
-                <a:prstClr val="black"/>
-              </a:solidFill>
-              <a:latin typeface="Calibri" panose="020F0502020204030204" pitchFamily="34" charset="0"/>
-              <a:ea typeface="Calibri" panose="020F0502020204030204" pitchFamily="34" charset="0"/>
-              <a:cs typeface="Calibri" panose="020F0502020204030204" pitchFamily="34" charset="0"/>
-            </a:endParaRPr>
-          </a:p>
-          <a:p>
-            <a:pPr marL="0" marR="0" lvl="0" indent="0" algn="just" defTabSz="914400" rtl="0" eaLnBrk="1" fontAlgn="base" latinLnBrk="0" hangingPunct="0">
+            <a:r>
+              <a:rPr lang="en-US" sz="1500" b="0" i="0" u="none" strike="noStrike" kern="1200" cap="none" spc="0" normalizeH="0" baseline="0" noProof="0" dirty="0">
+                <a:ln>
+                  <a:noFill/>
+                </a:ln>
+                <a:effectLst/>
+                <a:uLnTx/>
+                <a:uFillTx/>
+                <a:latin typeface="Calibri"/>
+                <a:ea typeface="Calibri"/>
+                <a:cs typeface="Calibri"/>
+              </a:rPr>
+              <a:t>Conducted failure analysis for regression test results and prepared detailed reports.</a:t>
+            </a:r>
+          </a:p>
+          <a:p>
+            <a:pPr marL="285750" marR="0" lvl="0" indent="-285750" algn="just" defTabSz="914400" rtl="0" eaLnBrk="1" fontAlgn="base" latinLnBrk="0" hangingPunct="0">
               <a:lnSpc>
                 <a:spcPct val="100000"/>
               </a:lnSpc>
@@ -8097,19 +8173,157 @@
               </a:spcAft>
               <a:buClrTx/>
               <a:buSzTx/>
-              <a:buFontTx/>
-              <a:buNone/>
+              <a:buFont typeface="Arial" panose="020B0604020202020204" pitchFamily="34" charset="0"/>
+              <a:buChar char="•"/>
               <a:tabLst/>
               <a:defRPr/>
             </a:pPr>
-            <a:endParaRPr lang="en-US" sz="1600" dirty="0">
-              <a:solidFill>
-                <a:prstClr val="black"/>
-              </a:solidFill>
-              <a:latin typeface="Calibri" panose="020F0502020204030204" pitchFamily="34" charset="0"/>
-              <a:ea typeface="Calibri" panose="020F0502020204030204" pitchFamily="34" charset="0"/>
-              <a:cs typeface="Calibri" panose="020F0502020204030204" pitchFamily="34" charset="0"/>
-            </a:endParaRPr>
+            <a:r>
+              <a:rPr lang="en-US" sz="1500" b="0" i="0" u="none" strike="noStrike" kern="1200" cap="none" spc="0" normalizeH="0" baseline="0" noProof="0" dirty="0">
+                <a:ln>
+                  <a:noFill/>
+                </a:ln>
+                <a:effectLst/>
+                <a:uLnTx/>
+                <a:uFillTx/>
+                <a:latin typeface="Calibri"/>
+                <a:ea typeface="Calibri"/>
+                <a:cs typeface="Calibri"/>
+              </a:rPr>
+              <a:t>Reported, tracked, and verified defects in JIRA, coordinating closely with the development team.</a:t>
+            </a:r>
+          </a:p>
+          <a:p>
+            <a:pPr marL="285750" marR="0" lvl="0" indent="-285750" algn="just" defTabSz="914400" rtl="0" eaLnBrk="1" fontAlgn="base" latinLnBrk="0" hangingPunct="0">
+              <a:lnSpc>
+                <a:spcPct val="100000"/>
+              </a:lnSpc>
+              <a:spcBef>
+                <a:spcPts val="0"/>
+              </a:spcBef>
+              <a:spcAft>
+                <a:spcPts val="0"/>
+              </a:spcAft>
+              <a:buClrTx/>
+              <a:buSzTx/>
+              <a:buFont typeface="Arial" panose="020B0604020202020204" pitchFamily="34" charset="0"/>
+              <a:buChar char="•"/>
+              <a:tabLst/>
+              <a:defRPr/>
+            </a:pPr>
+            <a:r>
+              <a:rPr lang="en-US" sz="1500" b="0" i="0" u="none" strike="noStrike" kern="1200" cap="none" spc="0" normalizeH="0" baseline="0" noProof="0" dirty="0">
+                <a:ln>
+                  <a:noFill/>
+                </a:ln>
+                <a:effectLst/>
+                <a:uLnTx/>
+                <a:uFillTx/>
+                <a:latin typeface="Calibri"/>
+                <a:ea typeface="Calibri"/>
+                <a:cs typeface="Calibri"/>
+              </a:rPr>
+              <a:t>Executed batch test runs in Jenkins and communicated results to management.</a:t>
+            </a:r>
+          </a:p>
+          <a:p>
+            <a:pPr marL="285750" marR="0" lvl="0" indent="-285750" algn="just" defTabSz="914400" rtl="0" eaLnBrk="1" fontAlgn="base" latinLnBrk="0" hangingPunct="0">
+              <a:lnSpc>
+                <a:spcPct val="100000"/>
+              </a:lnSpc>
+              <a:spcBef>
+                <a:spcPts val="0"/>
+              </a:spcBef>
+              <a:spcAft>
+                <a:spcPts val="0"/>
+              </a:spcAft>
+              <a:buClrTx/>
+              <a:buSzTx/>
+              <a:buFont typeface="Arial" panose="020B0604020202020204" pitchFamily="34" charset="0"/>
+              <a:buChar char="•"/>
+              <a:tabLst/>
+              <a:defRPr/>
+            </a:pPr>
+            <a:r>
+              <a:rPr lang="en-US" sz="1500" b="0" i="0" u="none" strike="noStrike" kern="1200" cap="none" spc="0" normalizeH="0" baseline="0" noProof="0" dirty="0">
+                <a:ln>
+                  <a:noFill/>
+                </a:ln>
+                <a:effectLst/>
+                <a:uLnTx/>
+                <a:uFillTx/>
+                <a:latin typeface="Calibri"/>
+                <a:ea typeface="Calibri"/>
+                <a:cs typeface="Calibri"/>
+              </a:rPr>
+              <a:t>Collaborated with developers and stakeholders to clarify requirements for testability, consistency, and completeness.</a:t>
+            </a:r>
+          </a:p>
+          <a:p>
+            <a:pPr marL="285750" marR="0" lvl="0" indent="-285750" algn="just" defTabSz="914400" rtl="0" eaLnBrk="1" fontAlgn="base" latinLnBrk="0" hangingPunct="0">
+              <a:lnSpc>
+                <a:spcPct val="100000"/>
+              </a:lnSpc>
+              <a:spcBef>
+                <a:spcPts val="0"/>
+              </a:spcBef>
+              <a:spcAft>
+                <a:spcPts val="0"/>
+              </a:spcAft>
+              <a:buClrTx/>
+              <a:buSzTx/>
+              <a:buFont typeface="Arial" panose="020B0604020202020204" pitchFamily="34" charset="0"/>
+              <a:buChar char="•"/>
+              <a:tabLst/>
+              <a:defRPr/>
+            </a:pPr>
+            <a:r>
+              <a:rPr lang="en-US" sz="1500" b="0" i="0" u="none" strike="noStrike" kern="1200" cap="none" spc="0" normalizeH="0" baseline="0" noProof="0" dirty="0">
+                <a:ln>
+                  <a:noFill/>
+                </a:ln>
+                <a:effectLst/>
+                <a:uLnTx/>
+                <a:uFillTx/>
+                <a:latin typeface="Calibri"/>
+                <a:ea typeface="Calibri"/>
+                <a:cs typeface="Calibri"/>
+              </a:rPr>
+              <a:t>Actively participated in Agile ceremonies including daily stand-up’s, story grooming,</a:t>
+            </a:r>
+          </a:p>
+          <a:p>
+            <a:pPr marL="285750" marR="0" lvl="0" indent="-285750" algn="just" defTabSz="914400" rtl="0" eaLnBrk="1" fontAlgn="base" latinLnBrk="0" hangingPunct="0">
+              <a:lnSpc>
+                <a:spcPct val="100000"/>
+              </a:lnSpc>
+              <a:spcBef>
+                <a:spcPts val="0"/>
+              </a:spcBef>
+              <a:spcAft>
+                <a:spcPts val="0"/>
+              </a:spcAft>
+              <a:buClrTx/>
+              <a:buSzTx/>
+              <a:buFont typeface="Arial" panose="020B0604020202020204" pitchFamily="34" charset="0"/>
+              <a:buChar char="•"/>
+              <a:tabLst/>
+              <a:defRPr/>
+            </a:pPr>
+            <a:r>
+              <a:rPr lang="en-US" sz="1500" b="0" i="0" u="none" strike="noStrike" kern="1200" cap="none" spc="0" normalizeH="0" baseline="0" noProof="0" dirty="0">
+                <a:ln>
+                  <a:noFill/>
+                </a:ln>
+                <a:effectLst/>
+                <a:uLnTx/>
+                <a:uFillTx/>
+                <a:latin typeface="Calibri"/>
+                <a:ea typeface="Calibri"/>
+                <a:cs typeface="Calibri"/>
+              </a:rPr>
+              <a:t>retrospectives, and process improvement initiatives.</a:t>
+            </a:r>
           </a:p>
         </p:txBody>
       </p:sp>
@@ -8118,7 +8332,7 @@
           <p:cNvPr id="12" name="TextBox 11">
             <a:extLst>
               <a:ext uri="{FF2B5EF4-FFF2-40B4-BE49-F238E27FC236}">
-                <a16:creationId xmlns:a16="http://schemas.microsoft.com/office/drawing/2014/main" id="{EC4B05AF-5824-1070-33D3-B60F3671B346}"/>
+                <a16:creationId xmlns:a16="http://schemas.microsoft.com/office/drawing/2014/main" id="{19720054-5A3B-212F-B9D3-BD19B3C4FC12}"/>
               </a:ext>
             </a:extLst>
           </p:cNvPr>
@@ -8127,8 +8341,8 @@
         </p:nvSpPr>
         <p:spPr>
           <a:xfrm>
-            <a:off x="304800" y="1712950"/>
-            <a:ext cx="1470274" cy="369332"/>
+            <a:off x="304800" y="1588014"/>
+            <a:ext cx="1216167" cy="338554"/>
           </a:xfrm>
           <a:prstGeom prst="rect">
             <a:avLst/>
@@ -8159,15 +8373,7 @@
               <a:defRPr/>
             </a:pPr>
             <a:r>
-              <a:rPr lang="en-US" b="1" dirty="0"/>
-              <a:t>D</a:t>
-            </a:r>
-            <a:r>
-              <a:rPr lang="en-IN" b="1" dirty="0"/>
-              <a:t>escription</a:t>
-            </a:r>
-            <a:r>
-              <a:rPr kumimoji="0" lang="en-IN" sz="1600" b="1" i="0" u="none" strike="noStrike" kern="1200" cap="none" spc="0" normalizeH="0" baseline="0" noProof="0" dirty="0">
+              <a:rPr kumimoji="0" lang="en-US" sz="1600" b="1" i="0" u="none" strike="noStrike" kern="1200" cap="none" spc="0" normalizeH="0" baseline="0" noProof="0" dirty="0">
                 <a:ln>
                   <a:noFill/>
                 </a:ln>
@@ -8181,7 +8387,24 @@
                 <a:ea typeface="Calibri"/>
                 <a:cs typeface="Calibri"/>
               </a:rPr>
-              <a:t>:</a:t>
+              <a:t>D</a:t>
+            </a:r>
+            <a:r>
+              <a:rPr kumimoji="0" lang="en-IN" sz="1600" b="1" i="0" u="none" strike="noStrike" kern="1200" cap="none" spc="0" normalizeH="0" baseline="0" noProof="0" dirty="0">
+                <a:ln>
+                  <a:noFill/>
+                </a:ln>
+                <a:solidFill>
+                  <a:srgbClr val="002060"/>
+                </a:solidFill>
+                <a:effectLst/>
+                <a:uLnTx/>
+                <a:uFillTx/>
+                <a:latin typeface="Calibri"/>
+                <a:ea typeface="Calibri"/>
+                <a:cs typeface="Calibri"/>
+              </a:rPr>
+              <a:t>escription:</a:t>
             </a:r>
           </a:p>
         </p:txBody>
@@ -8191,7 +8414,7 @@
           <p:cNvPr id="14" name="TextBox 13">
             <a:extLst>
               <a:ext uri="{FF2B5EF4-FFF2-40B4-BE49-F238E27FC236}">
-                <a16:creationId xmlns:a16="http://schemas.microsoft.com/office/drawing/2014/main" id="{E089050A-F255-FD90-6361-53F439F04326}"/>
+                <a16:creationId xmlns:a16="http://schemas.microsoft.com/office/drawing/2014/main" id="{CB36D734-3700-F0BC-46F5-7626E61D151F}"/>
               </a:ext>
             </a:extLst>
           </p:cNvPr>
@@ -8209,7 +8432,7 @@
           <a:noFill/>
         </p:spPr>
         <p:txBody>
-          <a:bodyPr wrap="square">
+          <a:bodyPr wrap="square" lIns="91440" tIns="45720" rIns="91440" bIns="45720" anchor="t">
             <a:spAutoFit/>
           </a:bodyPr>
           <a:lstStyle/>
@@ -8232,7 +8455,7 @@
               <a:defRPr/>
             </a:pPr>
             <a:r>
-              <a:rPr kumimoji="0" lang="en-US" b="1" i="0" u="none" strike="noStrike" kern="1200" cap="none" spc="0" normalizeH="0" baseline="0" noProof="0" dirty="0">
+              <a:rPr kumimoji="0" lang="en-US" b="1" i="0" u="none" strike="noStrike" kern="1200" cap="none" spc="0" normalizeH="0" baseline="0" noProof="0">
                 <a:ln>
                   <a:noFill/>
                 </a:ln>
@@ -8246,9 +8469,20 @@
                 <a:ea typeface="Calibri"/>
                 <a:cs typeface="Calibri"/>
               </a:rPr>
-              <a:t>Project 4</a:t>
-            </a:r>
-            <a:endParaRPr kumimoji="0" lang="en-US" b="0" i="0" u="none" strike="noStrike" kern="1200" cap="none" spc="0" normalizeH="0" baseline="0" noProof="0" dirty="0">
+              <a:t>Project </a:t>
+            </a:r>
+            <a:r>
+              <a:rPr lang="en-US" b="1">
+                <a:solidFill>
+                  <a:srgbClr val="002060"/>
+                </a:solidFill>
+                <a:latin typeface="Calibri"/>
+                <a:ea typeface="Calibri"/>
+                <a:cs typeface="Calibri"/>
+              </a:rPr>
+              <a:t>4</a:t>
+            </a:r>
+            <a:endParaRPr kumimoji="0" lang="en-US" b="0" i="0" u="none" strike="noStrike" kern="1200" cap="none" spc="0" normalizeH="0" baseline="0" noProof="0">
               <a:ln>
                 <a:noFill/>
               </a:ln>
@@ -8267,10 +8501,10 @@
       </p:sp>
       <p:pic>
         <p:nvPicPr>
-          <p:cNvPr id="3" name="Picture 2">
-            <a:extLst>
-              <a:ext uri="{FF2B5EF4-FFF2-40B4-BE49-F238E27FC236}">
-                <a16:creationId xmlns:a16="http://schemas.microsoft.com/office/drawing/2014/main" id="{6DF6DC0A-A01D-A51B-4BE2-9C419BBD790F}"/>
+          <p:cNvPr id="10" name="Picture 9">
+            <a:extLst>
+              <a:ext uri="{FF2B5EF4-FFF2-40B4-BE49-F238E27FC236}">
+                <a16:creationId xmlns:a16="http://schemas.microsoft.com/office/drawing/2014/main" id="{75977308-28D1-4B39-8C9C-977D2A6A28DD}"/>
               </a:ext>
             </a:extLst>
           </p:cNvPr>
@@ -8289,7 +8523,7 @@
         </p:blipFill>
         <p:spPr>
           <a:xfrm>
-            <a:off x="9993086" y="75293"/>
+            <a:off x="9973070" y="136525"/>
             <a:ext cx="2066530" cy="587639"/>
           </a:xfrm>
           <a:prstGeom prst="rect">
@@ -8303,7 +8537,7 @@
     </p:spTree>
     <p:extLst>
       <p:ext uri="{BB962C8B-B14F-4D97-AF65-F5344CB8AC3E}">
-        <p14:creationId xmlns:p14="http://schemas.microsoft.com/office/powerpoint/2010/main" val="119268449"/>
+        <p14:creationId xmlns:p14="http://schemas.microsoft.com/office/powerpoint/2010/main" val="88817511"/>
       </p:ext>
     </p:extLst>
   </p:cSld>

</xml_diff>

<commit_message>
integrate PPT changes - new template, structured key_projects
</commit_message>
<xml_diff>
--- a/templates/sample_ppt_template.pptx
+++ b/templates/sample_ppt_template.pptx
@@ -119,12 +119,20 @@
 </p:presentation>
 </file>
 
+<file path=ppt/revisionInfo.xml><?xml version="1.0" encoding="utf-8"?>
+<p1510:revInfo xmlns:a="http://schemas.openxmlformats.org/drawingml/2006/main" xmlns:r="http://schemas.openxmlformats.org/officeDocument/2006/relationships" xmlns:p1510="http://schemas.microsoft.com/office/powerpoint/2015/10/main">
+  <p1510:revLst>
+    <p1510:client id="{1C41BA2A-72C2-47F5-9097-D329EF710635}" v="14" dt="2026-03-16T11:17:40.628"/>
+  </p1510:revLst>
+</p1510:revInfo>
+</file>
+
 <file path=ppt/changesInfos/changesInfo1.xml><?xml version="1.0" encoding="utf-8"?>
 <pc:chgInfo xmlns:a="http://schemas.openxmlformats.org/drawingml/2006/main" xmlns:r="http://schemas.openxmlformats.org/officeDocument/2006/relationships" xmlns:ac="http://schemas.microsoft.com/office/drawing/2013/main/command" xmlns:pc="http://schemas.microsoft.com/office/powerpoint/2013/main/command">
   <pc:docChgLst>
     <pc:chgData name="jennis rufina" userId="82f03a850a9f00a2" providerId="LiveId" clId="{FAA1ECB5-B8B8-4660-8381-16C5214360E0}"/>
     <pc:docChg chg="modSld">
-      <pc:chgData name="jennis rufina" userId="82f03a850a9f00a2" providerId="LiveId" clId="{FAA1ECB5-B8B8-4660-8381-16C5214360E0}" dt="2026-03-10T10:44:36.489" v="284" actId="20577"/>
+      <pc:chgData name="jennis rufina" userId="82f03a850a9f00a2" providerId="LiveId" clId="{FAA1ECB5-B8B8-4660-8381-16C5214360E0}" dt="2026-03-16T11:17:40.628" v="577"/>
       <pc:docMkLst>
         <pc:docMk/>
       </pc:docMkLst>
@@ -152,13 +160,13 @@
         </pc:spChg>
       </pc:sldChg>
       <pc:sldChg chg="modSp mod">
-        <pc:chgData name="jennis rufina" userId="82f03a850a9f00a2" providerId="LiveId" clId="{FAA1ECB5-B8B8-4660-8381-16C5214360E0}" dt="2026-02-25T08:07:54.699" v="42" actId="20577"/>
+        <pc:chgData name="jennis rufina" userId="82f03a850a9f00a2" providerId="LiveId" clId="{FAA1ECB5-B8B8-4660-8381-16C5214360E0}" dt="2026-03-16T11:15:38.300" v="441" actId="14100"/>
         <pc:sldMkLst>
           <pc:docMk/>
           <pc:sldMk cId="4121649048" sldId="270"/>
         </pc:sldMkLst>
         <pc:spChg chg="mod">
-          <ac:chgData name="jennis rufina" userId="82f03a850a9f00a2" providerId="LiveId" clId="{FAA1ECB5-B8B8-4660-8381-16C5214360E0}" dt="2026-02-25T08:07:39.331" v="32" actId="20577"/>
+          <ac:chgData name="jennis rufina" userId="82f03a850a9f00a2" providerId="LiveId" clId="{FAA1ECB5-B8B8-4660-8381-16C5214360E0}" dt="2026-03-16T11:14:52.868" v="386"/>
           <ac:spMkLst>
             <pc:docMk/>
             <pc:sldMk cId="4121649048" sldId="270"/>
@@ -166,7 +174,7 @@
           </ac:spMkLst>
         </pc:spChg>
         <pc:spChg chg="mod">
-          <ac:chgData name="jennis rufina" userId="82f03a850a9f00a2" providerId="LiveId" clId="{FAA1ECB5-B8B8-4660-8381-16C5214360E0}" dt="2026-02-25T08:07:54.699" v="42" actId="20577"/>
+          <ac:chgData name="jennis rufina" userId="82f03a850a9f00a2" providerId="LiveId" clId="{FAA1ECB5-B8B8-4660-8381-16C5214360E0}" dt="2026-03-16T11:15:38.300" v="441" actId="14100"/>
           <ac:spMkLst>
             <pc:docMk/>
             <pc:sldMk cId="4121649048" sldId="270"/>
@@ -175,13 +183,13 @@
         </pc:spChg>
       </pc:sldChg>
       <pc:sldChg chg="modSp mod">
-        <pc:chgData name="jennis rufina" userId="82f03a850a9f00a2" providerId="LiveId" clId="{FAA1ECB5-B8B8-4660-8381-16C5214360E0}" dt="2026-03-10T10:44:36.489" v="284" actId="20577"/>
+        <pc:chgData name="jennis rufina" userId="82f03a850a9f00a2" providerId="LiveId" clId="{FAA1ECB5-B8B8-4660-8381-16C5214360E0}" dt="2026-03-16T11:16:24.248" v="495"/>
         <pc:sldMkLst>
           <pc:docMk/>
           <pc:sldMk cId="2821146086" sldId="281"/>
         </pc:sldMkLst>
         <pc:spChg chg="mod">
-          <ac:chgData name="jennis rufina" userId="82f03a850a9f00a2" providerId="LiveId" clId="{FAA1ECB5-B8B8-4660-8381-16C5214360E0}" dt="2026-03-10T10:44:36.489" v="284" actId="20577"/>
+          <ac:chgData name="jennis rufina" userId="82f03a850a9f00a2" providerId="LiveId" clId="{FAA1ECB5-B8B8-4660-8381-16C5214360E0}" dt="2026-03-16T11:15:55.620" v="443"/>
           <ac:spMkLst>
             <pc:docMk/>
             <pc:sldMk cId="2821146086" sldId="281"/>
@@ -189,7 +197,7 @@
           </ac:spMkLst>
         </pc:spChg>
         <pc:spChg chg="mod">
-          <ac:chgData name="jennis rufina" userId="82f03a850a9f00a2" providerId="LiveId" clId="{FAA1ECB5-B8B8-4660-8381-16C5214360E0}" dt="2026-02-25T08:08:28.423" v="73" actId="20577"/>
+          <ac:chgData name="jennis rufina" userId="82f03a850a9f00a2" providerId="LiveId" clId="{FAA1ECB5-B8B8-4660-8381-16C5214360E0}" dt="2026-03-16T11:16:24.248" v="495"/>
           <ac:spMkLst>
             <pc:docMk/>
             <pc:sldMk cId="2821146086" sldId="281"/>
@@ -198,13 +206,13 @@
         </pc:spChg>
       </pc:sldChg>
       <pc:sldChg chg="modSp mod">
-        <pc:chgData name="jennis rufina" userId="82f03a850a9f00a2" providerId="LiveId" clId="{FAA1ECB5-B8B8-4660-8381-16C5214360E0}" dt="2026-02-25T08:09:04.057" v="104" actId="20577"/>
+        <pc:chgData name="jennis rufina" userId="82f03a850a9f00a2" providerId="LiveId" clId="{FAA1ECB5-B8B8-4660-8381-16C5214360E0}" dt="2026-03-16T11:17:05.311" v="523"/>
         <pc:sldMkLst>
           <pc:docMk/>
           <pc:sldMk cId="2262051643" sldId="282"/>
         </pc:sldMkLst>
         <pc:spChg chg="mod">
-          <ac:chgData name="jennis rufina" userId="82f03a850a9f00a2" providerId="LiveId" clId="{FAA1ECB5-B8B8-4660-8381-16C5214360E0}" dt="2026-02-25T08:08:51.255" v="94" actId="20577"/>
+          <ac:chgData name="jennis rufina" userId="82f03a850a9f00a2" providerId="LiveId" clId="{FAA1ECB5-B8B8-4660-8381-16C5214360E0}" dt="2026-03-16T11:16:45.857" v="497"/>
           <ac:spMkLst>
             <pc:docMk/>
             <pc:sldMk cId="2262051643" sldId="282"/>
@@ -212,7 +220,7 @@
           </ac:spMkLst>
         </pc:spChg>
         <pc:spChg chg="mod">
-          <ac:chgData name="jennis rufina" userId="82f03a850a9f00a2" providerId="LiveId" clId="{FAA1ECB5-B8B8-4660-8381-16C5214360E0}" dt="2026-02-25T08:09:04.057" v="104" actId="20577"/>
+          <ac:chgData name="jennis rufina" userId="82f03a850a9f00a2" providerId="LiveId" clId="{FAA1ECB5-B8B8-4660-8381-16C5214360E0}" dt="2026-03-16T11:17:05.311" v="523"/>
           <ac:spMkLst>
             <pc:docMk/>
             <pc:sldMk cId="2262051643" sldId="282"/>
@@ -221,13 +229,13 @@
         </pc:spChg>
       </pc:sldChg>
       <pc:sldChg chg="modSp mod">
-        <pc:chgData name="jennis rufina" userId="82f03a850a9f00a2" providerId="LiveId" clId="{FAA1ECB5-B8B8-4660-8381-16C5214360E0}" dt="2026-03-03T14:13:17.818" v="203" actId="20577"/>
+        <pc:chgData name="jennis rufina" userId="82f03a850a9f00a2" providerId="LiveId" clId="{FAA1ECB5-B8B8-4660-8381-16C5214360E0}" dt="2026-03-16T11:17:40.628" v="577"/>
         <pc:sldMkLst>
           <pc:docMk/>
           <pc:sldMk cId="119268449" sldId="283"/>
         </pc:sldMkLst>
         <pc:spChg chg="mod">
-          <ac:chgData name="jennis rufina" userId="82f03a850a9f00a2" providerId="LiveId" clId="{FAA1ECB5-B8B8-4660-8381-16C5214360E0}" dt="2026-03-03T14:13:17.818" v="203" actId="20577"/>
+          <ac:chgData name="jennis rufina" userId="82f03a850a9f00a2" providerId="LiveId" clId="{FAA1ECB5-B8B8-4660-8381-16C5214360E0}" dt="2026-03-16T11:17:16.381" v="525"/>
           <ac:spMkLst>
             <pc:docMk/>
             <pc:sldMk cId="119268449" sldId="283"/>
@@ -235,7 +243,7 @@
           </ac:spMkLst>
         </pc:spChg>
         <pc:spChg chg="mod">
-          <ac:chgData name="jennis rufina" userId="82f03a850a9f00a2" providerId="LiveId" clId="{FAA1ECB5-B8B8-4660-8381-16C5214360E0}" dt="2026-02-25T08:09:51.622" v="137" actId="20577"/>
+          <ac:chgData name="jennis rufina" userId="82f03a850a9f00a2" providerId="LiveId" clId="{FAA1ECB5-B8B8-4660-8381-16C5214360E0}" dt="2026-03-16T11:17:40.628" v="577"/>
           <ac:spMkLst>
             <pc:docMk/>
             <pc:sldMk cId="119268449" sldId="283"/>
@@ -330,7 +338,7 @@
           <a:p>
             <a:fld id="{E40DDB01-B6F6-4D19-B7EB-82B79169DABA}" type="datetimeFigureOut">
               <a:rPr lang="en-IN" smtClean="0"/>
-              <a:t>10-03-2026</a:t>
+              <a:t>16-03-2026</a:t>
             </a:fld>
             <a:endParaRPr lang="en-IN"/>
           </a:p>
@@ -747,7 +755,7 @@
           <a:p>
             <a:fld id="{C456AD15-A154-4F8D-9983-D4D8643F4F81}" type="datetimeFigureOut">
               <a:rPr lang="en-IN" smtClean="0"/>
-              <a:t>10-03-2026</a:t>
+              <a:t>16-03-2026</a:t>
             </a:fld>
             <a:endParaRPr lang="en-IN"/>
           </a:p>
@@ -947,7 +955,7 @@
           <a:p>
             <a:fld id="{C456AD15-A154-4F8D-9983-D4D8643F4F81}" type="datetimeFigureOut">
               <a:rPr lang="en-IN" smtClean="0"/>
-              <a:t>10-03-2026</a:t>
+              <a:t>16-03-2026</a:t>
             </a:fld>
             <a:endParaRPr lang="en-IN"/>
           </a:p>
@@ -1157,7 +1165,7 @@
           <a:p>
             <a:fld id="{C456AD15-A154-4F8D-9983-D4D8643F4F81}" type="datetimeFigureOut">
               <a:rPr lang="en-IN" smtClean="0"/>
-              <a:t>10-03-2026</a:t>
+              <a:t>16-03-2026</a:t>
             </a:fld>
             <a:endParaRPr lang="en-IN"/>
           </a:p>
@@ -1357,7 +1365,7 @@
           <a:p>
             <a:fld id="{C456AD15-A154-4F8D-9983-D4D8643F4F81}" type="datetimeFigureOut">
               <a:rPr lang="en-IN" smtClean="0"/>
-              <a:t>10-03-2026</a:t>
+              <a:t>16-03-2026</a:t>
             </a:fld>
             <a:endParaRPr lang="en-IN"/>
           </a:p>
@@ -1633,7 +1641,7 @@
           <a:p>
             <a:fld id="{C456AD15-A154-4F8D-9983-D4D8643F4F81}" type="datetimeFigureOut">
               <a:rPr lang="en-IN" smtClean="0"/>
-              <a:t>10-03-2026</a:t>
+              <a:t>16-03-2026</a:t>
             </a:fld>
             <a:endParaRPr lang="en-IN"/>
           </a:p>
@@ -1901,7 +1909,7 @@
           <a:p>
             <a:fld id="{C456AD15-A154-4F8D-9983-D4D8643F4F81}" type="datetimeFigureOut">
               <a:rPr lang="en-IN" smtClean="0"/>
-              <a:t>10-03-2026</a:t>
+              <a:t>16-03-2026</a:t>
             </a:fld>
             <a:endParaRPr lang="en-IN"/>
           </a:p>
@@ -2316,7 +2324,7 @@
           <a:p>
             <a:fld id="{C456AD15-A154-4F8D-9983-D4D8643F4F81}" type="datetimeFigureOut">
               <a:rPr lang="en-IN" smtClean="0"/>
-              <a:t>10-03-2026</a:t>
+              <a:t>16-03-2026</a:t>
             </a:fld>
             <a:endParaRPr lang="en-IN"/>
           </a:p>
@@ -2458,7 +2466,7 @@
           <a:p>
             <a:fld id="{C456AD15-A154-4F8D-9983-D4D8643F4F81}" type="datetimeFigureOut">
               <a:rPr lang="en-IN" smtClean="0"/>
-              <a:t>10-03-2026</a:t>
+              <a:t>16-03-2026</a:t>
             </a:fld>
             <a:endParaRPr lang="en-IN"/>
           </a:p>
@@ -2571,7 +2579,7 @@
           <a:p>
             <a:fld id="{C456AD15-A154-4F8D-9983-D4D8643F4F81}" type="datetimeFigureOut">
               <a:rPr lang="en-IN" smtClean="0"/>
-              <a:t>10-03-2026</a:t>
+              <a:t>16-03-2026</a:t>
             </a:fld>
             <a:endParaRPr lang="en-IN"/>
           </a:p>
@@ -2884,7 +2892,7 @@
           <a:p>
             <a:fld id="{C456AD15-A154-4F8D-9983-D4D8643F4F81}" type="datetimeFigureOut">
               <a:rPr lang="en-IN" smtClean="0"/>
-              <a:t>10-03-2026</a:t>
+              <a:t>16-03-2026</a:t>
             </a:fld>
             <a:endParaRPr lang="en-IN"/>
           </a:p>
@@ -3173,7 +3181,7 @@
           <a:p>
             <a:fld id="{C456AD15-A154-4F8D-9983-D4D8643F4F81}" type="datetimeFigureOut">
               <a:rPr lang="en-IN" smtClean="0"/>
-              <a:t>10-03-2026</a:t>
+              <a:t>16-03-2026</a:t>
             </a:fld>
             <a:endParaRPr lang="en-IN"/>
           </a:p>
@@ -3416,7 +3424,7 @@
           <a:p>
             <a:fld id="{C456AD15-A154-4F8D-9983-D4D8643F4F81}" type="datetimeFigureOut">
               <a:rPr lang="en-IN" smtClean="0"/>
-              <a:t>10-03-2026</a:t>
+              <a:t>16-03-2026</a:t>
             </a:fld>
             <a:endParaRPr lang="en-IN"/>
           </a:p>
@@ -4895,32 +4903,8 @@
               <a:defRPr/>
             </a:pPr>
             <a:r>
-              <a:rPr kumimoji="0" lang="en-US" b="1" i="0" u="none" strike="noStrike" kern="1200" cap="none" spc="0" normalizeH="0" baseline="0" noProof="0" dirty="0">
-                <a:ln>
-                  <a:noFill/>
-                </a:ln>
-                <a:solidFill>
-                  <a:prstClr val="black"/>
-                </a:solidFill>
-                <a:effectLst/>
-                <a:uLnTx/>
-                <a:uFillTx/>
-                <a:latin typeface="Calibri"/>
-                <a:ea typeface="Calibri"/>
-                <a:cs typeface="Calibri"/>
-              </a:rPr>
-              <a:t>Project: {PROJECT1_NAME}</a:t>
-            </a:r>
-            <a:r>
-              <a:rPr lang="en-US" b="1" dirty="0">
-                <a:solidFill>
-                  <a:prstClr val="black"/>
-                </a:solidFill>
-                <a:latin typeface="Calibri"/>
-                <a:ea typeface="Calibri"/>
-                <a:cs typeface="Calibri"/>
-              </a:rPr>
-              <a:t>.</a:t>
+              <a:rPr lang="en-IN" dirty="0"/>
+              <a:t>Project Name: {PROJECT1_NAME}</a:t>
             </a:r>
             <a:endParaRPr lang="en-US" b="1" i="0" u="none" strike="noStrike" kern="1200" cap="none" spc="0" normalizeH="0" baseline="0" noProof="0" dirty="0">
               <a:ln>
@@ -4942,21 +4926,8 @@
               <a:defRPr/>
             </a:pPr>
             <a:r>
-              <a:rPr kumimoji="0" lang="en-US" b="1" i="0" u="none" strike="noStrike" kern="1200" cap="none" spc="0" normalizeH="0" baseline="0" noProof="0" dirty="0">
-                <a:ln>
-                  <a:noFill/>
-                </a:ln>
-                <a:solidFill>
-                  <a:prstClr val="black"/>
-                </a:solidFill>
-                <a:effectLst/>
-                <a:uLnTx/>
-                <a:uFillTx/>
-                <a:latin typeface="Calibri"/>
-                <a:ea typeface="Calibri"/>
-                <a:cs typeface="Calibri"/>
-              </a:rPr>
-              <a:t>Duration : {DURATION_PROJECT1}</a:t>
+              <a:rPr lang="en-IN" dirty="0"/>
+              <a:t>Duration: {PROJECT1_DURATION}</a:t>
             </a:r>
             <a:endParaRPr lang="en-US" b="1" dirty="0">
               <a:solidFill>
@@ -4972,12 +4943,8 @@
               <a:defRPr/>
             </a:pPr>
             <a:r>
-              <a:rPr lang="en-US" b="1" dirty="0"/>
-              <a:t>Role</a:t>
-            </a:r>
-            <a:r>
-              <a:rPr lang="en-US" dirty="0"/>
-              <a:t>: {ROLE_PROJECT1}</a:t>
+              <a:rPr lang="en-IN" dirty="0"/>
+              <a:t>Role: {PROJECT1_ROLE}</a:t>
             </a:r>
             <a:endParaRPr lang="en-US" b="1" i="0" u="none" strike="noStrike" kern="1200" cap="none" spc="0" normalizeH="0" baseline="0" noProof="0" dirty="0">
               <a:ln>
@@ -5010,8 +4977,8 @@
         </p:nvSpPr>
         <p:spPr>
           <a:xfrm>
-            <a:off x="304800" y="2132178"/>
-            <a:ext cx="11691257" cy="4524315"/>
+            <a:off x="304801" y="2258393"/>
+            <a:ext cx="11754816" cy="3293209"/>
           </a:xfrm>
           <a:prstGeom prst="rect">
             <a:avLst/>
@@ -5028,40 +4995,9 @@
               <a:defRPr/>
             </a:pPr>
             <a:r>
-              <a:rPr lang="en-US" sz="1600" i="0" u="none" strike="noStrike" kern="1200" cap="none" spc="0" normalizeH="0" baseline="0" noProof="0" dirty="0">
-                <a:ln>
-                  <a:noFill/>
-                </a:ln>
-                <a:solidFill>
-                  <a:prstClr val="black"/>
-                </a:solidFill>
-                <a:effectLst/>
-                <a:uLnTx/>
-                <a:uFillTx/>
-                <a:latin typeface="Calibri"/>
-                <a:ea typeface="Calibri"/>
-                <a:cs typeface="Calibri"/>
-              </a:rPr>
-              <a:t>{Project1_Description}:</a:t>
-            </a:r>
-          </a:p>
-          <a:p>
-            <a:pPr algn="just" fontAlgn="base" hangingPunct="0">
-              <a:defRPr/>
-            </a:pPr>
-            <a:endParaRPr lang="en-US" sz="1600" dirty="0">
-              <a:solidFill>
-                <a:prstClr val="black"/>
-              </a:solidFill>
-              <a:latin typeface="Calibri"/>
-              <a:ea typeface="Calibri"/>
-              <a:cs typeface="Calibri"/>
-            </a:endParaRPr>
-          </a:p>
-          <a:p>
-            <a:pPr algn="just" fontAlgn="base" hangingPunct="0">
-              <a:defRPr/>
-            </a:pPr>
+              <a:rPr lang="en-IN" sz="1600" dirty="0"/>
+              <a:t>{PROJECT1_DESCRIPTION}</a:t>
+            </a:r>
             <a:endParaRPr lang="en-US" sz="1600" i="0" u="none" strike="noStrike" kern="1200" cap="none" spc="0" normalizeH="0" baseline="0" noProof="0" dirty="0">
               <a:ln>
                 <a:noFill/>
@@ -5104,51 +5040,6 @@
               <a:effectLst/>
               <a:uLnTx/>
               <a:uFillTx/>
-              <a:latin typeface="Calibri"/>
-              <a:ea typeface="Calibri"/>
-              <a:cs typeface="Calibri"/>
-            </a:endParaRPr>
-          </a:p>
-          <a:p>
-            <a:pPr algn="just" fontAlgn="base" hangingPunct="0">
-              <a:defRPr/>
-            </a:pPr>
-            <a:endParaRPr lang="en-US" sz="1600" dirty="0">
-              <a:solidFill>
-                <a:prstClr val="black"/>
-              </a:solidFill>
-              <a:latin typeface="Calibri"/>
-              <a:ea typeface="Calibri"/>
-              <a:cs typeface="Calibri"/>
-            </a:endParaRPr>
-          </a:p>
-          <a:p>
-            <a:pPr algn="just" fontAlgn="base" hangingPunct="0">
-              <a:defRPr/>
-            </a:pPr>
-            <a:endParaRPr lang="en-US" sz="1600" i="0" u="none" strike="noStrike" kern="1200" cap="none" spc="0" normalizeH="0" baseline="0" noProof="0" dirty="0">
-              <a:ln>
-                <a:noFill/>
-              </a:ln>
-              <a:solidFill>
-                <a:prstClr val="black"/>
-              </a:solidFill>
-              <a:effectLst/>
-              <a:uLnTx/>
-              <a:uFillTx/>
-              <a:latin typeface="Calibri"/>
-              <a:ea typeface="Calibri"/>
-              <a:cs typeface="Calibri"/>
-            </a:endParaRPr>
-          </a:p>
-          <a:p>
-            <a:pPr algn="just" fontAlgn="base" hangingPunct="0">
-              <a:defRPr/>
-            </a:pPr>
-            <a:endParaRPr lang="en-US" sz="1600" dirty="0">
-              <a:solidFill>
-                <a:prstClr val="black"/>
-              </a:solidFill>
               <a:latin typeface="Calibri"/>
               <a:ea typeface="Calibri"/>
               <a:cs typeface="Calibri"/>
@@ -5204,34 +5095,21 @@
             </a:r>
           </a:p>
           <a:p>
-            <a:pPr marL="0" marR="0" lvl="0" indent="0" algn="just" defTabSz="914400" rtl="0" eaLnBrk="1" fontAlgn="base" latinLnBrk="0" hangingPunct="0">
-              <a:lnSpc>
-                <a:spcPct val="100000"/>
-              </a:lnSpc>
-              <a:spcBef>
-                <a:spcPts val="0"/>
-              </a:spcBef>
-              <a:spcAft>
-                <a:spcPts val="0"/>
-              </a:spcAft>
-              <a:buClrTx/>
-              <a:buSzTx/>
-              <a:buFontTx/>
-              <a:buNone/>
-              <a:tabLst/>
+            <a:pPr lvl="0" algn="just" fontAlgn="base" hangingPunct="0">
               <a:defRPr/>
             </a:pPr>
             <a:r>
-              <a:rPr lang="en-US" sz="1600" dirty="0">
-                <a:solidFill>
-                  <a:prstClr val="black"/>
-                </a:solidFill>
-                <a:latin typeface="Calibri" panose="020F0502020204030204" pitchFamily="34" charset="0"/>
-                <a:ea typeface="Calibri" panose="020F0502020204030204" pitchFamily="34" charset="0"/>
-                <a:cs typeface="Calibri" panose="020F0502020204030204" pitchFamily="34" charset="0"/>
-              </a:rPr>
-              <a:t>{Responsibilities_Project1}</a:t>
-            </a:r>
+              <a:rPr lang="en-IN" sz="1600" dirty="0"/>
+              <a:t>{PROJECT1_RESPONSIBILITIES}</a:t>
+            </a:r>
+            <a:endParaRPr lang="en-US" sz="1600" dirty="0">
+              <a:solidFill>
+                <a:prstClr val="black"/>
+              </a:solidFill>
+              <a:latin typeface="Calibri" panose="020F0502020204030204" pitchFamily="34" charset="0"/>
+              <a:ea typeface="Calibri" panose="020F0502020204030204" pitchFamily="34" charset="0"/>
+              <a:cs typeface="Calibri" panose="020F0502020204030204" pitchFamily="34" charset="0"/>
+            </a:endParaRPr>
           </a:p>
           <a:p>
             <a:pPr marL="0" marR="0" lvl="0" indent="0" algn="just" defTabSz="914400" rtl="0" eaLnBrk="1" fontAlgn="base" latinLnBrk="0" hangingPunct="0">
@@ -5780,32 +5658,22 @@
               <a:defRPr/>
             </a:pPr>
             <a:r>
-              <a:rPr kumimoji="0" lang="en-US" b="1" i="0" u="none" strike="noStrike" kern="1200" cap="none" spc="0" normalizeH="0" baseline="0" noProof="0" dirty="0">
-                <a:ln>
-                  <a:noFill/>
-                </a:ln>
-                <a:solidFill>
-                  <a:prstClr val="black"/>
-                </a:solidFill>
-                <a:effectLst/>
-                <a:uLnTx/>
-                <a:uFillTx/>
-                <a:latin typeface="Calibri"/>
-                <a:ea typeface="Calibri"/>
-                <a:cs typeface="Calibri"/>
-              </a:rPr>
-              <a:t>Project: {PROJECT2_NAME}</a:t>
-            </a:r>
-            <a:r>
-              <a:rPr lang="en-US" b="1" dirty="0">
-                <a:solidFill>
-                  <a:prstClr val="black"/>
-                </a:solidFill>
-                <a:latin typeface="Calibri"/>
-                <a:ea typeface="Calibri"/>
-                <a:cs typeface="Calibri"/>
-              </a:rPr>
-              <a:t>.</a:t>
+              <a:rPr lang="en-IN" dirty="0"/>
+              <a:t>Project Name: {PROJECT2_NAME}</a:t>
+            </a:r>
+            <a:br>
+              <a:rPr lang="en-IN" dirty="0"/>
+            </a:br>
+            <a:r>
+              <a:rPr lang="en-IN" dirty="0"/>
+              <a:t>Duration: {PROJECT2_DURATION}</a:t>
+            </a:r>
+            <a:br>
+              <a:rPr lang="en-IN" dirty="0"/>
+            </a:br>
+            <a:r>
+              <a:rPr lang="en-IN" dirty="0"/>
+              <a:t>Role: {PROJECT2_ROLE}</a:t>
             </a:r>
             <a:endParaRPr lang="en-US" b="1" i="0" u="none" strike="noStrike" kern="1200" cap="none" spc="0" normalizeH="0" baseline="0" noProof="0" dirty="0">
               <a:ln>
@@ -5822,63 +5690,6 @@
               <a:cs typeface="Calibri"/>
             </a:endParaRPr>
           </a:p>
-          <a:p>
-            <a:pPr>
-              <a:defRPr/>
-            </a:pPr>
-            <a:r>
-              <a:rPr kumimoji="0" lang="en-US" b="1" i="0" u="none" strike="noStrike" kern="1200" cap="none" spc="0" normalizeH="0" baseline="0" noProof="0" dirty="0">
-                <a:ln>
-                  <a:noFill/>
-                </a:ln>
-                <a:solidFill>
-                  <a:prstClr val="black"/>
-                </a:solidFill>
-                <a:effectLst/>
-                <a:uLnTx/>
-                <a:uFillTx/>
-                <a:latin typeface="Calibri"/>
-                <a:ea typeface="Calibri"/>
-                <a:cs typeface="Calibri"/>
-              </a:rPr>
-              <a:t>Duration : {DURATION_PROJECT2}</a:t>
-            </a:r>
-            <a:endParaRPr lang="en-US" b="1" dirty="0">
-              <a:solidFill>
-                <a:prstClr val="black"/>
-              </a:solidFill>
-              <a:latin typeface="Calibri"/>
-              <a:ea typeface="Calibri"/>
-              <a:cs typeface="Calibri"/>
-            </a:endParaRPr>
-          </a:p>
-          <a:p>
-            <a:pPr>
-              <a:defRPr/>
-            </a:pPr>
-            <a:r>
-              <a:rPr lang="en-US" b="1" dirty="0"/>
-              <a:t>Role</a:t>
-            </a:r>
-            <a:r>
-              <a:rPr lang="en-US" dirty="0"/>
-              <a:t>: {ROLE_PROJECT2}</a:t>
-            </a:r>
-            <a:endParaRPr lang="en-US" b="1" i="0" u="none" strike="noStrike" kern="1200" cap="none" spc="0" normalizeH="0" baseline="0" noProof="0" dirty="0">
-              <a:ln>
-                <a:noFill/>
-              </a:ln>
-              <a:solidFill>
-                <a:prstClr val="black"/>
-              </a:solidFill>
-              <a:effectLst/>
-              <a:uLnTx/>
-              <a:uFillTx/>
-              <a:latin typeface="Calibri"/>
-              <a:ea typeface="Calibri"/>
-              <a:cs typeface="Calibri"/>
-            </a:endParaRPr>
-          </a:p>
         </p:txBody>
       </p:sp>
       <p:sp>
@@ -5895,8 +5706,8 @@
         </p:nvSpPr>
         <p:spPr>
           <a:xfrm>
-            <a:off x="304800" y="2132178"/>
-            <a:ext cx="11691257" cy="4524315"/>
+            <a:off x="304800" y="2132179"/>
+            <a:ext cx="11691257" cy="3539430"/>
           </a:xfrm>
           <a:prstGeom prst="rect">
             <a:avLst/>
@@ -5913,72 +5724,9 @@
               <a:defRPr/>
             </a:pPr>
             <a:r>
-              <a:rPr lang="en-US" sz="1600" i="0" u="none" strike="noStrike" kern="1200" cap="none" spc="0" normalizeH="0" baseline="0" noProof="0" dirty="0">
-                <a:ln>
-                  <a:noFill/>
-                </a:ln>
-                <a:solidFill>
-                  <a:prstClr val="black"/>
-                </a:solidFill>
-                <a:effectLst/>
-                <a:uLnTx/>
-                <a:uFillTx/>
-                <a:latin typeface="Calibri"/>
-                <a:ea typeface="Calibri"/>
-                <a:cs typeface="Calibri"/>
-              </a:rPr>
-              <a:t>{Project2_Description}:</a:t>
-            </a:r>
-          </a:p>
-          <a:p>
-            <a:pPr algn="just" fontAlgn="base" hangingPunct="0">
-              <a:defRPr/>
-            </a:pPr>
-            <a:endParaRPr lang="en-US" sz="1600" dirty="0">
-              <a:solidFill>
-                <a:prstClr val="black"/>
-              </a:solidFill>
-              <a:latin typeface="Calibri"/>
-              <a:ea typeface="Calibri"/>
-              <a:cs typeface="Calibri"/>
-            </a:endParaRPr>
-          </a:p>
-          <a:p>
-            <a:pPr algn="just" fontAlgn="base" hangingPunct="0">
-              <a:defRPr/>
-            </a:pPr>
-            <a:endParaRPr lang="en-US" sz="1600" i="0" u="none" strike="noStrike" kern="1200" cap="none" spc="0" normalizeH="0" baseline="0" noProof="0" dirty="0">
-              <a:ln>
-                <a:noFill/>
-              </a:ln>
-              <a:solidFill>
-                <a:prstClr val="black"/>
-              </a:solidFill>
-              <a:effectLst/>
-              <a:uLnTx/>
-              <a:uFillTx/>
-              <a:latin typeface="Calibri"/>
-              <a:ea typeface="Calibri"/>
-              <a:cs typeface="Calibri"/>
-            </a:endParaRPr>
-          </a:p>
-          <a:p>
-            <a:pPr algn="just" fontAlgn="base" hangingPunct="0">
-              <a:defRPr/>
-            </a:pPr>
-            <a:endParaRPr lang="en-US" sz="1600" dirty="0">
-              <a:solidFill>
-                <a:prstClr val="black"/>
-              </a:solidFill>
-              <a:latin typeface="Calibri"/>
-              <a:ea typeface="Calibri"/>
-              <a:cs typeface="Calibri"/>
-            </a:endParaRPr>
-          </a:p>
-          <a:p>
-            <a:pPr algn="just" fontAlgn="base" hangingPunct="0">
-              <a:defRPr/>
-            </a:pPr>
+              <a:rPr lang="en-IN" sz="1600" dirty="0"/>
+              <a:t>{PROJECT2_DESCRIPTION}</a:t>
+            </a:r>
             <a:endParaRPr lang="en-US" sz="1600" i="0" u="none" strike="noStrike" kern="1200" cap="none" spc="0" normalizeH="0" baseline="0" noProof="0" dirty="0">
               <a:ln>
                 <a:noFill/>
@@ -6089,34 +5837,21 @@
             </a:r>
           </a:p>
           <a:p>
-            <a:pPr marL="0" marR="0" lvl="0" indent="0" algn="just" defTabSz="914400" rtl="0" eaLnBrk="1" fontAlgn="base" latinLnBrk="0" hangingPunct="0">
-              <a:lnSpc>
-                <a:spcPct val="100000"/>
-              </a:lnSpc>
-              <a:spcBef>
-                <a:spcPts val="0"/>
-              </a:spcBef>
-              <a:spcAft>
-                <a:spcPts val="0"/>
-              </a:spcAft>
-              <a:buClrTx/>
-              <a:buSzTx/>
-              <a:buFontTx/>
-              <a:buNone/>
-              <a:tabLst/>
+            <a:pPr lvl="0" algn="just" fontAlgn="base" hangingPunct="0">
               <a:defRPr/>
             </a:pPr>
             <a:r>
-              <a:rPr lang="en-US" sz="1600" dirty="0">
-                <a:solidFill>
-                  <a:prstClr val="black"/>
-                </a:solidFill>
-                <a:latin typeface="Calibri" panose="020F0502020204030204" pitchFamily="34" charset="0"/>
-                <a:ea typeface="Calibri" panose="020F0502020204030204" pitchFamily="34" charset="0"/>
-                <a:cs typeface="Calibri" panose="020F0502020204030204" pitchFamily="34" charset="0"/>
-              </a:rPr>
-              <a:t>{Responsibilities_project2}</a:t>
-            </a:r>
+              <a:rPr lang="en-IN" sz="1600" dirty="0"/>
+              <a:t>{PROJECT2_RESPONSIBILITIES}</a:t>
+            </a:r>
+            <a:endParaRPr lang="en-US" sz="1600" dirty="0">
+              <a:solidFill>
+                <a:prstClr val="black"/>
+              </a:solidFill>
+              <a:latin typeface="Calibri" panose="020F0502020204030204" pitchFamily="34" charset="0"/>
+              <a:ea typeface="Calibri" panose="020F0502020204030204" pitchFamily="34" charset="0"/>
+              <a:cs typeface="Calibri" panose="020F0502020204030204" pitchFamily="34" charset="0"/>
+            </a:endParaRPr>
           </a:p>
           <a:p>
             <a:pPr marL="0" marR="0" lvl="0" indent="0" algn="just" defTabSz="914400" rtl="0" eaLnBrk="1" fontAlgn="base" latinLnBrk="0" hangingPunct="0">
@@ -6665,32 +6400,22 @@
               <a:defRPr/>
             </a:pPr>
             <a:r>
-              <a:rPr kumimoji="0" lang="en-US" b="1" i="0" u="none" strike="noStrike" kern="1200" cap="none" spc="0" normalizeH="0" baseline="0" noProof="0" dirty="0">
-                <a:ln>
-                  <a:noFill/>
-                </a:ln>
-                <a:solidFill>
-                  <a:prstClr val="black"/>
-                </a:solidFill>
-                <a:effectLst/>
-                <a:uLnTx/>
-                <a:uFillTx/>
-                <a:latin typeface="Calibri"/>
-                <a:ea typeface="Calibri"/>
-                <a:cs typeface="Calibri"/>
-              </a:rPr>
-              <a:t>Project: {PROJECT3_NAME}</a:t>
-            </a:r>
-            <a:r>
-              <a:rPr lang="en-US" b="1" dirty="0">
-                <a:solidFill>
-                  <a:prstClr val="black"/>
-                </a:solidFill>
-                <a:latin typeface="Calibri"/>
-                <a:ea typeface="Calibri"/>
-                <a:cs typeface="Calibri"/>
-              </a:rPr>
-              <a:t>.</a:t>
+              <a:rPr lang="en-IN" dirty="0"/>
+              <a:t>Project Name: {PROJECT3_NAME}</a:t>
+            </a:r>
+            <a:br>
+              <a:rPr lang="en-IN" dirty="0"/>
+            </a:br>
+            <a:r>
+              <a:rPr lang="en-IN" dirty="0"/>
+              <a:t>Duration: {PROJECT3_DURATION}</a:t>
+            </a:r>
+            <a:br>
+              <a:rPr lang="en-IN" dirty="0"/>
+            </a:br>
+            <a:r>
+              <a:rPr lang="en-IN" dirty="0"/>
+              <a:t>Role: {PROJECT3_ROLE}</a:t>
             </a:r>
             <a:endParaRPr lang="en-US" b="1" i="0" u="none" strike="noStrike" kern="1200" cap="none" spc="0" normalizeH="0" baseline="0" noProof="0" dirty="0">
               <a:ln>
@@ -6707,49 +6432,44 @@
               <a:cs typeface="Calibri"/>
             </a:endParaRPr>
           </a:p>
-          <a:p>
-            <a:pPr>
+        </p:txBody>
+      </p:sp>
+      <p:sp>
+        <p:nvSpPr>
+          <p:cNvPr id="11" name="TextBox 10">
+            <a:extLst>
+              <a:ext uri="{FF2B5EF4-FFF2-40B4-BE49-F238E27FC236}">
+                <a16:creationId xmlns:a16="http://schemas.microsoft.com/office/drawing/2014/main" id="{8C183A66-42F8-F13C-795D-00913B38A72C}"/>
+              </a:ext>
+            </a:extLst>
+          </p:cNvPr>
+          <p:cNvSpPr txBox="1"/>
+          <p:nvPr/>
+        </p:nvSpPr>
+        <p:spPr>
+          <a:xfrm>
+            <a:off x="304800" y="2132178"/>
+            <a:ext cx="11691257" cy="3539430"/>
+          </a:xfrm>
+          <a:prstGeom prst="rect">
+            <a:avLst/>
+          </a:prstGeom>
+          <a:noFill/>
+        </p:spPr>
+        <p:txBody>
+          <a:bodyPr wrap="square" lIns="91440" tIns="45720" rIns="91440" bIns="45720" anchor="t">
+            <a:spAutoFit/>
+          </a:bodyPr>
+          <a:lstStyle/>
+          <a:p>
+            <a:pPr algn="just" fontAlgn="base" hangingPunct="0">
               <a:defRPr/>
             </a:pPr>
             <a:r>
-              <a:rPr kumimoji="0" lang="en-US" b="1" i="0" u="none" strike="noStrike" kern="1200" cap="none" spc="0" normalizeH="0" baseline="0" noProof="0" dirty="0">
-                <a:ln>
-                  <a:noFill/>
-                </a:ln>
-                <a:solidFill>
-                  <a:prstClr val="black"/>
-                </a:solidFill>
-                <a:effectLst/>
-                <a:uLnTx/>
-                <a:uFillTx/>
-                <a:latin typeface="Calibri"/>
-                <a:ea typeface="Calibri"/>
-                <a:cs typeface="Calibri"/>
-              </a:rPr>
-              <a:t>Duration : {DURATION_project3}</a:t>
-            </a:r>
-            <a:endParaRPr lang="en-US" b="1" dirty="0">
-              <a:solidFill>
-                <a:prstClr val="black"/>
-              </a:solidFill>
-              <a:latin typeface="Calibri"/>
-              <a:ea typeface="Calibri"/>
-              <a:cs typeface="Calibri"/>
-            </a:endParaRPr>
-          </a:p>
-          <a:p>
-            <a:pPr>
-              <a:defRPr/>
-            </a:pPr>
-            <a:r>
-              <a:rPr lang="en-US" b="1" dirty="0"/>
-              <a:t>Role</a:t>
-            </a:r>
-            <a:r>
-              <a:rPr lang="en-US" dirty="0"/>
-              <a:t>: {ROLE_project3}</a:t>
-            </a:r>
-            <a:endParaRPr lang="en-US" b="1" i="0" u="none" strike="noStrike" kern="1200" cap="none" spc="0" normalizeH="0" baseline="0" noProof="0" dirty="0">
+              <a:rPr lang="en-IN" sz="1600" dirty="0"/>
+              <a:t>{PROJECT3_DESCRIPTION}</a:t>
+            </a:r>
+            <a:endParaRPr lang="en-US" sz="1600" i="0" u="none" strike="noStrike" kern="1200" cap="none" spc="0" normalizeH="0" baseline="0" noProof="0" dirty="0">
               <a:ln>
                 <a:noFill/>
               </a:ln>
@@ -6764,57 +6484,6 @@
               <a:cs typeface="Calibri"/>
             </a:endParaRPr>
           </a:p>
-        </p:txBody>
-      </p:sp>
-      <p:sp>
-        <p:nvSpPr>
-          <p:cNvPr id="11" name="TextBox 10">
-            <a:extLst>
-              <a:ext uri="{FF2B5EF4-FFF2-40B4-BE49-F238E27FC236}">
-                <a16:creationId xmlns:a16="http://schemas.microsoft.com/office/drawing/2014/main" id="{8C183A66-42F8-F13C-795D-00913B38A72C}"/>
-              </a:ext>
-            </a:extLst>
-          </p:cNvPr>
-          <p:cNvSpPr txBox="1"/>
-          <p:nvPr/>
-        </p:nvSpPr>
-        <p:spPr>
-          <a:xfrm>
-            <a:off x="304800" y="2132178"/>
-            <a:ext cx="11691257" cy="4524315"/>
-          </a:xfrm>
-          <a:prstGeom prst="rect">
-            <a:avLst/>
-          </a:prstGeom>
-          <a:noFill/>
-        </p:spPr>
-        <p:txBody>
-          <a:bodyPr wrap="square" lIns="91440" tIns="45720" rIns="91440" bIns="45720" anchor="t">
-            <a:spAutoFit/>
-          </a:bodyPr>
-          <a:lstStyle/>
-          <a:p>
-            <a:pPr algn="just" fontAlgn="base" hangingPunct="0">
-              <a:defRPr/>
-            </a:pPr>
-            <a:r>
-              <a:rPr lang="en-US" sz="1600" i="0" u="none" strike="noStrike" kern="1200" cap="none" spc="0" normalizeH="0" baseline="0" noProof="0" dirty="0">
-                <a:ln>
-                  <a:noFill/>
-                </a:ln>
-                <a:solidFill>
-                  <a:prstClr val="black"/>
-                </a:solidFill>
-                <a:effectLst/>
-                <a:uLnTx/>
-                <a:uFillTx/>
-                <a:latin typeface="Calibri"/>
-                <a:ea typeface="Calibri"/>
-                <a:cs typeface="Calibri"/>
-              </a:rPr>
-              <a:t>{Project3_Description}:</a:t>
-            </a:r>
-          </a:p>
           <a:p>
             <a:pPr algn="just" fontAlgn="base" hangingPunct="0">
               <a:defRPr/>
@@ -6855,57 +6524,6 @@
               <a:solidFill>
                 <a:prstClr val="black"/>
               </a:solidFill>
-              <a:latin typeface="Calibri"/>
-              <a:ea typeface="Calibri"/>
-              <a:cs typeface="Calibri"/>
-            </a:endParaRPr>
-          </a:p>
-          <a:p>
-            <a:pPr algn="just" fontAlgn="base" hangingPunct="0">
-              <a:defRPr/>
-            </a:pPr>
-            <a:endParaRPr lang="en-US" sz="1600" i="0" u="none" strike="noStrike" kern="1200" cap="none" spc="0" normalizeH="0" baseline="0" noProof="0" dirty="0">
-              <a:ln>
-                <a:noFill/>
-              </a:ln>
-              <a:solidFill>
-                <a:prstClr val="black"/>
-              </a:solidFill>
-              <a:effectLst/>
-              <a:uLnTx/>
-              <a:uFillTx/>
-              <a:latin typeface="Calibri"/>
-              <a:ea typeface="Calibri"/>
-              <a:cs typeface="Calibri"/>
-            </a:endParaRPr>
-          </a:p>
-          <a:p>
-            <a:pPr algn="just" fontAlgn="base" hangingPunct="0">
-              <a:defRPr/>
-            </a:pPr>
-            <a:endParaRPr lang="en-US" sz="1600" dirty="0">
-              <a:solidFill>
-                <a:prstClr val="black"/>
-              </a:solidFill>
-              <a:latin typeface="Calibri"/>
-              <a:ea typeface="Calibri"/>
-              <a:cs typeface="Calibri"/>
-            </a:endParaRPr>
-          </a:p>
-          <a:p>
-            <a:pPr algn="just" fontAlgn="base" hangingPunct="0">
-              <a:defRPr/>
-            </a:pPr>
-            <a:endParaRPr lang="en-US" sz="1600" i="0" u="none" strike="noStrike" kern="1200" cap="none" spc="0" normalizeH="0" baseline="0" noProof="0" dirty="0">
-              <a:ln>
-                <a:noFill/>
-              </a:ln>
-              <a:solidFill>
-                <a:prstClr val="black"/>
-              </a:solidFill>
-              <a:effectLst/>
-              <a:uLnTx/>
-              <a:uFillTx/>
               <a:latin typeface="Calibri"/>
               <a:ea typeface="Calibri"/>
               <a:cs typeface="Calibri"/>
@@ -6974,53 +6592,13 @@
             </a:r>
           </a:p>
           <a:p>
-            <a:pPr marL="0" marR="0" lvl="0" indent="0" algn="just" defTabSz="914400" rtl="0" eaLnBrk="1" fontAlgn="base" latinLnBrk="0" hangingPunct="0">
-              <a:lnSpc>
-                <a:spcPct val="100000"/>
-              </a:lnSpc>
-              <a:spcBef>
-                <a:spcPts val="0"/>
-              </a:spcBef>
-              <a:spcAft>
-                <a:spcPts val="0"/>
-              </a:spcAft>
-              <a:buClrTx/>
-              <a:buSzTx/>
-              <a:buFontTx/>
-              <a:buNone/>
-              <a:tabLst/>
+            <a:pPr lvl="0" algn="just" fontAlgn="base" hangingPunct="0">
               <a:defRPr/>
             </a:pPr>
             <a:r>
-              <a:rPr lang="en-US" sz="1600" dirty="0">
-                <a:solidFill>
-                  <a:prstClr val="black"/>
-                </a:solidFill>
-                <a:latin typeface="Calibri" panose="020F0502020204030204" pitchFamily="34" charset="0"/>
-                <a:ea typeface="Calibri" panose="020F0502020204030204" pitchFamily="34" charset="0"/>
-                <a:cs typeface="Calibri" panose="020F0502020204030204" pitchFamily="34" charset="0"/>
-              </a:rPr>
-              <a:t>{Responsibilities_project3}</a:t>
-            </a:r>
-          </a:p>
-          <a:p>
-            <a:pPr marL="0" marR="0" lvl="0" indent="0" algn="just" defTabSz="914400" rtl="0" eaLnBrk="1" fontAlgn="base" latinLnBrk="0" hangingPunct="0">
-              <a:lnSpc>
-                <a:spcPct val="100000"/>
-              </a:lnSpc>
-              <a:spcBef>
-                <a:spcPts val="0"/>
-              </a:spcBef>
-              <a:spcAft>
-                <a:spcPts val="0"/>
-              </a:spcAft>
-              <a:buClrTx/>
-              <a:buSzTx/>
-              <a:buFontTx/>
-              <a:buNone/>
-              <a:tabLst/>
-              <a:defRPr/>
-            </a:pPr>
+              <a:rPr lang="en-IN" sz="1600" dirty="0"/>
+              <a:t>{PROJECT3_RESPONSIBILITIES}</a:t>
+            </a:r>
             <a:endParaRPr lang="en-US" sz="1600" dirty="0">
               <a:solidFill>
                 <a:prstClr val="black"/>
@@ -7550,66 +7128,22 @@
               <a:defRPr/>
             </a:pPr>
             <a:r>
-              <a:rPr kumimoji="0" lang="en-US" b="1" i="0" u="none" strike="noStrike" kern="1200" cap="none" spc="0" normalizeH="0" baseline="0" noProof="0" dirty="0">
-                <a:ln>
-                  <a:noFill/>
-                </a:ln>
-                <a:solidFill>
-                  <a:prstClr val="black"/>
-                </a:solidFill>
-                <a:effectLst/>
-                <a:uLnTx/>
-                <a:uFillTx/>
-                <a:latin typeface="Calibri"/>
-                <a:ea typeface="Calibri"/>
-                <a:cs typeface="Calibri"/>
-              </a:rPr>
-              <a:t>Project: </a:t>
-            </a:r>
-            <a:r>
-              <a:rPr kumimoji="0" lang="en-US" b="1" i="0" u="none" strike="noStrike" kern="1200" cap="none" spc="0" normalizeH="0" baseline="0" noProof="0">
-                <a:ln>
-                  <a:noFill/>
-                </a:ln>
-                <a:solidFill>
-                  <a:prstClr val="black"/>
-                </a:solidFill>
-                <a:effectLst/>
-                <a:uLnTx/>
-                <a:uFillTx/>
-                <a:latin typeface="Calibri"/>
-                <a:ea typeface="Calibri"/>
-                <a:cs typeface="Calibri"/>
-              </a:rPr>
-              <a:t>{PROJECT4_</a:t>
-            </a:r>
-            <a:r>
-              <a:rPr kumimoji="0" lang="en-US" b="1" i="0" u="none" strike="noStrike" kern="1200" cap="none" spc="0" normalizeH="0" baseline="0" noProof="0" dirty="0">
-                <a:ln>
-                  <a:noFill/>
-                </a:ln>
-                <a:solidFill>
-                  <a:prstClr val="black"/>
-                </a:solidFill>
-                <a:effectLst/>
-                <a:uLnTx/>
-                <a:uFillTx/>
-                <a:latin typeface="Calibri"/>
-                <a:ea typeface="Calibri"/>
-                <a:cs typeface="Calibri"/>
-              </a:rPr>
-              <a:t>NAME}</a:t>
-            </a:r>
-            <a:r>
-              <a:rPr lang="en-US" b="1" dirty="0">
-                <a:solidFill>
-                  <a:prstClr val="black"/>
-                </a:solidFill>
-                <a:latin typeface="Calibri"/>
-                <a:ea typeface="Calibri"/>
-                <a:cs typeface="Calibri"/>
-              </a:rPr>
-              <a:t>.</a:t>
+              <a:rPr lang="en-IN" dirty="0"/>
+              <a:t>Project Name: {PROJECT4_NAME}</a:t>
+            </a:r>
+            <a:br>
+              <a:rPr lang="en-IN" dirty="0"/>
+            </a:br>
+            <a:r>
+              <a:rPr lang="en-IN" dirty="0"/>
+              <a:t>Duration: {PROJECT4_DURATION}</a:t>
+            </a:r>
+            <a:br>
+              <a:rPr lang="en-IN" dirty="0"/>
+            </a:br>
+            <a:r>
+              <a:rPr lang="en-IN" dirty="0"/>
+              <a:t>Role: {PROJECT4_ROLE}</a:t>
             </a:r>
             <a:endParaRPr lang="en-US" b="1" i="0" u="none" strike="noStrike" kern="1200" cap="none" spc="0" normalizeH="0" baseline="0" noProof="0" dirty="0">
               <a:ln>
@@ -7626,49 +7160,44 @@
               <a:cs typeface="Calibri"/>
             </a:endParaRPr>
           </a:p>
-          <a:p>
-            <a:pPr>
+        </p:txBody>
+      </p:sp>
+      <p:sp>
+        <p:nvSpPr>
+          <p:cNvPr id="11" name="TextBox 10">
+            <a:extLst>
+              <a:ext uri="{FF2B5EF4-FFF2-40B4-BE49-F238E27FC236}">
+                <a16:creationId xmlns:a16="http://schemas.microsoft.com/office/drawing/2014/main" id="{E710390A-553C-B68D-9AAF-E63341E911D8}"/>
+              </a:ext>
+            </a:extLst>
+          </p:cNvPr>
+          <p:cNvSpPr txBox="1"/>
+          <p:nvPr/>
+        </p:nvSpPr>
+        <p:spPr>
+          <a:xfrm>
+            <a:off x="304800" y="2132178"/>
+            <a:ext cx="11691257" cy="3785652"/>
+          </a:xfrm>
+          <a:prstGeom prst="rect">
+            <a:avLst/>
+          </a:prstGeom>
+          <a:noFill/>
+        </p:spPr>
+        <p:txBody>
+          <a:bodyPr wrap="square" lIns="91440" tIns="45720" rIns="91440" bIns="45720" anchor="t">
+            <a:spAutoFit/>
+          </a:bodyPr>
+          <a:lstStyle/>
+          <a:p>
+            <a:pPr algn="just" fontAlgn="base" hangingPunct="0">
               <a:defRPr/>
             </a:pPr>
             <a:r>
-              <a:rPr kumimoji="0" lang="en-US" b="1" i="0" u="none" strike="noStrike" kern="1200" cap="none" spc="0" normalizeH="0" baseline="0" noProof="0" dirty="0">
-                <a:ln>
-                  <a:noFill/>
-                </a:ln>
-                <a:solidFill>
-                  <a:prstClr val="black"/>
-                </a:solidFill>
-                <a:effectLst/>
-                <a:uLnTx/>
-                <a:uFillTx/>
-                <a:latin typeface="Calibri"/>
-                <a:ea typeface="Calibri"/>
-                <a:cs typeface="Calibri"/>
-              </a:rPr>
-              <a:t>Duration : {DURATION_project4}</a:t>
-            </a:r>
-            <a:endParaRPr lang="en-US" b="1" dirty="0">
-              <a:solidFill>
-                <a:prstClr val="black"/>
-              </a:solidFill>
-              <a:latin typeface="Calibri"/>
-              <a:ea typeface="Calibri"/>
-              <a:cs typeface="Calibri"/>
-            </a:endParaRPr>
-          </a:p>
-          <a:p>
-            <a:pPr>
-              <a:defRPr/>
-            </a:pPr>
-            <a:r>
-              <a:rPr lang="en-US" b="1" dirty="0"/>
-              <a:t>Role</a:t>
-            </a:r>
-            <a:r>
-              <a:rPr lang="en-US" dirty="0"/>
-              <a:t>: {ROLE_project4}</a:t>
-            </a:r>
-            <a:endParaRPr lang="en-US" b="1" i="0" u="none" strike="noStrike" kern="1200" cap="none" spc="0" normalizeH="0" baseline="0" noProof="0" dirty="0">
+              <a:rPr lang="en-IN" sz="1600" dirty="0"/>
+              <a:t>{PROJECT4_DESCRIPTION}</a:t>
+            </a:r>
+            <a:endParaRPr lang="en-US" sz="1600" i="0" u="none" strike="noStrike" kern="1200" cap="none" spc="0" normalizeH="0" baseline="0" noProof="0" dirty="0">
               <a:ln>
                 <a:noFill/>
               </a:ln>
@@ -7683,57 +7212,6 @@
               <a:cs typeface="Calibri"/>
             </a:endParaRPr>
           </a:p>
-        </p:txBody>
-      </p:sp>
-      <p:sp>
-        <p:nvSpPr>
-          <p:cNvPr id="11" name="TextBox 10">
-            <a:extLst>
-              <a:ext uri="{FF2B5EF4-FFF2-40B4-BE49-F238E27FC236}">
-                <a16:creationId xmlns:a16="http://schemas.microsoft.com/office/drawing/2014/main" id="{E710390A-553C-B68D-9AAF-E63341E911D8}"/>
-              </a:ext>
-            </a:extLst>
-          </p:cNvPr>
-          <p:cNvSpPr txBox="1"/>
-          <p:nvPr/>
-        </p:nvSpPr>
-        <p:spPr>
-          <a:xfrm>
-            <a:off x="304800" y="2132178"/>
-            <a:ext cx="11691257" cy="4524315"/>
-          </a:xfrm>
-          <a:prstGeom prst="rect">
-            <a:avLst/>
-          </a:prstGeom>
-          <a:noFill/>
-        </p:spPr>
-        <p:txBody>
-          <a:bodyPr wrap="square" lIns="91440" tIns="45720" rIns="91440" bIns="45720" anchor="t">
-            <a:spAutoFit/>
-          </a:bodyPr>
-          <a:lstStyle/>
-          <a:p>
-            <a:pPr algn="just" fontAlgn="base" hangingPunct="0">
-              <a:defRPr/>
-            </a:pPr>
-            <a:r>
-              <a:rPr lang="en-US" sz="1600" i="0" u="none" strike="noStrike" kern="1200" cap="none" spc="0" normalizeH="0" baseline="0" noProof="0" dirty="0">
-                <a:ln>
-                  <a:noFill/>
-                </a:ln>
-                <a:solidFill>
-                  <a:prstClr val="black"/>
-                </a:solidFill>
-                <a:effectLst/>
-                <a:uLnTx/>
-                <a:uFillTx/>
-                <a:latin typeface="Calibri"/>
-                <a:ea typeface="Calibri"/>
-                <a:cs typeface="Calibri"/>
-              </a:rPr>
-              <a:t>{Project4_Description}:</a:t>
-            </a:r>
-          </a:p>
           <a:p>
             <a:pPr algn="just" fontAlgn="base" hangingPunct="0">
               <a:defRPr/>
@@ -7793,51 +7271,6 @@
               <a:effectLst/>
               <a:uLnTx/>
               <a:uFillTx/>
-              <a:latin typeface="Calibri"/>
-              <a:ea typeface="Calibri"/>
-              <a:cs typeface="Calibri"/>
-            </a:endParaRPr>
-          </a:p>
-          <a:p>
-            <a:pPr algn="just" fontAlgn="base" hangingPunct="0">
-              <a:defRPr/>
-            </a:pPr>
-            <a:endParaRPr lang="en-US" sz="1600" dirty="0">
-              <a:solidFill>
-                <a:prstClr val="black"/>
-              </a:solidFill>
-              <a:latin typeface="Calibri"/>
-              <a:ea typeface="Calibri"/>
-              <a:cs typeface="Calibri"/>
-            </a:endParaRPr>
-          </a:p>
-          <a:p>
-            <a:pPr algn="just" fontAlgn="base" hangingPunct="0">
-              <a:defRPr/>
-            </a:pPr>
-            <a:endParaRPr lang="en-US" sz="1600" i="0" u="none" strike="noStrike" kern="1200" cap="none" spc="0" normalizeH="0" baseline="0" noProof="0" dirty="0">
-              <a:ln>
-                <a:noFill/>
-              </a:ln>
-              <a:solidFill>
-                <a:prstClr val="black"/>
-              </a:solidFill>
-              <a:effectLst/>
-              <a:uLnTx/>
-              <a:uFillTx/>
-              <a:latin typeface="Calibri"/>
-              <a:ea typeface="Calibri"/>
-              <a:cs typeface="Calibri"/>
-            </a:endParaRPr>
-          </a:p>
-          <a:p>
-            <a:pPr algn="just" fontAlgn="base" hangingPunct="0">
-              <a:defRPr/>
-            </a:pPr>
-            <a:endParaRPr lang="en-US" sz="1600" dirty="0">
-              <a:solidFill>
-                <a:prstClr val="black"/>
-              </a:solidFill>
               <a:latin typeface="Calibri"/>
               <a:ea typeface="Calibri"/>
               <a:cs typeface="Calibri"/>
@@ -7893,34 +7326,21 @@
             </a:r>
           </a:p>
           <a:p>
-            <a:pPr marL="0" marR="0" lvl="0" indent="0" algn="just" defTabSz="914400" rtl="0" eaLnBrk="1" fontAlgn="base" latinLnBrk="0" hangingPunct="0">
-              <a:lnSpc>
-                <a:spcPct val="100000"/>
-              </a:lnSpc>
-              <a:spcBef>
-                <a:spcPts val="0"/>
-              </a:spcBef>
-              <a:spcAft>
-                <a:spcPts val="0"/>
-              </a:spcAft>
-              <a:buClrTx/>
-              <a:buSzTx/>
-              <a:buFontTx/>
-              <a:buNone/>
-              <a:tabLst/>
+            <a:pPr lvl="0" algn="just" fontAlgn="base" hangingPunct="0">
               <a:defRPr/>
             </a:pPr>
             <a:r>
-              <a:rPr lang="en-US" sz="1600" dirty="0">
-                <a:solidFill>
-                  <a:prstClr val="black"/>
-                </a:solidFill>
-                <a:latin typeface="Calibri" panose="020F0502020204030204" pitchFamily="34" charset="0"/>
-                <a:ea typeface="Calibri" panose="020F0502020204030204" pitchFamily="34" charset="0"/>
-                <a:cs typeface="Calibri" panose="020F0502020204030204" pitchFamily="34" charset="0"/>
-              </a:rPr>
-              <a:t>{Responsibilities_project4}</a:t>
-            </a:r>
+              <a:rPr lang="en-IN" sz="1600"/>
+              <a:t>{PROJECT4_RESPONSIBILITIES}</a:t>
+            </a:r>
+            <a:endParaRPr lang="en-US" sz="1600" dirty="0">
+              <a:solidFill>
+                <a:prstClr val="black"/>
+              </a:solidFill>
+              <a:latin typeface="Calibri" panose="020F0502020204030204" pitchFamily="34" charset="0"/>
+              <a:ea typeface="Calibri" panose="020F0502020204030204" pitchFamily="34" charset="0"/>
+              <a:cs typeface="Calibri" panose="020F0502020204030204" pitchFamily="34" charset="0"/>
+            </a:endParaRPr>
           </a:p>
           <a:p>
             <a:pPr marL="0" marR="0" lvl="0" indent="0" algn="just" defTabSz="914400" rtl="0" eaLnBrk="1" fontAlgn="base" latinLnBrk="0" hangingPunct="0">

</xml_diff>